<commit_message>
docs(ppt): add hybrid RAG rationale and full pipeline slides (pro deck 13)
Co-authored-by: Cursor <cursoragent@cursor.com>
</commit_message>
<xml_diff>
--- a/docs/deliverables/v0.1/zooplus-assistant-interview-15min-pro.pptx
+++ b/docs/deliverables/v0.1/zooplus-assistant-interview-15min-pro.pptx
@@ -9,6 +9,8 @@
     <p:sldId id="257" r:id="rId9"/>
     <p:sldId id="258" r:id="rId10"/>
     <p:sldId id="259" r:id="rId11"/>
+    <p:sldId id="267" r:id="rId19"/>
+    <p:sldId id="268" r:id="rId20"/>
     <p:sldId id="260" r:id="rId12"/>
     <p:sldId id="261" r:id="rId13"/>
     <p:sldId id="262" r:id="rId14"/>
@@ -5421,7 +5423,7 @@
               </a:defRPr>
             </a:pPr>
             <a:r>
-              <a:t>10</a:t>
+              <a:t>12</a:t>
             </a:r>
           </a:p>
         </p:txBody>
@@ -6298,7 +6300,1899 @@
               </a:defRPr>
             </a:pPr>
             <a:r>
-              <a:t>11</a:t>
+              <a:t>13</a:t>
+            </a:r>
+          </a:p>
+        </p:txBody>
+      </p:sp>
+    </p:spTree>
+  </p:cSld>
+  <p:clrMapOvr>
+    <a:masterClrMapping/>
+  </p:clrMapOvr>
+</p:sld>
+</file>
+
+<file path=ppt/slides/slide12.xml><?xml version="1.0" encoding="utf-8"?>
+<p:sld xmlns:a="http://schemas.openxmlformats.org/drawingml/2006/main" xmlns:p="http://schemas.openxmlformats.org/presentationml/2006/main" xmlns:r="http://schemas.openxmlformats.org/officeDocument/2006/relationships">
+  <p:cSld>
+    <p:spTree>
+      <p:nvGrpSpPr>
+        <p:cNvPr id="1" name=""/>
+        <p:cNvGrpSpPr/>
+        <p:nvPr/>
+      </p:nvGrpSpPr>
+      <p:grpSpPr/>
+      <p:sp>
+        <p:nvSpPr>
+          <p:cNvPr id="2" name="Rectangle 1"/>
+          <p:cNvSpPr/>
+          <p:nvPr/>
+        </p:nvSpPr>
+        <p:spPr>
+          <a:xfrm>
+            <a:off x="429768" y="0"/>
+            <a:ext cx="11761927" cy="6858000"/>
+          </a:xfrm>
+          <a:prstGeom prst="rect">
+            <a:avLst/>
+          </a:prstGeom>
+          <a:solidFill>
+            <a:srgbClr val="FFFFFF"/>
+          </a:solidFill>
+          <a:ln>
+            <a:noFill/>
+          </a:ln>
+        </p:spPr>
+        <p:style>
+          <a:lnRef idx="1">
+            <a:schemeClr val="accent1"/>
+          </a:lnRef>
+          <a:fillRef idx="3">
+            <a:schemeClr val="accent1"/>
+          </a:fillRef>
+          <a:effectRef idx="2">
+            <a:schemeClr val="accent1"/>
+          </a:effectRef>
+          <a:fontRef idx="minor">
+            <a:schemeClr val="lt1"/>
+          </a:fontRef>
+        </p:style>
+        <p:txBody>
+          <a:bodyPr rtlCol="0" anchor="ctr"/>
+          <a:lstStyle/>
+          <a:p>
+            <a:pPr algn="ctr"/>
+          </a:p>
+        </p:txBody>
+      </p:sp>
+      <p:sp>
+        <p:nvSpPr>
+          <p:cNvPr id="3" name="Rectangle 2"/>
+          <p:cNvSpPr/>
+          <p:nvPr/>
+        </p:nvSpPr>
+        <p:spPr>
+          <a:xfrm>
+            <a:off x="0" y="0"/>
+            <a:ext cx="384048" cy="6858000"/>
+          </a:xfrm>
+          <a:prstGeom prst="rect">
+            <a:avLst/>
+          </a:prstGeom>
+          <a:solidFill>
+            <a:srgbClr val="0A2540"/>
+          </a:solidFill>
+          <a:ln>
+            <a:noFill/>
+          </a:ln>
+        </p:spPr>
+        <p:style>
+          <a:lnRef idx="1">
+            <a:schemeClr val="accent1"/>
+          </a:lnRef>
+          <a:fillRef idx="3">
+            <a:schemeClr val="accent1"/>
+          </a:fillRef>
+          <a:effectRef idx="2">
+            <a:schemeClr val="accent1"/>
+          </a:effectRef>
+          <a:fontRef idx="minor">
+            <a:schemeClr val="lt1"/>
+          </a:fontRef>
+        </p:style>
+        <p:txBody>
+          <a:bodyPr rtlCol="0" anchor="ctr"/>
+          <a:lstStyle/>
+          <a:p>
+            <a:pPr algn="ctr"/>
+          </a:p>
+        </p:txBody>
+      </p:sp>
+      <p:sp>
+        <p:nvSpPr>
+          <p:cNvPr id="4" name="Rectangle 3"/>
+          <p:cNvSpPr/>
+          <p:nvPr/>
+        </p:nvSpPr>
+        <p:spPr>
+          <a:xfrm>
+            <a:off x="384048" y="0"/>
+            <a:ext cx="45720" cy="6858000"/>
+          </a:xfrm>
+          <a:prstGeom prst="rect">
+            <a:avLst/>
+          </a:prstGeom>
+          <a:solidFill>
+            <a:srgbClr val="2563EB"/>
+          </a:solidFill>
+          <a:ln>
+            <a:noFill/>
+          </a:ln>
+        </p:spPr>
+        <p:style>
+          <a:lnRef idx="1">
+            <a:schemeClr val="accent1"/>
+          </a:lnRef>
+          <a:fillRef idx="3">
+            <a:schemeClr val="accent1"/>
+          </a:fillRef>
+          <a:effectRef idx="2">
+            <a:schemeClr val="accent1"/>
+          </a:effectRef>
+          <a:fontRef idx="minor">
+            <a:schemeClr val="lt1"/>
+          </a:fontRef>
+        </p:style>
+        <p:txBody>
+          <a:bodyPr rtlCol="0" anchor="ctr"/>
+          <a:lstStyle/>
+          <a:p>
+            <a:pPr algn="ctr"/>
+          </a:p>
+        </p:txBody>
+      </p:sp>
+      <p:sp>
+        <p:nvSpPr>
+          <p:cNvPr id="5" name="Rectangle 4"/>
+          <p:cNvSpPr/>
+          <p:nvPr/>
+        </p:nvSpPr>
+        <p:spPr>
+          <a:xfrm>
+            <a:off x="429768" y="0"/>
+            <a:ext cx="11761927" cy="1115568"/>
+          </a:xfrm>
+          <a:prstGeom prst="rect">
+            <a:avLst/>
+          </a:prstGeom>
+          <a:solidFill>
+            <a:srgbClr val="0A2540"/>
+          </a:solidFill>
+          <a:ln>
+            <a:noFill/>
+          </a:ln>
+        </p:spPr>
+        <p:style>
+          <a:lnRef idx="1">
+            <a:schemeClr val="accent1"/>
+          </a:lnRef>
+          <a:fillRef idx="3">
+            <a:schemeClr val="accent1"/>
+          </a:fillRef>
+          <a:effectRef idx="2">
+            <a:schemeClr val="accent1"/>
+          </a:effectRef>
+          <a:fontRef idx="minor">
+            <a:schemeClr val="lt1"/>
+          </a:fontRef>
+        </p:style>
+        <p:txBody>
+          <a:bodyPr rtlCol="0" anchor="ctr"/>
+          <a:lstStyle/>
+          <a:p>
+            <a:pPr algn="ctr"/>
+          </a:p>
+        </p:txBody>
+      </p:sp>
+      <p:sp>
+        <p:nvSpPr>
+          <p:cNvPr id="6" name="Rectangle 5"/>
+          <p:cNvSpPr/>
+          <p:nvPr/>
+        </p:nvSpPr>
+        <p:spPr>
+          <a:xfrm>
+            <a:off x="429768" y="1115568"/>
+            <a:ext cx="11761927" cy="54864"/>
+          </a:xfrm>
+          <a:prstGeom prst="rect">
+            <a:avLst/>
+          </a:prstGeom>
+          <a:solidFill>
+            <a:srgbClr val="2563EB"/>
+          </a:solidFill>
+          <a:ln>
+            <a:noFill/>
+          </a:ln>
+        </p:spPr>
+        <p:style>
+          <a:lnRef idx="1">
+            <a:schemeClr val="accent1"/>
+          </a:lnRef>
+          <a:fillRef idx="3">
+            <a:schemeClr val="accent1"/>
+          </a:fillRef>
+          <a:effectRef idx="2">
+            <a:schemeClr val="accent1"/>
+          </a:effectRef>
+          <a:fontRef idx="minor">
+            <a:schemeClr val="lt1"/>
+          </a:fontRef>
+        </p:style>
+        <p:txBody>
+          <a:bodyPr rtlCol="0" anchor="ctr"/>
+          <a:lstStyle/>
+          <a:p>
+            <a:pPr algn="ctr"/>
+          </a:p>
+        </p:txBody>
+      </p:sp>
+      <p:sp>
+        <p:nvSpPr>
+          <p:cNvPr id="7" name="Rectangle 6"/>
+          <p:cNvSpPr/>
+          <p:nvPr/>
+        </p:nvSpPr>
+        <p:spPr>
+          <a:xfrm>
+            <a:off x="429768" y="6419088"/>
+            <a:ext cx="11761927" cy="438912"/>
+          </a:xfrm>
+          <a:prstGeom prst="rect">
+            <a:avLst/>
+          </a:prstGeom>
+          <a:solidFill>
+            <a:srgbClr val="0A2540"/>
+          </a:solidFill>
+          <a:ln>
+            <a:noFill/>
+          </a:ln>
+        </p:spPr>
+        <p:style>
+          <a:lnRef idx="1">
+            <a:schemeClr val="accent1"/>
+          </a:lnRef>
+          <a:fillRef idx="3">
+            <a:schemeClr val="accent1"/>
+          </a:fillRef>
+          <a:effectRef idx="2">
+            <a:schemeClr val="accent1"/>
+          </a:effectRef>
+          <a:fontRef idx="minor">
+            <a:schemeClr val="lt1"/>
+          </a:fontRef>
+        </p:style>
+        <p:txBody>
+          <a:bodyPr rtlCol="0" anchor="ctr"/>
+          <a:lstStyle/>
+          <a:p>
+            <a:pPr algn="ctr"/>
+          </a:p>
+        </p:txBody>
+      </p:sp>
+      <p:sp>
+        <p:nvSpPr>
+          <p:cNvPr id="8" name="Rectangle 7"/>
+          <p:cNvSpPr/>
+          <p:nvPr/>
+        </p:nvSpPr>
+        <p:spPr>
+          <a:xfrm>
+            <a:off x="0" y="0"/>
+            <a:ext cx="384048" cy="6858000"/>
+          </a:xfrm>
+          <a:prstGeom prst="rect">
+            <a:avLst/>
+          </a:prstGeom>
+          <a:solidFill>
+            <a:srgbClr val="0A2540"/>
+          </a:solidFill>
+          <a:ln>
+            <a:noFill/>
+          </a:ln>
+        </p:spPr>
+        <p:style>
+          <a:lnRef idx="1">
+            <a:schemeClr val="accent1"/>
+          </a:lnRef>
+          <a:fillRef idx="3">
+            <a:schemeClr val="accent1"/>
+          </a:fillRef>
+          <a:effectRef idx="2">
+            <a:schemeClr val="accent1"/>
+          </a:effectRef>
+          <a:fontRef idx="minor">
+            <a:schemeClr val="lt1"/>
+          </a:fontRef>
+        </p:style>
+        <p:txBody>
+          <a:bodyPr rtlCol="0" anchor="ctr"/>
+          <a:lstStyle/>
+          <a:p>
+            <a:pPr algn="ctr"/>
+          </a:p>
+        </p:txBody>
+      </p:sp>
+      <p:sp>
+        <p:nvSpPr>
+          <p:cNvPr id="9" name="Rectangle 8"/>
+          <p:cNvSpPr/>
+          <p:nvPr/>
+        </p:nvSpPr>
+        <p:spPr>
+          <a:xfrm>
+            <a:off x="384048" y="0"/>
+            <a:ext cx="45720" cy="6858000"/>
+          </a:xfrm>
+          <a:prstGeom prst="rect">
+            <a:avLst/>
+          </a:prstGeom>
+          <a:solidFill>
+            <a:srgbClr val="2563EB"/>
+          </a:solidFill>
+          <a:ln>
+            <a:noFill/>
+          </a:ln>
+        </p:spPr>
+        <p:style>
+          <a:lnRef idx="1">
+            <a:schemeClr val="accent1"/>
+          </a:lnRef>
+          <a:fillRef idx="3">
+            <a:schemeClr val="accent1"/>
+          </a:fillRef>
+          <a:effectRef idx="2">
+            <a:schemeClr val="accent1"/>
+          </a:effectRef>
+          <a:fontRef idx="minor">
+            <a:schemeClr val="lt1"/>
+          </a:fontRef>
+        </p:style>
+        <p:txBody>
+          <a:bodyPr rtlCol="0" anchor="ctr"/>
+          <a:lstStyle/>
+          <a:p>
+            <a:pPr algn="ctr"/>
+          </a:p>
+        </p:txBody>
+      </p:sp>
+      <p:sp>
+        <p:nvSpPr>
+          <p:cNvPr id="10" name="TextBox 9"/>
+          <p:cNvSpPr txBox="1"/>
+          <p:nvPr/>
+        </p:nvSpPr>
+        <p:spPr>
+          <a:xfrm>
+            <a:off x="658368" y="182880"/>
+            <a:ext cx="9144000" cy="566928"/>
+          </a:xfrm>
+          <a:prstGeom prst="rect">
+            <a:avLst/>
+          </a:prstGeom>
+          <a:noFill/>
+        </p:spPr>
+        <p:txBody>
+          <a:bodyPr wrap="square" anchor="t">
+            <a:spAutoFit/>
+          </a:bodyPr>
+          <a:lstStyle/>
+          <a:p>
+            <a:pPr algn="l">
+              <a:defRPr sz="3400" b="1">
+                <a:solidFill>
+                  <a:srgbClr val="FFFFFF"/>
+                </a:solidFill>
+                <a:latin typeface="Arial"/>
+              </a:defRPr>
+            </a:pPr>
+            <a:r>
+              <a:t>Why hybrid retrieval?</a:t>
+            </a:r>
+          </a:p>
+        </p:txBody>
+      </p:sp>
+      <p:sp>
+        <p:nvSpPr>
+          <p:cNvPr id="11" name="TextBox 10"/>
+          <p:cNvSpPr txBox="1"/>
+          <p:nvPr/>
+        </p:nvSpPr>
+        <p:spPr>
+          <a:xfrm>
+            <a:off x="658368" y="713232"/>
+            <a:ext cx="8046720" cy="347472"/>
+          </a:xfrm>
+          <a:prstGeom prst="rect">
+            <a:avLst/>
+          </a:prstGeom>
+          <a:noFill/>
+        </p:spPr>
+        <p:txBody>
+          <a:bodyPr wrap="square" anchor="t">
+            <a:spAutoFit/>
+          </a:bodyPr>
+          <a:lstStyle/>
+          <a:p>
+            <a:pPr algn="l">
+              <a:defRPr sz="1700" b="0">
+                <a:solidFill>
+                  <a:srgbClr val="BFDBFE"/>
+                </a:solidFill>
+                <a:latin typeface="Arial"/>
+              </a:defRPr>
+            </a:pPr>
+            <a:r>
+              <a:t>Chroma vectors + BM25 lexical + business rerank — not vector-only</a:t>
+            </a:r>
+          </a:p>
+        </p:txBody>
+      </p:sp>
+      <p:sp>
+        <p:nvSpPr>
+          <p:cNvPr id="12" name="Rectangle 11"/>
+          <p:cNvSpPr/>
+          <p:nvPr/>
+        </p:nvSpPr>
+        <p:spPr>
+          <a:xfrm>
+            <a:off x="10241280" y="292608"/>
+            <a:ext cx="1600200" cy="438912"/>
+          </a:xfrm>
+          <a:prstGeom prst="rect">
+            <a:avLst/>
+          </a:prstGeom>
+          <a:solidFill>
+            <a:srgbClr val="2563EB"/>
+          </a:solidFill>
+          <a:ln>
+            <a:noFill/>
+          </a:ln>
+        </p:spPr>
+        <p:style>
+          <a:lnRef idx="1">
+            <a:schemeClr val="accent1"/>
+          </a:lnRef>
+          <a:fillRef idx="3">
+            <a:schemeClr val="accent1"/>
+          </a:fillRef>
+          <a:effectRef idx="2">
+            <a:schemeClr val="accent1"/>
+          </a:effectRef>
+          <a:fontRef idx="minor">
+            <a:schemeClr val="lt1"/>
+          </a:fontRef>
+        </p:style>
+        <p:txBody>
+          <a:bodyPr rtlCol="0" anchor="ctr"/>
+          <a:lstStyle/>
+          <a:p>
+            <a:pPr algn="ctr"/>
+          </a:p>
+        </p:txBody>
+      </p:sp>
+      <p:sp>
+        <p:nvSpPr>
+          <p:cNvPr id="13" name="TextBox 12"/>
+          <p:cNvSpPr txBox="1"/>
+          <p:nvPr/>
+        </p:nvSpPr>
+        <p:spPr>
+          <a:xfrm>
+            <a:off x="10314432" y="347472"/>
+            <a:ext cx="1463040" cy="365760"/>
+          </a:xfrm>
+          <a:prstGeom prst="rect">
+            <a:avLst/>
+          </a:prstGeom>
+          <a:noFill/>
+        </p:spPr>
+        <p:txBody>
+          <a:bodyPr wrap="square" anchor="t">
+            <a:spAutoFit/>
+          </a:bodyPr>
+          <a:lstStyle/>
+          <a:p>
+            <a:pPr algn="ctr">
+              <a:defRPr sz="1300" b="1">
+                <a:solidFill>
+                  <a:srgbClr val="FFFFFF"/>
+                </a:solidFill>
+                <a:latin typeface="Arial"/>
+              </a:defRPr>
+            </a:pPr>
+            <a:r>
+              <a:t>RAG · Hybrid</a:t>
+            </a:r>
+          </a:p>
+        </p:txBody>
+      </p:sp>
+      <p:sp>
+        <p:nvSpPr>
+          <p:cNvPr id="14" name="TextBox 13"/>
+          <p:cNvSpPr txBox="1"/>
+          <p:nvPr/>
+        </p:nvSpPr>
+        <p:spPr>
+          <a:xfrm>
+            <a:off x="658368" y="6492240"/>
+            <a:ext cx="9326880" cy="329184"/>
+          </a:xfrm>
+          <a:prstGeom prst="rect">
+            <a:avLst/>
+          </a:prstGeom>
+          <a:noFill/>
+        </p:spPr>
+        <p:txBody>
+          <a:bodyPr wrap="square" anchor="t">
+            <a:spAutoFit/>
+          </a:bodyPr>
+          <a:lstStyle/>
+          <a:p>
+            <a:pPr algn="l">
+              <a:defRPr sz="1200" b="0">
+                <a:solidFill>
+                  <a:srgbClr val="BFDBFE"/>
+                </a:solidFill>
+                <a:latin typeface="Arial"/>
+              </a:defRPr>
+            </a:pPr>
+            <a:r>
+              <a:t>zooplus Assistant — Coding Task PoC v0.1</a:t>
+            </a:r>
+          </a:p>
+        </p:txBody>
+      </p:sp>
+      <p:sp>
+        <p:nvSpPr>
+          <p:cNvPr id="15" name="TextBox 14"/>
+          <p:cNvSpPr txBox="1"/>
+          <p:nvPr/>
+        </p:nvSpPr>
+        <p:spPr>
+          <a:xfrm>
+            <a:off x="11155680" y="6473952"/>
+            <a:ext cx="868680" cy="329184"/>
+          </a:xfrm>
+          <a:prstGeom prst="rect">
+            <a:avLst/>
+          </a:prstGeom>
+          <a:noFill/>
+        </p:spPr>
+        <p:txBody>
+          <a:bodyPr wrap="square" anchor="t">
+            <a:spAutoFit/>
+          </a:bodyPr>
+          <a:lstStyle/>
+          <a:p>
+            <a:pPr algn="l">
+              <a:defRPr sz="1500" b="1">
+                <a:solidFill>
+                  <a:srgbClr val="FFFFFF"/>
+                </a:solidFill>
+                <a:latin typeface="Arial"/>
+              </a:defRPr>
+            </a:pPr>
+            <a:r>
+              <a:t>5</a:t>
+            </a:r>
+          </a:p>
+        </p:txBody>
+      </p:sp>
+      <p:sp>
+        <p:nvSpPr>
+          <p:cNvPr id="16" name="Rectangle 15"/>
+          <p:cNvSpPr/>
+          <p:nvPr/>
+        </p:nvSpPr>
+        <p:spPr>
+          <a:xfrm>
+            <a:off x="585216" y="1261872"/>
+            <a:ext cx="10972800" cy="4983480"/>
+          </a:xfrm>
+          <a:prstGeom prst="rect">
+            <a:avLst/>
+          </a:prstGeom>
+          <a:solidFill>
+            <a:srgbClr val="F8FAFC"/>
+          </a:solidFill>
+          <a:ln>
+            <a:noFill/>
+          </a:ln>
+        </p:spPr>
+        <p:style>
+          <a:lnRef idx="1">
+            <a:schemeClr val="accent1"/>
+          </a:lnRef>
+          <a:fillRef idx="3">
+            <a:schemeClr val="accent1"/>
+          </a:fillRef>
+          <a:effectRef idx="2">
+            <a:schemeClr val="accent1"/>
+          </a:effectRef>
+          <a:fontRef idx="minor">
+            <a:schemeClr val="lt1"/>
+          </a:fontRef>
+        </p:style>
+        <p:txBody>
+          <a:bodyPr rtlCol="0" anchor="ctr"/>
+          <a:lstStyle/>
+          <a:p>
+            <a:pPr algn="ctr"/>
+          </a:p>
+        </p:txBody>
+      </p:sp>
+      <p:sp>
+        <p:nvSpPr>
+          <p:cNvPr id="17" name="TextBox 16"/>
+          <p:cNvSpPr txBox="1"/>
+          <p:nvPr/>
+        </p:nvSpPr>
+        <p:spPr>
+          <a:xfrm>
+            <a:off x="749808" y="1417320"/>
+            <a:ext cx="5120640" cy="4663440"/>
+          </a:xfrm>
+          <a:prstGeom prst="rect">
+            <a:avLst/>
+          </a:prstGeom>
+          <a:noFill/>
+        </p:spPr>
+        <p:txBody>
+          <a:bodyPr wrap="square" anchor="t">
+            <a:spAutoFit/>
+          </a:bodyPr>
+          <a:lstStyle/>
+          <a:p>
+            <a:pPr>
+              <a:spcAft>
+                <a:spcPts val="600"/>
+              </a:spcAft>
+              <a:defRPr sz="1700" b="1">
+                <a:solidFill>
+                  <a:srgbClr val="0A2540"/>
+                </a:solidFill>
+                <a:latin typeface="Arial"/>
+              </a:defRPr>
+            </a:pPr>
+            <a:r>
+              <a:t>Problem we saw in the catalog</a:t>
+            </a:r>
+          </a:p>
+          <a:p>
+            <a:pPr>
+              <a:spcAft>
+                <a:spcPts val="600"/>
+              </a:spcAft>
+              <a:defRPr sz="1700" b="0">
+                <a:solidFill>
+                  <a:srgbClr val="334155"/>
+                </a:solidFill>
+                <a:latin typeface="Arial"/>
+              </a:defRPr>
+            </a:pPr>
+            <a:r>
+              <a:t>• Vector search alone misses exact tokens (brands, SKUs, “grain-free”).</a:t>
+            </a:r>
+          </a:p>
+          <a:p>
+            <a:pPr>
+              <a:spcAft>
+                <a:spcPts val="600"/>
+              </a:spcAft>
+              <a:defRPr sz="1700" b="0">
+                <a:solidFill>
+                  <a:srgbClr val="334155"/>
+                </a:solidFill>
+                <a:latin typeface="Arial"/>
+              </a:defRPr>
+            </a:pPr>
+            <a:r>
+              <a:t>• Pure keyword search misses intent (“puppy sensitive stomach”).</a:t>
+            </a:r>
+          </a:p>
+          <a:p>
+            <a:pPr>
+              <a:spcAft>
+                <a:spcPts val="600"/>
+              </a:spcAft>
+              <a:defRPr sz="1700" b="1">
+                <a:solidFill>
+                  <a:srgbClr val="0A2540"/>
+                </a:solidFill>
+                <a:latin typeface="Arial"/>
+              </a:defRPr>
+            </a:pPr>
+            <a:r>
+              <a:t>Why this hybrid design</a:t>
+            </a:r>
+          </a:p>
+          <a:p>
+            <a:pPr>
+              <a:spcAft>
+                <a:spcPts val="600"/>
+              </a:spcAft>
+              <a:defRPr sz="1700" b="0">
+                <a:solidFill>
+                  <a:srgbClr val="334155"/>
+                </a:solidFill>
+                <a:latin typeface="Arial"/>
+              </a:defRPr>
+            </a:pPr>
+            <a:r>
+              <a:t>• Chroma: semantic candidates from embedded product text (local, no API key).</a:t>
+            </a:r>
+          </a:p>
+          <a:p>
+            <a:pPr>
+              <a:spcAft>
+                <a:spcPts val="600"/>
+              </a:spcAft>
+              <a:defRPr sz="1700" b="0">
+                <a:solidFill>
+                  <a:srgbClr val="334155"/>
+                </a:solidFill>
+                <a:latin typeface="Arial"/>
+              </a:defRPr>
+            </a:pPr>
+            <a:r>
+              <a:t>• BM25 on the same candidate pool: lexical match without a second DB.</a:t>
+            </a:r>
+          </a:p>
+          <a:p>
+            <a:pPr>
+              <a:spcAft>
+                <a:spcPts val="600"/>
+              </a:spcAft>
+              <a:defRPr sz="1700" b="0">
+                <a:solidFill>
+                  <a:srgbClr val="334155"/>
+                </a:solidFill>
+                <a:latin typeface="Arial"/>
+              </a:defRPr>
+            </a:pPr>
+            <a:r>
+              <a:t>• Fuse 50% vector + 35% BM25 + 15% rating/sales/stock.</a:t>
+            </a:r>
+          </a:p>
+          <a:p>
+            <a:pPr>
+              <a:spcAft>
+                <a:spcPts val="600"/>
+              </a:spcAft>
+              <a:defRPr sz="1700" b="1">
+                <a:solidFill>
+                  <a:srgbClr val="0A2540"/>
+                </a:solidFill>
+                <a:latin typeface="Arial"/>
+              </a:defRPr>
+            </a:pPr>
+            <a:r>
+              <a:t>PoC trade-off</a:t>
+            </a:r>
+          </a:p>
+          <a:p>
+            <a:pPr>
+              <a:spcAft>
+                <a:spcPts val="600"/>
+              </a:spcAft>
+              <a:defRPr sz="1700" b="0">
+                <a:solidFill>
+                  <a:srgbClr val="334155"/>
+                </a:solidFill>
+                <a:latin typeface="Arial"/>
+              </a:defRPr>
+            </a:pPr>
+            <a:r>
+              <a:t>• Zero extra infra vs hosted vector DB; A/B via ZOOPLUS_RETRIEVAL_MODE=vector.</a:t>
+            </a:r>
+          </a:p>
+        </p:txBody>
+      </p:sp>
+      <p:sp>
+        <p:nvSpPr>
+          <p:cNvPr id="18" name="TextBox 17"/>
+          <p:cNvSpPr txBox="1"/>
+          <p:nvPr/>
+        </p:nvSpPr>
+        <p:spPr>
+          <a:xfrm>
+            <a:off x="5989320" y="1417320"/>
+            <a:ext cx="5394960" cy="4663440"/>
+          </a:xfrm>
+          <a:prstGeom prst="rect">
+            <a:avLst/>
+          </a:prstGeom>
+          <a:noFill/>
+        </p:spPr>
+        <p:txBody>
+          <a:bodyPr wrap="square" anchor="t">
+            <a:spAutoFit/>
+          </a:bodyPr>
+          <a:lstStyle/>
+          <a:p>
+            <a:pPr>
+              <a:spcAft>
+                <a:spcPts val="600"/>
+              </a:spcAft>
+              <a:defRPr sz="1700" b="1">
+                <a:solidFill>
+                  <a:srgbClr val="0A2540"/>
+                </a:solidFill>
+                <a:latin typeface="Arial"/>
+              </a:defRPr>
+            </a:pPr>
+            <a:r>
+              <a:t>Query path (hybrid default)</a:t>
+            </a:r>
+          </a:p>
+          <a:p>
+            <a:pPr>
+              <a:spcAft>
+                <a:spcPts val="600"/>
+              </a:spcAft>
+              <a:defRPr sz="1700" b="0">
+                <a:solidFill>
+                  <a:srgbClr val="334155"/>
+                </a:solidFill>
+                <a:latin typeface="Arial"/>
+              </a:defRPr>
+            </a:pPr>
+            <a:r>
+              <a:t>1. Hard filter site_id in Chroma metadata</a:t>
+            </a:r>
+          </a:p>
+          <a:p>
+            <a:pPr>
+              <a:spcAft>
+                <a:spcPts val="600"/>
+              </a:spcAft>
+              <a:defRPr sz="1700" b="0">
+                <a:solidFill>
+                  <a:srgbClr val="334155"/>
+                </a:solidFill>
+                <a:latin typeface="Arial"/>
+              </a:defRPr>
+            </a:pPr>
+            <a:r>
+              <a:t>2. Pull ≥24 vector candidates</a:t>
+            </a:r>
+          </a:p>
+          <a:p>
+            <a:pPr>
+              <a:spcAft>
+                <a:spcPts val="600"/>
+              </a:spcAft>
+              <a:defRPr sz="1700" b="0">
+                <a:solidFill>
+                  <a:srgbClr val="334155"/>
+                </a:solidFill>
+                <a:latin typeface="Arial"/>
+              </a:defRPr>
+            </a:pPr>
+            <a:r>
+              <a:t>3. Score BM25 on candidate documents</a:t>
+            </a:r>
+          </a:p>
+          <a:p>
+            <a:pPr>
+              <a:spcAft>
+                <a:spcPts val="600"/>
+              </a:spcAft>
+              <a:defRPr sz="1700" b="0">
+                <a:solidFill>
+                  <a:srgbClr val="334155"/>
+                </a:solidFill>
+                <a:latin typeface="Arial"/>
+              </a:defRPr>
+            </a:pPr>
+            <a:r>
+              <a:t>4. Rerank → top 4 for API + UI cards</a:t>
+            </a:r>
+          </a:p>
+          <a:p>
+            <a:pPr>
+              <a:spcAft>
+                <a:spcPts val="600"/>
+              </a:spcAft>
+              <a:defRPr sz="1700" b="1">
+                <a:solidFill>
+                  <a:srgbClr val="0A2540"/>
+                </a:solidFill>
+                <a:latin typeface="Arial"/>
+              </a:defRPr>
+            </a:pPr>
+            <a:r>
+              <a:t>When vector-only is enough</a:t>
+            </a:r>
+          </a:p>
+          <a:p>
+            <a:pPr>
+              <a:spcAft>
+                <a:spcPts val="600"/>
+              </a:spcAft>
+              <a:defRPr sz="1700" b="0">
+                <a:solidFill>
+                  <a:srgbClr val="334155"/>
+                </a:solidFill>
+                <a:latin typeface="Arial"/>
+              </a:defRPr>
+            </a:pPr>
+            <a:r>
+              <a:t>• Short brand lookups or regression tests</a:t>
+            </a:r>
+          </a:p>
+          <a:p>
+            <a:pPr>
+              <a:spcAft>
+                <a:spcPts val="600"/>
+              </a:spcAft>
+              <a:defRPr sz="1700" b="0">
+                <a:solidFill>
+                  <a:srgbClr val="334155"/>
+                </a:solidFill>
+                <a:latin typeface="Arial"/>
+              </a:defRPr>
+            </a:pPr>
+            <a:r>
+              <a:t>• Hybrid wins on natural-language shopper queries</a:t>
+            </a:r>
+          </a:p>
+        </p:txBody>
+      </p:sp>
+    </p:spTree>
+  </p:cSld>
+  <p:clrMapOvr>
+    <a:masterClrMapping/>
+  </p:clrMapOvr>
+</p:sld>
+</file>
+
+<file path=ppt/slides/slide13.xml><?xml version="1.0" encoding="utf-8"?>
+<p:sld xmlns:a="http://schemas.openxmlformats.org/drawingml/2006/main" xmlns:p="http://schemas.openxmlformats.org/presentationml/2006/main" xmlns:r="http://schemas.openxmlformats.org/officeDocument/2006/relationships">
+  <p:cSld>
+    <p:spTree>
+      <p:nvGrpSpPr>
+        <p:cNvPr id="1" name=""/>
+        <p:cNvGrpSpPr/>
+        <p:nvPr/>
+      </p:nvGrpSpPr>
+      <p:grpSpPr/>
+      <p:sp>
+        <p:nvSpPr>
+          <p:cNvPr id="2" name="Rectangle 1"/>
+          <p:cNvSpPr/>
+          <p:nvPr/>
+        </p:nvSpPr>
+        <p:spPr>
+          <a:xfrm>
+            <a:off x="429768" y="0"/>
+            <a:ext cx="11761927" cy="6858000"/>
+          </a:xfrm>
+          <a:prstGeom prst="rect">
+            <a:avLst/>
+          </a:prstGeom>
+          <a:solidFill>
+            <a:srgbClr val="FFFFFF"/>
+          </a:solidFill>
+          <a:ln>
+            <a:noFill/>
+          </a:ln>
+        </p:spPr>
+        <p:style>
+          <a:lnRef idx="1">
+            <a:schemeClr val="accent1"/>
+          </a:lnRef>
+          <a:fillRef idx="3">
+            <a:schemeClr val="accent1"/>
+          </a:fillRef>
+          <a:effectRef idx="2">
+            <a:schemeClr val="accent1"/>
+          </a:effectRef>
+          <a:fontRef idx="minor">
+            <a:schemeClr val="lt1"/>
+          </a:fontRef>
+        </p:style>
+        <p:txBody>
+          <a:bodyPr rtlCol="0" anchor="ctr"/>
+          <a:lstStyle/>
+          <a:p>
+            <a:pPr algn="ctr"/>
+          </a:p>
+        </p:txBody>
+      </p:sp>
+      <p:sp>
+        <p:nvSpPr>
+          <p:cNvPr id="3" name="Rectangle 2"/>
+          <p:cNvSpPr/>
+          <p:nvPr/>
+        </p:nvSpPr>
+        <p:spPr>
+          <a:xfrm>
+            <a:off x="0" y="0"/>
+            <a:ext cx="384048" cy="6858000"/>
+          </a:xfrm>
+          <a:prstGeom prst="rect">
+            <a:avLst/>
+          </a:prstGeom>
+          <a:solidFill>
+            <a:srgbClr val="0A2540"/>
+          </a:solidFill>
+          <a:ln>
+            <a:noFill/>
+          </a:ln>
+        </p:spPr>
+        <p:style>
+          <a:lnRef idx="1">
+            <a:schemeClr val="accent1"/>
+          </a:lnRef>
+          <a:fillRef idx="3">
+            <a:schemeClr val="accent1"/>
+          </a:fillRef>
+          <a:effectRef idx="2">
+            <a:schemeClr val="accent1"/>
+          </a:effectRef>
+          <a:fontRef idx="minor">
+            <a:schemeClr val="lt1"/>
+          </a:fontRef>
+        </p:style>
+        <p:txBody>
+          <a:bodyPr rtlCol="0" anchor="ctr"/>
+          <a:lstStyle/>
+          <a:p>
+            <a:pPr algn="ctr"/>
+          </a:p>
+        </p:txBody>
+      </p:sp>
+      <p:sp>
+        <p:nvSpPr>
+          <p:cNvPr id="4" name="Rectangle 3"/>
+          <p:cNvSpPr/>
+          <p:nvPr/>
+        </p:nvSpPr>
+        <p:spPr>
+          <a:xfrm>
+            <a:off x="384048" y="0"/>
+            <a:ext cx="45720" cy="6858000"/>
+          </a:xfrm>
+          <a:prstGeom prst="rect">
+            <a:avLst/>
+          </a:prstGeom>
+          <a:solidFill>
+            <a:srgbClr val="2563EB"/>
+          </a:solidFill>
+          <a:ln>
+            <a:noFill/>
+          </a:ln>
+        </p:spPr>
+        <p:style>
+          <a:lnRef idx="1">
+            <a:schemeClr val="accent1"/>
+          </a:lnRef>
+          <a:fillRef idx="3">
+            <a:schemeClr val="accent1"/>
+          </a:fillRef>
+          <a:effectRef idx="2">
+            <a:schemeClr val="accent1"/>
+          </a:effectRef>
+          <a:fontRef idx="minor">
+            <a:schemeClr val="lt1"/>
+          </a:fontRef>
+        </p:style>
+        <p:txBody>
+          <a:bodyPr rtlCol="0" anchor="ctr"/>
+          <a:lstStyle/>
+          <a:p>
+            <a:pPr algn="ctr"/>
+          </a:p>
+        </p:txBody>
+      </p:sp>
+      <p:sp>
+        <p:nvSpPr>
+          <p:cNvPr id="5" name="Rectangle 4"/>
+          <p:cNvSpPr/>
+          <p:nvPr/>
+        </p:nvSpPr>
+        <p:spPr>
+          <a:xfrm>
+            <a:off x="429768" y="0"/>
+            <a:ext cx="11761927" cy="1115568"/>
+          </a:xfrm>
+          <a:prstGeom prst="rect">
+            <a:avLst/>
+          </a:prstGeom>
+          <a:solidFill>
+            <a:srgbClr val="0A2540"/>
+          </a:solidFill>
+          <a:ln>
+            <a:noFill/>
+          </a:ln>
+        </p:spPr>
+        <p:style>
+          <a:lnRef idx="1">
+            <a:schemeClr val="accent1"/>
+          </a:lnRef>
+          <a:fillRef idx="3">
+            <a:schemeClr val="accent1"/>
+          </a:fillRef>
+          <a:effectRef idx="2">
+            <a:schemeClr val="accent1"/>
+          </a:effectRef>
+          <a:fontRef idx="minor">
+            <a:schemeClr val="lt1"/>
+          </a:fontRef>
+        </p:style>
+        <p:txBody>
+          <a:bodyPr rtlCol="0" anchor="ctr"/>
+          <a:lstStyle/>
+          <a:p>
+            <a:pPr algn="ctr"/>
+          </a:p>
+        </p:txBody>
+      </p:sp>
+      <p:sp>
+        <p:nvSpPr>
+          <p:cNvPr id="6" name="Rectangle 5"/>
+          <p:cNvSpPr/>
+          <p:nvPr/>
+        </p:nvSpPr>
+        <p:spPr>
+          <a:xfrm>
+            <a:off x="429768" y="1115568"/>
+            <a:ext cx="11761927" cy="54864"/>
+          </a:xfrm>
+          <a:prstGeom prst="rect">
+            <a:avLst/>
+          </a:prstGeom>
+          <a:solidFill>
+            <a:srgbClr val="2563EB"/>
+          </a:solidFill>
+          <a:ln>
+            <a:noFill/>
+          </a:ln>
+        </p:spPr>
+        <p:style>
+          <a:lnRef idx="1">
+            <a:schemeClr val="accent1"/>
+          </a:lnRef>
+          <a:fillRef idx="3">
+            <a:schemeClr val="accent1"/>
+          </a:fillRef>
+          <a:effectRef idx="2">
+            <a:schemeClr val="accent1"/>
+          </a:effectRef>
+          <a:fontRef idx="minor">
+            <a:schemeClr val="lt1"/>
+          </a:fontRef>
+        </p:style>
+        <p:txBody>
+          <a:bodyPr rtlCol="0" anchor="ctr"/>
+          <a:lstStyle/>
+          <a:p>
+            <a:pPr algn="ctr"/>
+          </a:p>
+        </p:txBody>
+      </p:sp>
+      <p:sp>
+        <p:nvSpPr>
+          <p:cNvPr id="7" name="Rectangle 6"/>
+          <p:cNvSpPr/>
+          <p:nvPr/>
+        </p:nvSpPr>
+        <p:spPr>
+          <a:xfrm>
+            <a:off x="429768" y="6419088"/>
+            <a:ext cx="11761927" cy="438912"/>
+          </a:xfrm>
+          <a:prstGeom prst="rect">
+            <a:avLst/>
+          </a:prstGeom>
+          <a:solidFill>
+            <a:srgbClr val="0A2540"/>
+          </a:solidFill>
+          <a:ln>
+            <a:noFill/>
+          </a:ln>
+        </p:spPr>
+        <p:style>
+          <a:lnRef idx="1">
+            <a:schemeClr val="accent1"/>
+          </a:lnRef>
+          <a:fillRef idx="3">
+            <a:schemeClr val="accent1"/>
+          </a:fillRef>
+          <a:effectRef idx="2">
+            <a:schemeClr val="accent1"/>
+          </a:effectRef>
+          <a:fontRef idx="minor">
+            <a:schemeClr val="lt1"/>
+          </a:fontRef>
+        </p:style>
+        <p:txBody>
+          <a:bodyPr rtlCol="0" anchor="ctr"/>
+          <a:lstStyle/>
+          <a:p>
+            <a:pPr algn="ctr"/>
+          </a:p>
+        </p:txBody>
+      </p:sp>
+      <p:sp>
+        <p:nvSpPr>
+          <p:cNvPr id="8" name="Rectangle 7"/>
+          <p:cNvSpPr/>
+          <p:nvPr/>
+        </p:nvSpPr>
+        <p:spPr>
+          <a:xfrm>
+            <a:off x="0" y="0"/>
+            <a:ext cx="384048" cy="6858000"/>
+          </a:xfrm>
+          <a:prstGeom prst="rect">
+            <a:avLst/>
+          </a:prstGeom>
+          <a:solidFill>
+            <a:srgbClr val="0A2540"/>
+          </a:solidFill>
+          <a:ln>
+            <a:noFill/>
+          </a:ln>
+        </p:spPr>
+        <p:style>
+          <a:lnRef idx="1">
+            <a:schemeClr val="accent1"/>
+          </a:lnRef>
+          <a:fillRef idx="3">
+            <a:schemeClr val="accent1"/>
+          </a:fillRef>
+          <a:effectRef idx="2">
+            <a:schemeClr val="accent1"/>
+          </a:effectRef>
+          <a:fontRef idx="minor">
+            <a:schemeClr val="lt1"/>
+          </a:fontRef>
+        </p:style>
+        <p:txBody>
+          <a:bodyPr rtlCol="0" anchor="ctr"/>
+          <a:lstStyle/>
+          <a:p>
+            <a:pPr algn="ctr"/>
+          </a:p>
+        </p:txBody>
+      </p:sp>
+      <p:sp>
+        <p:nvSpPr>
+          <p:cNvPr id="9" name="Rectangle 8"/>
+          <p:cNvSpPr/>
+          <p:nvPr/>
+        </p:nvSpPr>
+        <p:spPr>
+          <a:xfrm>
+            <a:off x="384048" y="0"/>
+            <a:ext cx="45720" cy="6858000"/>
+          </a:xfrm>
+          <a:prstGeom prst="rect">
+            <a:avLst/>
+          </a:prstGeom>
+          <a:solidFill>
+            <a:srgbClr val="2563EB"/>
+          </a:solidFill>
+          <a:ln>
+            <a:noFill/>
+          </a:ln>
+        </p:spPr>
+        <p:style>
+          <a:lnRef idx="1">
+            <a:schemeClr val="accent1"/>
+          </a:lnRef>
+          <a:fillRef idx="3">
+            <a:schemeClr val="accent1"/>
+          </a:fillRef>
+          <a:effectRef idx="2">
+            <a:schemeClr val="accent1"/>
+          </a:effectRef>
+          <a:fontRef idx="minor">
+            <a:schemeClr val="lt1"/>
+          </a:fontRef>
+        </p:style>
+        <p:txBody>
+          <a:bodyPr rtlCol="0" anchor="ctr"/>
+          <a:lstStyle/>
+          <a:p>
+            <a:pPr algn="ctr"/>
+          </a:p>
+        </p:txBody>
+      </p:sp>
+      <p:sp>
+        <p:nvSpPr>
+          <p:cNvPr id="10" name="TextBox 9"/>
+          <p:cNvSpPr txBox="1"/>
+          <p:nvPr/>
+        </p:nvSpPr>
+        <p:spPr>
+          <a:xfrm>
+            <a:off x="658368" y="182880"/>
+            <a:ext cx="9144000" cy="566928"/>
+          </a:xfrm>
+          <a:prstGeom prst="rect">
+            <a:avLst/>
+          </a:prstGeom>
+          <a:noFill/>
+        </p:spPr>
+        <p:txBody>
+          <a:bodyPr wrap="square" anchor="t">
+            <a:spAutoFit/>
+          </a:bodyPr>
+          <a:lstStyle/>
+          <a:p>
+            <a:pPr algn="l">
+              <a:defRPr sz="3400" b="1">
+                <a:solidFill>
+                  <a:srgbClr val="FFFFFF"/>
+                </a:solidFill>
+                <a:latin typeface="Arial"/>
+              </a:defRPr>
+            </a:pPr>
+            <a:r>
+              <a:t>RAG strategy — end to end</a:t>
+            </a:r>
+          </a:p>
+        </p:txBody>
+      </p:sp>
+      <p:sp>
+        <p:nvSpPr>
+          <p:cNvPr id="11" name="TextBox 10"/>
+          <p:cNvSpPr txBox="1"/>
+          <p:nvPr/>
+        </p:nvSpPr>
+        <p:spPr>
+          <a:xfrm>
+            <a:off x="658368" y="713232"/>
+            <a:ext cx="8046720" cy="347472"/>
+          </a:xfrm>
+          <a:prstGeom prst="rect">
+            <a:avLst/>
+          </a:prstGeom>
+          <a:noFill/>
+        </p:spPr>
+        <p:txBody>
+          <a:bodyPr wrap="square" anchor="t">
+            <a:spAutoFit/>
+          </a:bodyPr>
+          <a:lstStyle/>
+          <a:p>
+            <a:pPr algn="l">
+              <a:defRPr sz="1700" b="0">
+                <a:solidFill>
+                  <a:srgbClr val="BFDBFE"/>
+                </a:solidFill>
+                <a:latin typeface="Arial"/>
+              </a:defRPr>
+            </a:pPr>
+            <a:r>
+              <a:t>Ingest → retrieve → ground → synthesize (catalog-only, site-scoped)</a:t>
+            </a:r>
+          </a:p>
+        </p:txBody>
+      </p:sp>
+      <p:sp>
+        <p:nvSpPr>
+          <p:cNvPr id="12" name="Rectangle 11"/>
+          <p:cNvSpPr/>
+          <p:nvPr/>
+        </p:nvSpPr>
+        <p:spPr>
+          <a:xfrm>
+            <a:off x="10241280" y="292608"/>
+            <a:ext cx="1600200" cy="438912"/>
+          </a:xfrm>
+          <a:prstGeom prst="rect">
+            <a:avLst/>
+          </a:prstGeom>
+          <a:solidFill>
+            <a:srgbClr val="2563EB"/>
+          </a:solidFill>
+          <a:ln>
+            <a:noFill/>
+          </a:ln>
+        </p:spPr>
+        <p:style>
+          <a:lnRef idx="1">
+            <a:schemeClr val="accent1"/>
+          </a:lnRef>
+          <a:fillRef idx="3">
+            <a:schemeClr val="accent1"/>
+          </a:fillRef>
+          <a:effectRef idx="2">
+            <a:schemeClr val="accent1"/>
+          </a:effectRef>
+          <a:fontRef idx="minor">
+            <a:schemeClr val="lt1"/>
+          </a:fontRef>
+        </p:style>
+        <p:txBody>
+          <a:bodyPr rtlCol="0" anchor="ctr"/>
+          <a:lstStyle/>
+          <a:p>
+            <a:pPr algn="ctr"/>
+          </a:p>
+        </p:txBody>
+      </p:sp>
+      <p:sp>
+        <p:nvSpPr>
+          <p:cNvPr id="13" name="TextBox 12"/>
+          <p:cNvSpPr txBox="1"/>
+          <p:nvPr/>
+        </p:nvSpPr>
+        <p:spPr>
+          <a:xfrm>
+            <a:off x="10314432" y="347472"/>
+            <a:ext cx="1463040" cy="365760"/>
+          </a:xfrm>
+          <a:prstGeom prst="rect">
+            <a:avLst/>
+          </a:prstGeom>
+          <a:noFill/>
+        </p:spPr>
+        <p:txBody>
+          <a:bodyPr wrap="square" anchor="t">
+            <a:spAutoFit/>
+          </a:bodyPr>
+          <a:lstStyle/>
+          <a:p>
+            <a:pPr algn="ctr">
+              <a:defRPr sz="1300" b="1">
+                <a:solidFill>
+                  <a:srgbClr val="FFFFFF"/>
+                </a:solidFill>
+                <a:latin typeface="Arial"/>
+              </a:defRPr>
+            </a:pPr>
+            <a:r>
+              <a:t>FR3 · RAG</a:t>
+            </a:r>
+          </a:p>
+        </p:txBody>
+      </p:sp>
+      <p:sp>
+        <p:nvSpPr>
+          <p:cNvPr id="14" name="TextBox 13"/>
+          <p:cNvSpPr txBox="1"/>
+          <p:nvPr/>
+        </p:nvSpPr>
+        <p:spPr>
+          <a:xfrm>
+            <a:off x="658368" y="6492240"/>
+            <a:ext cx="9326880" cy="329184"/>
+          </a:xfrm>
+          <a:prstGeom prst="rect">
+            <a:avLst/>
+          </a:prstGeom>
+          <a:noFill/>
+        </p:spPr>
+        <p:txBody>
+          <a:bodyPr wrap="square" anchor="t">
+            <a:spAutoFit/>
+          </a:bodyPr>
+          <a:lstStyle/>
+          <a:p>
+            <a:pPr algn="l">
+              <a:defRPr sz="1200" b="0">
+                <a:solidFill>
+                  <a:srgbClr val="BFDBFE"/>
+                </a:solidFill>
+                <a:latin typeface="Arial"/>
+              </a:defRPr>
+            </a:pPr>
+            <a:r>
+              <a:t>zooplus Assistant — Coding Task PoC v0.1</a:t>
+            </a:r>
+          </a:p>
+        </p:txBody>
+      </p:sp>
+      <p:sp>
+        <p:nvSpPr>
+          <p:cNvPr id="15" name="TextBox 14"/>
+          <p:cNvSpPr txBox="1"/>
+          <p:nvPr/>
+        </p:nvSpPr>
+        <p:spPr>
+          <a:xfrm>
+            <a:off x="11155680" y="6473952"/>
+            <a:ext cx="868680" cy="329184"/>
+          </a:xfrm>
+          <a:prstGeom prst="rect">
+            <a:avLst/>
+          </a:prstGeom>
+          <a:noFill/>
+        </p:spPr>
+        <p:txBody>
+          <a:bodyPr wrap="square" anchor="t">
+            <a:spAutoFit/>
+          </a:bodyPr>
+          <a:lstStyle/>
+          <a:p>
+            <a:pPr algn="l">
+              <a:defRPr sz="1500" b="1">
+                <a:solidFill>
+                  <a:srgbClr val="FFFFFF"/>
+                </a:solidFill>
+                <a:latin typeface="Arial"/>
+              </a:defRPr>
+            </a:pPr>
+            <a:r>
+              <a:t>6</a:t>
+            </a:r>
+          </a:p>
+        </p:txBody>
+      </p:sp>
+      <p:sp>
+        <p:nvSpPr>
+          <p:cNvPr id="16" name="Rectangle 15"/>
+          <p:cNvSpPr/>
+          <p:nvPr/>
+        </p:nvSpPr>
+        <p:spPr>
+          <a:xfrm>
+            <a:off x="585216" y="1261872"/>
+            <a:ext cx="10972800" cy="4983480"/>
+          </a:xfrm>
+          <a:prstGeom prst="rect">
+            <a:avLst/>
+          </a:prstGeom>
+          <a:solidFill>
+            <a:srgbClr val="F8FAFC"/>
+          </a:solidFill>
+          <a:ln>
+            <a:noFill/>
+          </a:ln>
+        </p:spPr>
+        <p:style>
+          <a:lnRef idx="1">
+            <a:schemeClr val="accent1"/>
+          </a:lnRef>
+          <a:fillRef idx="3">
+            <a:schemeClr val="accent1"/>
+          </a:fillRef>
+          <a:effectRef idx="2">
+            <a:schemeClr val="accent1"/>
+          </a:effectRef>
+          <a:fontRef idx="minor">
+            <a:schemeClr val="lt1"/>
+          </a:fontRef>
+        </p:style>
+        <p:txBody>
+          <a:bodyPr rtlCol="0" anchor="ctr"/>
+          <a:lstStyle/>
+          <a:p>
+            <a:pPr algn="ctr"/>
+          </a:p>
+        </p:txBody>
+      </p:sp>
+      <p:sp>
+        <p:nvSpPr>
+          <p:cNvPr id="17" name="TextBox 16"/>
+          <p:cNvSpPr txBox="1"/>
+          <p:nvPr/>
+        </p:nvSpPr>
+        <p:spPr>
+          <a:xfrm>
+            <a:off x="749808" y="1417320"/>
+            <a:ext cx="5349240" cy="4663440"/>
+          </a:xfrm>
+          <a:prstGeom prst="rect">
+            <a:avLst/>
+          </a:prstGeom>
+          <a:noFill/>
+        </p:spPr>
+        <p:txBody>
+          <a:bodyPr wrap="square" anchor="t">
+            <a:spAutoFit/>
+          </a:bodyPr>
+          <a:lstStyle/>
+          <a:p>
+            <a:pPr>
+              <a:spcAft>
+                <a:spcPts val="600"/>
+              </a:spcAft>
+              <a:defRPr sz="1600" b="1">
+                <a:solidFill>
+                  <a:srgbClr val="0A2540"/>
+                </a:solidFill>
+                <a:latin typeface="Arial"/>
+              </a:defRPr>
+            </a:pPr>
+            <a:r>
+              <a:t>Ingest (offline)</a:t>
+            </a:r>
+          </a:p>
+          <a:p>
+            <a:pPr>
+              <a:spcAft>
+                <a:spcPts val="600"/>
+              </a:spcAft>
+              <a:defRPr sz="1600" b="0">
+                <a:solidFill>
+                  <a:srgbClr val="334155"/>
+                </a:solidFill>
+                <a:latin typeface="Arial"/>
+              </a:defRPr>
+            </a:pPr>
+            <a:r>
+              <a:t>• Source of truth: instructions JSON → data/raw (300 variants).</a:t>
+            </a:r>
+          </a:p>
+          <a:p>
+            <a:pPr>
+              <a:spcAft>
+                <a:spcPts val="600"/>
+              </a:spcAft>
+              <a:defRPr sz="1600" b="0">
+                <a:solidFill>
+                  <a:srgbClr val="334155"/>
+                </a:solidFill>
+                <a:latin typeface="Arial"/>
+              </a:defRPr>
+            </a:pPr>
+            <a:r>
+              <a:t>• Strip HTML, one Chroma doc per article_id row.</a:t>
+            </a:r>
+          </a:p>
+          <a:p>
+            <a:pPr>
+              <a:spcAft>
+                <a:spcPts val="600"/>
+              </a:spcAft>
+              <a:defRPr sz="1600" b="0">
+                <a:solidFill>
+                  <a:srgbClr val="334155"/>
+                </a:solidFill>
+                <a:latin typeface="Arial"/>
+              </a:defRPr>
+            </a:pPr>
+            <a:r>
+              <a:t>• Metadata: site_id, pet_type, price, stock, ingredients flag.</a:t>
+            </a:r>
+          </a:p>
+          <a:p>
+            <a:pPr>
+              <a:spcAft>
+                <a:spcPts val="600"/>
+              </a:spcAft>
+              <a:defRPr sz="1600" b="0">
+                <a:solidFill>
+                  <a:srgbClr val="334155"/>
+                </a:solidFill>
+                <a:latin typeface="Arial"/>
+              </a:defRPr>
+            </a:pPr>
+            <a:r>
+              <a:t>• CLI: python -m cli ingest → artifacts/index/chroma</a:t>
+            </a:r>
+          </a:p>
+          <a:p>
+            <a:pPr>
+              <a:spcAft>
+                <a:spcPts val="600"/>
+              </a:spcAft>
+              <a:defRPr sz="1600" b="1">
+                <a:solidFill>
+                  <a:srgbClr val="0A2540"/>
+                </a:solidFill>
+                <a:latin typeface="Arial"/>
+              </a:defRPr>
+            </a:pPr>
+            <a:r>
+              <a:t>Online retrieval</a:t>
+            </a:r>
+          </a:p>
+          <a:p>
+            <a:pPr>
+              <a:spcAft>
+                <a:spcPts val="600"/>
+              </a:spcAft>
+              <a:defRPr sz="1600" b="0">
+                <a:solidFill>
+                  <a:srgbClr val="334155"/>
+                </a:solidFill>
+                <a:latin typeface="Arial"/>
+              </a:defRPr>
+            </a:pPr>
+            <a:r>
+              <a:t>• Topic guard ALLOW → process lane search_catalog().</a:t>
+            </a:r>
+          </a:p>
+          <a:p>
+            <a:pPr>
+              <a:spcAft>
+                <a:spcPts val="600"/>
+              </a:spcAft>
+              <a:defRPr sz="1600" b="0">
+                <a:solidFill>
+                  <a:srgbClr val="334155"/>
+                </a:solidFill>
+                <a:latin typeface="Arial"/>
+              </a:defRPr>
+            </a:pPr>
+            <a:r>
+              <a:t>• Optional price-band filter parsed from query (EUR range).</a:t>
+            </a:r>
+          </a:p>
+          <a:p>
+            <a:pPr>
+              <a:spcAft>
+                <a:spcPts val="600"/>
+              </a:spcAft>
+              <a:defRPr sz="1600" b="0">
+                <a:solidFill>
+                  <a:srgbClr val="334155"/>
+                </a:solidFill>
+                <a:latin typeface="Arial"/>
+              </a:defRPr>
+            </a:pPr>
+            <a:r>
+              <a:t>• Max 4 recommendations (constraints.yaml).</a:t>
+            </a:r>
+          </a:p>
+        </p:txBody>
+      </p:sp>
+      <p:sp>
+        <p:nvSpPr>
+          <p:cNvPr id="18" name="TextBox 17"/>
+          <p:cNvSpPr txBox="1"/>
+          <p:nvPr/>
+        </p:nvSpPr>
+        <p:spPr>
+          <a:xfrm>
+            <a:off x="6126480" y="1417320"/>
+            <a:ext cx="5257800" cy="4663440"/>
+          </a:xfrm>
+          <a:prstGeom prst="rect">
+            <a:avLst/>
+          </a:prstGeom>
+          <a:noFill/>
+        </p:spPr>
+        <p:txBody>
+          <a:bodyPr wrap="square" anchor="t">
+            <a:spAutoFit/>
+          </a:bodyPr>
+          <a:lstStyle/>
+          <a:p>
+            <a:pPr>
+              <a:spcAft>
+                <a:spcPts val="600"/>
+              </a:spcAft>
+              <a:defRPr sz="1600" b="1">
+                <a:solidFill>
+                  <a:srgbClr val="0A2540"/>
+                </a:solidFill>
+                <a:latin typeface="Arial"/>
+              </a:defRPr>
+            </a:pPr>
+            <a:r>
+              <a:t>Grounding &amp; answer</a:t>
+            </a:r>
+          </a:p>
+          <a:p>
+            <a:pPr>
+              <a:spcAft>
+                <a:spcPts val="600"/>
+              </a:spcAft>
+              <a:defRPr sz="1600" b="0">
+                <a:solidFill>
+                  <a:srgbClr val="334155"/>
+                </a:solidFill>
+                <a:latin typeface="Arial"/>
+              </a:defRPr>
+            </a:pPr>
+            <a:r>
+              <a:t>• retrieved_products[] always from same site_id hits.</a:t>
+            </a:r>
+          </a:p>
+          <a:p>
+            <a:pPr>
+              <a:spcAft>
+                <a:spcPts val="600"/>
+              </a:spcAft>
+              <a:defRPr sz="1600" b="0">
+                <a:solidFill>
+                  <a:srgbClr val="334155"/>
+                </a:solidFill>
+                <a:latin typeface="Arial"/>
+              </a:defRPr>
+            </a:pPr>
+            <a:r>
+              <a:t>• Off-topic → empty list + polite decline (FR4).</a:t>
+            </a:r>
+          </a:p>
+          <a:p>
+            <a:pPr>
+              <a:spcAft>
+                <a:spcPts val="600"/>
+              </a:spcAft>
+              <a:defRPr sz="1600" b="0">
+                <a:solidFill>
+                  <a:srgbClr val="334155"/>
+                </a:solidFill>
+                <a:latin typeface="Arial"/>
+              </a:defRPr>
+            </a:pPr>
+            <a:r>
+              <a:t>• Synthesis: OpenCode agents or template — never invent SKUs.</a:t>
+            </a:r>
+          </a:p>
+          <a:p>
+            <a:pPr>
+              <a:spcAft>
+                <a:spcPts val="600"/>
+              </a:spcAft>
+              <a:defRPr sz="1600" b="0">
+                <a:solidFill>
+                  <a:srgbClr val="334155"/>
+                </a:solidFill>
+                <a:latin typeface="Arial"/>
+              </a:defRPr>
+            </a:pPr>
+            <a:r>
+              <a:t>• Stream: /chat/stream emits topic → products → answer chunks.</a:t>
+            </a:r>
+          </a:p>
+          <a:p>
+            <a:pPr>
+              <a:spcAft>
+                <a:spcPts val="600"/>
+              </a:spcAft>
+              <a:defRPr sz="1600" b="1">
+                <a:solidFill>
+                  <a:srgbClr val="0A2540"/>
+                </a:solidFill>
+                <a:latin typeface="Arial"/>
+              </a:defRPr>
+            </a:pPr>
+            <a:r>
+              <a:t>Production path</a:t>
+            </a:r>
+          </a:p>
+          <a:p>
+            <a:pPr>
+              <a:spcAft>
+                <a:spcPts val="600"/>
+              </a:spcAft>
+              <a:defRPr sz="1600" b="0">
+                <a:solidFill>
+                  <a:srgbClr val="334155"/>
+                </a:solidFill>
+                <a:latin typeface="Arial"/>
+              </a:defRPr>
+            </a:pPr>
+            <a:r>
+              <a:t>• Swap Chroma for managed vector DB; keep hybrid fusion logic.</a:t>
+            </a:r>
+          </a:p>
+          <a:p>
+            <a:pPr>
+              <a:spcAft>
+                <a:spcPts val="600"/>
+              </a:spcAft>
+              <a:defRPr sz="1600" b="0">
+                <a:solidFill>
+                  <a:srgbClr val="334155"/>
+                </a:solidFill>
+                <a:latin typeface="Arial"/>
+              </a:defRPr>
+            </a:pPr>
+            <a:r>
+              <a:t>• Scheduled re-ingest when catalog JSON changes (roadmap P1).</a:t>
             </a:r>
           </a:p>
         </p:txBody>
@@ -9964,7 +11858,7 @@
               </a:defRPr>
             </a:pPr>
             <a:r>
-              <a:t>5</a:t>
+              <a:t>7</a:t>
             </a:r>
           </a:p>
         </p:txBody>
@@ -10879,7 +12773,7 @@
               </a:defRPr>
             </a:pPr>
             <a:r>
-              <a:t>6</a:t>
+              <a:t>8</a:t>
             </a:r>
           </a:p>
         </p:txBody>
@@ -11737,7 +13631,7 @@
               </a:defRPr>
             </a:pPr>
             <a:r>
-              <a:t>7</a:t>
+              <a:t>9</a:t>
             </a:r>
           </a:p>
         </p:txBody>
@@ -12595,7 +14489,7 @@
               </a:defRPr>
             </a:pPr>
             <a:r>
-              <a:t>8</a:t>
+              <a:t>10</a:t>
             </a:r>
           </a:p>
         </p:txBody>
@@ -13472,7 +15366,7 @@
               </a:defRPr>
             </a:pPr>
             <a:r>
-              <a:t>9</a:t>
+              <a:t>11</a:t>
             </a:r>
           </a:p>
         </p:txBody>

</xml_diff>

<commit_message>
fix(ppt): clean slide 3 layout — no overlaps on FR1 async evidence
Co-authored-by: Cursor <cursoragent@cursor.com>
</commit_message>
<xml_diff>
--- a/docs/deliverables/v0.1/zooplus-assistant-interview-15min-pro.pptx
+++ b/docs/deliverables/v0.1/zooplus-assistant-interview-15min-pro.pptx
@@ -9322,7 +9322,7 @@
               </a:defRPr>
             </a:pPr>
             <a:r>
-              <a:t>FR1 — Async FastAPI (Coding Task §1) · evidence in code + test B1</a:t>
+              <a:t>FR1 — Functional Requirement 1: async FastAPI + POST /chat</a:t>
             </a:r>
           </a:p>
         </p:txBody>
@@ -9389,7 +9389,7 @@
         <p:spPr>
           <a:xfrm>
             <a:off x="585216" y="1261872"/>
-            <a:ext cx="5312664" cy="4864608"/>
+            <a:ext cx="4892040" cy="5074920"/>
           </a:xfrm>
           <a:prstGeom prst="rect">
             <a:avLst/>
@@ -9398,9 +9398,7 @@
             <a:srgbClr val="F8FAFC"/>
           </a:solidFill>
           <a:ln w="12700">
-            <a:solidFill>
-              <a:srgbClr val="CBD5E1"/>
-            </a:solidFill>
+            <a:noFill/>
           </a:ln>
         </p:spPr>
         <p:style>
@@ -9433,8 +9431,8 @@
         </p:nvSpPr>
         <p:spPr>
           <a:xfrm>
-            <a:off x="658368" y="1353312"/>
-            <a:ext cx="5166360" cy="4754880"/>
+            <a:off x="713232" y="1389888"/>
+            <a:ext cx="4617720" cy="1783080"/>
           </a:xfrm>
           <a:prstGeom prst="rect">
             <a:avLst/>
@@ -9452,9 +9450,9 @@
                 <a:spcPct val="115000"/>
               </a:lnSpc>
               <a:spcAft>
-                <a:spcPts val="400"/>
+                <a:spcPts val="600"/>
               </a:spcAft>
-              <a:defRPr sz="1500" b="1">
+              <a:defRPr sz="1400" b="1">
                 <a:solidFill>
                   <a:srgbClr val="0A2540"/>
                 </a:solidFill>
@@ -9462,177 +9460,55 @@
               </a:defRPr>
             </a:pPr>
             <a:r>
-              <a:t>FR1 = Functional Requirement 1 (Coding Task §1)</a:t>
+              <a:t>FR1 — Async FastAPI · POST /chat { site_id, query }</a:t>
             </a:r>
           </a:p>
           <a:p>
             <a:pPr>
               <a:spcAft>
-                <a:spcPts val="400"/>
+                <a:spcPts val="600"/>
               </a:spcAft>
-              <a:defRPr sz="1500" b="1">
-                <a:solidFill>
-                  <a:srgbClr val="0A2540"/>
+              <a:defRPr sz="1400" b="0">
+                <a:solidFill>
+                  <a:srgbClr val="334155"/>
                 </a:solidFill>
                 <a:latin typeface="Arial"/>
               </a:defRPr>
             </a:pPr>
             <a:r>
-              <a:t>Async Python FastAPI · POST /chat { site_id, query }</a:t>
+              <a:t>async def chat() → await handle_chat()  (routes/chat.py)</a:t>
             </a:r>
           </a:p>
           <a:p>
             <a:pPr>
               <a:spcAft>
-                <a:spcPts val="400"/>
+                <a:spcPts val="600"/>
               </a:spcAft>
-              <a:defRPr sz="1500" b="0">
+              <a:defRPr sz="1400" b="0">
                 <a:solidFill>
                   <a:srgbClr val="334155"/>
                 </a:solidFill>
                 <a:latin typeface="Arial"/>
               </a:defRPr>
             </a:pPr>
+            <a:r>
+              <a:t>Orchestrator async; Chroma/intent via asyncio.to_thread</a:t>
+            </a:r>
           </a:p>
           <a:p>
             <a:pPr>
               <a:spcAft>
-                <a:spcPts val="400"/>
+                <a:spcPts val="600"/>
               </a:spcAft>
-              <a:defRPr sz="1500" b="1">
-                <a:solidFill>
-                  <a:srgbClr val="0A2540"/>
+              <a:defRPr sz="1400" b="0">
+                <a:solidFill>
+                  <a:srgbClr val="334155"/>
                 </a:solidFill>
                 <a:latin typeface="Arial"/>
               </a:defRPr>
             </a:pPr>
             <a:r>
-              <a:t>Async evidence (B1)</a:t>
-            </a:r>
-          </a:p>
-          <a:p>
-            <a:pPr>
-              <a:spcAft>
-                <a:spcPts val="400"/>
-              </a:spcAft>
-              <a:defRPr sz="1500" b="0">
-                <a:solidFill>
-                  <a:srgbClr val="334155"/>
-                </a:solidFill>
-                <a:latin typeface="Arial"/>
-              </a:defRPr>
-            </a:pPr>
-            <a:r>
-              <a:t>• Endpoint: async def chat() → await handle_chat()</a:t>
-            </a:r>
-          </a:p>
-          <a:p>
-            <a:pPr>
-              <a:spcAft>
-                <a:spcPts val="400"/>
-              </a:spcAft>
-              <a:defRPr sz="1500" b="0">
-                <a:solidFill>
-                  <a:srgbClr val="334155"/>
-                </a:solidFill>
-                <a:latin typeface="Arial"/>
-              </a:defRPr>
-            </a:pPr>
-            <a:r>
-              <a:t>  src/api/routes/chat.py</a:t>
-            </a:r>
-          </a:p>
-          <a:p>
-            <a:pPr>
-              <a:spcAft>
-                <a:spcPts val="400"/>
-              </a:spcAft>
-              <a:defRPr sz="1500" b="0">
-                <a:solidFill>
-                  <a:srgbClr val="334155"/>
-                </a:solidFill>
-                <a:latin typeface="Arial"/>
-              </a:defRPr>
-            </a:pPr>
-            <a:r>
-              <a:t>• Pipeline: handle_chat / process lane are async coroutines</a:t>
-            </a:r>
-          </a:p>
-          <a:p>
-            <a:pPr>
-              <a:spcAft>
-                <a:spcPts val="400"/>
-              </a:spcAft>
-              <a:defRPr sz="1500" b="0">
-                <a:solidFill>
-                  <a:srgbClr val="334155"/>
-                </a:solidFill>
-                <a:latin typeface="Arial"/>
-              </a:defRPr>
-            </a:pPr>
-            <a:r>
-              <a:t>• Blocking I/O (Chroma, intent) → asyncio.to_thread</a:t>
-            </a:r>
-          </a:p>
-          <a:p>
-            <a:pPr>
-              <a:spcAft>
-                <a:spcPts val="400"/>
-              </a:spcAft>
-              <a:defRPr sz="1500" b="0">
-                <a:solidFill>
-                  <a:srgbClr val="334155"/>
-                </a:solidFill>
-                <a:latin typeface="Arial"/>
-              </a:defRPr>
-            </a:pPr>
-            <a:r>
-              <a:t>• Runtime: uvicorn ASGI (Dockerfile CMD)</a:t>
-            </a:r>
-          </a:p>
-          <a:p>
-            <a:pPr>
-              <a:spcAft>
-                <a:spcPts val="400"/>
-              </a:spcAft>
-              <a:defRPr sz="1500" b="0">
-                <a:solidFill>
-                  <a:srgbClr val="334155"/>
-                </a:solidFill>
-                <a:latin typeface="Arial"/>
-              </a:defRPr>
-            </a:pPr>
-            <a:r>
-              <a:t>• Test: test_app_is_async_fastapi — inspect.iscoroutinefunction(chat)</a:t>
-            </a:r>
-          </a:p>
-          <a:p>
-            <a:pPr>
-              <a:spcAft>
-                <a:spcPts val="400"/>
-              </a:spcAft>
-              <a:defRPr sz="1500" b="0">
-                <a:solidFill>
-                  <a:srgbClr val="334155"/>
-                </a:solidFill>
-                <a:latin typeface="Arial"/>
-              </a:defRPr>
-            </a:pPr>
-          </a:p>
-          <a:p>
-            <a:pPr>
-              <a:spcAft>
-                <a:spcPts val="400"/>
-              </a:spcAft>
-              <a:defRPr sz="1500" b="1">
-                <a:solidFill>
-                  <a:srgbClr val="0A2540"/>
-                </a:solidFill>
-                <a:latin typeface="Arial"/>
-              </a:defRPr>
-            </a:pPr>
-            <a:r>
-              <a:t>Live: Swagger /docs — Try it out + mandatory brief query</a:t>
+              <a:t>Deploy: uvicorn ASGI  ·  Test B1: iscoroutinefunction(chat)</a:t>
             </a:r>
           </a:p>
         </p:txBody>
@@ -9645,19 +9521,17 @@
         </p:nvSpPr>
         <p:spPr>
           <a:xfrm>
-            <a:off x="658368" y="3364992"/>
-            <a:ext cx="5394960" cy="1234440"/>
-          </a:xfrm>
-          <a:prstGeom prst="rect">
-            <a:avLst/>
-          </a:prstGeom>
-          <a:solidFill>
-            <a:srgbClr val="F1F5F9"/>
+            <a:off x="713232" y="3310128"/>
+            <a:ext cx="4617720" cy="1234440"/>
+          </a:xfrm>
+          <a:prstGeom prst="rect">
+            <a:avLst/>
+          </a:prstGeom>
+          <a:solidFill>
+            <a:srgbClr val="E0F2FE"/>
           </a:solidFill>
           <a:ln w="12700">
-            <a:solidFill>
-              <a:srgbClr val="1E3A8A"/>
-            </a:solidFill>
+            <a:noFill/>
           </a:ln>
         </p:spPr>
         <p:style>
@@ -9690,8 +9564,8 @@
         </p:nvSpPr>
         <p:spPr>
           <a:xfrm>
-            <a:off x="786384" y="3474720"/>
-            <a:ext cx="5138928" cy="1069848"/>
+            <a:off x="841248" y="3456432"/>
+            <a:ext cx="4343400" cy="960120"/>
           </a:xfrm>
           <a:prstGeom prst="rect">
             <a:avLst/>
@@ -9705,9 +9579,12 @@
           <a:lstStyle/>
           <a:p>
             <a:pPr>
-              <a:defRPr sz="1400">
-                <a:solidFill>
-                  <a:srgbClr val="0F172A"/>
+              <a:spcAft>
+                <a:spcPts val="100"/>
+              </a:spcAft>
+              <a:defRPr sz="1200">
+                <a:solidFill>
+                  <a:srgbClr val="0A2540"/>
                 </a:solidFill>
                 <a:latin typeface="Consolas"/>
               </a:defRPr>
@@ -9718,9 +9595,12 @@
           </a:p>
           <a:p>
             <a:pPr>
-              <a:defRPr sz="1400">
-                <a:solidFill>
-                  <a:srgbClr val="0F172A"/>
+              <a:spcAft>
+                <a:spcPts val="100"/>
+              </a:spcAft>
+              <a:defRPr sz="1200">
+                <a:solidFill>
+                  <a:srgbClr val="0A2540"/>
                 </a:solidFill>
                 <a:latin typeface="Consolas"/>
               </a:defRPr>
@@ -9731,9 +9611,12 @@
           </a:p>
           <a:p>
             <a:pPr>
-              <a:defRPr sz="1400">
-                <a:solidFill>
-                  <a:srgbClr val="0F172A"/>
+              <a:spcAft>
+                <a:spcPts val="100"/>
+              </a:spcAft>
+              <a:defRPr sz="1200">
+                <a:solidFill>
+                  <a:srgbClr val="0A2540"/>
                 </a:solidFill>
                 <a:latin typeface="Consolas"/>
               </a:defRPr>
@@ -9744,9 +9627,12 @@
           </a:p>
           <a:p>
             <a:pPr>
-              <a:defRPr sz="1400">
-                <a:solidFill>
-                  <a:srgbClr val="0F172A"/>
+              <a:spcAft>
+                <a:spcPts val="100"/>
+              </a:spcAft>
+              <a:defRPr sz="1200">
+                <a:solidFill>
+                  <a:srgbClr val="0A2540"/>
                 </a:solidFill>
                 <a:latin typeface="Consolas"/>
               </a:defRPr>
@@ -9765,8 +9651,8 @@
         </p:nvSpPr>
         <p:spPr>
           <a:xfrm>
-            <a:off x="6089904" y="1252728"/>
-            <a:ext cx="5687568" cy="4983480"/>
+            <a:off x="5989320" y="1261872"/>
+            <a:ext cx="5230368" cy="5074920"/>
           </a:xfrm>
           <a:prstGeom prst="roundRect">
             <a:avLst/>
@@ -9775,9 +9661,7 @@
             <a:srgbClr val="FFFFFF"/>
           </a:solidFill>
           <a:ln w="25400">
-            <a:solidFill>
-              <a:srgbClr val="CBD5E1"/>
-            </a:solidFill>
+            <a:noFill/>
           </a:ln>
         </p:spPr>
         <p:style>
@@ -9818,8 +9702,8 @@
         </p:blipFill>
         <p:spPr>
           <a:xfrm>
-            <a:off x="6144768" y="1307592"/>
-            <a:ext cx="5577840" cy="5522062"/>
+            <a:off x="6053328" y="1325880"/>
+            <a:ext cx="5102352" cy="2880360"/>
           </a:xfrm>
           <a:prstGeom prst="rect">
             <a:avLst/>
@@ -10029,14 +9913,50 @@
       </p:sp>
       <p:sp>
         <p:nvSpPr>
-          <p:cNvPr id="23" name="Panel AsyncEvidence"/>
+          <p:cNvPr id="23" name="TextBox SwaggerCTA"/>
+          <p:cNvSpPr txBox="1"/>
+          <p:nvPr/>
+        </p:nvSpPr>
+        <p:spPr>
+          <a:xfrm>
+            <a:off x="713232" y="4709160"/>
+            <a:ext cx="4617720" cy="502920"/>
+          </a:xfrm>
+          <a:prstGeom prst="rect">
+            <a:avLst/>
+          </a:prstGeom>
+          <a:noFill/>
+        </p:spPr>
+        <p:txBody>
+          <a:bodyPr wrap="none">
+            <a:spAutoFit/>
+          </a:bodyPr>
+          <a:lstStyle/>
+          <a:p>
+            <a:pPr>
+              <a:defRPr sz="1300" b="1">
+                <a:solidFill>
+                  <a:srgbClr val="2563EB"/>
+                </a:solidFill>
+                <a:latin typeface="Arial"/>
+              </a:defRPr>
+            </a:pPr>
+            <a:r>
+              <a:t>Live proof: /docs — Try it out with the mandatory brief query above</a:t>
+            </a:r>
+          </a:p>
+        </p:txBody>
+      </p:sp>
+      <p:sp>
+        <p:nvSpPr>
+          <p:cNvPr id="24" name="Panel AsyncEvidenceV2"/>
           <p:cNvSpPr/>
           <p:nvPr/>
         </p:nvSpPr>
         <p:spPr>
           <a:xfrm>
-            <a:off x="6080760" y="4892040"/>
-            <a:ext cx="5074920" cy="1417320"/>
+            <a:off x="6053328" y="4315968"/>
+            <a:ext cx="5102352" cy="1874519"/>
           </a:xfrm>
           <a:prstGeom prst="rect">
             <a:avLst/>
@@ -10072,14 +9992,14 @@
       </p:sp>
       <p:sp>
         <p:nvSpPr>
-          <p:cNvPr id="24" name="TextBox AsyncEvidence"/>
+          <p:cNvPr id="25" name="TextBox AsyncEvidenceV2"/>
           <p:cNvSpPr txBox="1"/>
           <p:nvPr/>
         </p:nvSpPr>
         <p:spPr>
           <a:xfrm>
-            <a:off x="6199632" y="4983480"/>
-            <a:ext cx="4846320" cy="1234440"/>
+            <a:off x="6163056" y="4407408"/>
+            <a:ext cx="4892040" cy="1691640"/>
           </a:xfrm>
           <a:prstGeom prst="rect">
             <a:avLst/>
@@ -10095,13 +10015,13 @@
             <a:pPr>
               <a:defRPr sz="1100" b="1">
                 <a:solidFill>
-                  <a:srgbClr val="2563EB"/>
+                  <a:srgbClr val="16A34A"/>
                 </a:solidFill>
                 <a:latin typeface="Arial"/>
               </a:defRPr>
             </a:pPr>
             <a:r>
-              <a:t>Async evidence (source)</a:t>
+              <a:t>Async evidence (source) — B1 PASS</a:t>
             </a:r>
           </a:p>
           <a:p>
@@ -10114,11 +10034,11 @@
               </a:defRPr>
             </a:pPr>
             <a:r>
-              <a:t>@router.post("/chat", response_model=ChatResponse)</a:t>
+              <a:t>@router.post("/chat")</a:t>
             </a:r>
             <a:br/>
             <a:r>
-              <a:t>async def chat(body: ChatRequest) -&gt; ChatResponse:</a:t>
+              <a:t>async def chat(body: ChatRequest):</a:t>
             </a:r>
             <a:br/>
             <a:r>
@@ -10127,47 +10047,11 @@
             <a:br/>
             <a:br/>
             <a:r>
-              <a:t># tests/acceptance/test_coding_task_brief.py</a:t>
+              <a:t># B1  tests/acceptance/test_coding_task_brief.py</a:t>
             </a:r>
             <a:br/>
             <a:r>
-              <a:t>assert inspect.iscoroutinefunction(chat)  # B1 ✅</a:t>
-            </a:r>
-          </a:p>
-        </p:txBody>
-      </p:sp>
-      <p:sp>
-        <p:nvSpPr>
-          <p:cNvPr id="25" name="TextBox B1Badge"/>
-          <p:cNvSpPr txBox="1"/>
-          <p:nvPr/>
-        </p:nvSpPr>
-        <p:spPr>
-          <a:xfrm>
-            <a:off x="6199632" y="4681728"/>
-            <a:ext cx="2011680" cy="256032"/>
-          </a:xfrm>
-          <a:prstGeom prst="rect">
-            <a:avLst/>
-          </a:prstGeom>
-          <a:noFill/>
-        </p:spPr>
-        <p:txBody>
-          <a:bodyPr wrap="none">
-            <a:spAutoFit/>
-          </a:bodyPr>
-          <a:lstStyle/>
-          <a:p>
-            <a:pPr>
-              <a:defRPr sz="1100" b="1">
-                <a:solidFill>
-                  <a:srgbClr val="16A34A"/>
-                </a:solidFill>
-                <a:latin typeface="Arial"/>
-              </a:defRPr>
-            </a:pPr>
-            <a:r>
-              <a:t>B1 test_app_is_async_fastapi ✅</a:t>
+              <a:t>assert inspect.iscoroutinefunction(chat)</a:t>
             </a:r>
           </a:p>
         </p:txBody>

</xml_diff>

<commit_message>
docs(ppt): changelog v0.1.3 and update pro deck for agentic UX improvements.
Co-authored-by: Cursor <cursoragent@cursor.com>
</commit_message>
<xml_diff>
--- a/docs/deliverables/v0.1/zooplus-assistant-interview-15min-pro.pptx
+++ b/docs/deliverables/v0.1/zooplus-assistant-interview-15min-pro.pptx
@@ -12550,9 +12550,9 @@
           <a:p>
             <a:pPr>
               <a:spcAft>
-                <a:spcPts val="600"/>
+                <a:spcPts val="500"/>
               </a:spcAft>
-              <a:defRPr sz="1600" b="1">
+              <a:defRPr sz="1500" b="1">
                 <a:solidFill>
                   <a:srgbClr val="0A2540"/>
                 </a:solidFill>
@@ -12560,15 +12560,111 @@
               </a:defRPr>
             </a:pPr>
             <a:r>
-              <a:t>Ingest (offline)</a:t>
+              <a:t>Grounding &amp; answer</a:t>
+            </a:r>
+          </a:p>
+          <a:p>
+            <a:pPr lvl="1">
+              <a:spcAft>
+                <a:spcPts val="500"/>
+              </a:spcAft>
+              <a:defRPr sz="1500" b="0">
+                <a:solidFill>
+                  <a:srgbClr val="334155"/>
+                </a:solidFill>
+                <a:latin typeface="Arial"/>
+              </a:defRPr>
+            </a:pPr>
+            <a:r>
+              <a:t>• retrieved_products[] from same site_id hits only.</a:t>
+            </a:r>
+          </a:p>
+          <a:p>
+            <a:pPr lvl="1">
+              <a:spcAft>
+                <a:spcPts val="500"/>
+              </a:spcAft>
+              <a:defRPr sz="1500" b="0">
+                <a:solidFill>
+                  <a:srgbClr val="334155"/>
+                </a:solidFill>
+                <a:latin typeface="Arial"/>
+              </a:defRPr>
+            </a:pPr>
+            <a:r>
+              <a:t>• Off-topic → empty list + polite decline (FR4).</a:t>
+            </a:r>
+          </a:p>
+          <a:p>
+            <a:pPr lvl="1">
+              <a:spcAft>
+                <a:spcPts val="500"/>
+              </a:spcAft>
+              <a:defRPr sz="1500" b="0">
+                <a:solidFill>
+                  <a:srgbClr val="334155"/>
+                </a:solidFill>
+                <a:latin typeface="Arial"/>
+              </a:defRPr>
+            </a:pPr>
+            <a:r>
+              <a:t>• Synthesis: per-agent OpenCode LLM — never invent SKUs.</a:t>
+            </a:r>
+          </a:p>
+          <a:p>
+            <a:pPr lvl="1">
+              <a:spcAft>
+                <a:spcPts val="500"/>
+              </a:spcAft>
+              <a:defRPr sz="1500" b="0">
+                <a:solidFill>
+                  <a:srgbClr val="334155"/>
+                </a:solidFill>
+                <a:latin typeface="Arial"/>
+              </a:defRPr>
+            </a:pPr>
+            <a:r>
+              <a:t>• Stream: /chat/stream → status* → products → done</a:t>
+            </a:r>
+          </a:p>
+          <a:p>
+            <a:pPr lvl="1">
+              <a:spcAft>
+                <a:spcPts val="500"/>
+              </a:spcAft>
+              <a:defRPr sz="1500" b="0">
+                <a:solidFill>
+                  <a:srgbClr val="334155"/>
+                </a:solidFill>
+                <a:latin typeface="Arial"/>
+              </a:defRPr>
+            </a:pPr>
+            <a:r>
+              <a:t>• UI: one transient status bubble (agent shopper_status).</a:t>
             </a:r>
           </a:p>
           <a:p>
             <a:pPr>
               <a:spcAft>
-                <a:spcPts val="600"/>
+                <a:spcPts val="500"/>
               </a:spcAft>
-              <a:defRPr sz="1600" b="0">
+              <a:defRPr sz="1500" b="1">
+                <a:solidFill>
+                  <a:srgbClr val="0A2540"/>
+                </a:solidFill>
+                <a:latin typeface="Arial"/>
+              </a:defRPr>
+            </a:pPr>
+            <a:r>
+              <a:t>Production path</a:t>
+            </a:r>
+          </a:p>
+          <a:p>
+            <a:pPr lvl="1">
+              <a:spcAft>
+                <a:spcPts val="500"/>
+              </a:spcAft>
+              <a:defRPr sz="1500" b="0">
                 <a:solidFill>
                   <a:srgbClr val="334155"/>
                 </a:solidFill>
@@ -12576,15 +12672,15 @@
               </a:defRPr>
             </a:pPr>
             <a:r>
-              <a:t>• Source of truth: instructions JSON → data/raw (300 variants).</a:t>
-            </a:r>
-          </a:p>
-          <a:p>
-            <a:pPr>
+              <a:t>• routing_lexicon.json at ingest; optional Redis mirror.</a:t>
+            </a:r>
+          </a:p>
+          <a:p>
+            <a:pPr lvl="1">
               <a:spcAft>
-                <a:spcPts val="600"/>
+                <a:spcPts val="500"/>
               </a:spcAft>
-              <a:defRPr sz="1600" b="0">
+              <a:defRPr sz="1500" b="0">
                 <a:solidFill>
                   <a:srgbClr val="334155"/>
                 </a:solidFill>
@@ -12592,103 +12688,7 @@
               </a:defRPr>
             </a:pPr>
             <a:r>
-              <a:t>• Strip HTML, one Chroma doc per article_id row.</a:t>
-            </a:r>
-          </a:p>
-          <a:p>
-            <a:pPr>
-              <a:spcAft>
-                <a:spcPts val="600"/>
-              </a:spcAft>
-              <a:defRPr sz="1600" b="0">
-                <a:solidFill>
-                  <a:srgbClr val="334155"/>
-                </a:solidFill>
-                <a:latin typeface="Arial"/>
-              </a:defRPr>
-            </a:pPr>
-            <a:r>
-              <a:t>• Metadata: site_id, pet_type, price, stock, ingredients flag.</a:t>
-            </a:r>
-          </a:p>
-          <a:p>
-            <a:pPr>
-              <a:spcAft>
-                <a:spcPts val="600"/>
-              </a:spcAft>
-              <a:defRPr sz="1600" b="0">
-                <a:solidFill>
-                  <a:srgbClr val="334155"/>
-                </a:solidFill>
-                <a:latin typeface="Arial"/>
-              </a:defRPr>
-            </a:pPr>
-            <a:r>
-              <a:t>• CLI: python -m cli ingest → artifacts/index/chroma</a:t>
-            </a:r>
-          </a:p>
-          <a:p>
-            <a:pPr>
-              <a:spcAft>
-                <a:spcPts val="600"/>
-              </a:spcAft>
-              <a:defRPr sz="1600" b="1">
-                <a:solidFill>
-                  <a:srgbClr val="0A2540"/>
-                </a:solidFill>
-                <a:latin typeface="Arial"/>
-              </a:defRPr>
-            </a:pPr>
-            <a:r>
-              <a:t>Online retrieval</a:t>
-            </a:r>
-          </a:p>
-          <a:p>
-            <a:pPr>
-              <a:spcAft>
-                <a:spcPts val="600"/>
-              </a:spcAft>
-              <a:defRPr sz="1600" b="0">
-                <a:solidFill>
-                  <a:srgbClr val="334155"/>
-                </a:solidFill>
-                <a:latin typeface="Arial"/>
-              </a:defRPr>
-            </a:pPr>
-            <a:r>
-              <a:t>• Topic guard ALLOW → process lane search_catalog().</a:t>
-            </a:r>
-          </a:p>
-          <a:p>
-            <a:pPr>
-              <a:spcAft>
-                <a:spcPts val="600"/>
-              </a:spcAft>
-              <a:defRPr sz="1600" b="0">
-                <a:solidFill>
-                  <a:srgbClr val="334155"/>
-                </a:solidFill>
-                <a:latin typeface="Arial"/>
-              </a:defRPr>
-            </a:pPr>
-            <a:r>
-              <a:t>• Optional price-band filter parsed from query (EUR range).</a:t>
-            </a:r>
-          </a:p>
-          <a:p>
-            <a:pPr>
-              <a:spcAft>
-                <a:spcPts val="600"/>
-              </a:spcAft>
-              <a:defRPr sz="1600" b="0">
-                <a:solidFill>
-                  <a:srgbClr val="334155"/>
-                </a:solidFill>
-                <a:latin typeface="Arial"/>
-              </a:defRPr>
-            </a:pPr>
-            <a:r>
-              <a:t>• Max 4 recommendations (constraints.yaml).</a:t>
+              <a:t>• Managed vector DB + scheduled re-ingest (roadmap P1).</a:t>
             </a:r>
           </a:p>
         </p:txBody>
@@ -13230,7 +13230,7 @@
               </a:defRPr>
             </a:pPr>
             <a:r>
-              <a:t>How each request is routed — one shopper API, dual lane</a:t>
+              <a:t>Conductor-first · catalog lexicon · stream status — fast multilingual UX</a:t>
             </a:r>
           </a:p>
         </p:txBody>
@@ -13329,7 +13329,100 @@
           <a:bodyPr rtlCol="0" anchor="ctr"/>
           <a:lstStyle/>
           <a:p>
-            <a:pPr algn="ctr"/>
+            <a:pPr algn="ctr">
+              <a:spcAft>
+                <a:spcPts val="500"/>
+              </a:spcAft>
+              <a:defRPr sz="1600" b="1">
+                <a:solidFill>
+                  <a:srgbClr val="0A2540"/>
+                </a:solidFill>
+                <a:latin typeface="Arial"/>
+              </a:defRPr>
+            </a:pPr>
+            <a:r>
+              <a:t>Agentic routing (v0.1.3)</a:t>
+            </a:r>
+          </a:p>
+          <a:p>
+            <a:pPr lvl="1">
+              <a:spcAft>
+                <a:spcPts val="500"/>
+              </a:spcAft>
+              <a:defRPr sz="1600" b="0">
+                <a:solidFill>
+                  <a:srgbClr val="334155"/>
+                </a:solidFill>
+                <a:latin typeface="Arial"/>
+              </a:defRPr>
+            </a:pPr>
+            <a:r>
+              <a:t>• Shopper: ONE assistant · POST /chat contract unchanged.</a:t>
+            </a:r>
+          </a:p>
+          <a:p>
+            <a:pPr lvl="1">
+              <a:spcAft>
+                <a:spcPts val="500"/>
+              </a:spcAft>
+              <a:defRPr sz="1600" b="0">
+                <a:solidFill>
+                  <a:srgbClr val="334155"/>
+                </a:solidFill>
+                <a:latin typeface="Arial"/>
+              </a:defRPr>
+            </a:pPr>
+            <a:r>
+              <a:t>• Conductor-first: classify TOPIC before catalog search.</a:t>
+            </a:r>
+          </a:p>
+          <a:p>
+            <a:pPr lvl="1">
+              <a:spcAft>
+                <a:spcPts val="500"/>
+              </a:spcAft>
+              <a:defRPr sz="1600" b="0">
+                <a:solidFill>
+                  <a:srgbClr val="334155"/>
+                </a:solidFill>
+                <a:latin typeface="Arial"/>
+              </a:defRPr>
+            </a:pPr>
+            <a:r>
+              <a:t>• Social/greeting → social agent only (no Chroma).</a:t>
+            </a:r>
+          </a:p>
+          <a:p>
+            <a:pPr lvl="1">
+              <a:spcAft>
+                <a:spcPts val="500"/>
+              </a:spcAft>
+              <a:defRPr sz="1600" b="0">
+                <a:solidFill>
+                  <a:srgbClr val="334155"/>
+                </a:solidFill>
+                <a:latin typeface="Arial"/>
+              </a:defRPr>
+            </a:pPr>
+            <a:r>
+              <a:t>• Catalog lane → prefetch search → process → synthesis.</a:t>
+            </a:r>
+          </a:p>
+          <a:p>
+            <a:pPr lvl="1">
+              <a:spcAft>
+                <a:spcPts val="500"/>
+              </a:spcAft>
+              <a:defRPr sz="1600" b="0">
+                <a:solidFill>
+                  <a:srgbClr val="334155"/>
+                </a:solidFill>
+                <a:latin typeface="Arial"/>
+              </a:defRPr>
+            </a:pPr>
+            <a:r>
+              <a:t>• Any language: agent + catalog lexicon in prompt.</a:t>
+            </a:r>
           </a:p>
         </p:txBody>
       </p:sp>
@@ -13360,9 +13453,9 @@
                 <a:spcPct val="115000"/>
               </a:lnSpc>
               <a:spcAft>
-                <a:spcPts val="800"/>
+                <a:spcPts val="500"/>
               </a:spcAft>
-              <a:defRPr sz="1800" b="1">
+              <a:defRPr sz="1600" b="1">
                 <a:solidFill>
                   <a:srgbClr val="0A2540"/>
                 </a:solidFill>
@@ -13370,56 +13463,47 @@
               </a:defRPr>
             </a:pPr>
             <a:r>
-              <a:t>Not an FR number — how we deliver agentic RAG (evaluation focus)</a:t>
-            </a:r>
-          </a:p>
-          <a:p>
-            <a:pPr>
-              <a:lnSpc>
-                <a:spcPct val="115000"/>
-              </a:lnSpc>
+              <a:t>Latency &amp; pre-index</a:t>
+            </a:r>
+          </a:p>
+          <a:p>
+            <a:pPr lvl="1">
               <a:spcAft>
-                <a:spcPts val="800"/>
+                <a:spcPts val="500"/>
               </a:spcAft>
-              <a:defRPr sz="1800" b="0">
-                <a:solidFill>
-                  <a:srgbClr val="0F172A"/>
-                </a:solidFill>
-                <a:latin typeface="Arial"/>
-              </a:defRPr>
-            </a:pPr>
-            <a:r>
-              <a:t>Shopper always sees ONE assistant; POST /chat contract unchanged</a:t>
-            </a:r>
-          </a:p>
-          <a:p>
-            <a:pPr>
-              <a:lnSpc>
-                <a:spcPct val="115000"/>
-              </a:lnSpc>
+              <a:defRPr sz="1600" b="0">
+                <a:solidFill>
+                  <a:srgbClr val="334155"/>
+                </a:solidFill>
+                <a:latin typeface="Arial"/>
+              </a:defRPr>
+            </a:pPr>
+            <a:r>
+              <a:t>• TTL cache: intent · chat · retrieval (600s).</a:t>
+            </a:r>
+          </a:p>
+          <a:p>
+            <a:pPr lvl="1">
               <a:spcAft>
-                <a:spcPts val="800"/>
+                <a:spcPts val="500"/>
               </a:spcAft>
-              <a:defRPr sz="1800" b="0">
-                <a:solidFill>
-                  <a:srgbClr val="0F172A"/>
-                </a:solidFill>
-                <a:latin typeface="Arial"/>
-              </a:defRPr>
-            </a:pPr>
-            <a:r>
-              <a:t>Orchestrator (src/lanes/orchestrator.py) on every turn:</a:t>
+              <a:defRPr sz="1600" b="0">
+                <a:solidFill>
+                  <a:srgbClr val="334155"/>
+                </a:solidFill>
+                <a:latin typeface="Arial"/>
+              </a:defRPr>
+            </a:pPr>
+            <a:r>
+              <a:t>• Optional Redis: shared cache + lexicon (scale-out).</a:t>
             </a:r>
           </a:p>
           <a:p>
             <a:pPr lvl="1">
-              <a:lnSpc>
-                <a:spcPct val="115000"/>
-              </a:lnSpc>
               <a:spcAft>
-                <a:spcPts val="800"/>
+                <a:spcPts val="500"/>
               </a:spcAft>
-              <a:defRPr sz="1800" b="0">
+              <a:defRPr sz="1600" b="0">
                 <a:solidFill>
                   <a:srgbClr val="334155"/>
                 </a:solidFill>
@@ -13427,18 +13511,15 @@
               </a:defRPr>
             </a:pPr>
             <a:r>
-              <a:t>  1) Intent agent → lane: catalog | conversational | decline</a:t>
+              <a:t>• Lexicon: brands/tokens from indexed JSON at ingest.</a:t>
             </a:r>
           </a:p>
           <a:p>
             <a:pPr lvl="1">
-              <a:lnSpc>
-                <a:spcPct val="115000"/>
-              </a:lnSpc>
               <a:spcAft>
-                <a:spcPts val="800"/>
+                <a:spcPts val="500"/>
               </a:spcAft>
-              <a:defRPr sz="1800" b="0">
+              <a:defRPr sz="1600" b="0">
                 <a:solidFill>
                   <a:srgbClr val="334155"/>
                 </a:solidFill>
@@ -13446,18 +13527,15 @@
               </a:defRPr>
             </a:pPr>
             <a:r>
-              <a:t>  2a) Social lane → social agent → answer, products=[]</a:t>
+              <a:t>• No hardcoded perro/gato — catalog-derived signals only.</a:t>
             </a:r>
           </a:p>
           <a:p>
             <a:pPr lvl="1">
-              <a:lnSpc>
-                <a:spcPct val="115000"/>
-              </a:lnSpc>
               <a:spcAft>
-                <a:spcPts val="800"/>
+                <a:spcPts val="500"/>
               </a:spcAft>
-              <a:defRPr sz="1800" b="0">
+              <a:defRPr sz="1600" b="0">
                 <a:solidFill>
                   <a:srgbClr val="334155"/>
                 </a:solidFill>
@@ -13465,7 +13543,7 @@
               </a:defRPr>
             </a:pPr>
             <a:r>
-              <a:t>  2b) Process lane → RAG + logic (≤4) → synthesis → answer + products</a:t>
+              <a:t>• Fast social path: hola que tal ≈ seconds, not 30s+.</a:t>
             </a:r>
           </a:p>
         </p:txBody>
@@ -14225,7 +14303,100 @@
           <a:bodyPr rtlCol="0" anchor="ctr"/>
           <a:lstStyle/>
           <a:p>
-            <a:pPr algn="ctr"/>
+            <a:pPr algn="ctr">
+              <a:spcAft>
+                <a:spcPts val="500"/>
+              </a:spcAft>
+              <a:defRPr sz="1500" b="1">
+                <a:solidFill>
+                  <a:srgbClr val="0A2540"/>
+                </a:solidFill>
+                <a:latin typeface="Arial"/>
+              </a:defRPr>
+            </a:pPr>
+            <a:r>
+              <a:t>OpenCode specialists (.opencode/agents/*.md)</a:t>
+            </a:r>
+          </a:p>
+          <a:p>
+            <a:pPr lvl="1">
+              <a:spcAft>
+                <a:spcPts val="500"/>
+              </a:spcAft>
+              <a:defRPr sz="1500" b="0">
+                <a:solidFill>
+                  <a:srgbClr val="334155"/>
+                </a:solidFill>
+                <a:latin typeface="Arial"/>
+              </a:defRPr>
+            </a:pPr>
+            <a:r>
+              <a:t>• zooplus-conductor → lane + shopper_status (JSON).</a:t>
+            </a:r>
+          </a:p>
+          <a:p>
+            <a:pPr lvl="1">
+              <a:spcAft>
+                <a:spcPts val="500"/>
+              </a:spcAft>
+              <a:defRPr sz="1500" b="0">
+                <a:solidFill>
+                  <a:srgbClr val="334155"/>
+                </a:solidFill>
+                <a:latin typeface="Arial"/>
+              </a:defRPr>
+            </a:pPr>
+            <a:r>
+              <a:t>• zooplus-social-agent → multilingual social/decline.</a:t>
+            </a:r>
+          </a:p>
+          <a:p>
+            <a:pPr lvl="1">
+              <a:spcAft>
+                <a:spcPts val="500"/>
+              </a:spcAft>
+              <a:defRPr sz="1500" b="0">
+                <a:solidFill>
+                  <a:srgbClr val="334155"/>
+                </a:solidFill>
+                <a:latin typeface="Arial"/>
+              </a:defRPr>
+            </a:pPr>
+            <a:r>
+              <a:t>• zooplus-intent-agent → fallback cascade.</a:t>
+            </a:r>
+          </a:p>
+          <a:p>
+            <a:pPr lvl="1">
+              <a:spcAft>
+                <a:spcPts val="500"/>
+              </a:spcAft>
+              <a:defRPr sz="1500" b="0">
+                <a:solidFill>
+                  <a:srgbClr val="334155"/>
+                </a:solidFill>
+                <a:latin typeface="Arial"/>
+              </a:defRPr>
+            </a:pPr>
+            <a:r>
+              <a:t>• rag-worker + logic-worker → hybrid retrieve, cap 4.</a:t>
+            </a:r>
+          </a:p>
+          <a:p>
+            <a:pPr lvl="1">
+              <a:spcAft>
+                <a:spcPts val="500"/>
+              </a:spcAft>
+              <a:defRPr sz="1500" b="0">
+                <a:solidFill>
+                  <a:srgbClr val="334155"/>
+                </a:solidFill>
+                <a:latin typeface="Arial"/>
+              </a:defRPr>
+            </a:pPr>
+            <a:r>
+              <a:t>• zooplus-synthesis → grounded prose from hits only.</a:t>
+            </a:r>
           </a:p>
         </p:txBody>
       </p:sp>
@@ -14256,9 +14427,9 @@
                 <a:spcPct val="115000"/>
               </a:lnSpc>
               <a:spcAft>
-                <a:spcPts val="800"/>
+                <a:spcPts val="500"/>
               </a:spcAft>
-              <a:defRPr sz="1800" b="1">
+              <a:defRPr sz="1500" b="1">
                 <a:solidFill>
                   <a:srgbClr val="0A2540"/>
                 </a:solidFill>
@@ -14266,121 +14437,87 @@
               </a:defRPr>
             </a:pPr>
             <a:r>
-              <a:t>Runtime: OpenCode subprocesses (.opencode/agents/*.md)</a:t>
-            </a:r>
-          </a:p>
-          <a:p>
-            <a:pPr>
-              <a:lnSpc>
-                <a:spcPct val="115000"/>
-              </a:lnSpc>
+              <a:t>Per-agent LLMs (official OpenCode config)</a:t>
+            </a:r>
+          </a:p>
+          <a:p>
+            <a:pPr lvl="1">
               <a:spcAft>
-                <a:spcPts val="800"/>
+                <a:spcPts val="500"/>
               </a:spcAft>
-              <a:defRPr sz="1800" b="0">
-                <a:solidFill>
-                  <a:srgbClr val="0F172A"/>
-                </a:solidFill>
-                <a:latin typeface="Arial"/>
-              </a:defRPr>
-            </a:pPr>
-            <a:r>
-              <a:t>zooplus-intent-agent → lane + topic + reason (JSON); blocks off-topic RAG</a:t>
-            </a:r>
-          </a:p>
-          <a:p>
-            <a:pPr>
-              <a:lnSpc>
-                <a:spcPct val="115000"/>
-              </a:lnSpc>
+              <a:defRPr sz="1500" b="0">
+                <a:solidFill>
+                  <a:srgbClr val="334155"/>
+                </a:solidFill>
+                <a:latin typeface="Arial"/>
+              </a:defRPr>
+            </a:pPr>
+            <a:r>
+              <a:t>• Conductor / social: mimo-v2.5-free (fast).</a:t>
+            </a:r>
+          </a:p>
+          <a:p>
+            <a:pPr lvl="1">
               <a:spcAft>
-                <a:spcPts val="800"/>
+                <a:spcPts val="500"/>
               </a:spcAft>
-              <a:defRPr sz="1800" b="0">
-                <a:solidFill>
-                  <a:srgbClr val="0F172A"/>
-                </a:solidFill>
-                <a:latin typeface="Arial"/>
-              </a:defRPr>
-            </a:pPr>
-            <a:r>
-              <a:t>zooplus-social-agent → greeting, help, decline; never invents catalog SKUs</a:t>
-            </a:r>
-          </a:p>
-          <a:p>
-            <a:pPr>
-              <a:lnSpc>
-                <a:spcPct val="115000"/>
-              </a:lnSpc>
+              <a:defRPr sz="1500" b="0">
+                <a:solidFill>
+                  <a:srgbClr val="334155"/>
+                </a:solidFill>
+                <a:latin typeface="Arial"/>
+              </a:defRPr>
+            </a:pPr>
+            <a:r>
+              <a:t>• Intent / RAG: deepseek-v4-flash.</a:t>
+            </a:r>
+          </a:p>
+          <a:p>
+            <a:pPr lvl="1">
               <a:spcAft>
-                <a:spcPts val="800"/>
+                <a:spcPts val="500"/>
               </a:spcAft>
-              <a:defRPr sz="1800" b="0">
-                <a:solidFill>
-                  <a:srgbClr val="0F172A"/>
-                </a:solidFill>
-                <a:latin typeface="Arial"/>
-              </a:defRPr>
-            </a:pPr>
-            <a:r>
-              <a:t>zooplus-rag-worker → retrieval by site_id · logic-worker → rank, cap 4</a:t>
-            </a:r>
-          </a:p>
-          <a:p>
-            <a:pPr>
-              <a:lnSpc>
-                <a:spcPct val="115000"/>
-              </a:lnSpc>
+              <a:defRPr sz="1500" b="0">
+                <a:solidFill>
+                  <a:srgbClr val="334155"/>
+                </a:solidFill>
+                <a:latin typeface="Arial"/>
+              </a:defRPr>
+            </a:pPr>
+            <a:r>
+              <a:t>• Logic: qwen3.6-plus · Topic-guard: minimax-m2.5.</a:t>
+            </a:r>
+          </a:p>
+          <a:p>
+            <a:pPr lvl="1">
               <a:spcAft>
-                <a:spcPts val="800"/>
+                <a:spcPts val="500"/>
               </a:spcAft>
-              <a:defRPr sz="1800" b="0">
-                <a:solidFill>
-                  <a:srgbClr val="0F172A"/>
-                </a:solidFill>
-                <a:latin typeface="Arial"/>
-              </a:defRPr>
-            </a:pPr>
-            <a:r>
-              <a:t>zooplus-synthesis → prose grounded ONLY in retrieved hits</a:t>
-            </a:r>
-          </a:p>
-          <a:p>
-            <a:pPr>
-              <a:lnSpc>
-                <a:spcPct val="115000"/>
-              </a:lnSpc>
+              <a:defRPr sz="1500" b="0">
+                <a:solidFill>
+                  <a:srgbClr val="334155"/>
+                </a:solidFill>
+                <a:latin typeface="Arial"/>
+              </a:defRPr>
+            </a:pPr>
+            <a:r>
+              <a:t>• Synthesis: deepseek-v4-flash-free.</a:t>
+            </a:r>
+          </a:p>
+          <a:p>
+            <a:pPr lvl="1">
               <a:spcAft>
-                <a:spcPts val="800"/>
+                <a:spcPts val="500"/>
               </a:spcAft>
-              <a:defRPr sz="1800" b="0">
-                <a:solidFill>
-                  <a:srgbClr val="0F172A"/>
-                </a:solidFill>
-                <a:latin typeface="Arial"/>
-              </a:defRPr>
-            </a:pPr>
-            <a:r>
-              <a:t>zooplus-conductor → cascade fallback (src/agents/registry.py)</a:t>
-            </a:r>
-          </a:p>
-          <a:p>
-            <a:pPr>
-              <a:lnSpc>
-                <a:spcPct val="115000"/>
-              </a:lnSpc>
-              <a:spcAft>
-                <a:spcPts val="800"/>
-              </a:spcAft>
-              <a:defRPr sz="1800" b="0">
-                <a:solidFill>
-                  <a:srgbClr val="0F172A"/>
-                </a:solidFill>
-                <a:latin typeface="Arial"/>
-              </a:defRPr>
-            </a:pPr>
-            <a:r>
-              <a:t>Handoff brief: intent context → social / synthesis (handoff.py)</a:t>
+              <a:defRPr sz="1500" b="0">
+                <a:solidFill>
+                  <a:srgbClr val="334155"/>
+                </a:solidFill>
+                <a:latin typeface="Arial"/>
+              </a:defRPr>
+            </a:pPr>
+            <a:r>
+              <a:t>• UI badge shows real model from response meta.</a:t>
             </a:r>
           </a:p>
         </p:txBody>
@@ -15140,7 +15277,116 @@
           <a:bodyPr rtlCol="0" anchor="ctr"/>
           <a:lstStyle/>
           <a:p>
-            <a:pPr algn="ctr"/>
+            <a:pPr algn="ctr">
+              <a:spcAft>
+                <a:spcPts val="500"/>
+              </a:spcAft>
+              <a:defRPr sz="1500" b="1">
+                <a:solidFill>
+                  <a:srgbClr val="0A2540"/>
+                </a:solidFill>
+                <a:latin typeface="Arial"/>
+              </a:defRPr>
+            </a:pPr>
+            <a:r>
+              <a:t>FR4 guardrails + live demo</a:t>
+            </a:r>
+          </a:p>
+          <a:p>
+            <a:pPr lvl="1">
+              <a:spcAft>
+                <a:spcPts val="500"/>
+              </a:spcAft>
+              <a:defRPr sz="1500" b="0">
+                <a:solidFill>
+                  <a:srgbClr val="334155"/>
+                </a:solidFill>
+                <a:latin typeface="Arial"/>
+              </a:defRPr>
+            </a:pPr>
+            <a:r>
+              <a:t>• Pet catalog only · default-deny off-topic.</a:t>
+            </a:r>
+          </a:p>
+          <a:p>
+            <a:pPr lvl="1">
+              <a:spcAft>
+                <a:spcPts val="500"/>
+              </a:spcAft>
+              <a:defRPr sz="1500" b="0">
+                <a:solidFill>
+                  <a:srgbClr val="334155"/>
+                </a:solidFill>
+                <a:latin typeface="Arial"/>
+              </a:defRPr>
+            </a:pPr>
+            <a:r>
+              <a:t>• constraints.yaml + agentic intent + social decline.</a:t>
+            </a:r>
+          </a:p>
+          <a:p>
+            <a:pPr lvl="1">
+              <a:spcAft>
+                <a:spcPts val="500"/>
+              </a:spcAft>
+              <a:defRPr sz="1500" b="0">
+                <a:solidFill>
+                  <a:srgbClr val="334155"/>
+                </a:solidFill>
+                <a:latin typeface="Arial"/>
+              </a:defRPr>
+            </a:pPr>
+            <a:r>
+              <a:t>• Demo A: hola que tal → fast social (no RAG).</a:t>
+            </a:r>
+          </a:p>
+          <a:p>
+            <a:pPr lvl="1">
+              <a:spcAft>
+                <a:spcPts val="500"/>
+              </a:spcAft>
+              <a:defRPr sz="1500" b="0">
+                <a:solidFill>
+                  <a:srgbClr val="334155"/>
+                </a:solidFill>
+                <a:latin typeface="Arial"/>
+              </a:defRPr>
+            </a:pPr>
+            <a:r>
+              <a:t>• Demo B: cat food 40–60 € → stream status → products.</a:t>
+            </a:r>
+          </a:p>
+          <a:p>
+            <a:pPr lvl="1">
+              <a:spcAft>
+                <a:spcPts val="500"/>
+              </a:spcAft>
+              <a:defRPr sz="1500" b="0">
+                <a:solidFill>
+                  <a:srgbClr val="334155"/>
+                </a:solidFill>
+                <a:latin typeface="Arial"/>
+              </a:defRPr>
+            </a:pPr>
+            <a:r>
+              <a:t>• Demo C: off-topic weather → polite decline.</a:t>
+            </a:r>
+          </a:p>
+          <a:p>
+            <a:pPr lvl="1">
+              <a:spcAft>
+                <a:spcPts val="500"/>
+              </a:spcAft>
+              <a:defRPr sz="1500" b="0">
+                <a:solidFill>
+                  <a:srgbClr val="334155"/>
+                </a:solidFill>
+                <a:latin typeface="Arial"/>
+              </a:defRPr>
+            </a:pPr>
+            <a:r>
+              <a:t>• http://127.0.0.1:8090/ui/ · shops 1 / 3 / 15</a:t>
+            </a:r>
           </a:p>
         </p:txBody>
       </p:sp>

</xml_diff>

<commit_message>
fix(ppt): slide 7-9 layout keeps titles and footers
Co-authored-by: Cursor <cursoragent@cursor.com>
</commit_message>
<xml_diff>
--- a/docs/deliverables/v0.1/zooplus-assistant-interview-15min-pro.pptx
+++ b/docs/deliverables/v0.1/zooplus-assistant-interview-15min-pro.pptx
@@ -12717,9 +12717,9 @@
           <a:p>
             <a:pPr>
               <a:spcAft>
-                <a:spcPts val="600"/>
+                <a:spcPts val="400"/>
               </a:spcAft>
-              <a:defRPr sz="1600" b="1">
+              <a:defRPr sz="1400" b="1">
                 <a:solidFill>
                   <a:srgbClr val="0A2540"/>
                 </a:solidFill>
@@ -12728,14 +12728,110 @@
             </a:pPr>
             <a:r>
               <a:t>Grounding &amp; answer</a:t>
+            </a:r>
+          </a:p>
+          <a:p>
+            <a:pPr lvl="1">
+              <a:spcAft>
+                <a:spcPts val="400"/>
+              </a:spcAft>
+              <a:defRPr sz="1400" b="0">
+                <a:solidFill>
+                  <a:srgbClr val="334155"/>
+                </a:solidFill>
+                <a:latin typeface="Arial"/>
+              </a:defRPr>
+            </a:pPr>
+            <a:r>
+              <a:t>• retrieved_products[] from same site_id hits only.</a:t>
+            </a:r>
+          </a:p>
+          <a:p>
+            <a:pPr lvl="1">
+              <a:spcAft>
+                <a:spcPts val="400"/>
+              </a:spcAft>
+              <a:defRPr sz="1400" b="0">
+                <a:solidFill>
+                  <a:srgbClr val="334155"/>
+                </a:solidFill>
+                <a:latin typeface="Arial"/>
+              </a:defRPr>
+            </a:pPr>
+            <a:r>
+              <a:t>• Off-topic → empty list + polite decline (FR4).</a:t>
+            </a:r>
+          </a:p>
+          <a:p>
+            <a:pPr lvl="1">
+              <a:spcAft>
+                <a:spcPts val="400"/>
+              </a:spcAft>
+              <a:defRPr sz="1400" b="0">
+                <a:solidFill>
+                  <a:srgbClr val="334155"/>
+                </a:solidFill>
+                <a:latin typeface="Arial"/>
+              </a:defRPr>
+            </a:pPr>
+            <a:r>
+              <a:t>• Synthesis: per-agent OpenCode LLM — never invent SKUs.</a:t>
+            </a:r>
+          </a:p>
+          <a:p>
+            <a:pPr lvl="1">
+              <a:spcAft>
+                <a:spcPts val="400"/>
+              </a:spcAft>
+              <a:defRPr sz="1400" b="0">
+                <a:solidFill>
+                  <a:srgbClr val="334155"/>
+                </a:solidFill>
+                <a:latin typeface="Arial"/>
+              </a:defRPr>
+            </a:pPr>
+            <a:r>
+              <a:t>• Stream: /chat/stream → status → products → done.</a:t>
+            </a:r>
+          </a:p>
+          <a:p>
+            <a:pPr lvl="1">
+              <a:spcAft>
+                <a:spcPts val="400"/>
+              </a:spcAft>
+              <a:defRPr sz="1400" b="0">
+                <a:solidFill>
+                  <a:srgbClr val="334155"/>
+                </a:solidFill>
+                <a:latin typeface="Arial"/>
+              </a:defRPr>
+            </a:pPr>
+            <a:r>
+              <a:t>• UI: one transient status bubble (agent shopper_status).</a:t>
             </a:r>
           </a:p>
           <a:p>
             <a:pPr>
               <a:spcAft>
-                <a:spcPts val="600"/>
+                <a:spcPts val="400"/>
               </a:spcAft>
-              <a:defRPr sz="1600" b="0">
+              <a:defRPr sz="1400" b="1">
+                <a:solidFill>
+                  <a:srgbClr val="0A2540"/>
+                </a:solidFill>
+                <a:latin typeface="Arial"/>
+              </a:defRPr>
+            </a:pPr>
+            <a:r>
+              <a:t>Production path</a:t>
+            </a:r>
+          </a:p>
+          <a:p>
+            <a:pPr lvl="1">
+              <a:spcAft>
+                <a:spcPts val="400"/>
+              </a:spcAft>
+              <a:defRPr sz="1400" b="0">
                 <a:solidFill>
                   <a:srgbClr val="334155"/>
                 </a:solidFill>
@@ -12743,15 +12839,15 @@
               </a:defRPr>
             </a:pPr>
             <a:r>
-              <a:t>• retrieved_products[] always from same site_id hits.</a:t>
-            </a:r>
-          </a:p>
-          <a:p>
-            <a:pPr>
+              <a:t>• routing_lexicon.json at ingest; optional Redis mirror.</a:t>
+            </a:r>
+          </a:p>
+          <a:p>
+            <a:pPr lvl="1">
               <a:spcAft>
-                <a:spcPts val="600"/>
+                <a:spcPts val="400"/>
               </a:spcAft>
-              <a:defRPr sz="1600" b="0">
+              <a:defRPr sz="1400" b="0">
                 <a:solidFill>
                   <a:srgbClr val="334155"/>
                 </a:solidFill>
@@ -12759,87 +12855,7 @@
               </a:defRPr>
             </a:pPr>
             <a:r>
-              <a:t>• Off-topic → empty list + polite decline (FR4).</a:t>
-            </a:r>
-          </a:p>
-          <a:p>
-            <a:pPr>
-              <a:spcAft>
-                <a:spcPts val="600"/>
-              </a:spcAft>
-              <a:defRPr sz="1600" b="0">
-                <a:solidFill>
-                  <a:srgbClr val="334155"/>
-                </a:solidFill>
-                <a:latin typeface="Arial"/>
-              </a:defRPr>
-            </a:pPr>
-            <a:r>
-              <a:t>• Synthesis: OpenCode agents or template — never invent SKUs.</a:t>
-            </a:r>
-          </a:p>
-          <a:p>
-            <a:pPr>
-              <a:spcAft>
-                <a:spcPts val="600"/>
-              </a:spcAft>
-              <a:defRPr sz="1600" b="0">
-                <a:solidFill>
-                  <a:srgbClr val="334155"/>
-                </a:solidFill>
-                <a:latin typeface="Arial"/>
-              </a:defRPr>
-            </a:pPr>
-            <a:r>
-              <a:t>• Stream: /chat/stream emits topic → products → answer chunks.</a:t>
-            </a:r>
-          </a:p>
-          <a:p>
-            <a:pPr>
-              <a:spcAft>
-                <a:spcPts val="600"/>
-              </a:spcAft>
-              <a:defRPr sz="1600" b="1">
-                <a:solidFill>
-                  <a:srgbClr val="0A2540"/>
-                </a:solidFill>
-                <a:latin typeface="Arial"/>
-              </a:defRPr>
-            </a:pPr>
-            <a:r>
-              <a:t>Production path</a:t>
-            </a:r>
-          </a:p>
-          <a:p>
-            <a:pPr>
-              <a:spcAft>
-                <a:spcPts val="600"/>
-              </a:spcAft>
-              <a:defRPr sz="1600" b="0">
-                <a:solidFill>
-                  <a:srgbClr val="334155"/>
-                </a:solidFill>
-                <a:latin typeface="Arial"/>
-              </a:defRPr>
-            </a:pPr>
-            <a:r>
-              <a:t>• Swap Chroma for managed vector DB; keep hybrid fusion logic.</a:t>
-            </a:r>
-          </a:p>
-          <a:p>
-            <a:pPr>
-              <a:spcAft>
-                <a:spcPts val="600"/>
-              </a:spcAft>
-              <a:defRPr sz="1600" b="0">
-                <a:solidFill>
-                  <a:srgbClr val="334155"/>
-                </a:solidFill>
-                <a:latin typeface="Arial"/>
-              </a:defRPr>
-            </a:pPr>
-            <a:r>
-              <a:t>• Scheduled re-ingest when catalog JSON changes (roadmap P1).</a:t>
+              <a:t>• Managed vector DB + scheduled re-ingest (roadmap P1).</a:t>
             </a:r>
           </a:p>
         </p:txBody>
@@ -13331,9 +13347,9 @@
           <a:p>
             <a:pPr algn="ctr">
               <a:spcAft>
-                <a:spcPts val="500"/>
+                <a:spcPts val="400"/>
               </a:spcAft>
-              <a:defRPr sz="1600" b="1">
+              <a:defRPr sz="1400" b="1">
                 <a:solidFill>
                   <a:srgbClr val="0A2540"/>
                 </a:solidFill>
@@ -13347,9 +13363,9 @@
           <a:p>
             <a:pPr lvl="1">
               <a:spcAft>
-                <a:spcPts val="500"/>
+                <a:spcPts val="400"/>
               </a:spcAft>
-              <a:defRPr sz="1600" b="0">
+              <a:defRPr sz="1400" b="0">
                 <a:solidFill>
                   <a:srgbClr val="334155"/>
                 </a:solidFill>
@@ -13357,15 +13373,15 @@
               </a:defRPr>
             </a:pPr>
             <a:r>
-              <a:t>• Shopper: ONE assistant · POST /chat contract unchanged.</a:t>
+              <a:t>• Conductor-first: classify TOPIC before catalog search.</a:t>
             </a:r>
           </a:p>
           <a:p>
             <a:pPr lvl="1">
               <a:spcAft>
-                <a:spcPts val="500"/>
+                <a:spcPts val="400"/>
               </a:spcAft>
-              <a:defRPr sz="1600" b="0">
+              <a:defRPr sz="1400" b="0">
                 <a:solidFill>
                   <a:srgbClr val="334155"/>
                 </a:solidFill>
@@ -13373,15 +13389,15 @@
               </a:defRPr>
             </a:pPr>
             <a:r>
-              <a:t>• Conductor-first: classify TOPIC before catalog search.</a:t>
+              <a:t>• Social greeting → social agent only (no Chroma).</a:t>
             </a:r>
           </a:p>
           <a:p>
             <a:pPr lvl="1">
               <a:spcAft>
-                <a:spcPts val="500"/>
+                <a:spcPts val="400"/>
               </a:spcAft>
-              <a:defRPr sz="1600" b="0">
+              <a:defRPr sz="1400" b="0">
                 <a:solidFill>
                   <a:srgbClr val="334155"/>
                 </a:solidFill>
@@ -13389,15 +13405,15 @@
               </a:defRPr>
             </a:pPr>
             <a:r>
-              <a:t>• Social/greeting → social agent only (no Chroma).</a:t>
+              <a:t>• Catalog lane → prefetch → process → synthesis.</a:t>
             </a:r>
           </a:p>
           <a:p>
             <a:pPr lvl="1">
               <a:spcAft>
-                <a:spcPts val="500"/>
+                <a:spcPts val="400"/>
               </a:spcAft>
-              <a:defRPr sz="1600" b="0">
+              <a:defRPr sz="1400" b="0">
                 <a:solidFill>
                   <a:srgbClr val="334155"/>
                 </a:solidFill>
@@ -13405,15 +13421,31 @@
               </a:defRPr>
             </a:pPr>
             <a:r>
-              <a:t>• Catalog lane → prefetch search → process → synthesis.</a:t>
+              <a:t>• Catalog lexicon in prompt (brands/tokens from ingest).</a:t>
+            </a:r>
+          </a:p>
+          <a:p>
+            <a:pPr>
+              <a:spcAft>
+                <a:spcPts val="400"/>
+              </a:spcAft>
+              <a:defRPr sz="1400" b="1">
+                <a:solidFill>
+                  <a:srgbClr val="0A2540"/>
+                </a:solidFill>
+                <a:latin typeface="Arial"/>
+              </a:defRPr>
+            </a:pPr>
+            <a:r>
+              <a:t>Latency &amp; cache</a:t>
             </a:r>
           </a:p>
           <a:p>
             <a:pPr lvl="1">
               <a:spcAft>
-                <a:spcPts val="500"/>
+                <a:spcPts val="400"/>
               </a:spcAft>
-              <a:defRPr sz="1600" b="0">
+              <a:defRPr sz="1400" b="0">
                 <a:solidFill>
                   <a:srgbClr val="334155"/>
                 </a:solidFill>
@@ -13421,57 +13453,15 @@
               </a:defRPr>
             </a:pPr>
             <a:r>
-              <a:t>• Any language: agent + catalog lexicon in prompt.</a:t>
-            </a:r>
-          </a:p>
-        </p:txBody>
-      </p:sp>
-      <p:sp>
-        <p:nvSpPr>
-          <p:cNvPr id="13" name="TextBox 12"/>
-          <p:cNvSpPr txBox="1"/>
-          <p:nvPr/>
-        </p:nvSpPr>
-        <p:spPr>
-          <a:xfrm>
-            <a:off x="658368" y="1353312"/>
-            <a:ext cx="4983480" cy="4754880"/>
-          </a:xfrm>
-          <a:prstGeom prst="rect">
-            <a:avLst/>
-          </a:prstGeom>
-          <a:noFill/>
-        </p:spPr>
-        <p:txBody>
-          <a:bodyPr wrap="square">
-            <a:spAutoFit/>
-          </a:bodyPr>
-          <a:lstStyle/>
-          <a:p>
-            <a:pPr>
-              <a:lnSpc>
-                <a:spcPct val="115000"/>
-              </a:lnSpc>
-              <a:spcAft>
-                <a:spcPts val="500"/>
-              </a:spcAft>
-              <a:defRPr sz="1600" b="1">
-                <a:solidFill>
-                  <a:srgbClr val="0A2540"/>
-                </a:solidFill>
-                <a:latin typeface="Arial"/>
-              </a:defRPr>
-            </a:pPr>
-            <a:r>
-              <a:t>Latency &amp; pre-index</a:t>
+              <a:t>• TTL cache: intent · chat · retrieval.</a:t>
             </a:r>
           </a:p>
           <a:p>
             <a:pPr lvl="1">
               <a:spcAft>
-                <a:spcPts val="500"/>
+                <a:spcPts val="400"/>
               </a:spcAft>
-              <a:defRPr sz="1600" b="0">
+              <a:defRPr sz="1400" b="0">
                 <a:solidFill>
                   <a:srgbClr val="334155"/>
                 </a:solidFill>
@@ -13479,15 +13469,15 @@
               </a:defRPr>
             </a:pPr>
             <a:r>
-              <a:t>• TTL cache: intent · chat · retrieval (600s).</a:t>
+              <a:t>• Optional Redis: shared cache + lexicon.</a:t>
             </a:r>
           </a:p>
           <a:p>
             <a:pPr lvl="1">
               <a:spcAft>
-                <a:spcPts val="500"/>
+                <a:spcPts val="400"/>
               </a:spcAft>
-              <a:defRPr sz="1600" b="0">
+              <a:defRPr sz="1400" b="0">
                 <a:solidFill>
                   <a:srgbClr val="334155"/>
                 </a:solidFill>
@@ -13495,55 +13485,7 @@
               </a:defRPr>
             </a:pPr>
             <a:r>
-              <a:t>• Optional Redis: shared cache + lexicon (scale-out).</a:t>
-            </a:r>
-          </a:p>
-          <a:p>
-            <a:pPr lvl="1">
-              <a:spcAft>
-                <a:spcPts val="500"/>
-              </a:spcAft>
-              <a:defRPr sz="1600" b="0">
-                <a:solidFill>
-                  <a:srgbClr val="334155"/>
-                </a:solidFill>
-                <a:latin typeface="Arial"/>
-              </a:defRPr>
-            </a:pPr>
-            <a:r>
-              <a:t>• Lexicon: brands/tokens from indexed JSON at ingest.</a:t>
-            </a:r>
-          </a:p>
-          <a:p>
-            <a:pPr lvl="1">
-              <a:spcAft>
-                <a:spcPts val="500"/>
-              </a:spcAft>
-              <a:defRPr sz="1600" b="0">
-                <a:solidFill>
-                  <a:srgbClr val="334155"/>
-                </a:solidFill>
-                <a:latin typeface="Arial"/>
-              </a:defRPr>
-            </a:pPr>
-            <a:r>
-              <a:t>• No hardcoded perro/gato — catalog-derived signals only.</a:t>
-            </a:r>
-          </a:p>
-          <a:p>
-            <a:pPr lvl="1">
-              <a:spcAft>
-                <a:spcPts val="500"/>
-              </a:spcAft>
-              <a:defRPr sz="1600" b="0">
-                <a:solidFill>
-                  <a:srgbClr val="334155"/>
-                </a:solidFill>
-                <a:latin typeface="Arial"/>
-              </a:defRPr>
-            </a:pPr>
-            <a:r>
-              <a:t>• Fast social path: hola que tal ≈ seconds, not 30s+.</a:t>
+              <a:t>• Fast social: hola que tal in seconds, not 30s+.</a:t>
             </a:r>
           </a:p>
         </p:txBody>
@@ -14305,9 +14247,9 @@
           <a:p>
             <a:pPr algn="ctr">
               <a:spcAft>
-                <a:spcPts val="500"/>
+                <a:spcPts val="400"/>
               </a:spcAft>
-              <a:defRPr sz="1500" b="1">
+              <a:defRPr sz="1300" b="1">
                 <a:solidFill>
                   <a:srgbClr val="0A2540"/>
                 </a:solidFill>
@@ -14315,15 +14257,15 @@
               </a:defRPr>
             </a:pPr>
             <a:r>
-              <a:t>OpenCode specialists (.opencode/agents/*.md)</a:t>
+              <a:t>OpenCode specialists</a:t>
             </a:r>
           </a:p>
           <a:p>
             <a:pPr lvl="1">
               <a:spcAft>
-                <a:spcPts val="500"/>
+                <a:spcPts val="400"/>
               </a:spcAft>
-              <a:defRPr sz="1500" b="0">
+              <a:defRPr sz="1300" b="0">
                 <a:solidFill>
                   <a:srgbClr val="334155"/>
                 </a:solidFill>
@@ -14331,15 +14273,15 @@
               </a:defRPr>
             </a:pPr>
             <a:r>
-              <a:t>• zooplus-conductor → lane + shopper_status (JSON).</a:t>
+              <a:t>• conductor → lane + shopper_status (JSON).</a:t>
             </a:r>
           </a:p>
           <a:p>
             <a:pPr lvl="1">
               <a:spcAft>
-                <a:spcPts val="500"/>
+                <a:spcPts val="400"/>
               </a:spcAft>
-              <a:defRPr sz="1500" b="0">
+              <a:defRPr sz="1300" b="0">
                 <a:solidFill>
                   <a:srgbClr val="334155"/>
                 </a:solidFill>
@@ -14347,15 +14289,15 @@
               </a:defRPr>
             </a:pPr>
             <a:r>
-              <a:t>• zooplus-social-agent → multilingual social/decline.</a:t>
+              <a:t>• social-agent → multilingual social / decline.</a:t>
             </a:r>
           </a:p>
           <a:p>
             <a:pPr lvl="1">
               <a:spcAft>
-                <a:spcPts val="500"/>
+                <a:spcPts val="400"/>
               </a:spcAft>
-              <a:defRPr sz="1500" b="0">
+              <a:defRPr sz="1300" b="0">
                 <a:solidFill>
                   <a:srgbClr val="334155"/>
                 </a:solidFill>
@@ -14363,15 +14305,15 @@
               </a:defRPr>
             </a:pPr>
             <a:r>
-              <a:t>• zooplus-intent-agent → fallback cascade.</a:t>
+              <a:t>• intent-agent → fallback cascade.</a:t>
             </a:r>
           </a:p>
           <a:p>
             <a:pPr lvl="1">
               <a:spcAft>
-                <a:spcPts val="500"/>
+                <a:spcPts val="400"/>
               </a:spcAft>
-              <a:defRPr sz="1500" b="0">
+              <a:defRPr sz="1300" b="0">
                 <a:solidFill>
                   <a:srgbClr val="334155"/>
                 </a:solidFill>
@@ -14379,15 +14321,15 @@
               </a:defRPr>
             </a:pPr>
             <a:r>
-              <a:t>• rag-worker + logic-worker → hybrid retrieve, cap 4.</a:t>
+              <a:t>• rag + logic workers → hybrid retrieve, cap 4.</a:t>
             </a:r>
           </a:p>
           <a:p>
             <a:pPr lvl="1">
               <a:spcAft>
-                <a:spcPts val="500"/>
+                <a:spcPts val="400"/>
               </a:spcAft>
-              <a:defRPr sz="1500" b="0">
+              <a:defRPr sz="1300" b="0">
                 <a:solidFill>
                   <a:srgbClr val="334155"/>
                 </a:solidFill>
@@ -14395,41 +14337,15 @@
               </a:defRPr>
             </a:pPr>
             <a:r>
-              <a:t>• zooplus-synthesis → grounded prose from hits only.</a:t>
-            </a:r>
-          </a:p>
-        </p:txBody>
-      </p:sp>
-      <p:sp>
-        <p:nvSpPr>
-          <p:cNvPr id="13" name="TextBox 12"/>
-          <p:cNvSpPr txBox="1"/>
-          <p:nvPr/>
-        </p:nvSpPr>
-        <p:spPr>
-          <a:xfrm>
-            <a:off x="658368" y="1353312"/>
-            <a:ext cx="4892040" cy="4754880"/>
-          </a:xfrm>
-          <a:prstGeom prst="rect">
-            <a:avLst/>
-          </a:prstGeom>
-          <a:noFill/>
-        </p:spPr>
-        <p:txBody>
-          <a:bodyPr wrap="square">
-            <a:spAutoFit/>
-          </a:bodyPr>
-          <a:lstStyle/>
+              <a:t>• synthesis → grounded prose from hits only.</a:t>
+            </a:r>
+          </a:p>
           <a:p>
             <a:pPr>
-              <a:lnSpc>
-                <a:spcPct val="115000"/>
-              </a:lnSpc>
               <a:spcAft>
-                <a:spcPts val="500"/>
+                <a:spcPts val="400"/>
               </a:spcAft>
-              <a:defRPr sz="1500" b="1">
+              <a:defRPr sz="1300" b="1">
                 <a:solidFill>
                   <a:srgbClr val="0A2540"/>
                 </a:solidFill>
@@ -14437,15 +14353,15 @@
               </a:defRPr>
             </a:pPr>
             <a:r>
-              <a:t>Per-agent LLMs (official OpenCode config)</a:t>
+              <a:t>Per-agent LLMs (opencode.json)</a:t>
             </a:r>
           </a:p>
           <a:p>
             <a:pPr lvl="1">
               <a:spcAft>
-                <a:spcPts val="500"/>
+                <a:spcPts val="400"/>
               </a:spcAft>
-              <a:defRPr sz="1500" b="0">
+              <a:defRPr sz="1300" b="0">
                 <a:solidFill>
                   <a:srgbClr val="334155"/>
                 </a:solidFill>
@@ -14453,15 +14369,15 @@
               </a:defRPr>
             </a:pPr>
             <a:r>
-              <a:t>• Conductor / social: mimo-v2.5-free (fast).</a:t>
+              <a:t>• Conductor / social: mimo-v2.5-free.</a:t>
             </a:r>
           </a:p>
           <a:p>
             <a:pPr lvl="1">
               <a:spcAft>
-                <a:spcPts val="500"/>
+                <a:spcPts val="400"/>
               </a:spcAft>
-              <a:defRPr sz="1500" b="0">
+              <a:defRPr sz="1300" b="0">
                 <a:solidFill>
                   <a:srgbClr val="334155"/>
                 </a:solidFill>
@@ -14475,9 +14391,9 @@
           <a:p>
             <a:pPr lvl="1">
               <a:spcAft>
-                <a:spcPts val="500"/>
+                <a:spcPts val="400"/>
               </a:spcAft>
-              <a:defRPr sz="1500" b="0">
+              <a:defRPr sz="1300" b="0">
                 <a:solidFill>
                   <a:srgbClr val="334155"/>
                 </a:solidFill>
@@ -14491,9 +14407,9 @@
           <a:p>
             <a:pPr lvl="1">
               <a:spcAft>
-                <a:spcPts val="500"/>
+                <a:spcPts val="400"/>
               </a:spcAft>
-              <a:defRPr sz="1500" b="0">
+              <a:defRPr sz="1300" b="0">
                 <a:solidFill>
                   <a:srgbClr val="334155"/>
                 </a:solidFill>
@@ -14507,9 +14423,9 @@
           <a:p>
             <a:pPr lvl="1">
               <a:spcAft>
-                <a:spcPts val="500"/>
+                <a:spcPts val="400"/>
               </a:spcAft>
-              <a:defRPr sz="1500" b="0">
+              <a:defRPr sz="1300" b="0">
                 <a:solidFill>
                   <a:srgbClr val="334155"/>
                 </a:solidFill>
@@ -15279,9 +15195,9 @@
           <a:p>
             <a:pPr algn="ctr">
               <a:spcAft>
-                <a:spcPts val="500"/>
+                <a:spcPts val="400"/>
               </a:spcAft>
-              <a:defRPr sz="1500" b="1">
+              <a:defRPr sz="1400" b="1">
                 <a:solidFill>
                   <a:srgbClr val="0A2540"/>
                 </a:solidFill>
@@ -15295,9 +15211,9 @@
           <a:p>
             <a:pPr lvl="1">
               <a:spcAft>
-                <a:spcPts val="500"/>
+                <a:spcPts val="400"/>
               </a:spcAft>
-              <a:defRPr sz="1500" b="0">
+              <a:defRPr sz="1400" b="0">
                 <a:solidFill>
                   <a:srgbClr val="334155"/>
                 </a:solidFill>
@@ -15311,9 +15227,9 @@
           <a:p>
             <a:pPr lvl="1">
               <a:spcAft>
-                <a:spcPts val="500"/>
+                <a:spcPts val="400"/>
               </a:spcAft>
-              <a:defRPr sz="1500" b="0">
+              <a:defRPr sz="1400" b="0">
                 <a:solidFill>
                   <a:srgbClr val="334155"/>
                 </a:solidFill>
@@ -15322,14 +15238,30 @@
             </a:pPr>
             <a:r>
               <a:t>• constraints.yaml + agentic intent + social decline.</a:t>
+            </a:r>
+          </a:p>
+          <a:p>
+            <a:pPr>
+              <a:spcAft>
+                <a:spcPts val="400"/>
+              </a:spcAft>
+              <a:defRPr sz="1400" b="1">
+                <a:solidFill>
+                  <a:srgbClr val="0A2540"/>
+                </a:solidFill>
+                <a:latin typeface="Arial"/>
+              </a:defRPr>
+            </a:pPr>
+            <a:r>
+              <a:t>Demo (http://127.0.0.1:8090/ui/)</a:t>
             </a:r>
           </a:p>
           <a:p>
             <a:pPr lvl="1">
               <a:spcAft>
-                <a:spcPts val="500"/>
+                <a:spcPts val="400"/>
               </a:spcAft>
-              <a:defRPr sz="1500" b="0">
+              <a:defRPr sz="1400" b="0">
                 <a:solidFill>
                   <a:srgbClr val="334155"/>
                 </a:solidFill>
@@ -15337,15 +15269,15 @@
               </a:defRPr>
             </a:pPr>
             <a:r>
-              <a:t>• Demo A: hola que tal → fast social (no RAG).</a:t>
+              <a:t>• A: hola que tal → fast social (no RAG).</a:t>
             </a:r>
           </a:p>
           <a:p>
             <a:pPr lvl="1">
               <a:spcAft>
-                <a:spcPts val="500"/>
+                <a:spcPts val="400"/>
               </a:spcAft>
-              <a:defRPr sz="1500" b="0">
+              <a:defRPr sz="1400" b="0">
                 <a:solidFill>
                   <a:srgbClr val="334155"/>
                 </a:solidFill>
@@ -15353,15 +15285,15 @@
               </a:defRPr>
             </a:pPr>
             <a:r>
-              <a:t>• Demo B: cat food 40–60 € → stream status → products.</a:t>
+              <a:t>• B: cat food 40–60 EUR → stream status → products.</a:t>
             </a:r>
           </a:p>
           <a:p>
             <a:pPr lvl="1">
               <a:spcAft>
-                <a:spcPts val="500"/>
+                <a:spcPts val="400"/>
               </a:spcAft>
-              <a:defRPr sz="1500" b="0">
+              <a:defRPr sz="1400" b="0">
                 <a:solidFill>
                   <a:srgbClr val="334155"/>
                 </a:solidFill>
@@ -15369,15 +15301,15 @@
               </a:defRPr>
             </a:pPr>
             <a:r>
-              <a:t>• Demo C: off-topic weather → polite decline.</a:t>
+              <a:t>• C: weather / news → polite decline.</a:t>
             </a:r>
           </a:p>
           <a:p>
             <a:pPr lvl="1">
               <a:spcAft>
-                <a:spcPts val="500"/>
+                <a:spcPts val="400"/>
               </a:spcAft>
-              <a:defRPr sz="1500" b="0">
+              <a:defRPr sz="1400" b="0">
                 <a:solidFill>
                   <a:srgbClr val="334155"/>
                 </a:solidFill>
@@ -15385,106 +15317,7 @@
               </a:defRPr>
             </a:pPr>
             <a:r>
-              <a:t>• http://127.0.0.1:8090/ui/ · shops 1 / 3 / 15</a:t>
-            </a:r>
-          </a:p>
-        </p:txBody>
-      </p:sp>
-      <p:sp>
-        <p:nvSpPr>
-          <p:cNvPr id="13" name="TextBox 12"/>
-          <p:cNvSpPr txBox="1"/>
-          <p:nvPr/>
-        </p:nvSpPr>
-        <p:spPr>
-          <a:xfrm>
-            <a:off x="658368" y="1353312"/>
-            <a:ext cx="5166360" cy="4754880"/>
-          </a:xfrm>
-          <a:prstGeom prst="rect">
-            <a:avLst/>
-          </a:prstGeom>
-          <a:noFill/>
-        </p:spPr>
-        <p:txBody>
-          <a:bodyPr wrap="square">
-            <a:spAutoFit/>
-          </a:bodyPr>
-          <a:lstStyle/>
-          <a:p>
-            <a:pPr>
-              <a:lnSpc>
-                <a:spcPct val="115000"/>
-              </a:lnSpc>
-              <a:spcAft>
-                <a:spcPts val="800"/>
-              </a:spcAft>
-              <a:defRPr sz="2000" b="1">
-                <a:solidFill>
-                  <a:srgbClr val="0A2540"/>
-                </a:solidFill>
-                <a:latin typeface="Arial"/>
-              </a:defRPr>
-            </a:pPr>
-            <a:r>
-              <a:t>FR4 = Guardrails: pet-product questions only</a:t>
-            </a:r>
-          </a:p>
-          <a:p>
-            <a:pPr>
-              <a:lnSpc>
-                <a:spcPct val="115000"/>
-              </a:lnSpc>
-              <a:spcAft>
-                <a:spcPts val="800"/>
-              </a:spcAft>
-              <a:defRPr sz="2000" b="0">
-                <a:solidFill>
-                  <a:srgbClr val="0F172A"/>
-                </a:solidFill>
-                <a:latin typeface="Arial"/>
-              </a:defRPr>
-            </a:pPr>
-            <a:r>
-              <a:t>Off-topic → polite decline · retrieved_products=[]</a:t>
-            </a:r>
-          </a:p>
-          <a:p>
-            <a:pPr>
-              <a:lnSpc>
-                <a:spcPct val="115000"/>
-              </a:lnSpc>
-              <a:spcAft>
-                <a:spcPts val="800"/>
-              </a:spcAft>
-              <a:defRPr sz="2000" b="0">
-                <a:solidFill>
-                  <a:srgbClr val="0F172A"/>
-                </a:solidFill>
-                <a:latin typeface="Arial"/>
-              </a:defRPr>
-            </a:pPr>
-            <a:r>
-              <a:t>Policy: constraints.yaml + intent default-deny + social agent</a:t>
-            </a:r>
-          </a:p>
-          <a:p>
-            <a:pPr>
-              <a:lnSpc>
-                <a:spcPct val="115000"/>
-              </a:lnSpc>
-              <a:spcAft>
-                <a:spcPts val="800"/>
-              </a:spcAft>
-              <a:defRPr sz="2000" b="0">
-                <a:solidFill>
-                  <a:srgbClr val="0F172A"/>
-                </a:solidFill>
-                <a:latin typeface="Arial"/>
-              </a:defRPr>
-            </a:pPr>
-            <a:r>
-              <a:t>Demo: hello · cats · site 15 · humans · puppy docx query</a:t>
+              <a:t>• Pick shop 1, 3, or 15 before sending.</a:t>
             </a:r>
           </a:p>
         </p:txBody>

</xml_diff>

<commit_message>
feat(v2.0): pacing, conductor integration tests, PPT and docs
Phase 2-3: chunk pacing in stream/UI, mocked conductor stream test,
minimax-m2.7 registry fix, interview deck v2.0 slides, CHANGELOG.

Co-authored-by: Cursor <cursoragent@cursor.com>
</commit_message>
<xml_diff>
--- a/docs/deliverables/v0.1/zooplus-assistant-interview-15min-pro.pptx
+++ b/docs/deliverables/v0.1/zooplus-assistant-interview-15min-pro.pptx
@@ -12779,6 +12779,22 @@
             </a:r>
           </a:p>
           <a:p>
+            <a:pPr>
+              <a:spcAft>
+                <a:spcPts val="400"/>
+              </a:spcAft>
+              <a:defRPr sz="1400" b="1">
+                <a:solidFill>
+                  <a:srgbClr val="0A2540"/>
+                </a:solidFill>
+                <a:latin typeface="Arial"/>
+              </a:defRPr>
+            </a:pPr>
+            <a:r>
+              <a:t>v2.0 — invisible conductor</a:t>
+            </a:r>
+          </a:p>
+          <a:p>
             <a:pPr lvl="1">
               <a:spcAft>
                 <a:spcPts val="400"/>
@@ -12791,7 +12807,7 @@
               </a:defRPr>
             </a:pPr>
             <a:r>
-              <a:t>• Stream: /chat/stream → status → products → done.</a:t>
+              <a:t>• Strong LLM admin decides each stream tick (JSON actions).</a:t>
             </a:r>
           </a:p>
           <a:p>
@@ -12807,23 +12823,7 @@
               </a:defRPr>
             </a:pPr>
             <a:r>
-              <a:t>• UI: one transient status bubble (agent shopper_status).</a:t>
-            </a:r>
-          </a:p>
-          <a:p>
-            <a:pPr>
-              <a:spcAft>
-                <a:spcPts val="400"/>
-              </a:spcAft>
-              <a:defRPr sz="1400" b="1">
-                <a:solidFill>
-                  <a:srgbClr val="0A2540"/>
-                </a:solidFill>
-                <a:latin typeface="Arial"/>
-              </a:defRPr>
-            </a:pPr>
-            <a:r>
-              <a:t>Production path</a:t>
+              <a:t>• social-agent voices briefs; shopper never sees conductor.</a:t>
             </a:r>
           </a:p>
           <a:p>
@@ -12839,7 +12839,7 @@
               </a:defRPr>
             </a:pPr>
             <a:r>
-              <a:t>• routing_lexicon.json at ingest; optional Redis mirror.</a:t>
+              <a:t>• Anti-repeat: scope disclaimer once, then progress only.</a:t>
             </a:r>
           </a:p>
           <a:p>
@@ -12855,7 +12855,7 @@
               </a:defRPr>
             </a:pPr>
             <a:r>
-              <a:t>• Managed vector DB + scheduled re-ingest (roadmap P1).</a:t>
+              <a:t>• Parallel catalog + paced typing/chunks (v1.4 UX kept).</a:t>
             </a:r>
           </a:p>
         </p:txBody>
@@ -13357,7 +13357,7 @@
               </a:defRPr>
             </a:pPr>
             <a:r>
-              <a:t>Agentic routing (v0.1.3)</a:t>
+              <a:t>Invisible conductor (v2.0 official)</a:t>
             </a:r>
           </a:p>
           <a:p>
@@ -13373,7 +13373,7 @@
               </a:defRPr>
             </a:pPr>
             <a:r>
-              <a:t>• Conductor-first: classify TOPIC before catalog search.</a:t>
+              <a:t>• minimax-m2.7 orchestrator — emit_message | wait | complete.</a:t>
             </a:r>
           </a:p>
           <a:p>
@@ -13389,7 +13389,7 @@
               </a:defRPr>
             </a:pPr>
             <a:r>
-              <a:t>• Social greeting → social agent only (no Chroma).</a:t>
+              <a:t>• Delegates: social · topic-guard · RAG · logic · synthesis.</a:t>
             </a:r>
           </a:p>
           <a:p>
@@ -13405,7 +13405,7 @@
               </a:defRPr>
             </a:pPr>
             <a:r>
-              <a:t>• Catalog lane → prefetch → process → synthesis.</a:t>
+              <a:t>• Each tick: new brief only — no repeated tortuga/gato disclaimers.</a:t>
             </a:r>
           </a:p>
           <a:p>
@@ -13421,7 +13421,7 @@
               </a:defRPr>
             </a:pPr>
             <a:r>
-              <a:t>• Catalog lexicon in prompt (brands/tokens from ingest).</a:t>
+              <a:t>• ZOOPLUS_STREAM_MODE=conductor (timed = v1.4 fallback).</a:t>
             </a:r>
           </a:p>
           <a:p>
@@ -13437,7 +13437,7 @@
               </a:defRPr>
             </a:pPr>
             <a:r>
-              <a:t>Latency &amp; cache</a:t>
+              <a:t>Agentic core (unchanged)</a:t>
             </a:r>
           </a:p>
           <a:p>
@@ -13453,7 +13453,7 @@
               </a:defRPr>
             </a:pPr>
             <a:r>
-              <a:t>• TTL cache: intent · chat · retrieval.</a:t>
+              <a:t>• Conductor-first intent before Chroma.</a:t>
             </a:r>
           </a:p>
           <a:p>
@@ -13469,23 +13469,7 @@
               </a:defRPr>
             </a:pPr>
             <a:r>
-              <a:t>• Optional Redis: shared cache + lexicon.</a:t>
-            </a:r>
-          </a:p>
-          <a:p>
-            <a:pPr lvl="1">
-              <a:spcAft>
-                <a:spcPts val="400"/>
-              </a:spcAft>
-              <a:defRPr sz="1400" b="0">
-                <a:solidFill>
-                  <a:srgbClr val="334155"/>
-                </a:solidFill>
-                <a:latin typeface="Arial"/>
-              </a:defRPr>
-            </a:pPr>
-            <a:r>
-              <a:t>• Fast social: hola que tal in seconds, not 30s+.</a:t>
+              <a:t>• Catalog lexicon from ingest; optional Redis + session turns.</a:t>
             </a:r>
           </a:p>
         </p:txBody>
@@ -14273,7 +14257,7 @@
               </a:defRPr>
             </a:pPr>
             <a:r>
-              <a:t>• conductor → lane + shopper_status (JSON).</a:t>
+              <a:t>• zooplus-conductor → invisible stream orchestrator (v2.0).</a:t>
             </a:r>
           </a:p>
           <a:p>
@@ -14289,7 +14273,7 @@
               </a:defRPr>
             </a:pPr>
             <a:r>
-              <a:t>• social-agent → multilingual social / decline.</a:t>
+              <a:t>• social-agent → shopper voice from conductor briefs.</a:t>
             </a:r>
           </a:p>
           <a:p>
@@ -14305,7 +14289,7 @@
               </a:defRPr>
             </a:pPr>
             <a:r>
-              <a:t>• intent-agent → fallback cascade.</a:t>
+              <a:t>• intent / topic-guard → scope filter.</a:t>
             </a:r>
           </a:p>
           <a:p>
@@ -14321,7 +14305,23 @@
               </a:defRPr>
             </a:pPr>
             <a:r>
-              <a:t>• rag + logic workers → hybrid retrieve, cap 4.</a:t>
+              <a:t>• rag + logic + synthesis → grounded catalog answer.</a:t>
+            </a:r>
+          </a:p>
+          <a:p>
+            <a:pPr>
+              <a:spcAft>
+                <a:spcPts val="400"/>
+              </a:spcAft>
+              <a:defRPr sz="1300" b="1">
+                <a:solidFill>
+                  <a:srgbClr val="0A2540"/>
+                </a:solidFill>
+                <a:latin typeface="Arial"/>
+              </a:defRPr>
+            </a:pPr>
+            <a:r>
+              <a:t>Per-agent LLMs (OpenCode Go)</a:t>
             </a:r>
           </a:p>
           <a:p>
@@ -14337,23 +14337,7 @@
               </a:defRPr>
             </a:pPr>
             <a:r>
-              <a:t>• synthesis → grounded prose from hits only.</a:t>
-            </a:r>
-          </a:p>
-          <a:p>
-            <a:pPr>
-              <a:spcAft>
-                <a:spcPts val="400"/>
-              </a:spcAft>
-              <a:defRPr sz="1300" b="1">
-                <a:solidFill>
-                  <a:srgbClr val="0A2540"/>
-                </a:solidFill>
-                <a:latin typeface="Arial"/>
-              </a:defRPr>
-            </a:pPr>
-            <a:r>
-              <a:t>Per-agent LLMs (opencode.json)</a:t>
+              <a:t>• Conductor + logic: minimax-m2.7.</a:t>
             </a:r>
           </a:p>
           <a:p>
@@ -14369,55 +14353,7 @@
               </a:defRPr>
             </a:pPr>
             <a:r>
-              <a:t>• Conductor / social: mimo-v2.5-free.</a:t>
-            </a:r>
-          </a:p>
-          <a:p>
-            <a:pPr lvl="1">
-              <a:spcAft>
-                <a:spcPts val="400"/>
-              </a:spcAft>
-              <a:defRPr sz="1300" b="0">
-                <a:solidFill>
-                  <a:srgbClr val="334155"/>
-                </a:solidFill>
-                <a:latin typeface="Arial"/>
-              </a:defRPr>
-            </a:pPr>
-            <a:r>
-              <a:t>• Intent / RAG: deepseek-v4-flash.</a:t>
-            </a:r>
-          </a:p>
-          <a:p>
-            <a:pPr lvl="1">
-              <a:spcAft>
-                <a:spcPts val="400"/>
-              </a:spcAft>
-              <a:defRPr sz="1300" b="0">
-                <a:solidFill>
-                  <a:srgbClr val="334155"/>
-                </a:solidFill>
-                <a:latin typeface="Arial"/>
-              </a:defRPr>
-            </a:pPr>
-            <a:r>
-              <a:t>• Logic: qwen3.6-plus · Topic-guard: minimax-m2.5.</a:t>
-            </a:r>
-          </a:p>
-          <a:p>
-            <a:pPr lvl="1">
-              <a:spcAft>
-                <a:spcPts val="400"/>
-              </a:spcAft>
-              <a:defRPr sz="1300" b="0">
-                <a:solidFill>
-                  <a:srgbClr val="334155"/>
-                </a:solidFill>
-                <a:latin typeface="Arial"/>
-              </a:defRPr>
-            </a:pPr>
-            <a:r>
-              <a:t>• Synthesis: deepseek-v4-flash-free.</a:t>
+              <a:t>• Social + intent: fast flash models.</a:t>
             </a:r>
           </a:p>
           <a:p>
@@ -15225,6 +15161,22 @@
             </a:r>
           </a:p>
           <a:p>
+            <a:pPr>
+              <a:spcAft>
+                <a:spcPts val="400"/>
+              </a:spcAft>
+              <a:defRPr sz="1400" b="1">
+                <a:solidFill>
+                  <a:srgbClr val="0A2540"/>
+                </a:solidFill>
+                <a:latin typeface="Arial"/>
+              </a:defRPr>
+            </a:pPr>
+            <a:r>
+              <a:t>Demo — v2.0 live loop</a:t>
+            </a:r>
+          </a:p>
+          <a:p>
             <a:pPr lvl="1">
               <a:spcAft>
                 <a:spcPts val="400"/>
@@ -15237,23 +15189,7 @@
               </a:defRPr>
             </a:pPr>
             <a:r>
-              <a:t>• constraints.yaml + agentic intent + social decline.</a:t>
-            </a:r>
-          </a:p>
-          <a:p>
-            <a:pPr>
-              <a:spcAft>
-                <a:spcPts val="400"/>
-              </a:spcAft>
-              <a:defRPr sz="1400" b="1">
-                <a:solidFill>
-                  <a:srgbClr val="0A2540"/>
-                </a:solidFill>
-                <a:latin typeface="Arial"/>
-              </a:defRPr>
-            </a:pPr>
-            <a:r>
-              <a:t>Demo (http://127.0.0.1:8090/ui/)</a:t>
+              <a:t>• A: hola → fast social.</a:t>
             </a:r>
           </a:p>
           <a:p>
@@ -15269,7 +15205,7 @@
               </a:defRPr>
             </a:pPr>
             <a:r>
-              <a:t>• A: hola que tal → fast social (no RAG).</a:t>
+              <a:t>• B: gatos/tortugas 20–50€ → 2–3 different bubbles, no repeat.</a:t>
             </a:r>
           </a:p>
           <a:p>
@@ -15285,7 +15221,7 @@
               </a:defRPr>
             </a:pPr>
             <a:r>
-              <a:t>• B: cat food 40–60 EUR → stream status → products.</a:t>
+              <a:t>• C: weather → decline.</a:t>
             </a:r>
           </a:p>
           <a:p>
@@ -15301,23 +15237,7 @@
               </a:defRPr>
             </a:pPr>
             <a:r>
-              <a:t>• C: weather / news → polite decline.</a:t>
-            </a:r>
-          </a:p>
-          <a:p>
-            <a:pPr lvl="1">
-              <a:spcAft>
-                <a:spcPts val="400"/>
-              </a:spcAft>
-              <a:defRPr sz="1400" b="0">
-                <a:solidFill>
-                  <a:srgbClr val="334155"/>
-                </a:solidFill>
-                <a:latin typeface="Arial"/>
-              </a:defRPr>
-            </a:pPr>
-            <a:r>
-              <a:t>• Pick shop 1, 3, or 15 before sending.</a:t>
+              <a:t>• http://127.0.0.1:8090/ui/ — shop Spain (15).</a:t>
             </a:r>
           </a:p>
         </p:txBody>

</xml_diff>

<commit_message>
feat(v2.1): conductor playbook, smart social/catalog ack, multilingual stream
Single MD playbook drives instant ack probe (social vs catalog), dedupe, and
conductor auto-learn. Fixes rigid catalog greeting on hola que tal. ES/EN/DE/FR
shopper language. PPT slides 6-9 and changelog updated.

Co-authored-by: Cursor <cursoragent@cursor.com>
</commit_message>
<xml_diff>
--- a/docs/deliverables/v0.1/zooplus-assistant-interview-15min-pro.pptx
+++ b/docs/deliverables/v0.1/zooplus-assistant-interview-15min-pro.pptx
@@ -12791,7 +12791,7 @@
               </a:defRPr>
             </a:pPr>
             <a:r>
-              <a:t>v2.0 — invisible conductor</a:t>
+              <a:t>v2.1 — conductor playbook (internal)</a:t>
             </a:r>
           </a:p>
           <a:p>
@@ -12807,7 +12807,7 @@
               </a:defRPr>
             </a:pPr>
             <a:r>
-              <a:t>• Strong LLM admin decides each stream tick (JSON actions).</a:t>
+              <a:t>• conductor_playbook.md — species, templates, forbidden phrases.</a:t>
             </a:r>
           </a:p>
           <a:p>
@@ -12823,7 +12823,7 @@
               </a:defRPr>
             </a:pPr>
             <a:r>
-              <a:t>• social-agent voices briefs; shopper never sees conductor.</a:t>
+              <a:t>• Fast lane probe: social vs catalog — no rigid catalog ack on hola.</a:t>
             </a:r>
           </a:p>
           <a:p>
@@ -12839,7 +12839,7 @@
               </a:defRPr>
             </a:pPr>
             <a:r>
-              <a:t>• Anti-repeat: scope disclaimer once, then progress only.</a:t>
+              <a:t>• Auto-learn: conductor appends repeats to playbook (shopper never sees).</a:t>
             </a:r>
           </a:p>
           <a:p>
@@ -12855,7 +12855,7 @@
               </a:defRPr>
             </a:pPr>
             <a:r>
-              <a:t>• Parallel catalog + paced typing/chunks (v1.4 UX kept).</a:t>
+              <a:t>• Catalog lane: instant contextual ack + parallel RAG (ES/EN/DE/FR).</a:t>
             </a:r>
           </a:p>
         </p:txBody>
@@ -13357,7 +13357,7 @@
               </a:defRPr>
             </a:pPr>
             <a:r>
-              <a:t>Invisible conductor (v2.0 official)</a:t>
+              <a:t>Invisible conductor (releases v2.0+)</a:t>
             </a:r>
           </a:p>
           <a:p>
@@ -13373,7 +13373,7 @@
               </a:defRPr>
             </a:pPr>
             <a:r>
-              <a:t>• minimax-m2.7 orchestrator — emit_message | wait | complete.</a:t>
+              <a:t>• Internal MD playbook — conductor maintains silently.</a:t>
             </a:r>
           </a:p>
           <a:p>
@@ -13389,7 +13389,7 @@
               </a:defRPr>
             </a:pPr>
             <a:r>
-              <a:t>• Delegates: social · topic-guard · RAG · logic · synthesis.</a:t>
+              <a:t>• Social turn → one natural bubble (social-agent only).</a:t>
             </a:r>
           </a:p>
           <a:p>
@@ -13405,7 +13405,7 @@
               </a:defRPr>
             </a:pPr>
             <a:r>
-              <a:t>• Each tick: new brief only — no repeated tortuga/gato disclaimers.</a:t>
+              <a:t>• Catalog turn → protocol ack from query (species, price, lang).</a:t>
             </a:r>
           </a:p>
           <a:p>
@@ -13421,7 +13421,7 @@
               </a:defRPr>
             </a:pPr>
             <a:r>
-              <a:t>• ZOOPLUS_STREAM_MODE=conductor (timed = v1.4 fallback).</a:t>
+              <a:t>• Anti-repeat + dedupe final answer vs live chunks.</a:t>
             </a:r>
           </a:p>
           <a:p>
@@ -13437,7 +13437,7 @@
               </a:defRPr>
             </a:pPr>
             <a:r>
-              <a:t>Agentic core (unchanged)</a:t>
+              <a:t>Stream + agentic core</a:t>
             </a:r>
           </a:p>
           <a:p>
@@ -13453,7 +13453,7 @@
               </a:defRPr>
             </a:pPr>
             <a:r>
-              <a:t>• Conductor-first intent before Chroma.</a:t>
+              <a:t>• Intent before Chroma · catalog lexicon from ingest.</a:t>
             </a:r>
           </a:p>
           <a:p>
@@ -13469,7 +13469,7 @@
               </a:defRPr>
             </a:pPr>
             <a:r>
-              <a:t>• Catalog lexicon from ingest; optional Redis + session turns.</a:t>
+              <a:t>• ZOOPLUS_STREAM_MODE=conductor (timed = v1.4 fallback).</a:t>
             </a:r>
           </a:p>
         </p:txBody>
@@ -14257,7 +14257,7 @@
               </a:defRPr>
             </a:pPr>
             <a:r>
-              <a:t>• zooplus-conductor → invisible stream orchestrator (v2.0).</a:t>
+              <a:t>• zooplus-conductor → playbook + stream orchestration (invisible).</a:t>
             </a:r>
           </a:p>
           <a:p>
@@ -14273,7 +14273,7 @@
               </a:defRPr>
             </a:pPr>
             <a:r>
-              <a:t>• social-agent → shopper voice from conductor briefs.</a:t>
+              <a:t>• social-agent → shopper voice; greetings ≠ catalog templates.</a:t>
             </a:r>
           </a:p>
           <a:p>
@@ -14321,7 +14321,7 @@
               </a:defRPr>
             </a:pPr>
             <a:r>
-              <a:t>Per-agent LLMs (OpenCode Go)</a:t>
+              <a:t>Per-agent LLMs + language</a:t>
             </a:r>
           </a:p>
           <a:p>
@@ -14337,7 +14337,7 @@
               </a:defRPr>
             </a:pPr>
             <a:r>
-              <a:t>• Conductor + logic: minimax-m2.7.</a:t>
+              <a:t>• Reply language: query → Accept-Language → shop locale.</a:t>
             </a:r>
           </a:p>
           <a:p>
@@ -14353,23 +14353,7 @@
               </a:defRPr>
             </a:pPr>
             <a:r>
-              <a:t>• Social + intent: fast flash models.</a:t>
-            </a:r>
-          </a:p>
-          <a:p>
-            <a:pPr lvl="1">
-              <a:spcAft>
-                <a:spcPts val="400"/>
-              </a:spcAft>
-              <a:defRPr sz="1300" b="0">
-                <a:solidFill>
-                  <a:srgbClr val="334155"/>
-                </a:solidFill>
-                <a:latin typeface="Arial"/>
-              </a:defRPr>
-            </a:pPr>
-            <a:r>
-              <a:t>• UI badge shows real model from response meta.</a:t>
+              <a:t>• ES · EN · DE · FR supported on stream ack + synthesis.</a:t>
             </a:r>
           </a:p>
         </p:txBody>
@@ -15173,7 +15157,7 @@
               </a:defRPr>
             </a:pPr>
             <a:r>
-              <a:t>Demo — v2.0 live loop</a:t>
+              <a:t>Demo — v2.1 smart loop</a:t>
             </a:r>
           </a:p>
           <a:p>
@@ -15189,7 +15173,7 @@
               </a:defRPr>
             </a:pPr>
             <a:r>
-              <a:t>• A: hola → fast social.</a:t>
+              <a:t>• A: hola que tal → ONE social reply (no catalog chunk).</a:t>
             </a:r>
           </a:p>
           <a:p>
@@ -15205,7 +15189,7 @@
               </a:defRPr>
             </a:pPr>
             <a:r>
-              <a:t>• B: gatos/tortugas 20–50€ → 2–3 different bubbles, no repeat.</a:t>
+              <a:t>• B: hamsters/tortugas/perros 50€ → scoped ack + progress + products.</a:t>
             </a:r>
           </a:p>
           <a:p>
@@ -15221,7 +15205,7 @@
               </a:defRPr>
             </a:pPr>
             <a:r>
-              <a:t>• C: weather → decline.</a:t>
+              <a:t>• C: hello / bonjour — same language as shopper.</a:t>
             </a:r>
           </a:p>
           <a:p>

</xml_diff>

<commit_message>
docs(v2.1.1): PPT release progress slide v0.1.0 to v2.1
Add slide 14 closing the interview deck with milestone timeline from
Coding Task baseline through current releases tag. Patch script is idempotent;
speaker notes updated (Q&A on slide 14).

Co-authored-by: Cursor <cursoragent@cursor.com>
</commit_message>
<xml_diff>
--- a/docs/deliverables/v0.1/zooplus-assistant-interview-15min-pro.pptx
+++ b/docs/deliverables/v0.1/zooplus-assistant-interview-15min-pro.pptx
@@ -18,6 +18,7 @@
     <p:sldId id="264" r:id="rId16"/>
     <p:sldId id="265" r:id="rId17"/>
     <p:sldId id="266" r:id="rId18"/>
+    <p:sldId id="269" r:id="rId21"/>
   </p:sldIdLst>
   <p:sldSz cx="12191695" cy="6858000" type="screen4x3"/>
   <p:notesSz cx="6858000" cy="9144000"/>
@@ -8036,6 +8037,808 @@
             </a:pPr>
             <a:r>
               <a:t>13</a:t>
+            </a:r>
+          </a:p>
+        </p:txBody>
+      </p:sp>
+    </p:spTree>
+  </p:cSld>
+  <p:clrMapOvr>
+    <a:masterClrMapping/>
+  </p:clrMapOvr>
+</p:sld>
+</file>
+
+<file path=ppt/slides/slide14.xml><?xml version="1.0" encoding="utf-8"?>
+<p:sld xmlns:a="http://schemas.openxmlformats.org/drawingml/2006/main" xmlns:p="http://schemas.openxmlformats.org/presentationml/2006/main" xmlns:r="http://schemas.openxmlformats.org/officeDocument/2006/relationships">
+  <p:cSld>
+    <p:spTree>
+      <p:nvGrpSpPr>
+        <p:cNvPr id="1" name=""/>
+        <p:cNvGrpSpPr/>
+        <p:nvPr/>
+      </p:nvGrpSpPr>
+      <p:grpSpPr/>
+      <p:sp>
+        <p:nvSpPr>
+          <p:cNvPr id="2" name="Rectangle 1"/>
+          <p:cNvSpPr/>
+          <p:nvPr/>
+        </p:nvSpPr>
+        <p:spPr>
+          <a:xfrm>
+            <a:off x="429768" y="0"/>
+            <a:ext cx="11761927" cy="6858000"/>
+          </a:xfrm>
+          <a:prstGeom prst="rect">
+            <a:avLst/>
+          </a:prstGeom>
+          <a:solidFill>
+            <a:srgbClr val="FFFFFF"/>
+          </a:solidFill>
+          <a:ln>
+            <a:noFill/>
+          </a:ln>
+        </p:spPr>
+        <p:style>
+          <a:lnRef idx="1">
+            <a:schemeClr val="accent1"/>
+          </a:lnRef>
+          <a:fillRef idx="3">
+            <a:schemeClr val="accent1"/>
+          </a:fillRef>
+          <a:effectRef idx="2">
+            <a:schemeClr val="accent1"/>
+          </a:effectRef>
+          <a:fontRef idx="minor">
+            <a:schemeClr val="lt1"/>
+          </a:fontRef>
+        </p:style>
+        <p:txBody>
+          <a:bodyPr rtlCol="0" anchor="ctr"/>
+          <a:lstStyle/>
+          <a:p>
+            <a:pPr algn="ctr"/>
+          </a:p>
+        </p:txBody>
+      </p:sp>
+      <p:sp>
+        <p:nvSpPr>
+          <p:cNvPr id="3" name="Rectangle 2"/>
+          <p:cNvSpPr/>
+          <p:nvPr/>
+        </p:nvSpPr>
+        <p:spPr>
+          <a:xfrm>
+            <a:off x="0" y="0"/>
+            <a:ext cx="384048" cy="6858000"/>
+          </a:xfrm>
+          <a:prstGeom prst="rect">
+            <a:avLst/>
+          </a:prstGeom>
+          <a:solidFill>
+            <a:srgbClr val="0A2540"/>
+          </a:solidFill>
+          <a:ln>
+            <a:noFill/>
+          </a:ln>
+        </p:spPr>
+        <p:style>
+          <a:lnRef idx="1">
+            <a:schemeClr val="accent1"/>
+          </a:lnRef>
+          <a:fillRef idx="3">
+            <a:schemeClr val="accent1"/>
+          </a:fillRef>
+          <a:effectRef idx="2">
+            <a:schemeClr val="accent1"/>
+          </a:effectRef>
+          <a:fontRef idx="minor">
+            <a:schemeClr val="lt1"/>
+          </a:fontRef>
+        </p:style>
+        <p:txBody>
+          <a:bodyPr rtlCol="0" anchor="ctr"/>
+          <a:lstStyle/>
+          <a:p>
+            <a:pPr algn="ctr"/>
+          </a:p>
+        </p:txBody>
+      </p:sp>
+      <p:sp>
+        <p:nvSpPr>
+          <p:cNvPr id="4" name="Rectangle 3"/>
+          <p:cNvSpPr/>
+          <p:nvPr/>
+        </p:nvSpPr>
+        <p:spPr>
+          <a:xfrm>
+            <a:off x="384048" y="0"/>
+            <a:ext cx="45720" cy="6858000"/>
+          </a:xfrm>
+          <a:prstGeom prst="rect">
+            <a:avLst/>
+          </a:prstGeom>
+          <a:solidFill>
+            <a:srgbClr val="2563EB"/>
+          </a:solidFill>
+          <a:ln>
+            <a:noFill/>
+          </a:ln>
+        </p:spPr>
+        <p:style>
+          <a:lnRef idx="1">
+            <a:schemeClr val="accent1"/>
+          </a:lnRef>
+          <a:fillRef idx="3">
+            <a:schemeClr val="accent1"/>
+          </a:fillRef>
+          <a:effectRef idx="2">
+            <a:schemeClr val="accent1"/>
+          </a:effectRef>
+          <a:fontRef idx="minor">
+            <a:schemeClr val="lt1"/>
+          </a:fontRef>
+        </p:style>
+        <p:txBody>
+          <a:bodyPr rtlCol="0" anchor="ctr"/>
+          <a:lstStyle/>
+          <a:p>
+            <a:pPr algn="ctr"/>
+          </a:p>
+        </p:txBody>
+      </p:sp>
+      <p:sp>
+        <p:nvSpPr>
+          <p:cNvPr id="5" name="Rectangle 4"/>
+          <p:cNvSpPr/>
+          <p:nvPr/>
+        </p:nvSpPr>
+        <p:spPr>
+          <a:xfrm>
+            <a:off x="429768" y="0"/>
+            <a:ext cx="11761927" cy="1115568"/>
+          </a:xfrm>
+          <a:prstGeom prst="rect">
+            <a:avLst/>
+          </a:prstGeom>
+          <a:solidFill>
+            <a:srgbClr val="0A2540"/>
+          </a:solidFill>
+          <a:ln>
+            <a:noFill/>
+          </a:ln>
+        </p:spPr>
+        <p:style>
+          <a:lnRef idx="1">
+            <a:schemeClr val="accent1"/>
+          </a:lnRef>
+          <a:fillRef idx="3">
+            <a:schemeClr val="accent1"/>
+          </a:fillRef>
+          <a:effectRef idx="2">
+            <a:schemeClr val="accent1"/>
+          </a:effectRef>
+          <a:fontRef idx="minor">
+            <a:schemeClr val="lt1"/>
+          </a:fontRef>
+        </p:style>
+        <p:txBody>
+          <a:bodyPr rtlCol="0" anchor="ctr"/>
+          <a:lstStyle/>
+          <a:p>
+            <a:pPr algn="ctr"/>
+          </a:p>
+        </p:txBody>
+      </p:sp>
+      <p:sp>
+        <p:nvSpPr>
+          <p:cNvPr id="6" name="Rectangle 5"/>
+          <p:cNvSpPr/>
+          <p:nvPr/>
+        </p:nvSpPr>
+        <p:spPr>
+          <a:xfrm>
+            <a:off x="429768" y="1115568"/>
+            <a:ext cx="11761927" cy="54864"/>
+          </a:xfrm>
+          <a:prstGeom prst="rect">
+            <a:avLst/>
+          </a:prstGeom>
+          <a:solidFill>
+            <a:srgbClr val="2563EB"/>
+          </a:solidFill>
+          <a:ln>
+            <a:noFill/>
+          </a:ln>
+        </p:spPr>
+        <p:style>
+          <a:lnRef idx="1">
+            <a:schemeClr val="accent1"/>
+          </a:lnRef>
+          <a:fillRef idx="3">
+            <a:schemeClr val="accent1"/>
+          </a:fillRef>
+          <a:effectRef idx="2">
+            <a:schemeClr val="accent1"/>
+          </a:effectRef>
+          <a:fontRef idx="minor">
+            <a:schemeClr val="lt1"/>
+          </a:fontRef>
+        </p:style>
+        <p:txBody>
+          <a:bodyPr rtlCol="0" anchor="ctr"/>
+          <a:lstStyle/>
+          <a:p>
+            <a:pPr algn="ctr"/>
+          </a:p>
+        </p:txBody>
+      </p:sp>
+      <p:sp>
+        <p:nvSpPr>
+          <p:cNvPr id="7" name="Rectangle 6"/>
+          <p:cNvSpPr/>
+          <p:nvPr/>
+        </p:nvSpPr>
+        <p:spPr>
+          <a:xfrm>
+            <a:off x="429768" y="6419088"/>
+            <a:ext cx="11761927" cy="438912"/>
+          </a:xfrm>
+          <a:prstGeom prst="rect">
+            <a:avLst/>
+          </a:prstGeom>
+          <a:solidFill>
+            <a:srgbClr val="0A2540"/>
+          </a:solidFill>
+          <a:ln>
+            <a:noFill/>
+          </a:ln>
+        </p:spPr>
+        <p:style>
+          <a:lnRef idx="1">
+            <a:schemeClr val="accent1"/>
+          </a:lnRef>
+          <a:fillRef idx="3">
+            <a:schemeClr val="accent1"/>
+          </a:fillRef>
+          <a:effectRef idx="2">
+            <a:schemeClr val="accent1"/>
+          </a:effectRef>
+          <a:fontRef idx="minor">
+            <a:schemeClr val="lt1"/>
+          </a:fontRef>
+        </p:style>
+        <p:txBody>
+          <a:bodyPr rtlCol="0" anchor="ctr"/>
+          <a:lstStyle/>
+          <a:p>
+            <a:pPr algn="ctr"/>
+          </a:p>
+        </p:txBody>
+      </p:sp>
+      <p:sp>
+        <p:nvSpPr>
+          <p:cNvPr id="8" name="Rectangle 7"/>
+          <p:cNvSpPr/>
+          <p:nvPr/>
+        </p:nvSpPr>
+        <p:spPr>
+          <a:xfrm>
+            <a:off x="0" y="0"/>
+            <a:ext cx="384048" cy="6858000"/>
+          </a:xfrm>
+          <a:prstGeom prst="rect">
+            <a:avLst/>
+          </a:prstGeom>
+          <a:solidFill>
+            <a:srgbClr val="0A2540"/>
+          </a:solidFill>
+          <a:ln>
+            <a:noFill/>
+          </a:ln>
+        </p:spPr>
+        <p:style>
+          <a:lnRef idx="1">
+            <a:schemeClr val="accent1"/>
+          </a:lnRef>
+          <a:fillRef idx="3">
+            <a:schemeClr val="accent1"/>
+          </a:fillRef>
+          <a:effectRef idx="2">
+            <a:schemeClr val="accent1"/>
+          </a:effectRef>
+          <a:fontRef idx="minor">
+            <a:schemeClr val="lt1"/>
+          </a:fontRef>
+        </p:style>
+        <p:txBody>
+          <a:bodyPr rtlCol="0" anchor="ctr"/>
+          <a:lstStyle/>
+          <a:p>
+            <a:pPr algn="ctr"/>
+          </a:p>
+        </p:txBody>
+      </p:sp>
+      <p:sp>
+        <p:nvSpPr>
+          <p:cNvPr id="9" name="Rectangle 8"/>
+          <p:cNvSpPr/>
+          <p:nvPr/>
+        </p:nvSpPr>
+        <p:spPr>
+          <a:xfrm>
+            <a:off x="384048" y="0"/>
+            <a:ext cx="45720" cy="6858000"/>
+          </a:xfrm>
+          <a:prstGeom prst="rect">
+            <a:avLst/>
+          </a:prstGeom>
+          <a:solidFill>
+            <a:srgbClr val="2563EB"/>
+          </a:solidFill>
+          <a:ln>
+            <a:noFill/>
+          </a:ln>
+        </p:spPr>
+        <p:style>
+          <a:lnRef idx="1">
+            <a:schemeClr val="accent1"/>
+          </a:lnRef>
+          <a:fillRef idx="3">
+            <a:schemeClr val="accent1"/>
+          </a:fillRef>
+          <a:effectRef idx="2">
+            <a:schemeClr val="accent1"/>
+          </a:effectRef>
+          <a:fontRef idx="minor">
+            <a:schemeClr val="lt1"/>
+          </a:fontRef>
+        </p:style>
+        <p:txBody>
+          <a:bodyPr rtlCol="0" anchor="ctr"/>
+          <a:lstStyle/>
+          <a:p>
+            <a:pPr algn="ctr"/>
+          </a:p>
+        </p:txBody>
+      </p:sp>
+      <p:sp>
+        <p:nvSpPr>
+          <p:cNvPr id="10" name="TextBox 9"/>
+          <p:cNvSpPr txBox="1"/>
+          <p:nvPr/>
+        </p:nvSpPr>
+        <p:spPr>
+          <a:xfrm>
+            <a:off x="658368" y="182880"/>
+            <a:ext cx="9144000" cy="566928"/>
+          </a:xfrm>
+          <a:prstGeom prst="rect">
+            <a:avLst/>
+          </a:prstGeom>
+          <a:noFill/>
+        </p:spPr>
+        <p:txBody>
+          <a:bodyPr wrap="square" anchor="t">
+            <a:spAutoFit/>
+          </a:bodyPr>
+          <a:lstStyle/>
+          <a:p>
+            <a:pPr algn="l">
+              <a:defRPr sz="3400" b="1">
+                <a:solidFill>
+                  <a:srgbClr val="FFFFFF"/>
+                </a:solidFill>
+                <a:latin typeface="Arial"/>
+              </a:defRPr>
+            </a:pPr>
+            <a:r>
+              <a:t>Release progress — v0.1.0 → v2.1</a:t>
+            </a:r>
+          </a:p>
+        </p:txBody>
+      </p:sp>
+      <p:sp>
+        <p:nvSpPr>
+          <p:cNvPr id="11" name="TextBox 10"/>
+          <p:cNvSpPr txBox="1"/>
+          <p:nvPr/>
+        </p:nvSpPr>
+        <p:spPr>
+          <a:xfrm>
+            <a:off x="658368" y="713232"/>
+            <a:ext cx="8046720" cy="347472"/>
+          </a:xfrm>
+          <a:prstGeom prst="rect">
+            <a:avLst/>
+          </a:prstGeom>
+          <a:noFill/>
+        </p:spPr>
+        <p:txBody>
+          <a:bodyPr wrap="square" anchor="t">
+            <a:spAutoFit/>
+          </a:bodyPr>
+          <a:lstStyle/>
+          <a:p>
+            <a:pPr algn="l">
+              <a:defRPr sz="1700" b="0">
+                <a:solidFill>
+                  <a:srgbClr val="BFDBFE"/>
+                </a:solidFill>
+                <a:latin typeface="Arial"/>
+              </a:defRPr>
+            </a:pPr>
+            <a:r>
+              <a:t>Same five FRs · stronger agentic orchestration and live shopper UX</a:t>
+            </a:r>
+          </a:p>
+        </p:txBody>
+      </p:sp>
+      <p:sp>
+        <p:nvSpPr>
+          <p:cNvPr id="12" name="Rectangle 11"/>
+          <p:cNvSpPr/>
+          <p:nvPr/>
+        </p:nvSpPr>
+        <p:spPr>
+          <a:xfrm>
+            <a:off x="10241280" y="292608"/>
+            <a:ext cx="1600200" cy="438912"/>
+          </a:xfrm>
+          <a:prstGeom prst="rect">
+            <a:avLst/>
+          </a:prstGeom>
+          <a:solidFill>
+            <a:srgbClr val="2563EB"/>
+          </a:solidFill>
+          <a:ln>
+            <a:noFill/>
+          </a:ln>
+        </p:spPr>
+        <p:style>
+          <a:lnRef idx="1">
+            <a:schemeClr val="accent1"/>
+          </a:lnRef>
+          <a:fillRef idx="3">
+            <a:schemeClr val="accent1"/>
+          </a:fillRef>
+          <a:effectRef idx="2">
+            <a:schemeClr val="accent1"/>
+          </a:effectRef>
+          <a:fontRef idx="minor">
+            <a:schemeClr val="lt1"/>
+          </a:fontRef>
+        </p:style>
+        <p:txBody>
+          <a:bodyPr rtlCol="0" anchor="ctr"/>
+          <a:lstStyle/>
+          <a:p>
+            <a:pPr algn="ctr"/>
+          </a:p>
+        </p:txBody>
+      </p:sp>
+      <p:sp>
+        <p:nvSpPr>
+          <p:cNvPr id="13" name="TextBox 12"/>
+          <p:cNvSpPr txBox="1"/>
+          <p:nvPr/>
+        </p:nvSpPr>
+        <p:spPr>
+          <a:xfrm>
+            <a:off x="10314432" y="347472"/>
+            <a:ext cx="1463040" cy="365760"/>
+          </a:xfrm>
+          <a:prstGeom prst="rect">
+            <a:avLst/>
+          </a:prstGeom>
+          <a:noFill/>
+        </p:spPr>
+        <p:txBody>
+          <a:bodyPr wrap="square" anchor="t">
+            <a:spAutoFit/>
+          </a:bodyPr>
+          <a:lstStyle/>
+          <a:p>
+            <a:pPr algn="ctr">
+              <a:defRPr sz="1300" b="1">
+                <a:solidFill>
+                  <a:srgbClr val="FFFFFF"/>
+                </a:solidFill>
+                <a:latin typeface="Arial"/>
+              </a:defRPr>
+            </a:pPr>
+            <a:r>
+              <a:t>Progress · releases</a:t>
+            </a:r>
+          </a:p>
+        </p:txBody>
+      </p:sp>
+      <p:sp>
+        <p:nvSpPr>
+          <p:cNvPr id="14" name="TextBox 13"/>
+          <p:cNvSpPr txBox="1"/>
+          <p:nvPr/>
+        </p:nvSpPr>
+        <p:spPr>
+          <a:xfrm>
+            <a:off x="658368" y="6492240"/>
+            <a:ext cx="9326880" cy="329184"/>
+          </a:xfrm>
+          <a:prstGeom prst="rect">
+            <a:avLst/>
+          </a:prstGeom>
+          <a:noFill/>
+        </p:spPr>
+        <p:txBody>
+          <a:bodyPr wrap="square" anchor="t">
+            <a:spAutoFit/>
+          </a:bodyPr>
+          <a:lstStyle/>
+          <a:p>
+            <a:pPr algn="l">
+              <a:defRPr sz="1200" b="0">
+                <a:solidFill>
+                  <a:srgbClr val="BFDBFE"/>
+                </a:solidFill>
+                <a:latin typeface="Arial"/>
+              </a:defRPr>
+            </a:pPr>
+            <a:r>
+              <a:t>zooplus Assistant — releases v2.1 · progress since v0.1.0</a:t>
+            </a:r>
+          </a:p>
+        </p:txBody>
+      </p:sp>
+      <p:sp>
+        <p:nvSpPr>
+          <p:cNvPr id="15" name="TextBox 14"/>
+          <p:cNvSpPr txBox="1"/>
+          <p:nvPr/>
+        </p:nvSpPr>
+        <p:spPr>
+          <a:xfrm>
+            <a:off x="11155680" y="6473952"/>
+            <a:ext cx="868680" cy="329184"/>
+          </a:xfrm>
+          <a:prstGeom prst="rect">
+            <a:avLst/>
+          </a:prstGeom>
+          <a:noFill/>
+        </p:spPr>
+        <p:txBody>
+          <a:bodyPr wrap="square" anchor="t">
+            <a:spAutoFit/>
+          </a:bodyPr>
+          <a:lstStyle/>
+          <a:p>
+            <a:pPr algn="l">
+              <a:defRPr sz="1500" b="1">
+                <a:solidFill>
+                  <a:srgbClr val="FFFFFF"/>
+                </a:solidFill>
+                <a:latin typeface="Arial"/>
+              </a:defRPr>
+            </a:pPr>
+            <a:r>
+              <a:t>14</a:t>
+            </a:r>
+          </a:p>
+        </p:txBody>
+      </p:sp>
+      <p:sp>
+        <p:nvSpPr>
+          <p:cNvPr id="16" name="Rectangle 15"/>
+          <p:cNvSpPr/>
+          <p:nvPr/>
+        </p:nvSpPr>
+        <p:spPr>
+          <a:xfrm>
+            <a:off x="585216" y="1261872"/>
+            <a:ext cx="10972800" cy="4983480"/>
+          </a:xfrm>
+          <a:prstGeom prst="rect">
+            <a:avLst/>
+          </a:prstGeom>
+          <a:solidFill>
+            <a:srgbClr val="F8FAFC"/>
+          </a:solidFill>
+          <a:ln>
+            <a:noFill/>
+          </a:ln>
+        </p:spPr>
+        <p:style>
+          <a:lnRef idx="1">
+            <a:schemeClr val="accent1"/>
+          </a:lnRef>
+          <a:fillRef idx="3">
+            <a:schemeClr val="accent1"/>
+          </a:fillRef>
+          <a:effectRef idx="2">
+            <a:schemeClr val="accent1"/>
+          </a:effectRef>
+          <a:fontRef idx="minor">
+            <a:schemeClr val="lt1"/>
+          </a:fontRef>
+        </p:style>
+        <p:txBody>
+          <a:bodyPr rtlCol="0" anchor="ctr"/>
+          <a:lstStyle/>
+          <a:p>
+            <a:pPr algn="ctr"/>
+          </a:p>
+        </p:txBody>
+      </p:sp>
+      <p:sp>
+        <p:nvSpPr>
+          <p:cNvPr id="17" name="TextBox 16"/>
+          <p:cNvSpPr txBox="1"/>
+          <p:nvPr/>
+        </p:nvSpPr>
+        <p:spPr>
+          <a:xfrm>
+            <a:off x="749808" y="1417320"/>
+            <a:ext cx="5349240" cy="4663440"/>
+          </a:xfrm>
+          <a:prstGeom prst="rect">
+            <a:avLst/>
+          </a:prstGeom>
+          <a:noFill/>
+        </p:spPr>
+        <p:txBody>
+          <a:bodyPr wrap="square" anchor="t">
+            <a:spAutoFit/>
+          </a:bodyPr>
+          <a:lstStyle/>
+          <a:p>
+            <a:pPr>
+              <a:spcAft>
+                <a:spcPts val="600"/>
+              </a:spcAft>
+              <a:defRPr sz="1500" b="1">
+                <a:solidFill>
+                  <a:srgbClr val="0A2540"/>
+                </a:solidFill>
+                <a:latin typeface="Arial"/>
+              </a:defRPr>
+            </a:pPr>
+            <a:r>
+              <a:t>Foundation — v0.1.0 → v1.0</a:t>
+            </a:r>
+          </a:p>
+          <a:p>
+            <a:pPr>
+              <a:spcAft>
+                <a:spcPts val="600"/>
+              </a:spcAft>
+              <a:defRPr sz="1500" b="0">
+                <a:solidFill>
+                  <a:srgbClr val="334155"/>
+                </a:solidFill>
+                <a:latin typeface="Arial"/>
+              </a:defRPr>
+            </a:pPr>
+            <a:r>
+              <a:t>v0.1.0 — Coding Task PoC: FR1–5, hybrid RAG, FR4 guardrails.</a:t>
+            </a:r>
+          </a:p>
+          <a:p>
+            <a:pPr>
+              <a:spcAft>
+                <a:spcPts val="600"/>
+              </a:spcAft>
+              <a:defRPr sz="1500" b="0">
+                <a:solidFill>
+                  <a:srgbClr val="334155"/>
+                </a:solidFill>
+                <a:latin typeface="Arial"/>
+              </a:defRPr>
+            </a:pPr>
+            <a:r>
+              <a:t>v0.1.3 — Conductor-first routing; /chat/stream; per-agent OpenCode.</a:t>
+            </a:r>
+          </a:p>
+          <a:p>
+            <a:pPr>
+              <a:spcAft>
+                <a:spcPts val="600"/>
+              </a:spcAft>
+              <a:defRPr sz="1500" b="0">
+                <a:solidFill>
+                  <a:srgbClr val="334155"/>
+                </a:solidFill>
+                <a:latin typeface="Arial"/>
+              </a:defRPr>
+            </a:pPr>
+            <a:r>
+              <a:t>v1.0 — Stable tag: catalog lexicon at ingest, cache, multilingual.</a:t>
+            </a:r>
+          </a:p>
+        </p:txBody>
+      </p:sp>
+      <p:sp>
+        <p:nvSpPr>
+          <p:cNvPr id="18" name="TextBox 17"/>
+          <p:cNvSpPr txBox="1"/>
+          <p:nvPr/>
+        </p:nvSpPr>
+        <p:spPr>
+          <a:xfrm>
+            <a:off x="6126480" y="1417320"/>
+            <a:ext cx="5257800" cy="4663440"/>
+          </a:xfrm>
+          <a:prstGeom prst="rect">
+            <a:avLst/>
+          </a:prstGeom>
+          <a:noFill/>
+        </p:spPr>
+        <p:txBody>
+          <a:bodyPr wrap="square" anchor="t">
+            <a:spAutoFit/>
+          </a:bodyPr>
+          <a:lstStyle/>
+          <a:p>
+            <a:pPr>
+              <a:spcAft>
+                <a:spcPts val="600"/>
+              </a:spcAft>
+              <a:defRPr sz="1500" b="1">
+                <a:solidFill>
+                  <a:srgbClr val="0A2540"/>
+                </a:solidFill>
+                <a:latin typeface="Arial"/>
+              </a:defRPr>
+            </a:pPr>
+            <a:r>
+              <a:t>Shopper experience — v1.4 → v2.1 (now)</a:t>
+            </a:r>
+          </a:p>
+          <a:p>
+            <a:pPr>
+              <a:spcAft>
+                <a:spcPts val="600"/>
+              </a:spcAft>
+              <a:defRPr sz="1500" b="0">
+                <a:solidFill>
+                  <a:srgbClr val="334155"/>
+                </a:solidFill>
+                <a:latin typeface="Arial"/>
+              </a:defRPr>
+            </a:pPr>
+            <a:r>
+              <a:t>v1.4 — Live loop: timed chunks, parallel catalog, typing pace.</a:t>
+            </a:r>
+          </a:p>
+          <a:p>
+            <a:pPr>
+              <a:spcAft>
+                <a:spcPts val="600"/>
+              </a:spcAft>
+              <a:defRPr sz="1500" b="0">
+                <a:solidFill>
+                  <a:srgbClr val="334155"/>
+                </a:solidFill>
+                <a:latin typeface="Arial"/>
+              </a:defRPr>
+            </a:pPr>
+            <a:r>
+              <a:t>v2.0 — Invisible conductor; brief-driven ticks; anti-repeat scope.</a:t>
+            </a:r>
+          </a:p>
+          <a:p>
+            <a:pPr>
+              <a:spcAft>
+                <a:spcPts val="600"/>
+              </a:spcAft>
+              <a:defRPr sz="1500" b="0">
+                <a:solidFill>
+                  <a:srgbClr val="334155"/>
+                </a:solidFill>
+                <a:latin typeface="Arial"/>
+              </a:defRPr>
+            </a:pPr>
+            <a:r>
+              <a:t>v2.1 — Playbook MD; social vs catalog probe; ES · EN · DE · FR.</a:t>
             </a:r>
           </a:p>
         </p:txBody>

</xml_diff>

<commit_message>
docs(v2.1.2): agent-driven multilingual — not a fixed locale list
PPT slides 6/8/9/14 and speaker notes: language is handled by OpenCode
agents from shopper context, not limited to ES/EN/DE/FR.

Co-authored-by: Cursor <cursoragent@cursor.com>
</commit_message>
<xml_diff>
--- a/docs/deliverables/v0.1/zooplus-assistant-interview-15min-pro.pptx
+++ b/docs/deliverables/v0.1/zooplus-assistant-interview-15min-pro.pptx
@@ -8838,7 +8838,7 @@
               </a:defRPr>
             </a:pPr>
             <a:r>
-              <a:t>v2.1 — Playbook MD; social vs catalog probe; ES · EN · DE · FR.</a:t>
+              <a:t>v2.1 — Playbook MD; social vs catalog probe; agent-multilingual.</a:t>
             </a:r>
           </a:p>
         </p:txBody>
@@ -13658,7 +13658,7 @@
               </a:defRPr>
             </a:pPr>
             <a:r>
-              <a:t>• Catalog lane: instant contextual ack + parallel RAG (ES/EN/DE/FR).</a:t>
+              <a:t>• Catalog lane: instant contextual ack + parallel RAG (shopper language).</a:t>
             </a:r>
           </a:p>
         </p:txBody>
@@ -15140,7 +15140,7 @@
               </a:defRPr>
             </a:pPr>
             <a:r>
-              <a:t>• Reply language: query → Accept-Language → shop locale.</a:t>
+              <a:t>• Reply language: agent mirrors shopper (query · headers · shop).</a:t>
             </a:r>
           </a:p>
           <a:p>
@@ -15156,7 +15156,7 @@
               </a:defRPr>
             </a:pPr>
             <a:r>
-              <a:t>• ES · EN · DE · FR supported on stream ack + synthesis.</a:t>
+              <a:t>• No fixed locale list — OpenCode agents handle any language.</a:t>
             </a:r>
           </a:p>
         </p:txBody>
@@ -16008,7 +16008,7 @@
               </a:defRPr>
             </a:pPr>
             <a:r>
-              <a:t>• C: hello / bonjour — same language as shopper.</a:t>
+              <a:t>• C: any-language greeting — agent replies in kind.</a:t>
             </a:r>
           </a:p>
           <a:p>

</xml_diff>

<commit_message>
feat(v2.1.6): social help routing, dynamic picks, phrase index, and PPT update
Co-authored-by: Cursor <cursoragent@cursor.com>
</commit_message>
<xml_diff>
--- a/docs/deliverables/v0.1/zooplus-assistant-interview-15min-pro.pptx
+++ b/docs/deliverables/v0.1/zooplus-assistant-interview-15min-pro.pptx
@@ -8434,7 +8434,7 @@
               </a:defRPr>
             </a:pPr>
             <a:r>
-              <a:t>Release progress — v0.1.0 → v2.1</a:t>
+              <a:t>Release progress — v0.1.0 → v2.1.6</a:t>
             </a:r>
           </a:p>
         </p:txBody>
@@ -8470,7 +8470,7 @@
               </a:defRPr>
             </a:pPr>
             <a:r>
-              <a:t>Same five FRs · stronger agentic orchestration and live shopper UX</a:t>
+              <a:t>Same five FRs · smarter social routing, flexible picks, chunked UX</a:t>
             </a:r>
           </a:p>
         </p:txBody>
@@ -8585,7 +8585,7 @@
               </a:defRPr>
             </a:pPr>
             <a:r>
-              <a:t>zooplus Assistant — releases v2.1 · progress since v0.1.0</a:t>
+              <a:t>zooplus Assistant — releases v2.1.6 · progress since v0.1.0</a:t>
             </a:r>
           </a:p>
         </p:txBody>
@@ -8790,7 +8790,7 @@
               </a:defRPr>
             </a:pPr>
             <a:r>
-              <a:t>Shopper experience — v1.4 → v2.1 (now)</a:t>
+              <a:t>Shopper experience — v1.4 → v2.1.6 (now)</a:t>
             </a:r>
           </a:p>
           <a:p>
@@ -8806,7 +8806,7 @@
               </a:defRPr>
             </a:pPr>
             <a:r>
-              <a:t>v1.4 — Live loop: timed chunks, parallel catalog, typing pace.</a:t>
+              <a:t>v2.1 — Playbook MD; social/catalog probe; agent-multilingual.</a:t>
             </a:r>
           </a:p>
           <a:p>
@@ -8822,7 +8822,7 @@
               </a:defRPr>
             </a:pPr>
             <a:r>
-              <a:t>v2.0 — Invisible conductor; brief-driven ticks; anti-repeat scope.</a:t>
+              <a:t>v2.1.3 — Fast intent-first stream; conductor intent opt-in.</a:t>
             </a:r>
           </a:p>
           <a:p>
@@ -8838,7 +8838,23 @@
               </a:defRPr>
             </a:pPr>
             <a:r>
-              <a:t>v2.1 — Playbook MD; social vs catalog probe; agent-multilingual.</a:t>
+              <a:t>v2.1.4–5 — Species inference; help/saludo detect + dedupe.</a:t>
+            </a:r>
+          </a:p>
+          <a:p>
+            <a:pPr>
+              <a:spcAft>
+                <a:spcPts val="600"/>
+              </a:spcAft>
+              <a:defRPr sz="1500" b="0">
+                <a:solidFill>
+                  <a:srgbClr val="334155"/>
+                </a:solidFill>
+                <a:latin typeface="Arial"/>
+              </a:defRPr>
+            </a:pPr>
+            <a:r>
+              <a:t>v2.1.6 — Dynamic count (4→20); phrase index; product_batch UI.</a:t>
             </a:r>
           </a:p>
         </p:txBody>
@@ -13594,7 +13610,7 @@
               </a:defRPr>
             </a:pPr>
             <a:r>
-              <a:t>v2.1 — conductor playbook (internal)</a:t>
+              <a:t>v2.1.6 — playbook + smart limits</a:t>
             </a:r>
           </a:p>
           <a:p>
@@ -13610,7 +13626,7 @@
               </a:defRPr>
             </a:pPr>
             <a:r>
-              <a:t>• conductor_playbook.md — species, templates, forbidden phrases.</a:t>
+              <a:t>• 4 picks default · shopper can ask for more (e.g. 10 opciones, cap 20).</a:t>
             </a:r>
           </a:p>
           <a:p>
@@ -13626,7 +13642,7 @@
               </a:defRPr>
             </a:pPr>
             <a:r>
-              <a:t>• Fast lane probe: social vs catalog — no rigid catalog ack on hola.</a:t>
+              <a:t>• product_batch stream — cards arrive in chunks of 4 in the UI.</a:t>
             </a:r>
           </a:p>
           <a:p>
@@ -13642,7 +13658,7 @@
               </a:defRPr>
             </a:pPr>
             <a:r>
-              <a:t>• Auto-learn: conductor appends repeats to playbook (shopper never sees).</a:t>
+              <a:t>• social_phrases.yaml index + playbook auto-learn (help/greeting).</a:t>
             </a:r>
           </a:p>
           <a:p>
@@ -13658,7 +13674,7 @@
               </a:defRPr>
             </a:pPr>
             <a:r>
-              <a:t>• Catalog lane: instant contextual ack + parallel RAG (shopper language).</a:t>
+              <a:t>• Dynamic species inference (iguana, capibara…) — not a fixed list.</a:t>
             </a:r>
           </a:p>
         </p:txBody>
@@ -14192,7 +14208,7 @@
               </a:defRPr>
             </a:pPr>
             <a:r>
-              <a:t>• Social turn → one natural bubble (social-agent only).</a:t>
+              <a:t>• Social turn → one bubble; help asks never hit catalog progress.</a:t>
             </a:r>
           </a:p>
           <a:p>
@@ -14208,7 +14224,7 @@
               </a:defRPr>
             </a:pPr>
             <a:r>
-              <a:t>• Catalog turn → protocol ack from query (species, price, lang).</a:t>
+              <a:t>• Catalog turn → ack from query (species, price, lang, count).</a:t>
             </a:r>
           </a:p>
           <a:p>
@@ -14224,7 +14240,7 @@
               </a:defRPr>
             </a:pPr>
             <a:r>
-              <a:t>• Anti-repeat + dedupe final answer vs live chunks.</a:t>
+              <a:t>• Dedupe: no re-greeting / no repeated scope in final answer.</a:t>
             </a:r>
           </a:p>
           <a:p>
@@ -14240,7 +14256,7 @@
               </a:defRPr>
             </a:pPr>
             <a:r>
-              <a:t>Stream + agentic core</a:t>
+              <a:t>Stream + fast intent (v2.1.3+)</a:t>
             </a:r>
           </a:p>
           <a:p>
@@ -14256,7 +14272,7 @@
               </a:defRPr>
             </a:pPr>
             <a:r>
-              <a:t>• Intent before Chroma · catalog lexicon from ingest.</a:t>
+              <a:t>• Policy + intent-agent first; conductor opt-in (lower latency).</a:t>
             </a:r>
           </a:p>
           <a:p>
@@ -14272,7 +14288,7 @@
               </a:defRPr>
             </a:pPr>
             <a:r>
-              <a:t>• ZOOPLUS_STREAM_MODE=conductor (timed = v1.4 fallback).</a:t>
+              <a:t>• Parallel social/catalog · ZOOPLUS_STREAM_MODE=conductor.</a:t>
             </a:r>
           </a:p>
         </p:txBody>
@@ -15076,7 +15092,7 @@
               </a:defRPr>
             </a:pPr>
             <a:r>
-              <a:t>• social-agent → shopper voice; greetings ≠ catalog templates.</a:t>
+              <a:t>• social-agent → shopper voice; mid-session help without re-intro.</a:t>
             </a:r>
           </a:p>
           <a:p>
@@ -15124,7 +15140,7 @@
               </a:defRPr>
             </a:pPr>
             <a:r>
-              <a:t>Per-agent LLMs + language</a:t>
+              <a:t>Phrase index + language</a:t>
             </a:r>
           </a:p>
           <a:p>
@@ -15140,7 +15156,7 @@
               </a:defRPr>
             </a:pPr>
             <a:r>
-              <a:t>• Reply language: agent mirrors shopper (query · headers · shop).</a:t>
+              <a:t>• ~90 curated social phrases (ES/EN/DE/FR) — fast in-memory match.</a:t>
             </a:r>
           </a:p>
           <a:p>
@@ -15156,7 +15172,7 @@
               </a:defRPr>
             </a:pPr>
             <a:r>
-              <a:t>• No fixed locale list — OpenCode agents handle any language.</a:t>
+              <a:t>• Agent mirrors shopper language; playbook learns novel phrases.</a:t>
             </a:r>
           </a:p>
         </p:txBody>
@@ -15960,7 +15976,7 @@
               </a:defRPr>
             </a:pPr>
             <a:r>
-              <a:t>Demo — v2.1 smart loop</a:t>
+              <a:t>Demo — v2.1.6 smart loop</a:t>
             </a:r>
           </a:p>
           <a:p>
@@ -15976,7 +15992,7 @@
               </a:defRPr>
             </a:pPr>
             <a:r>
-              <a:t>• A: hola que tal → ONE social reply (no catalog chunk).</a:t>
+              <a:t>• A: me puedes ayudar → social help, no catalog progress.</a:t>
             </a:r>
           </a:p>
           <a:p>
@@ -15992,7 +16008,7 @@
               </a:defRPr>
             </a:pPr>
             <a:r>
-              <a:t>• B: hamsters/tortugas/perros 50€ → scoped ack + progress + products.</a:t>
+              <a:t>• B: y para iguanas → scope reply, no duplicate Hola intro.</a:t>
             </a:r>
           </a:p>
           <a:p>
@@ -16008,7 +16024,7 @@
               </a:defRPr>
             </a:pPr>
             <a:r>
-              <a:t>• C: any-language greeting — agent replies in kind.</a:t>
+              <a:t>• C: dame 10 opciones perros → up to 10 cards in batches.</a:t>
             </a:r>
           </a:p>
           <a:p>

</xml_diff>

<commit_message>
docs(v2.1.6): refresh architecture diagrams and PPT flow graphics
Co-authored-by: Cursor <cursoragent@cursor.com>
</commit_message>
<xml_diff>
--- a/docs/deliverables/v0.1/zooplus-assistant-interview-15min-pro.pptx
+++ b/docs/deliverables/v0.1/zooplus-assistant-interview-15min-pro.pptx
@@ -12590,9 +12590,9 @@
           <a:p>
             <a:pPr>
               <a:spcAft>
-                <a:spcPts val="600"/>
+                <a:spcPts val="400"/>
               </a:spcAft>
-              <a:defRPr sz="1700" b="1">
+              <a:defRPr sz="1400" b="1">
                 <a:solidFill>
                   <a:srgbClr val="0A2540"/>
                 </a:solidFill>
@@ -12606,9 +12606,9 @@
           <a:p>
             <a:pPr>
               <a:spcAft>
-                <a:spcPts val="600"/>
+                <a:spcPts val="400"/>
               </a:spcAft>
-              <a:defRPr sz="1700" b="0">
+              <a:defRPr sz="1400" b="0">
                 <a:solidFill>
                   <a:srgbClr val="334155"/>
                 </a:solidFill>
@@ -12622,9 +12622,9 @@
           <a:p>
             <a:pPr>
               <a:spcAft>
-                <a:spcPts val="600"/>
+                <a:spcPts val="400"/>
               </a:spcAft>
-              <a:defRPr sz="1700" b="0">
+              <a:defRPr sz="1400" b="0">
                 <a:solidFill>
                   <a:srgbClr val="334155"/>
                 </a:solidFill>
@@ -12632,15 +12632,15 @@
               </a:defRPr>
             </a:pPr>
             <a:r>
-              <a:t>2. Pull ≥24 vector candidates</a:t>
+              <a:t>2. Pull candidates — pool scales with price band / requested count</a:t>
             </a:r>
           </a:p>
           <a:p>
             <a:pPr>
               <a:spcAft>
-                <a:spcPts val="600"/>
+                <a:spcPts val="400"/>
               </a:spcAft>
-              <a:defRPr sz="1700" b="0">
+              <a:defRPr sz="1400" b="0">
                 <a:solidFill>
                   <a:srgbClr val="334155"/>
                 </a:solidFill>
@@ -12648,15 +12648,15 @@
               </a:defRPr>
             </a:pPr>
             <a:r>
-              <a:t>3. Score BM25 on candidate documents</a:t>
+              <a:t>3. Score BM25 + business signals on candidate pool</a:t>
             </a:r>
           </a:p>
           <a:p>
             <a:pPr>
               <a:spcAft>
-                <a:spcPts val="600"/>
+                <a:spcPts val="400"/>
               </a:spcAft>
-              <a:defRPr sz="1700" b="0">
+              <a:defRPr sz="1400" b="0">
                 <a:solidFill>
                   <a:srgbClr val="334155"/>
                 </a:solidFill>
@@ -12664,15 +12664,15 @@
               </a:defRPr>
             </a:pPr>
             <a:r>
-              <a:t>4. Rerank → top 4 for API + UI cards</a:t>
+              <a:t>4. Rerank → default 4 picks; shopper can ask up to 20</a:t>
             </a:r>
           </a:p>
           <a:p>
             <a:pPr>
               <a:spcAft>
-                <a:spcPts val="600"/>
+                <a:spcPts val="400"/>
               </a:spcAft>
-              <a:defRPr sz="1700" b="1">
+              <a:defRPr sz="1400" b="1">
                 <a:solidFill>
                   <a:srgbClr val="0A2540"/>
                 </a:solidFill>
@@ -12680,15 +12680,15 @@
               </a:defRPr>
             </a:pPr>
             <a:r>
-              <a:t>When vector-only is enough</a:t>
-            </a:r>
-          </a:p>
-          <a:p>
-            <a:pPr>
+              <a:t>Stream delivery (v2.1.6)</a:t>
+            </a:r>
+          </a:p>
+          <a:p>
+            <a:pPr lvl="1">
               <a:spcAft>
-                <a:spcPts val="600"/>
+                <a:spcPts val="400"/>
               </a:spcAft>
-              <a:defRPr sz="1700" b="0">
+              <a:defRPr sz="1400" b="0">
                 <a:solidFill>
                   <a:srgbClr val="334155"/>
                 </a:solidFill>
@@ -12696,15 +12696,15 @@
               </a:defRPr>
             </a:pPr>
             <a:r>
-              <a:t>• Short brand lookups or regression tests</a:t>
-            </a:r>
-          </a:p>
-          <a:p>
-            <a:pPr>
+              <a:t>• product_batch NDJSON — UI reveals product cards in chunks of 4</a:t>
+            </a:r>
+          </a:p>
+          <a:p>
+            <a:pPr lvl="1">
               <a:spcAft>
-                <a:spcPts val="600"/>
+                <a:spcPts val="400"/>
               </a:spcAft>
-              <a:defRPr sz="1700" b="0">
+              <a:defRPr sz="1400" b="0">
                 <a:solidFill>
                   <a:srgbClr val="334155"/>
                 </a:solidFill>
@@ -12712,7 +12712,7 @@
               </a:defRPr>
             </a:pPr>
             <a:r>
-              <a:t>• Hybrid wins on natural-language shopper queries</a:t>
+              <a:t>• A/B vector-only: ZOOPLUS_RETRIEVAL_MODE=vector</a:t>
             </a:r>
           </a:p>
         </p:txBody>
@@ -13341,7 +13341,148 @@
           <a:bodyPr rtlCol="0" anchor="ctr"/>
           <a:lstStyle/>
           <a:p>
-            <a:pPr algn="ctr"/>
+            <a:pPr algn="ctr">
+              <a:spcAft>
+                <a:spcPts val="400"/>
+              </a:spcAft>
+              <a:defRPr sz="1400" b="1">
+                <a:solidFill>
+                  <a:srgbClr val="0A2540"/>
+                </a:solidFill>
+                <a:latin typeface="Arial"/>
+              </a:defRPr>
+            </a:pPr>
+            <a:r>
+              <a:t>Ingest (offline)</a:t>
+            </a:r>
+          </a:p>
+          <a:p>
+            <a:pPr lvl="1">
+              <a:spcAft>
+                <a:spcPts val="400"/>
+              </a:spcAft>
+              <a:defRPr sz="1400" b="0">
+                <a:solidFill>
+                  <a:srgbClr val="334155"/>
+                </a:solidFill>
+                <a:latin typeface="Arial"/>
+              </a:defRPr>
+            </a:pPr>
+            <a:r>
+              <a:t>• Source JSON → data/raw (300 variants) · strip HTML.</a:t>
+            </a:r>
+          </a:p>
+          <a:p>
+            <a:pPr lvl="1">
+              <a:spcAft>
+                <a:spcPts val="400"/>
+              </a:spcAft>
+              <a:defRPr sz="1400" b="0">
+                <a:solidFill>
+                  <a:srgbClr val="334155"/>
+                </a:solidFill>
+                <a:latin typeface="Arial"/>
+              </a:defRPr>
+            </a:pPr>
+            <a:r>
+              <a:t>• Chroma per article_id · routing_lexicon.json at ingest.</a:t>
+            </a:r>
+          </a:p>
+          <a:p>
+            <a:pPr>
+              <a:spcAft>
+                <a:spcPts val="400"/>
+              </a:spcAft>
+              <a:defRPr sz="1400" b="1">
+                <a:solidFill>
+                  <a:srgbClr val="0A2540"/>
+                </a:solidFill>
+                <a:latin typeface="Arial"/>
+              </a:defRPr>
+            </a:pPr>
+            <a:r>
+              <a:t>Online path (catalog lane)</a:t>
+            </a:r>
+          </a:p>
+          <a:p>
+            <a:pPr lvl="1">
+              <a:spcAft>
+                <a:spcPts val="400"/>
+              </a:spcAft>
+              <a:defRPr sz="1400" b="0">
+                <a:solidFill>
+                  <a:srgbClr val="334155"/>
+                </a:solidFill>
+                <a:latin typeface="Arial"/>
+              </a:defRPr>
+            </a:pPr>
+            <a:r>
+              <a:t>• probe_instant_lane: phrase index + playbook → social | catalog.</a:t>
+            </a:r>
+          </a:p>
+          <a:p>
+            <a:pPr lvl="1">
+              <a:spcAft>
+                <a:spcPts val="400"/>
+              </a:spcAft>
+              <a:defRPr sz="1400" b="0">
+                <a:solidFill>
+                  <a:srgbClr val="334155"/>
+                </a:solidFill>
+                <a:latin typeface="Arial"/>
+              </a:defRPr>
+            </a:pPr>
+            <a:r>
+              <a:t>• Hybrid retrieve → EUR price filter → resolve count from query.</a:t>
+            </a:r>
+          </a:p>
+          <a:p>
+            <a:pPr>
+              <a:spcAft>
+                <a:spcPts val="400"/>
+              </a:spcAft>
+              <a:defRPr sz="1400" b="1">
+                <a:solidFill>
+                  <a:srgbClr val="0A2540"/>
+                </a:solidFill>
+                <a:latin typeface="Arial"/>
+              </a:defRPr>
+            </a:pPr>
+            <a:r>
+              <a:t>NDJSON stream (/chat/stream)</a:t>
+            </a:r>
+          </a:p>
+          <a:p>
+            <a:pPr lvl="1">
+              <a:spcAft>
+                <a:spcPts val="400"/>
+              </a:spcAft>
+              <a:defRPr sz="1400" b="0">
+                <a:solidFill>
+                  <a:srgbClr val="334155"/>
+                </a:solidFill>
+                <a:latin typeface="Arial"/>
+              </a:defRPr>
+            </a:pPr>
+            <a:r>
+              <a:t>• typing → chunk* → product_batch* → done (+ meta).</a:t>
+            </a:r>
+          </a:p>
+          <a:p>
+            <a:pPr lvl="1">
+              <a:spcAft>
+                <a:spcPts val="400"/>
+              </a:spcAft>
+              <a:defRPr sz="1400" b="0">
+                <a:solidFill>
+                  <a:srgbClr val="334155"/>
+                </a:solidFill>
+                <a:latin typeface="Arial"/>
+              </a:defRPr>
+            </a:pPr>
+            <a:r>
+              <a:t>• Social/help: no catalog progress; dedupe final vs live chunks.</a:t>
+            </a:r>
           </a:p>
         </p:txBody>
       </p:sp>
@@ -14065,7 +14206,7 @@
               </a:defRPr>
             </a:pPr>
             <a:r>
-              <a:t>Conductor-first · catalog lexicon · stream status — fast multilingual UX</a:t>
+              <a:t>v2.1.6 · phrase-index probe · fast intent · product_batch stream</a:t>
             </a:r>
           </a:p>
         </p:txBody>

</xml_diff>

<commit_message>
fix(ppt): rebuild slide 5-6 columns to remove overlapping text boxes
Co-authored-by: Cursor <cursoragent@cursor.com>
</commit_message>
<xml_diff>
--- a/docs/deliverables/v0.1/zooplus-assistant-interview-15min-pro.pptx
+++ b/docs/deliverables/v0.1/zooplus-assistant-interview-15min-pro.pptx
@@ -12358,50 +12358,7 @@
       </p:sp>
       <p:sp>
         <p:nvSpPr>
-          <p:cNvPr id="16" name="Rectangle 15"/>
-          <p:cNvSpPr/>
-          <p:nvPr/>
-        </p:nvSpPr>
-        <p:spPr>
-          <a:xfrm>
-            <a:off x="585216" y="1261872"/>
-            <a:ext cx="10972800" cy="4983480"/>
-          </a:xfrm>
-          <a:prstGeom prst="rect">
-            <a:avLst/>
-          </a:prstGeom>
-          <a:solidFill>
-            <a:srgbClr val="F8FAFC"/>
-          </a:solidFill>
-          <a:ln>
-            <a:noFill/>
-          </a:ln>
-        </p:spPr>
-        <p:style>
-          <a:lnRef idx="1">
-            <a:schemeClr val="accent1"/>
-          </a:lnRef>
-          <a:fillRef idx="3">
-            <a:schemeClr val="accent1"/>
-          </a:fillRef>
-          <a:effectRef idx="2">
-            <a:schemeClr val="accent1"/>
-          </a:effectRef>
-          <a:fontRef idx="minor">
-            <a:schemeClr val="lt1"/>
-          </a:fontRef>
-        </p:style>
-        <p:txBody>
-          <a:bodyPr rtlCol="0" anchor="ctr"/>
-          <a:lstStyle/>
-          <a:p>
-            <a:pPr algn="ctr"/>
-          </a:p>
-        </p:txBody>
-      </p:sp>
-      <p:sp>
-        <p:nvSpPr>
-          <p:cNvPr id="17" name="TextBox 16"/>
+          <p:cNvPr id="16" name="TextBox 15"/>
           <p:cNvSpPr txBox="1"/>
           <p:nvPr/>
         </p:nvSpPr>
@@ -12568,7 +12525,7 @@
       </p:sp>
       <p:sp>
         <p:nvSpPr>
-          <p:cNvPr id="18" name="TextBox 17"/>
+          <p:cNvPr id="17" name="TextBox 16"/>
           <p:cNvSpPr txBox="1"/>
           <p:nvPr/>
         </p:nvSpPr>
@@ -12590,9 +12547,9 @@
           <a:p>
             <a:pPr>
               <a:spcAft>
-                <a:spcPts val="400"/>
+                <a:spcPts val="600"/>
               </a:spcAft>
-              <a:defRPr sz="1400" b="1">
+              <a:defRPr sz="1700" b="1">
                 <a:solidFill>
                   <a:srgbClr val="0A2540"/>
                 </a:solidFill>
@@ -12606,9 +12563,9 @@
           <a:p>
             <a:pPr>
               <a:spcAft>
-                <a:spcPts val="400"/>
+                <a:spcPts val="600"/>
               </a:spcAft>
-              <a:defRPr sz="1400" b="0">
+              <a:defRPr sz="1700" b="0">
                 <a:solidFill>
                   <a:srgbClr val="334155"/>
                 </a:solidFill>
@@ -12622,9 +12579,9 @@
           <a:p>
             <a:pPr>
               <a:spcAft>
-                <a:spcPts val="400"/>
+                <a:spcPts val="600"/>
               </a:spcAft>
-              <a:defRPr sz="1400" b="0">
+              <a:defRPr sz="1700" b="0">
                 <a:solidFill>
                   <a:srgbClr val="334155"/>
                 </a:solidFill>
@@ -12638,9 +12595,9 @@
           <a:p>
             <a:pPr>
               <a:spcAft>
-                <a:spcPts val="400"/>
+                <a:spcPts val="600"/>
               </a:spcAft>
-              <a:defRPr sz="1400" b="0">
+              <a:defRPr sz="1700" b="0">
                 <a:solidFill>
                   <a:srgbClr val="334155"/>
                 </a:solidFill>
@@ -12654,9 +12611,9 @@
           <a:p>
             <a:pPr>
               <a:spcAft>
-                <a:spcPts val="400"/>
+                <a:spcPts val="600"/>
               </a:spcAft>
-              <a:defRPr sz="1400" b="0">
+              <a:defRPr sz="1700" b="0">
                 <a:solidFill>
                   <a:srgbClr val="334155"/>
                 </a:solidFill>
@@ -12670,9 +12627,9 @@
           <a:p>
             <a:pPr>
               <a:spcAft>
-                <a:spcPts val="400"/>
+                <a:spcPts val="600"/>
               </a:spcAft>
-              <a:defRPr sz="1400" b="1">
+              <a:defRPr sz="1700" b="1">
                 <a:solidFill>
                   <a:srgbClr val="0A2540"/>
                 </a:solidFill>
@@ -12684,11 +12641,11 @@
             </a:r>
           </a:p>
           <a:p>
-            <a:pPr lvl="1">
+            <a:pPr>
               <a:spcAft>
-                <a:spcPts val="400"/>
+                <a:spcPts val="600"/>
               </a:spcAft>
-              <a:defRPr sz="1400" b="0">
+              <a:defRPr sz="1700" b="0">
                 <a:solidFill>
                   <a:srgbClr val="334155"/>
                 </a:solidFill>
@@ -12700,11 +12657,11 @@
             </a:r>
           </a:p>
           <a:p>
-            <a:pPr lvl="1">
+            <a:pPr>
               <a:spcAft>
-                <a:spcPts val="400"/>
+                <a:spcPts val="600"/>
               </a:spcAft>
-              <a:defRPr sz="1400" b="0">
+              <a:defRPr sz="1700" b="0">
                 <a:solidFill>
                   <a:srgbClr val="334155"/>
                 </a:solidFill>
@@ -13304,198 +13261,14 @@
       </p:sp>
       <p:sp>
         <p:nvSpPr>
-          <p:cNvPr id="16" name="Rectangle 15"/>
-          <p:cNvSpPr/>
-          <p:nvPr/>
-        </p:nvSpPr>
-        <p:spPr>
-          <a:xfrm>
-            <a:off x="585216" y="1261872"/>
-            <a:ext cx="10972800" cy="4983480"/>
-          </a:xfrm>
-          <a:prstGeom prst="rect">
-            <a:avLst/>
-          </a:prstGeom>
-          <a:solidFill>
-            <a:srgbClr val="F8FAFC"/>
-          </a:solidFill>
-          <a:ln>
-            <a:noFill/>
-          </a:ln>
-        </p:spPr>
-        <p:style>
-          <a:lnRef idx="1">
-            <a:schemeClr val="accent1"/>
-          </a:lnRef>
-          <a:fillRef idx="3">
-            <a:schemeClr val="accent1"/>
-          </a:fillRef>
-          <a:effectRef idx="2">
-            <a:schemeClr val="accent1"/>
-          </a:effectRef>
-          <a:fontRef idx="minor">
-            <a:schemeClr val="lt1"/>
-          </a:fontRef>
-        </p:style>
-        <p:txBody>
-          <a:bodyPr rtlCol="0" anchor="ctr"/>
-          <a:lstStyle/>
-          <a:p>
-            <a:pPr algn="ctr">
-              <a:spcAft>
-                <a:spcPts val="400"/>
-              </a:spcAft>
-              <a:defRPr sz="1400" b="1">
-                <a:solidFill>
-                  <a:srgbClr val="0A2540"/>
-                </a:solidFill>
-                <a:latin typeface="Arial"/>
-              </a:defRPr>
-            </a:pPr>
-            <a:r>
-              <a:t>Ingest (offline)</a:t>
-            </a:r>
-          </a:p>
-          <a:p>
-            <a:pPr lvl="1">
-              <a:spcAft>
-                <a:spcPts val="400"/>
-              </a:spcAft>
-              <a:defRPr sz="1400" b="0">
-                <a:solidFill>
-                  <a:srgbClr val="334155"/>
-                </a:solidFill>
-                <a:latin typeface="Arial"/>
-              </a:defRPr>
-            </a:pPr>
-            <a:r>
-              <a:t>• Source JSON → data/raw (300 variants) · strip HTML.</a:t>
-            </a:r>
-          </a:p>
-          <a:p>
-            <a:pPr lvl="1">
-              <a:spcAft>
-                <a:spcPts val="400"/>
-              </a:spcAft>
-              <a:defRPr sz="1400" b="0">
-                <a:solidFill>
-                  <a:srgbClr val="334155"/>
-                </a:solidFill>
-                <a:latin typeface="Arial"/>
-              </a:defRPr>
-            </a:pPr>
-            <a:r>
-              <a:t>• Chroma per article_id · routing_lexicon.json at ingest.</a:t>
-            </a:r>
-          </a:p>
-          <a:p>
-            <a:pPr>
-              <a:spcAft>
-                <a:spcPts val="400"/>
-              </a:spcAft>
-              <a:defRPr sz="1400" b="1">
-                <a:solidFill>
-                  <a:srgbClr val="0A2540"/>
-                </a:solidFill>
-                <a:latin typeface="Arial"/>
-              </a:defRPr>
-            </a:pPr>
-            <a:r>
-              <a:t>Online path (catalog lane)</a:t>
-            </a:r>
-          </a:p>
-          <a:p>
-            <a:pPr lvl="1">
-              <a:spcAft>
-                <a:spcPts val="400"/>
-              </a:spcAft>
-              <a:defRPr sz="1400" b="0">
-                <a:solidFill>
-                  <a:srgbClr val="334155"/>
-                </a:solidFill>
-                <a:latin typeface="Arial"/>
-              </a:defRPr>
-            </a:pPr>
-            <a:r>
-              <a:t>• probe_instant_lane: phrase index + playbook → social | catalog.</a:t>
-            </a:r>
-          </a:p>
-          <a:p>
-            <a:pPr lvl="1">
-              <a:spcAft>
-                <a:spcPts val="400"/>
-              </a:spcAft>
-              <a:defRPr sz="1400" b="0">
-                <a:solidFill>
-                  <a:srgbClr val="334155"/>
-                </a:solidFill>
-                <a:latin typeface="Arial"/>
-              </a:defRPr>
-            </a:pPr>
-            <a:r>
-              <a:t>• Hybrid retrieve → EUR price filter → resolve count from query.</a:t>
-            </a:r>
-          </a:p>
-          <a:p>
-            <a:pPr>
-              <a:spcAft>
-                <a:spcPts val="400"/>
-              </a:spcAft>
-              <a:defRPr sz="1400" b="1">
-                <a:solidFill>
-                  <a:srgbClr val="0A2540"/>
-                </a:solidFill>
-                <a:latin typeface="Arial"/>
-              </a:defRPr>
-            </a:pPr>
-            <a:r>
-              <a:t>NDJSON stream (/chat/stream)</a:t>
-            </a:r>
-          </a:p>
-          <a:p>
-            <a:pPr lvl="1">
-              <a:spcAft>
-                <a:spcPts val="400"/>
-              </a:spcAft>
-              <a:defRPr sz="1400" b="0">
-                <a:solidFill>
-                  <a:srgbClr val="334155"/>
-                </a:solidFill>
-                <a:latin typeface="Arial"/>
-              </a:defRPr>
-            </a:pPr>
-            <a:r>
-              <a:t>• typing → chunk* → product_batch* → done (+ meta).</a:t>
-            </a:r>
-          </a:p>
-          <a:p>
-            <a:pPr lvl="1">
-              <a:spcAft>
-                <a:spcPts val="400"/>
-              </a:spcAft>
-              <a:defRPr sz="1400" b="0">
-                <a:solidFill>
-                  <a:srgbClr val="334155"/>
-                </a:solidFill>
-                <a:latin typeface="Arial"/>
-              </a:defRPr>
-            </a:pPr>
-            <a:r>
-              <a:t>• Social/help: no catalog progress; dedupe final vs live chunks.</a:t>
-            </a:r>
-          </a:p>
-        </p:txBody>
-      </p:sp>
-      <p:sp>
-        <p:nvSpPr>
-          <p:cNvPr id="17" name="TextBox 16"/>
+          <p:cNvPr id="16" name="TextBox 15"/>
           <p:cNvSpPr txBox="1"/>
           <p:nvPr/>
         </p:nvSpPr>
         <p:spPr>
           <a:xfrm>
             <a:off x="749808" y="1417320"/>
-            <a:ext cx="5349240" cy="4663440"/>
+            <a:ext cx="5120640" cy="4663440"/>
           </a:xfrm>
           <a:prstGeom prst="rect">
             <a:avLst/>
@@ -13510,9 +13283,9 @@
           <a:p>
             <a:pPr>
               <a:spcAft>
-                <a:spcPts val="500"/>
+                <a:spcPts val="600"/>
               </a:spcAft>
-              <a:defRPr sz="1500" b="1">
+              <a:defRPr sz="1400" b="1">
                 <a:solidFill>
                   <a:srgbClr val="0A2540"/>
                 </a:solidFill>
@@ -13520,95 +13293,47 @@
               </a:defRPr>
             </a:pPr>
             <a:r>
-              <a:t>Grounding &amp; answer</a:t>
-            </a:r>
-          </a:p>
-          <a:p>
-            <a:pPr lvl="1">
-              <a:spcAft>
-                <a:spcPts val="500"/>
-              </a:spcAft>
-              <a:defRPr sz="1500" b="0">
-                <a:solidFill>
-                  <a:srgbClr val="334155"/>
-                </a:solidFill>
-                <a:latin typeface="Arial"/>
-              </a:defRPr>
-            </a:pPr>
-            <a:r>
-              <a:t>• retrieved_products[] from same site_id hits only.</a:t>
-            </a:r>
-          </a:p>
-          <a:p>
-            <a:pPr lvl="1">
-              <a:spcAft>
-                <a:spcPts val="500"/>
-              </a:spcAft>
-              <a:defRPr sz="1500" b="0">
-                <a:solidFill>
-                  <a:srgbClr val="334155"/>
-                </a:solidFill>
-                <a:latin typeface="Arial"/>
-              </a:defRPr>
-            </a:pPr>
-            <a:r>
-              <a:t>• Off-topic → empty list + polite decline (FR4).</a:t>
-            </a:r>
-          </a:p>
-          <a:p>
-            <a:pPr lvl="1">
-              <a:spcAft>
-                <a:spcPts val="500"/>
-              </a:spcAft>
-              <a:defRPr sz="1500" b="0">
-                <a:solidFill>
-                  <a:srgbClr val="334155"/>
-                </a:solidFill>
-                <a:latin typeface="Arial"/>
-              </a:defRPr>
-            </a:pPr>
-            <a:r>
-              <a:t>• Synthesis: per-agent OpenCode LLM — never invent SKUs.</a:t>
-            </a:r>
-          </a:p>
-          <a:p>
-            <a:pPr lvl="1">
-              <a:spcAft>
-                <a:spcPts val="500"/>
-              </a:spcAft>
-              <a:defRPr sz="1500" b="0">
-                <a:solidFill>
-                  <a:srgbClr val="334155"/>
-                </a:solidFill>
-                <a:latin typeface="Arial"/>
-              </a:defRPr>
-            </a:pPr>
-            <a:r>
-              <a:t>• Stream: /chat/stream → status* → products → done</a:t>
-            </a:r>
-          </a:p>
-          <a:p>
-            <a:pPr lvl="1">
-              <a:spcAft>
-                <a:spcPts val="500"/>
-              </a:spcAft>
-              <a:defRPr sz="1500" b="0">
-                <a:solidFill>
-                  <a:srgbClr val="334155"/>
-                </a:solidFill>
-                <a:latin typeface="Arial"/>
-              </a:defRPr>
-            </a:pPr>
-            <a:r>
-              <a:t>• UI: one transient status bubble (agent shopper_status).</a:t>
+              <a:t>Ingest (offline)</a:t>
             </a:r>
           </a:p>
           <a:p>
             <a:pPr>
               <a:spcAft>
-                <a:spcPts val="500"/>
+                <a:spcPts val="600"/>
               </a:spcAft>
-              <a:defRPr sz="1500" b="1">
+              <a:defRPr sz="1400" b="0">
+                <a:solidFill>
+                  <a:srgbClr val="334155"/>
+                </a:solidFill>
+                <a:latin typeface="Arial"/>
+              </a:defRPr>
+            </a:pPr>
+            <a:r>
+              <a:t>• Source JSON → data/raw (300 variants) · strip HTML.</a:t>
+            </a:r>
+          </a:p>
+          <a:p>
+            <a:pPr>
+              <a:spcAft>
+                <a:spcPts val="600"/>
+              </a:spcAft>
+              <a:defRPr sz="1400" b="0">
+                <a:solidFill>
+                  <a:srgbClr val="334155"/>
+                </a:solidFill>
+                <a:latin typeface="Arial"/>
+              </a:defRPr>
+            </a:pPr>
+            <a:r>
+              <a:t>• Chroma per article_id · routing_lexicon.json at ingest.</a:t>
+            </a:r>
+          </a:p>
+          <a:p>
+            <a:pPr>
+              <a:spcAft>
+                <a:spcPts val="600"/>
+              </a:spcAft>
+              <a:defRPr sz="1400" b="1">
                 <a:solidFill>
                   <a:srgbClr val="0A2540"/>
                 </a:solidFill>
@@ -13616,15 +13341,15 @@
               </a:defRPr>
             </a:pPr>
             <a:r>
-              <a:t>Production path</a:t>
-            </a:r>
-          </a:p>
-          <a:p>
-            <a:pPr lvl="1">
+              <a:t>Online path (catalog lane)</a:t>
+            </a:r>
+          </a:p>
+          <a:p>
+            <a:pPr>
               <a:spcAft>
-                <a:spcPts val="500"/>
+                <a:spcPts val="600"/>
               </a:spcAft>
-              <a:defRPr sz="1500" b="0">
+              <a:defRPr sz="1400" b="0">
                 <a:solidFill>
                   <a:srgbClr val="334155"/>
                 </a:solidFill>
@@ -13632,15 +13357,15 @@
               </a:defRPr>
             </a:pPr>
             <a:r>
-              <a:t>• routing_lexicon.json at ingest; optional Redis mirror.</a:t>
-            </a:r>
-          </a:p>
-          <a:p>
-            <a:pPr lvl="1">
+              <a:t>• probe_instant_lane: phrase index + playbook → social | catalog.</a:t>
+            </a:r>
+          </a:p>
+          <a:p>
+            <a:pPr>
               <a:spcAft>
-                <a:spcPts val="500"/>
+                <a:spcPts val="600"/>
               </a:spcAft>
-              <a:defRPr sz="1500" b="0">
+              <a:defRPr sz="1400" b="0">
                 <a:solidFill>
                   <a:srgbClr val="334155"/>
                 </a:solidFill>
@@ -13648,21 +13373,69 @@
               </a:defRPr>
             </a:pPr>
             <a:r>
-              <a:t>• Managed vector DB + scheduled re-ingest (roadmap P1).</a:t>
-            </a:r>
-          </a:p>
-        </p:txBody>
-      </p:sp>
-      <p:sp>
-        <p:nvSpPr>
-          <p:cNvPr id="18" name="TextBox 17"/>
+              <a:t>• Hybrid retrieve → EUR price filter → resolve count from query.</a:t>
+            </a:r>
+          </a:p>
+          <a:p>
+            <a:pPr>
+              <a:spcAft>
+                <a:spcPts val="600"/>
+              </a:spcAft>
+              <a:defRPr sz="1400" b="1">
+                <a:solidFill>
+                  <a:srgbClr val="0A2540"/>
+                </a:solidFill>
+                <a:latin typeface="Arial"/>
+              </a:defRPr>
+            </a:pPr>
+            <a:r>
+              <a:t>NDJSON stream (/chat/stream)</a:t>
+            </a:r>
+          </a:p>
+          <a:p>
+            <a:pPr>
+              <a:spcAft>
+                <a:spcPts val="600"/>
+              </a:spcAft>
+              <a:defRPr sz="1400" b="0">
+                <a:solidFill>
+                  <a:srgbClr val="334155"/>
+                </a:solidFill>
+                <a:latin typeface="Arial"/>
+              </a:defRPr>
+            </a:pPr>
+            <a:r>
+              <a:t>• typing → chunk* → product_batch* → done (+ meta).</a:t>
+            </a:r>
+          </a:p>
+          <a:p>
+            <a:pPr>
+              <a:spcAft>
+                <a:spcPts val="600"/>
+              </a:spcAft>
+              <a:defRPr sz="1400" b="0">
+                <a:solidFill>
+                  <a:srgbClr val="334155"/>
+                </a:solidFill>
+                <a:latin typeface="Arial"/>
+              </a:defRPr>
+            </a:pPr>
+            <a:r>
+              <a:t>• Social/help: no catalog progress; dedupe final vs live chunks.</a:t>
+            </a:r>
+          </a:p>
+        </p:txBody>
+      </p:sp>
+      <p:sp>
+        <p:nvSpPr>
+          <p:cNvPr id="17" name="TextBox 16"/>
           <p:cNvSpPr txBox="1"/>
           <p:nvPr/>
         </p:nvSpPr>
         <p:spPr>
           <a:xfrm>
-            <a:off x="6126480" y="1417320"/>
-            <a:ext cx="5257800" cy="4663440"/>
+            <a:off x="5989320" y="1417320"/>
+            <a:ext cx="5394960" cy="4663440"/>
           </a:xfrm>
           <a:prstGeom prst="rect">
             <a:avLst/>
@@ -13677,7 +13450,7 @@
           <a:p>
             <a:pPr>
               <a:spcAft>
-                <a:spcPts val="400"/>
+                <a:spcPts val="600"/>
               </a:spcAft>
               <a:defRPr sz="1400" b="1">
                 <a:solidFill>
@@ -13691,9 +13464,9 @@
             </a:r>
           </a:p>
           <a:p>
-            <a:pPr lvl="1">
+            <a:pPr>
               <a:spcAft>
-                <a:spcPts val="400"/>
+                <a:spcPts val="600"/>
               </a:spcAft>
               <a:defRPr sz="1400" b="0">
                 <a:solidFill>
@@ -13707,9 +13480,9 @@
             </a:r>
           </a:p>
           <a:p>
-            <a:pPr lvl="1">
+            <a:pPr>
               <a:spcAft>
-                <a:spcPts val="400"/>
+                <a:spcPts val="600"/>
               </a:spcAft>
               <a:defRPr sz="1400" b="0">
                 <a:solidFill>
@@ -13723,9 +13496,9 @@
             </a:r>
           </a:p>
           <a:p>
-            <a:pPr lvl="1">
+            <a:pPr>
               <a:spcAft>
-                <a:spcPts val="400"/>
+                <a:spcPts val="600"/>
               </a:spcAft>
               <a:defRPr sz="1400" b="0">
                 <a:solidFill>
@@ -13741,7 +13514,7 @@
           <a:p>
             <a:pPr>
               <a:spcAft>
-                <a:spcPts val="400"/>
+                <a:spcPts val="600"/>
               </a:spcAft>
               <a:defRPr sz="1400" b="1">
                 <a:solidFill>
@@ -13755,9 +13528,9 @@
             </a:r>
           </a:p>
           <a:p>
-            <a:pPr lvl="1">
+            <a:pPr>
               <a:spcAft>
-                <a:spcPts val="400"/>
+                <a:spcPts val="600"/>
               </a:spcAft>
               <a:defRPr sz="1400" b="0">
                 <a:solidFill>
@@ -13771,9 +13544,9 @@
             </a:r>
           </a:p>
           <a:p>
-            <a:pPr lvl="1">
+            <a:pPr>
               <a:spcAft>
-                <a:spcPts val="400"/>
+                <a:spcPts val="600"/>
               </a:spcAft>
               <a:defRPr sz="1400" b="0">
                 <a:solidFill>
@@ -13787,9 +13560,9 @@
             </a:r>
           </a:p>
           <a:p>
-            <a:pPr lvl="1">
+            <a:pPr>
               <a:spcAft>
-                <a:spcPts val="400"/>
+                <a:spcPts val="600"/>
               </a:spcAft>
               <a:defRPr sz="1400" b="0">
                 <a:solidFill>
@@ -13803,9 +13576,9 @@
             </a:r>
           </a:p>
           <a:p>
-            <a:pPr lvl="1">
+            <a:pPr>
               <a:spcAft>
-                <a:spcPts val="400"/>
+                <a:spcPts val="600"/>
               </a:spcAft>
               <a:defRPr sz="1400" b="0">
                 <a:solidFill>

</xml_diff>

<commit_message>
docs(ppt): add FR code evidence panels and English demo phrases
Add source-code panels on FR2-FR5 slides (like FR1), translate Spanish demo copy to English, and wire regeneration through v20_conductor.

Co-authored-by: Cursor <cursoragent@cursor.com>
</commit_message>
<xml_diff>
--- a/docs/deliverables/v0.1/zooplus-assistant-interview-15min-pro.pptx
+++ b/docs/deliverables/v0.1/zooplus-assistant-interview-15min-pro.pptx
@@ -5201,8 +5201,8 @@
         </p:blipFill>
         <p:spPr>
           <a:xfrm>
-            <a:off x="6236208" y="1307592"/>
-            <a:ext cx="5577840" cy="4196783"/>
+            <a:off x="6053328" y="1325880"/>
+            <a:ext cx="5102352" cy="2697480"/>
           </a:xfrm>
           <a:prstGeom prst="rect">
             <a:avLst/>
@@ -5406,6 +5406,226 @@
             </a:pPr>
             <a:r>
               <a:t>10</a:t>
+            </a:r>
+          </a:p>
+        </p:txBody>
+      </p:sp>
+      <p:sp>
+        <p:nvSpPr>
+          <p:cNvPr id="21" name="Panel FR5Code"/>
+          <p:cNvSpPr/>
+          <p:nvPr/>
+        </p:nvSpPr>
+        <p:spPr>
+          <a:xfrm>
+            <a:off x="6181344" y="4160520"/>
+            <a:ext cx="5102352" cy="2011680"/>
+          </a:xfrm>
+          <a:prstGeom prst="rect">
+            <a:avLst/>
+          </a:prstGeom>
+          <a:solidFill>
+            <a:srgbClr val="1E293B"/>
+          </a:solidFill>
+          <a:ln>
+            <a:noFill/>
+          </a:ln>
+        </p:spPr>
+        <p:style>
+          <a:lnRef idx="1">
+            <a:schemeClr val="accent1"/>
+          </a:lnRef>
+          <a:fillRef idx="3">
+            <a:schemeClr val="accent1"/>
+          </a:fillRef>
+          <a:effectRef idx="2">
+            <a:schemeClr val="accent1"/>
+          </a:effectRef>
+          <a:fontRef idx="minor">
+            <a:schemeClr val="lt1"/>
+          </a:fontRef>
+        </p:style>
+        <p:txBody>
+          <a:bodyPr rtlCol="0" anchor="ctr"/>
+          <a:lstStyle/>
+          <a:p>
+            <a:pPr algn="ctr"/>
+          </a:p>
+        </p:txBody>
+      </p:sp>
+      <p:sp>
+        <p:nvSpPr>
+          <p:cNvPr id="22" name="TextBox FR5Code"/>
+          <p:cNvSpPr txBox="1"/>
+          <p:nvPr/>
+        </p:nvSpPr>
+        <p:spPr>
+          <a:xfrm>
+            <a:off x="6291072" y="4251960"/>
+            <a:ext cx="4882896" cy="1874520"/>
+          </a:xfrm>
+          <a:prstGeom prst="rect">
+            <a:avLst/>
+          </a:prstGeom>
+          <a:noFill/>
+        </p:spPr>
+        <p:txBody>
+          <a:bodyPr wrap="square" anchor="t">
+            <a:spAutoFit/>
+          </a:bodyPr>
+          <a:lstStyle/>
+          <a:p>
+            <a:pPr>
+              <a:defRPr sz="1100" b="1">
+                <a:solidFill>
+                  <a:srgbClr val="16A34A"/>
+                </a:solidFill>
+                <a:latin typeface="Arial"/>
+              </a:defRPr>
+            </a:pPr>
+            <a:r>
+              <a:t>FR5 — Docker + repo layout (source)</a:t>
+            </a:r>
+          </a:p>
+          <a:p>
+            <a:pPr>
+              <a:spcAft>
+                <a:spcPts val="100"/>
+              </a:spcAft>
+              <a:defRPr sz="900">
+                <a:solidFill>
+                  <a:srgbClr val="E2E8F0"/>
+                </a:solidFill>
+                <a:latin typeface="Consolas"/>
+              </a:defRPr>
+            </a:pPr>
+            <a:r>
+              <a:t># docker-compose.yml — production-like stack</a:t>
+            </a:r>
+          </a:p>
+          <a:p>
+            <a:pPr>
+              <a:spcAft>
+                <a:spcPts val="100"/>
+              </a:spcAft>
+              <a:defRPr sz="900">
+                <a:solidFill>
+                  <a:srgbClr val="E2E8F0"/>
+                </a:solidFill>
+                <a:latin typeface="Consolas"/>
+              </a:defRPr>
+            </a:pPr>
+            <a:r>
+              <a:t>services:</a:t>
+            </a:r>
+          </a:p>
+          <a:p>
+            <a:pPr>
+              <a:spcAft>
+                <a:spcPts val="100"/>
+              </a:spcAft>
+              <a:defRPr sz="900">
+                <a:solidFill>
+                  <a:srgbClr val="E2E8F0"/>
+                </a:solidFill>
+                <a:latin typeface="Consolas"/>
+              </a:defRPr>
+            </a:pPr>
+            <a:r>
+              <a:t>  zooplus-api:</a:t>
+            </a:r>
+          </a:p>
+          <a:p>
+            <a:pPr>
+              <a:spcAft>
+                <a:spcPts val="100"/>
+              </a:spcAft>
+              <a:defRPr sz="900">
+                <a:solidFill>
+                  <a:srgbClr val="E2E8F0"/>
+                </a:solidFill>
+                <a:latin typeface="Consolas"/>
+              </a:defRPr>
+            </a:pPr>
+            <a:r>
+              <a:t>    build: .</a:t>
+            </a:r>
+          </a:p>
+          <a:p>
+            <a:pPr>
+              <a:spcAft>
+                <a:spcPts val="100"/>
+              </a:spcAft>
+              <a:defRPr sz="900">
+                <a:solidFill>
+                  <a:srgbClr val="E2E8F0"/>
+                </a:solidFill>
+                <a:latin typeface="Consolas"/>
+              </a:defRPr>
+            </a:pPr>
+            <a:r>
+              <a:t>    ports: ['8080:8080']</a:t>
+            </a:r>
+          </a:p>
+          <a:p>
+            <a:pPr>
+              <a:spcAft>
+                <a:spcPts val="100"/>
+              </a:spcAft>
+              <a:defRPr sz="900">
+                <a:solidFill>
+                  <a:srgbClr val="E2E8F0"/>
+                </a:solidFill>
+                <a:latin typeface="Consolas"/>
+              </a:defRPr>
+            </a:pPr>
+          </a:p>
+          <a:p>
+            <a:pPr>
+              <a:spcAft>
+                <a:spcPts val="100"/>
+              </a:spcAft>
+              <a:defRPr sz="900">
+                <a:solidFill>
+                  <a:srgbClr val="E2E8F0"/>
+                </a:solidFill>
+                <a:latin typeface="Consolas"/>
+              </a:defRPr>
+            </a:pPr>
+            <a:r>
+              <a:t># Repo layout (FR5)</a:t>
+            </a:r>
+          </a:p>
+          <a:p>
+            <a:pPr>
+              <a:spcAft>
+                <a:spcPts val="100"/>
+              </a:spcAft>
+              <a:defRPr sz="900">
+                <a:solidFill>
+                  <a:srgbClr val="E2E8F0"/>
+                </a:solidFill>
+                <a:latin typeface="Consolas"/>
+              </a:defRPr>
+            </a:pPr>
+            <a:r>
+              <a:t>cli/  src/  tests/  docs/  scripts/</a:t>
+            </a:r>
+          </a:p>
+          <a:p>
+            <a:pPr>
+              <a:spcAft>
+                <a:spcPts val="100"/>
+              </a:spcAft>
+              <a:defRPr sz="900">
+                <a:solidFill>
+                  <a:srgbClr val="E2E8F0"/>
+                </a:solidFill>
+                <a:latin typeface="Consolas"/>
+              </a:defRPr>
+            </a:pPr>
+            <a:r>
+              <a:t>scripts/run_release_verify.ps1</a:t>
             </a:r>
           </a:p>
         </p:txBody>
@@ -8838,7 +9058,7 @@
               </a:defRPr>
             </a:pPr>
             <a:r>
-              <a:t>v2.1.4–5 — Species inference; help/saludo detect + dedupe.</a:t>
+              <a:t>v2.1.4–5 — Species inference; help/greeting detect + dedupe.</a:t>
             </a:r>
           </a:p>
           <a:p>
@@ -11403,6 +11623,46 @@
             <a:r>
               <a:t>FR2 = Structured response: answer + retrieved_products[]</a:t>
             </a:r>
+            <a:br/>
+            <a:r>
+              <a:t>  answer must be conversational and grounded in hits</a:t>
+            </a:r>
+            <a:br/>
+            <a:r>
+              <a:t>  each product: article_id, names, price, pet_type, brands</a:t>
+            </a:r>
+            <a:br/>
+            <a:r>
+              <a:t>FR3 = Knowledge ONLY from product_catalog_dataset.json</a:t>
+            </a:r>
+            <a:br/>
+            <a:r>
+              <a:t>  ingest → Chroma → hybrid retrieve → synthesize · no web/APIs</a:t>
+            </a:r>
+            <a:br/>
+            <a:r>
+              <a:t>  300 variants · shops 1/3/15 · default 4 picks · up to 20 if asked</a:t>
+            </a:r>
+            <a:br/>
+            <a:r>
+              <a:t>  answer must be conversational and grounded in hits</a:t>
+            </a:r>
+            <a:br/>
+            <a:r>
+              <a:t>  each product: article_id, names, price, pet_type, brands</a:t>
+            </a:r>
+            <a:br/>
+            <a:r>
+              <a:t>FR3 = Knowledge ONLY from product_catalog_dataset.json</a:t>
+            </a:r>
+            <a:br/>
+            <a:r>
+              <a:t>  ingest → Chroma → hybrid retrieve → synthesize · no web/APIs</a:t>
+            </a:r>
+            <a:br/>
+            <a:r>
+              <a:t>  300 variants · shops 1/3/15 · default 4 picks · up to 20 if asked</a:t>
+            </a:r>
           </a:p>
           <a:p>
             <a:pPr lvl="1">
@@ -11562,8 +11822,8 @@
         </p:blipFill>
         <p:spPr>
           <a:xfrm>
-            <a:off x="6108192" y="1307592"/>
-            <a:ext cx="5577840" cy="3787184"/>
+            <a:off x="6053328" y="1325880"/>
+            <a:ext cx="5102352" cy="2697480"/>
           </a:xfrm>
           <a:prstGeom prst="rect">
             <a:avLst/>
@@ -11767,6 +12027,226 @@
             </a:pPr>
             <a:r>
               <a:t>4</a:t>
+            </a:r>
+          </a:p>
+        </p:txBody>
+      </p:sp>
+      <p:sp>
+        <p:nvSpPr>
+          <p:cNvPr id="21" name="Panel FR24Code"/>
+          <p:cNvSpPr/>
+          <p:nvPr/>
+        </p:nvSpPr>
+        <p:spPr>
+          <a:xfrm>
+            <a:off x="6053328" y="4160520"/>
+            <a:ext cx="5102352" cy="2011680"/>
+          </a:xfrm>
+          <a:prstGeom prst="rect">
+            <a:avLst/>
+          </a:prstGeom>
+          <a:solidFill>
+            <a:srgbClr val="1E293B"/>
+          </a:solidFill>
+          <a:ln>
+            <a:noFill/>
+          </a:ln>
+        </p:spPr>
+        <p:style>
+          <a:lnRef idx="1">
+            <a:schemeClr val="accent1"/>
+          </a:lnRef>
+          <a:fillRef idx="3">
+            <a:schemeClr val="accent1"/>
+          </a:fillRef>
+          <a:effectRef idx="2">
+            <a:schemeClr val="accent1"/>
+          </a:effectRef>
+          <a:fontRef idx="minor">
+            <a:schemeClr val="lt1"/>
+          </a:fontRef>
+        </p:style>
+        <p:txBody>
+          <a:bodyPr rtlCol="0" anchor="ctr"/>
+          <a:lstStyle/>
+          <a:p>
+            <a:pPr algn="ctr"/>
+          </a:p>
+        </p:txBody>
+      </p:sp>
+      <p:sp>
+        <p:nvSpPr>
+          <p:cNvPr id="22" name="TextBox FR24Code"/>
+          <p:cNvSpPr txBox="1"/>
+          <p:nvPr/>
+        </p:nvSpPr>
+        <p:spPr>
+          <a:xfrm>
+            <a:off x="6163056" y="4251960"/>
+            <a:ext cx="4882896" cy="1874520"/>
+          </a:xfrm>
+          <a:prstGeom prst="rect">
+            <a:avLst/>
+          </a:prstGeom>
+          <a:noFill/>
+        </p:spPr>
+        <p:txBody>
+          <a:bodyPr wrap="square" anchor="t">
+            <a:spAutoFit/>
+          </a:bodyPr>
+          <a:lstStyle/>
+          <a:p>
+            <a:pPr>
+              <a:defRPr sz="1100" b="1">
+                <a:solidFill>
+                  <a:srgbClr val="16A34A"/>
+                </a:solidFill>
+                <a:latin typeface="Arial"/>
+              </a:defRPr>
+            </a:pPr>
+            <a:r>
+              <a:t>FR2 + FR3 evidence (source)</a:t>
+            </a:r>
+          </a:p>
+          <a:p>
+            <a:pPr>
+              <a:spcAft>
+                <a:spcPts val="100"/>
+              </a:spcAft>
+              <a:defRPr sz="900">
+                <a:solidFill>
+                  <a:srgbClr val="E2E8F0"/>
+                </a:solidFill>
+                <a:latin typeface="Consolas"/>
+              </a:defRPr>
+            </a:pPr>
+            <a:r>
+              <a:t># models/chat.py — FR2 response contract</a:t>
+            </a:r>
+          </a:p>
+          <a:p>
+            <a:pPr>
+              <a:spcAft>
+                <a:spcPts val="100"/>
+              </a:spcAft>
+              <a:defRPr sz="900">
+                <a:solidFill>
+                  <a:srgbClr val="E2E8F0"/>
+                </a:solidFill>
+                <a:latin typeface="Consolas"/>
+              </a:defRPr>
+            </a:pPr>
+            <a:r>
+              <a:t>class ChatResponse(BaseModel):</a:t>
+            </a:r>
+          </a:p>
+          <a:p>
+            <a:pPr>
+              <a:spcAft>
+                <a:spcPts val="100"/>
+              </a:spcAft>
+              <a:defRPr sz="900">
+                <a:solidFill>
+                  <a:srgbClr val="E2E8F0"/>
+                </a:solidFill>
+                <a:latin typeface="Consolas"/>
+              </a:defRPr>
+            </a:pPr>
+            <a:r>
+              <a:t>    answer: str</a:t>
+            </a:r>
+          </a:p>
+          <a:p>
+            <a:pPr>
+              <a:spcAft>
+                <a:spcPts val="100"/>
+              </a:spcAft>
+              <a:defRPr sz="900">
+                <a:solidFill>
+                  <a:srgbClr val="E2E8F0"/>
+                </a:solidFill>
+                <a:latin typeface="Consolas"/>
+              </a:defRPr>
+            </a:pPr>
+            <a:r>
+              <a:t>    retrieved_products: list[RetrievedProduct]</a:t>
+            </a:r>
+          </a:p>
+          <a:p>
+            <a:pPr>
+              <a:spcAft>
+                <a:spcPts val="100"/>
+              </a:spcAft>
+              <a:defRPr sz="900">
+                <a:solidFill>
+                  <a:srgbClr val="E2E8F0"/>
+                </a:solidFill>
+                <a:latin typeface="Consolas"/>
+              </a:defRPr>
+            </a:pPr>
+          </a:p>
+          <a:p>
+            <a:pPr>
+              <a:spcAft>
+                <a:spcPts val="100"/>
+              </a:spcAft>
+              <a:defRPr sz="900">
+                <a:solidFill>
+                  <a:srgbClr val="E2E8F0"/>
+                </a:solidFill>
+                <a:latin typeface="Consolas"/>
+              </a:defRPr>
+            </a:pPr>
+            <a:r>
+              <a:t># lanes/process.py — FR3 catalog-only RAG</a:t>
+            </a:r>
+          </a:p>
+          <a:p>
+            <a:pPr>
+              <a:spcAft>
+                <a:spcPts val="100"/>
+              </a:spcAft>
+              <a:defRPr sz="900">
+                <a:solidFill>
+                  <a:srgbClr val="E2E8F0"/>
+                </a:solidFill>
+                <a:latin typeface="Consolas"/>
+              </a:defRPr>
+            </a:pPr>
+            <a:r>
+              <a:t>cap = resolve_recommendation_count(query)</a:t>
+            </a:r>
+          </a:p>
+          <a:p>
+            <a:pPr>
+              <a:spcAft>
+                <a:spcPts val="100"/>
+              </a:spcAft>
+              <a:defRPr sz="900">
+                <a:solidFill>
+                  <a:srgbClr val="E2E8F0"/>
+                </a:solidFill>
+                <a:latin typeface="Consolas"/>
+              </a:defRPr>
+            </a:pPr>
+            <a:r>
+              <a:t>hits = search_catalog(query, site_id, n_results=pool_n)</a:t>
+            </a:r>
+          </a:p>
+          <a:p>
+            <a:pPr>
+              <a:spcAft>
+                <a:spcPts val="100"/>
+              </a:spcAft>
+              <a:defRPr sz="900">
+                <a:solidFill>
+                  <a:srgbClr val="E2E8F0"/>
+                </a:solidFill>
+                <a:latin typeface="Consolas"/>
+              </a:defRPr>
+            </a:pPr>
+            <a:r>
+              <a:t>products = [_to_retrieved_product(h) for h in hits][:cap]</a:t>
             </a:r>
           </a:p>
         </p:txBody>
@@ -13268,7 +13748,7 @@
         <p:spPr>
           <a:xfrm>
             <a:off x="749808" y="1417320"/>
-            <a:ext cx="5120640" cy="4663440"/>
+            <a:ext cx="5120640" cy="3429000"/>
           </a:xfrm>
           <a:prstGeom prst="rect">
             <a:avLst/>
@@ -13435,7 +13915,7 @@
         <p:spPr>
           <a:xfrm>
             <a:off x="5989320" y="1417320"/>
-            <a:ext cx="5394960" cy="4663440"/>
+            <a:ext cx="5394960" cy="3429000"/>
           </a:xfrm>
           <a:prstGeom prst="rect">
             <a:avLst/>
@@ -13540,7 +14020,7 @@
               </a:defRPr>
             </a:pPr>
             <a:r>
-              <a:t>• 4 picks default · shopper can ask for more (e.g. 10 opciones, cap 20).</a:t>
+              <a:t>• 4 picks default · shopper can ask for more (e.g. 10 options, cap 20).</a:t>
             </a:r>
           </a:p>
           <a:p>
@@ -13589,6 +14069,194 @@
             </a:pPr>
             <a:r>
               <a:t>• Dynamic species inference (iguana, capibara…) — not a fixed list.</a:t>
+            </a:r>
+          </a:p>
+        </p:txBody>
+      </p:sp>
+      <p:sp>
+        <p:nvSpPr>
+          <p:cNvPr id="18" name="Panel FR3RagCode"/>
+          <p:cNvSpPr/>
+          <p:nvPr/>
+        </p:nvSpPr>
+        <p:spPr>
+          <a:xfrm>
+            <a:off x="5989320" y="4617720"/>
+            <a:ext cx="5394960" cy="1417320"/>
+          </a:xfrm>
+          <a:prstGeom prst="rect">
+            <a:avLst/>
+          </a:prstGeom>
+          <a:solidFill>
+            <a:srgbClr val="1E293B"/>
+          </a:solidFill>
+          <a:ln>
+            <a:noFill/>
+          </a:ln>
+        </p:spPr>
+        <p:style>
+          <a:lnRef idx="1">
+            <a:schemeClr val="accent1"/>
+          </a:lnRef>
+          <a:fillRef idx="3">
+            <a:schemeClr val="accent1"/>
+          </a:fillRef>
+          <a:effectRef idx="2">
+            <a:schemeClr val="accent1"/>
+          </a:effectRef>
+          <a:fontRef idx="minor">
+            <a:schemeClr val="lt1"/>
+          </a:fontRef>
+        </p:style>
+        <p:txBody>
+          <a:bodyPr rtlCol="0" anchor="ctr"/>
+          <a:lstStyle/>
+          <a:p>
+            <a:pPr algn="ctr"/>
+          </a:p>
+        </p:txBody>
+      </p:sp>
+      <p:sp>
+        <p:nvSpPr>
+          <p:cNvPr id="19" name="TextBox FR3RagCode"/>
+          <p:cNvSpPr txBox="1"/>
+          <p:nvPr/>
+        </p:nvSpPr>
+        <p:spPr>
+          <a:xfrm>
+            <a:off x="6099048" y="4709160"/>
+            <a:ext cx="5175504" cy="1280160"/>
+          </a:xfrm>
+          <a:prstGeom prst="rect">
+            <a:avLst/>
+          </a:prstGeom>
+          <a:noFill/>
+        </p:spPr>
+        <p:txBody>
+          <a:bodyPr wrap="square" anchor="t">
+            <a:spAutoFit/>
+          </a:bodyPr>
+          <a:lstStyle/>
+          <a:p>
+            <a:pPr>
+              <a:defRPr sz="1100" b="1">
+                <a:solidFill>
+                  <a:srgbClr val="16A34A"/>
+                </a:solidFill>
+                <a:latin typeface="Arial"/>
+              </a:defRPr>
+            </a:pPr>
+            <a:r>
+              <a:t>FR3 — hybrid RAG + ingest (source)</a:t>
+            </a:r>
+          </a:p>
+          <a:p>
+            <a:pPr>
+              <a:spcAft>
+                <a:spcPts val="100"/>
+              </a:spcAft>
+              <a:defRPr sz="900">
+                <a:solidFill>
+                  <a:srgbClr val="E2E8F0"/>
+                </a:solidFill>
+                <a:latin typeface="Consolas"/>
+              </a:defRPr>
+            </a:pPr>
+            <a:r>
+              <a:t># rag/hybrid.py — site_id filter + fusion</a:t>
+            </a:r>
+          </a:p>
+          <a:p>
+            <a:pPr>
+              <a:spcAft>
+                <a:spcPts val="100"/>
+              </a:spcAft>
+              <a:defRPr sz="900">
+                <a:solidFill>
+                  <a:srgbClr val="E2E8F0"/>
+                </a:solidFill>
+                <a:latin typeface="Consolas"/>
+              </a:defRPr>
+            </a:pPr>
+            <a:r>
+              <a:t>hits = chroma_query(index_dir(), query, site_id, n_results=pool)</a:t>
+            </a:r>
+          </a:p>
+          <a:p>
+            <a:pPr>
+              <a:spcAft>
+                <a:spcPts val="100"/>
+              </a:spcAft>
+              <a:defRPr sz="900">
+                <a:solidFill>
+                  <a:srgbClr val="E2E8F0"/>
+                </a:solidFill>
+                <a:latin typeface="Consolas"/>
+              </a:defRPr>
+            </a:pPr>
+            <a:r>
+              <a:t>hit['hybrid_score'] = fuse_hybrid_scores(vec, bm25, business)</a:t>
+            </a:r>
+          </a:p>
+          <a:p>
+            <a:pPr>
+              <a:spcAft>
+                <a:spcPts val="100"/>
+              </a:spcAft>
+              <a:defRPr sz="900">
+                <a:solidFill>
+                  <a:srgbClr val="E2E8F0"/>
+                </a:solidFill>
+                <a:latin typeface="Consolas"/>
+              </a:defRPr>
+            </a:pPr>
+            <a:r>
+              <a:t>return hits[:n_results]</a:t>
+            </a:r>
+          </a:p>
+          <a:p>
+            <a:pPr>
+              <a:spcAft>
+                <a:spcPts val="100"/>
+              </a:spcAft>
+              <a:defRPr sz="900">
+                <a:solidFill>
+                  <a:srgbClr val="E2E8F0"/>
+                </a:solidFill>
+                <a:latin typeface="Consolas"/>
+              </a:defRPr>
+            </a:pPr>
+          </a:p>
+          <a:p>
+            <a:pPr>
+              <a:spcAft>
+                <a:spcPts val="100"/>
+              </a:spcAft>
+              <a:defRPr sz="900">
+                <a:solidFill>
+                  <a:srgbClr val="E2E8F0"/>
+                </a:solidFill>
+                <a:latin typeface="Consolas"/>
+              </a:defRPr>
+            </a:pPr>
+            <a:r>
+              <a:t># Source of truth: product_catalog_dataset.json only</a:t>
+            </a:r>
+          </a:p>
+          <a:p>
+            <a:pPr>
+              <a:spcAft>
+                <a:spcPts val="100"/>
+              </a:spcAft>
+              <a:defRPr sz="900">
+                <a:solidFill>
+                  <a:srgbClr val="E2E8F0"/>
+                </a:solidFill>
+                <a:latin typeface="Consolas"/>
+              </a:defRPr>
+            </a:pPr>
+            <a:r>
+              <a:t>python -m cli ingest  →  artifacts/index/chroma</a:t>
             </a:r>
           </a:p>
         </p:txBody>
@@ -15906,7 +16574,7 @@
               </a:defRPr>
             </a:pPr>
             <a:r>
-              <a:t>• A: me puedes ayudar → social help, no catalog progress.</a:t>
+              <a:t>• A: can you help me → social help, no catalog progress.</a:t>
             </a:r>
           </a:p>
           <a:p>
@@ -15922,7 +16590,7 @@
               </a:defRPr>
             </a:pPr>
             <a:r>
-              <a:t>• B: y para iguanas → scope reply, no duplicate Hola intro.</a:t>
+              <a:t>• B: and what about iguanas → scope reply, no duplicate greeting intro.</a:t>
             </a:r>
           </a:p>
           <a:p>
@@ -15938,7 +16606,7 @@
               </a:defRPr>
             </a:pPr>
             <a:r>
-              <a:t>• C: dame 10 opciones perros → up to 10 cards in batches.</a:t>
+              <a:t>• C: give me 10 dog food options → up to 10 cards in batches.</a:t>
             </a:r>
           </a:p>
           <a:p>
@@ -16020,8 +16688,8 @@
         </p:blipFill>
         <p:spPr>
           <a:xfrm>
-            <a:off x="6080760" y="1307592"/>
-            <a:ext cx="5577840" cy="6111500"/>
+            <a:off x="6053328" y="1325880"/>
+            <a:ext cx="5102352" cy="3977639"/>
           </a:xfrm>
           <a:prstGeom prst="rect">
             <a:avLst/>
@@ -16225,6 +16893,210 @@
             </a:pPr>
             <a:r>
               <a:t>9</a:t>
+            </a:r>
+          </a:p>
+        </p:txBody>
+      </p:sp>
+      <p:sp>
+        <p:nvSpPr>
+          <p:cNvPr id="21" name="Panel FR4Code"/>
+          <p:cNvSpPr/>
+          <p:nvPr/>
+        </p:nvSpPr>
+        <p:spPr>
+          <a:xfrm>
+            <a:off x="6025896" y="5349240"/>
+            <a:ext cx="5102352" cy="1417320"/>
+          </a:xfrm>
+          <a:prstGeom prst="rect">
+            <a:avLst/>
+          </a:prstGeom>
+          <a:solidFill>
+            <a:srgbClr val="1E293B"/>
+          </a:solidFill>
+          <a:ln>
+            <a:noFill/>
+          </a:ln>
+        </p:spPr>
+        <p:style>
+          <a:lnRef idx="1">
+            <a:schemeClr val="accent1"/>
+          </a:lnRef>
+          <a:fillRef idx="3">
+            <a:schemeClr val="accent1"/>
+          </a:fillRef>
+          <a:effectRef idx="2">
+            <a:schemeClr val="accent1"/>
+          </a:effectRef>
+          <a:fontRef idx="minor">
+            <a:schemeClr val="lt1"/>
+          </a:fontRef>
+        </p:style>
+        <p:txBody>
+          <a:bodyPr rtlCol="0" anchor="ctr"/>
+          <a:lstStyle/>
+          <a:p>
+            <a:pPr algn="ctr"/>
+          </a:p>
+        </p:txBody>
+      </p:sp>
+      <p:sp>
+        <p:nvSpPr>
+          <p:cNvPr id="22" name="TextBox FR4Code"/>
+          <p:cNvSpPr txBox="1"/>
+          <p:nvPr/>
+        </p:nvSpPr>
+        <p:spPr>
+          <a:xfrm>
+            <a:off x="6135624" y="5440680"/>
+            <a:ext cx="4882896" cy="1280160"/>
+          </a:xfrm>
+          <a:prstGeom prst="rect">
+            <a:avLst/>
+          </a:prstGeom>
+          <a:noFill/>
+        </p:spPr>
+        <p:txBody>
+          <a:bodyPr wrap="square" anchor="t">
+            <a:spAutoFit/>
+          </a:bodyPr>
+          <a:lstStyle/>
+          <a:p>
+            <a:pPr>
+              <a:defRPr sz="1100" b="1">
+                <a:solidFill>
+                  <a:srgbClr val="16A34A"/>
+                </a:solidFill>
+                <a:latin typeface="Arial"/>
+              </a:defRPr>
+            </a:pPr>
+            <a:r>
+              <a:t>FR4 — topic_check + constraints (source)</a:t>
+            </a:r>
+          </a:p>
+          <a:p>
+            <a:pPr>
+              <a:spcAft>
+                <a:spcPts val="100"/>
+              </a:spcAft>
+              <a:defRPr sz="900">
+                <a:solidFill>
+                  <a:srgbClr val="E2E8F0"/>
+                </a:solidFill>
+                <a:latin typeface="Consolas"/>
+              </a:defRPr>
+            </a:pPr>
+            <a:r>
+              <a:t># guardian/engine.py — FR4 default-deny</a:t>
+            </a:r>
+          </a:p>
+          <a:p>
+            <a:pPr>
+              <a:spcAft>
+                <a:spcPts val="100"/>
+              </a:spcAft>
+              <a:defRPr sz="900">
+                <a:solidFill>
+                  <a:srgbClr val="E2E8F0"/>
+                </a:solidFill>
+                <a:latin typeface="Consolas"/>
+              </a:defRPr>
+            </a:pPr>
+            <a:r>
+              <a:t>def topic_check(query, site_id=3) -&gt; TopicDecision:</a:t>
+            </a:r>
+          </a:p>
+          <a:p>
+            <a:pPr>
+              <a:spcAft>
+                <a:spcPts val="100"/>
+              </a:spcAft>
+              <a:defRPr sz="900">
+                <a:solidFill>
+                  <a:srgbClr val="E2E8F0"/>
+                </a:solidFill>
+                <a:latin typeface="Consolas"/>
+              </a:defRPr>
+            </a:pPr>
+            <a:r>
+              <a:t>    if OFF_TOPIC_PATTERN.search(query):</a:t>
+            </a:r>
+          </a:p>
+          <a:p>
+            <a:pPr>
+              <a:spcAft>
+                <a:spcPts val="100"/>
+              </a:spcAft>
+              <a:defRPr sz="900">
+                <a:solidFill>
+                  <a:srgbClr val="E2E8F0"/>
+                </a:solidFill>
+                <a:latin typeface="Consolas"/>
+              </a:defRPr>
+            </a:pPr>
+            <a:r>
+              <a:t>        return TopicDecision(decision='DECLINE', ...)</a:t>
+            </a:r>
+          </a:p>
+          <a:p>
+            <a:pPr>
+              <a:spcAft>
+                <a:spcPts val="100"/>
+              </a:spcAft>
+              <a:defRPr sz="900">
+                <a:solidFill>
+                  <a:srgbClr val="E2E8F0"/>
+                </a:solidFill>
+                <a:latin typeface="Consolas"/>
+              </a:defRPr>
+            </a:pPr>
+          </a:p>
+          <a:p>
+            <a:pPr>
+              <a:spcAft>
+                <a:spcPts val="100"/>
+              </a:spcAft>
+              <a:defRPr sz="900">
+                <a:solidFill>
+                  <a:srgbClr val="E2E8F0"/>
+                </a:solidFill>
+                <a:latin typeface="Consolas"/>
+              </a:defRPr>
+            </a:pPr>
+            <a:r>
+              <a:t># constraints.yaml</a:t>
+            </a:r>
+          </a:p>
+          <a:p>
+            <a:pPr>
+              <a:spcAft>
+                <a:spcPts val="100"/>
+              </a:spcAft>
+              <a:defRPr sz="900">
+                <a:solidFill>
+                  <a:srgbClr val="E2E8F0"/>
+                </a:solidFill>
+                <a:latin typeface="Consolas"/>
+              </a:defRPr>
+            </a:pPr>
+            <a:r>
+              <a:t>topic_guard_mode: default_deny</a:t>
+            </a:r>
+          </a:p>
+          <a:p>
+            <a:pPr>
+              <a:spcAft>
+                <a:spcPts val="100"/>
+              </a:spcAft>
+              <a:defRPr sz="900">
+                <a:solidFill>
+                  <a:srgbClr val="E2E8F0"/>
+                </a:solidFill>
+                <a:latin typeface="Consolas"/>
+              </a:defRPr>
+            </a:pPr>
+            <a:r>
+              <a:t>decline_intents: [weather, non_pet_products, ...]</a:t>
             </a:r>
           </a:p>
         </p:txBody>

</xml_diff>

<commit_message>
docs(ppt): add dedicated LangGraph approach slide, pointing to feature/lg-catalog-probe-intent as the standalone showcase
</commit_message>
<xml_diff>
--- a/docs/deliverables/v0.1/zooplus-assistant-interview-15min-pro.pptx
+++ b/docs/deliverables/v0.1/zooplus-assistant-interview-15min-pro.pptx
@@ -18,6 +18,7 @@
     <p:sldId id="264" r:id="rId16"/>
     <p:sldId id="265" r:id="rId17"/>
     <p:sldId id="266" r:id="rId18"/>
+    <p:sldId id="270" r:id="rId22"/>
     <p:sldId id="269" r:id="rId21"/>
   </p:sldIdLst>
   <p:sldSz cx="12191695" cy="6858000" type="screen4x3"/>
@@ -8621,7 +8622,7 @@
               </a:defRPr>
             </a:pPr>
             <a:r>
-              <a:t>14</a:t>
+              <a:t>15</a:t>
             </a:r>
           </a:p>
         </p:txBody>
@@ -8855,6 +8856,1016 @@
             </a:pPr>
             <a:r>
               <a:t>v2.1.6 — Dynamic count (4→20); phrase index; product_batch UI.</a:t>
+            </a:r>
+          </a:p>
+        </p:txBody>
+      </p:sp>
+    </p:spTree>
+  </p:cSld>
+  <p:clrMapOvr>
+    <a:masterClrMapping/>
+  </p:clrMapOvr>
+</p:sld>
+</file>
+
+<file path=ppt/slides/slide15.xml><?xml version="1.0" encoding="utf-8"?>
+<p:sld xmlns:a="http://schemas.openxmlformats.org/drawingml/2006/main" xmlns:p="http://schemas.openxmlformats.org/presentationml/2006/main" xmlns:r="http://schemas.openxmlformats.org/officeDocument/2006/relationships">
+  <p:cSld>
+    <p:spTree>
+      <p:nvGrpSpPr>
+        <p:cNvPr id="1" name=""/>
+        <p:cNvGrpSpPr/>
+        <p:nvPr/>
+      </p:nvGrpSpPr>
+      <p:grpSpPr/>
+      <p:sp>
+        <p:nvSpPr>
+          <p:cNvPr id="2" name="Rectangle 1"/>
+          <p:cNvSpPr/>
+          <p:nvPr/>
+        </p:nvSpPr>
+        <p:spPr>
+          <a:xfrm>
+            <a:off x="429768" y="0"/>
+            <a:ext cx="11761927" cy="6858000"/>
+          </a:xfrm>
+          <a:prstGeom prst="rect">
+            <a:avLst/>
+          </a:prstGeom>
+          <a:solidFill>
+            <a:srgbClr val="FFFFFF"/>
+          </a:solidFill>
+          <a:ln>
+            <a:noFill/>
+          </a:ln>
+        </p:spPr>
+        <p:style>
+          <a:lnRef idx="1">
+            <a:schemeClr val="accent1"/>
+          </a:lnRef>
+          <a:fillRef idx="3">
+            <a:schemeClr val="accent1"/>
+          </a:fillRef>
+          <a:effectRef idx="2">
+            <a:schemeClr val="accent1"/>
+          </a:effectRef>
+          <a:fontRef idx="minor">
+            <a:schemeClr val="lt1"/>
+          </a:fontRef>
+        </p:style>
+        <p:txBody>
+          <a:bodyPr rtlCol="0" anchor="ctr"/>
+          <a:lstStyle/>
+          <a:p>
+            <a:pPr algn="ctr"/>
+          </a:p>
+        </p:txBody>
+      </p:sp>
+      <p:sp>
+        <p:nvSpPr>
+          <p:cNvPr id="3" name="Rectangle 2"/>
+          <p:cNvSpPr/>
+          <p:nvPr/>
+        </p:nvSpPr>
+        <p:spPr>
+          <a:xfrm>
+            <a:off x="0" y="0"/>
+            <a:ext cx="384048" cy="6858000"/>
+          </a:xfrm>
+          <a:prstGeom prst="rect">
+            <a:avLst/>
+          </a:prstGeom>
+          <a:solidFill>
+            <a:srgbClr val="0A2540"/>
+          </a:solidFill>
+          <a:ln>
+            <a:noFill/>
+          </a:ln>
+        </p:spPr>
+        <p:style>
+          <a:lnRef idx="1">
+            <a:schemeClr val="accent1"/>
+          </a:lnRef>
+          <a:fillRef idx="3">
+            <a:schemeClr val="accent1"/>
+          </a:fillRef>
+          <a:effectRef idx="2">
+            <a:schemeClr val="accent1"/>
+          </a:effectRef>
+          <a:fontRef idx="minor">
+            <a:schemeClr val="lt1"/>
+          </a:fontRef>
+        </p:style>
+        <p:txBody>
+          <a:bodyPr rtlCol="0" anchor="ctr"/>
+          <a:lstStyle/>
+          <a:p>
+            <a:pPr algn="ctr"/>
+          </a:p>
+        </p:txBody>
+      </p:sp>
+      <p:sp>
+        <p:nvSpPr>
+          <p:cNvPr id="4" name="Rectangle 3"/>
+          <p:cNvSpPr/>
+          <p:nvPr/>
+        </p:nvSpPr>
+        <p:spPr>
+          <a:xfrm>
+            <a:off x="384048" y="0"/>
+            <a:ext cx="45720" cy="6858000"/>
+          </a:xfrm>
+          <a:prstGeom prst="rect">
+            <a:avLst/>
+          </a:prstGeom>
+          <a:solidFill>
+            <a:srgbClr val="2563EB"/>
+          </a:solidFill>
+          <a:ln>
+            <a:noFill/>
+          </a:ln>
+        </p:spPr>
+        <p:style>
+          <a:lnRef idx="1">
+            <a:schemeClr val="accent1"/>
+          </a:lnRef>
+          <a:fillRef idx="3">
+            <a:schemeClr val="accent1"/>
+          </a:fillRef>
+          <a:effectRef idx="2">
+            <a:schemeClr val="accent1"/>
+          </a:effectRef>
+          <a:fontRef idx="minor">
+            <a:schemeClr val="lt1"/>
+          </a:fontRef>
+        </p:style>
+        <p:txBody>
+          <a:bodyPr rtlCol="0" anchor="ctr"/>
+          <a:lstStyle/>
+          <a:p>
+            <a:pPr algn="ctr"/>
+          </a:p>
+        </p:txBody>
+      </p:sp>
+      <p:sp>
+        <p:nvSpPr>
+          <p:cNvPr id="5" name="Rectangle 4"/>
+          <p:cNvSpPr/>
+          <p:nvPr/>
+        </p:nvSpPr>
+        <p:spPr>
+          <a:xfrm>
+            <a:off x="429768" y="0"/>
+            <a:ext cx="11761927" cy="1115568"/>
+          </a:xfrm>
+          <a:prstGeom prst="rect">
+            <a:avLst/>
+          </a:prstGeom>
+          <a:solidFill>
+            <a:srgbClr val="0A2540"/>
+          </a:solidFill>
+          <a:ln>
+            <a:noFill/>
+          </a:ln>
+        </p:spPr>
+        <p:style>
+          <a:lnRef idx="1">
+            <a:schemeClr val="accent1"/>
+          </a:lnRef>
+          <a:fillRef idx="3">
+            <a:schemeClr val="accent1"/>
+          </a:fillRef>
+          <a:effectRef idx="2">
+            <a:schemeClr val="accent1"/>
+          </a:effectRef>
+          <a:fontRef idx="minor">
+            <a:schemeClr val="lt1"/>
+          </a:fontRef>
+        </p:style>
+        <p:txBody>
+          <a:bodyPr rtlCol="0" anchor="ctr"/>
+          <a:lstStyle/>
+          <a:p>
+            <a:pPr algn="ctr"/>
+          </a:p>
+        </p:txBody>
+      </p:sp>
+      <p:sp>
+        <p:nvSpPr>
+          <p:cNvPr id="6" name="Rectangle 5"/>
+          <p:cNvSpPr/>
+          <p:nvPr/>
+        </p:nvSpPr>
+        <p:spPr>
+          <a:xfrm>
+            <a:off x="429768" y="1115568"/>
+            <a:ext cx="11761927" cy="54864"/>
+          </a:xfrm>
+          <a:prstGeom prst="rect">
+            <a:avLst/>
+          </a:prstGeom>
+          <a:solidFill>
+            <a:srgbClr val="2563EB"/>
+          </a:solidFill>
+          <a:ln>
+            <a:noFill/>
+          </a:ln>
+        </p:spPr>
+        <p:style>
+          <a:lnRef idx="1">
+            <a:schemeClr val="accent1"/>
+          </a:lnRef>
+          <a:fillRef idx="3">
+            <a:schemeClr val="accent1"/>
+          </a:fillRef>
+          <a:effectRef idx="2">
+            <a:schemeClr val="accent1"/>
+          </a:effectRef>
+          <a:fontRef idx="minor">
+            <a:schemeClr val="lt1"/>
+          </a:fontRef>
+        </p:style>
+        <p:txBody>
+          <a:bodyPr rtlCol="0" anchor="ctr"/>
+          <a:lstStyle/>
+          <a:p>
+            <a:pPr algn="ctr"/>
+          </a:p>
+        </p:txBody>
+      </p:sp>
+      <p:sp>
+        <p:nvSpPr>
+          <p:cNvPr id="7" name="Rectangle 6"/>
+          <p:cNvSpPr/>
+          <p:nvPr/>
+        </p:nvSpPr>
+        <p:spPr>
+          <a:xfrm>
+            <a:off x="429768" y="6419088"/>
+            <a:ext cx="11761927" cy="438912"/>
+          </a:xfrm>
+          <a:prstGeom prst="rect">
+            <a:avLst/>
+          </a:prstGeom>
+          <a:solidFill>
+            <a:srgbClr val="0A2540"/>
+          </a:solidFill>
+          <a:ln>
+            <a:noFill/>
+          </a:ln>
+        </p:spPr>
+        <p:style>
+          <a:lnRef idx="1">
+            <a:schemeClr val="accent1"/>
+          </a:lnRef>
+          <a:fillRef idx="3">
+            <a:schemeClr val="accent1"/>
+          </a:fillRef>
+          <a:effectRef idx="2">
+            <a:schemeClr val="accent1"/>
+          </a:effectRef>
+          <a:fontRef idx="minor">
+            <a:schemeClr val="lt1"/>
+          </a:fontRef>
+        </p:style>
+        <p:txBody>
+          <a:bodyPr rtlCol="0" anchor="ctr"/>
+          <a:lstStyle/>
+          <a:p>
+            <a:pPr algn="ctr"/>
+          </a:p>
+        </p:txBody>
+      </p:sp>
+      <p:sp>
+        <p:nvSpPr>
+          <p:cNvPr id="8" name="Rectangle 7"/>
+          <p:cNvSpPr/>
+          <p:nvPr/>
+        </p:nvSpPr>
+        <p:spPr>
+          <a:xfrm>
+            <a:off x="0" y="0"/>
+            <a:ext cx="384048" cy="6858000"/>
+          </a:xfrm>
+          <a:prstGeom prst="rect">
+            <a:avLst/>
+          </a:prstGeom>
+          <a:solidFill>
+            <a:srgbClr val="0A2540"/>
+          </a:solidFill>
+          <a:ln>
+            <a:noFill/>
+          </a:ln>
+        </p:spPr>
+        <p:style>
+          <a:lnRef idx="1">
+            <a:schemeClr val="accent1"/>
+          </a:lnRef>
+          <a:fillRef idx="3">
+            <a:schemeClr val="accent1"/>
+          </a:fillRef>
+          <a:effectRef idx="2">
+            <a:schemeClr val="accent1"/>
+          </a:effectRef>
+          <a:fontRef idx="minor">
+            <a:schemeClr val="lt1"/>
+          </a:fontRef>
+        </p:style>
+        <p:txBody>
+          <a:bodyPr rtlCol="0" anchor="ctr"/>
+          <a:lstStyle/>
+          <a:p>
+            <a:pPr algn="ctr"/>
+          </a:p>
+        </p:txBody>
+      </p:sp>
+      <p:sp>
+        <p:nvSpPr>
+          <p:cNvPr id="9" name="Rectangle 8"/>
+          <p:cNvSpPr/>
+          <p:nvPr/>
+        </p:nvSpPr>
+        <p:spPr>
+          <a:xfrm>
+            <a:off x="384048" y="0"/>
+            <a:ext cx="45720" cy="6858000"/>
+          </a:xfrm>
+          <a:prstGeom prst="rect">
+            <a:avLst/>
+          </a:prstGeom>
+          <a:solidFill>
+            <a:srgbClr val="2563EB"/>
+          </a:solidFill>
+          <a:ln>
+            <a:noFill/>
+          </a:ln>
+        </p:spPr>
+        <p:style>
+          <a:lnRef idx="1">
+            <a:schemeClr val="accent1"/>
+          </a:lnRef>
+          <a:fillRef idx="3">
+            <a:schemeClr val="accent1"/>
+          </a:fillRef>
+          <a:effectRef idx="2">
+            <a:schemeClr val="accent1"/>
+          </a:effectRef>
+          <a:fontRef idx="minor">
+            <a:schemeClr val="lt1"/>
+          </a:fontRef>
+        </p:style>
+        <p:txBody>
+          <a:bodyPr rtlCol="0" anchor="ctr"/>
+          <a:lstStyle/>
+          <a:p>
+            <a:pPr algn="ctr"/>
+          </a:p>
+        </p:txBody>
+      </p:sp>
+      <p:sp>
+        <p:nvSpPr>
+          <p:cNvPr id="10" name="TextBox 9"/>
+          <p:cNvSpPr txBox="1"/>
+          <p:nvPr/>
+        </p:nvSpPr>
+        <p:spPr>
+          <a:xfrm>
+            <a:off x="658368" y="182880"/>
+            <a:ext cx="9144000" cy="566928"/>
+          </a:xfrm>
+          <a:prstGeom prst="rect">
+            <a:avLst/>
+          </a:prstGeom>
+          <a:noFill/>
+        </p:spPr>
+        <p:txBody>
+          <a:bodyPr wrap="square" anchor="t">
+            <a:spAutoFit/>
+          </a:bodyPr>
+          <a:lstStyle/>
+          <a:p>
+            <a:pPr algn="l">
+              <a:defRPr sz="3400" b="1">
+                <a:solidFill>
+                  <a:srgbClr val="FFFFFF"/>
+                </a:solidFill>
+                <a:latin typeface="Arial"/>
+              </a:defRPr>
+            </a:pPr>
+            <a:r>
+              <a:t>LangGraph approach — standalone showcase branch</a:t>
+            </a:r>
+          </a:p>
+        </p:txBody>
+      </p:sp>
+      <p:sp>
+        <p:nvSpPr>
+          <p:cNvPr id="11" name="TextBox 10"/>
+          <p:cNvSpPr txBox="1"/>
+          <p:nvPr/>
+        </p:nvSpPr>
+        <p:spPr>
+          <a:xfrm>
+            <a:off x="658368" y="713232"/>
+            <a:ext cx="8046720" cy="347472"/>
+          </a:xfrm>
+          <a:prstGeom prst="rect">
+            <a:avLst/>
+          </a:prstGeom>
+          <a:noFill/>
+        </p:spPr>
+        <p:txBody>
+          <a:bodyPr wrap="square" anchor="t">
+            <a:spAutoFit/>
+          </a:bodyPr>
+          <a:lstStyle/>
+          <a:p>
+            <a:pPr algn="l">
+              <a:defRPr sz="1700" b="0">
+                <a:solidFill>
+                  <a:srgbClr val="BFDBFE"/>
+                </a:solidFill>
+                <a:latin typeface="Arial"/>
+              </a:defRPr>
+            </a:pPr>
+            <a:r>
+              <a:t>Faithful node/edge translation — every node calls this repo's own functions</a:t>
+            </a:r>
+          </a:p>
+        </p:txBody>
+      </p:sp>
+      <p:sp>
+        <p:nvSpPr>
+          <p:cNvPr id="12" name="Rectangle 11"/>
+          <p:cNvSpPr/>
+          <p:nvPr/>
+        </p:nvSpPr>
+        <p:spPr>
+          <a:xfrm>
+            <a:off x="10241280" y="292608"/>
+            <a:ext cx="1600200" cy="438912"/>
+          </a:xfrm>
+          <a:prstGeom prst="rect">
+            <a:avLst/>
+          </a:prstGeom>
+          <a:solidFill>
+            <a:srgbClr val="2563EB"/>
+          </a:solidFill>
+          <a:ln>
+            <a:noFill/>
+          </a:ln>
+        </p:spPr>
+        <p:style>
+          <a:lnRef idx="1">
+            <a:schemeClr val="accent1"/>
+          </a:lnRef>
+          <a:fillRef idx="3">
+            <a:schemeClr val="accent1"/>
+          </a:fillRef>
+          <a:effectRef idx="2">
+            <a:schemeClr val="accent1"/>
+          </a:effectRef>
+          <a:fontRef idx="minor">
+            <a:schemeClr val="lt1"/>
+          </a:fontRef>
+        </p:style>
+        <p:txBody>
+          <a:bodyPr rtlCol="0" anchor="ctr"/>
+          <a:lstStyle/>
+          <a:p>
+            <a:pPr algn="ctr"/>
+          </a:p>
+        </p:txBody>
+      </p:sp>
+      <p:sp>
+        <p:nvSpPr>
+          <p:cNvPr id="13" name="TextBox 12"/>
+          <p:cNvSpPr txBox="1"/>
+          <p:nvPr/>
+        </p:nvSpPr>
+        <p:spPr>
+          <a:xfrm>
+            <a:off x="10314432" y="347472"/>
+            <a:ext cx="1463040" cy="365760"/>
+          </a:xfrm>
+          <a:prstGeom prst="rect">
+            <a:avLst/>
+          </a:prstGeom>
+          <a:noFill/>
+        </p:spPr>
+        <p:txBody>
+          <a:bodyPr wrap="square" anchor="t">
+            <a:spAutoFit/>
+          </a:bodyPr>
+          <a:lstStyle/>
+          <a:p>
+            <a:pPr algn="ctr">
+              <a:defRPr sz="1300" b="1">
+                <a:solidFill>
+                  <a:srgbClr val="FFFFFF"/>
+                </a:solidFill>
+                <a:latin typeface="Arial"/>
+              </a:defRPr>
+            </a:pPr>
+            <a:r>
+              <a:t>Architecture · LG</a:t>
+            </a:r>
+          </a:p>
+        </p:txBody>
+      </p:sp>
+      <p:sp>
+        <p:nvSpPr>
+          <p:cNvPr id="14" name="TextBox 13"/>
+          <p:cNvSpPr txBox="1"/>
+          <p:nvPr/>
+        </p:nvSpPr>
+        <p:spPr>
+          <a:xfrm>
+            <a:off x="658368" y="6492240"/>
+            <a:ext cx="9326880" cy="329184"/>
+          </a:xfrm>
+          <a:prstGeom prst="rect">
+            <a:avLst/>
+          </a:prstGeom>
+          <a:noFill/>
+        </p:spPr>
+        <p:txBody>
+          <a:bodyPr wrap="square" anchor="t">
+            <a:spAutoFit/>
+          </a:bodyPr>
+          <a:lstStyle/>
+          <a:p>
+            <a:pPr algn="l">
+              <a:defRPr sz="1200" b="0">
+                <a:solidFill>
+                  <a:srgbClr val="BFDBFE"/>
+                </a:solidFill>
+                <a:latin typeface="Arial"/>
+              </a:defRPr>
+            </a:pPr>
+            <a:r>
+              <a:t>zooplus Assistant — Coding Task PoC v0.1</a:t>
+            </a:r>
+          </a:p>
+        </p:txBody>
+      </p:sp>
+      <p:sp>
+        <p:nvSpPr>
+          <p:cNvPr id="15" name="TextBox 14"/>
+          <p:cNvSpPr txBox="1"/>
+          <p:nvPr/>
+        </p:nvSpPr>
+        <p:spPr>
+          <a:xfrm>
+            <a:off x="11155680" y="6473952"/>
+            <a:ext cx="868680" cy="329184"/>
+          </a:xfrm>
+          <a:prstGeom prst="rect">
+            <a:avLst/>
+          </a:prstGeom>
+          <a:noFill/>
+        </p:spPr>
+        <p:txBody>
+          <a:bodyPr wrap="square" anchor="t">
+            <a:spAutoFit/>
+          </a:bodyPr>
+          <a:lstStyle/>
+          <a:p>
+            <a:pPr algn="l">
+              <a:defRPr sz="1500" b="1">
+                <a:solidFill>
+                  <a:srgbClr val="FFFFFF"/>
+                </a:solidFill>
+                <a:latin typeface="Arial"/>
+              </a:defRPr>
+            </a:pPr>
+            <a:r>
+              <a:t>14</a:t>
+            </a:r>
+          </a:p>
+        </p:txBody>
+      </p:sp>
+      <p:sp>
+        <p:nvSpPr>
+          <p:cNvPr id="16" name="Rectangle 15"/>
+          <p:cNvSpPr/>
+          <p:nvPr/>
+        </p:nvSpPr>
+        <p:spPr>
+          <a:xfrm>
+            <a:off x="585216" y="1261872"/>
+            <a:ext cx="10972800" cy="4983480"/>
+          </a:xfrm>
+          <a:prstGeom prst="rect">
+            <a:avLst/>
+          </a:prstGeom>
+          <a:solidFill>
+            <a:srgbClr val="F8FAFC"/>
+          </a:solidFill>
+          <a:ln>
+            <a:noFill/>
+          </a:ln>
+        </p:spPr>
+        <p:style>
+          <a:lnRef idx="1">
+            <a:schemeClr val="accent1"/>
+          </a:lnRef>
+          <a:fillRef idx="3">
+            <a:schemeClr val="accent1"/>
+          </a:fillRef>
+          <a:effectRef idx="2">
+            <a:schemeClr val="accent1"/>
+          </a:effectRef>
+          <a:fontRef idx="minor">
+            <a:schemeClr val="lt1"/>
+          </a:fontRef>
+        </p:style>
+        <p:txBody>
+          <a:bodyPr rtlCol="0" anchor="ctr"/>
+          <a:lstStyle/>
+          <a:p>
+            <a:pPr algn="ctr"/>
+          </a:p>
+        </p:txBody>
+      </p:sp>
+      <p:sp>
+        <p:nvSpPr>
+          <p:cNvPr id="17" name="TextBox 16"/>
+          <p:cNvSpPr txBox="1"/>
+          <p:nvPr/>
+        </p:nvSpPr>
+        <p:spPr>
+          <a:xfrm>
+            <a:off x="749808" y="1417320"/>
+            <a:ext cx="5349240" cy="4663440"/>
+          </a:xfrm>
+          <a:prstGeom prst="rect">
+            <a:avLst/>
+          </a:prstGeom>
+          <a:noFill/>
+        </p:spPr>
+        <p:txBody>
+          <a:bodyPr wrap="square" anchor="t">
+            <a:spAutoFit/>
+          </a:bodyPr>
+          <a:lstStyle/>
+          <a:p>
+            <a:pPr>
+              <a:spcAft>
+                <a:spcPts val="600"/>
+              </a:spcAft>
+              <a:defRPr sz="1300" b="1">
+                <a:solidFill>
+                  <a:srgbClr val="0A2540"/>
+                </a:solidFill>
+                <a:latin typeface="Arial"/>
+              </a:defRPr>
+            </a:pPr>
+            <a:r>
+              <a:t>feature/lg-catalog-probe-intent</a:t>
+            </a:r>
+          </a:p>
+          <a:p>
+            <a:pPr>
+              <a:spcAft>
+                <a:spcPts val="600"/>
+              </a:spcAft>
+              <a:defRPr sz="1300" b="0">
+                <a:solidFill>
+                  <a:srgbClr val="334155"/>
+                </a:solidFill>
+                <a:latin typeface="Arial"/>
+              </a:defRPr>
+            </a:pPr>
+            <a:r>
+              <a:t>• Standalone branch — not merged into dev/main/releases.</a:t>
+            </a:r>
+          </a:p>
+          <a:p>
+            <a:pPr>
+              <a:spcAft>
+                <a:spcPts val="600"/>
+              </a:spcAft>
+              <a:defRPr sz="1300" b="0">
+                <a:solidFill>
+                  <a:srgbClr val="334155"/>
+                </a:solidFill>
+                <a:latin typeface="Arial"/>
+              </a:defRPr>
+            </a:pPr>
+            <a:r>
+              <a:t>• Same agentic core re-expressed as an explicit LangGraph StateGraph</a:t>
+            </a:r>
+          </a:p>
+          <a:p>
+            <a:pPr>
+              <a:spcAft>
+                <a:spcPts val="600"/>
+              </a:spcAft>
+              <a:defRPr sz="1300" b="0">
+                <a:solidFill>
+                  <a:srgbClr val="334155"/>
+                </a:solidFill>
+                <a:latin typeface="Arial"/>
+              </a:defRPr>
+            </a:pPr>
+            <a:r>
+              <a:t>  (nodes + typed conditional edges) instead of Python if/else.</a:t>
+            </a:r>
+          </a:p>
+          <a:p>
+            <a:pPr>
+              <a:spcAft>
+                <a:spcPts val="600"/>
+              </a:spcAft>
+              <a:defRPr sz="1300" b="0">
+                <a:solidFill>
+                  <a:srgbClr val="334155"/>
+                </a:solidFill>
+                <a:latin typeface="Arial"/>
+              </a:defRPr>
+            </a:pPr>
+            <a:r>
+              <a:t>• Design rule: every node calls THIS repo's own orchestrator</a:t>
+            </a:r>
+          </a:p>
+          <a:p>
+            <a:pPr>
+              <a:spcAft>
+                <a:spcPts val="600"/>
+              </a:spcAft>
+              <a:defRPr sz="1300" b="0">
+                <a:solidFill>
+                  <a:srgbClr val="334155"/>
+                </a:solidFill>
+                <a:latin typeface="Arial"/>
+              </a:defRPr>
+            </a:pPr>
+            <a:r>
+              <a:t>  functions directly — zero re-implemented logic, nothing invented.</a:t>
+            </a:r>
+          </a:p>
+          <a:p>
+            <a:pPr>
+              <a:spcAft>
+                <a:spcPts val="600"/>
+              </a:spcAft>
+              <a:defRPr sz="1300" b="1">
+                <a:solidFill>
+                  <a:srgbClr val="0A2540"/>
+                </a:solidFill>
+                <a:latin typeface="Arial"/>
+              </a:defRPr>
+            </a:pPr>
+            <a:r>
+              <a:t>Why explore a state graph</a:t>
+            </a:r>
+          </a:p>
+          <a:p>
+            <a:pPr>
+              <a:spcAft>
+                <a:spcPts val="600"/>
+              </a:spcAft>
+              <a:defRPr sz="1300" b="0">
+                <a:solidFill>
+                  <a:srgbClr val="334155"/>
+                </a:solidFill>
+                <a:latin typeface="Arial"/>
+              </a:defRPr>
+            </a:pPr>
+            <a:r>
+              <a:t>• Retry/fallback decisions become named, independently unit-tested</a:t>
+            </a:r>
+          </a:p>
+          <a:p>
+            <a:pPr>
+              <a:spcAft>
+                <a:spcPts val="600"/>
+              </a:spcAft>
+              <a:defRPr sz="1300" b="0">
+                <a:solidFill>
+                  <a:srgbClr val="334155"/>
+                </a:solidFill>
+                <a:latin typeface="Arial"/>
+              </a:defRPr>
+            </a:pPr>
+            <a:r>
+              <a:t>  routing functions instead of nested control flow in one function.</a:t>
+            </a:r>
+          </a:p>
+          <a:p>
+            <a:pPr>
+              <a:spcAft>
+                <a:spcPts val="600"/>
+              </a:spcAft>
+              <a:defRPr sz="1300" b="0">
+                <a:solidFill>
+                  <a:srgbClr val="334155"/>
+                </a:solidFill>
+                <a:latin typeface="Arial"/>
+              </a:defRPr>
+            </a:pPr>
+            <a:r>
+              <a:t>• Declarative node/edge graph — visualizable, replayable per request.</a:t>
+            </a:r>
+          </a:p>
+        </p:txBody>
+      </p:sp>
+      <p:sp>
+        <p:nvSpPr>
+          <p:cNvPr id="18" name="TextBox 17"/>
+          <p:cNvSpPr txBox="1"/>
+          <p:nvPr/>
+        </p:nvSpPr>
+        <p:spPr>
+          <a:xfrm>
+            <a:off x="6126480" y="1417320"/>
+            <a:ext cx="5257800" cy="4663440"/>
+          </a:xfrm>
+          <a:prstGeom prst="rect">
+            <a:avLst/>
+          </a:prstGeom>
+          <a:noFill/>
+        </p:spPr>
+        <p:txBody>
+          <a:bodyPr wrap="square" anchor="t">
+            <a:spAutoFit/>
+          </a:bodyPr>
+          <a:lstStyle/>
+          <a:p>
+            <a:pPr>
+              <a:spcAft>
+                <a:spcPts val="600"/>
+              </a:spcAft>
+              <a:defRPr sz="1300" b="1">
+                <a:solidFill>
+                  <a:srgbClr val="0A2540"/>
+                </a:solidFill>
+                <a:latin typeface="Arial"/>
+              </a:defRPr>
+            </a:pPr>
+            <a:r>
+              <a:t>Topology on that branch</a:t>
+            </a:r>
+          </a:p>
+          <a:p>
+            <a:pPr>
+              <a:spcAft>
+                <a:spcPts val="600"/>
+              </a:spcAft>
+              <a:defRPr sz="1300" b="0">
+                <a:solidFill>
+                  <a:srgbClr val="334155"/>
+                </a:solidFill>
+                <a:latin typeface="Arial"/>
+              </a:defRPr>
+            </a:pPr>
+            <a:r>
+              <a:t>• cache_check -&gt; classify_intent -&gt; [route_by_lane]</a:t>
+            </a:r>
+          </a:p>
+          <a:p>
+            <a:pPr>
+              <a:spcAft>
+                <a:spcPts val="600"/>
+              </a:spcAft>
+              <a:defRPr sz="1300" b="0">
+                <a:solidFill>
+                  <a:srgbClr val="334155"/>
+                </a:solidFill>
+                <a:latin typeface="Arial"/>
+              </a:defRPr>
+            </a:pPr>
+            <a:r>
+              <a:t>•      -&gt; social (decline_off_topic | conversational)</a:t>
+            </a:r>
+          </a:p>
+          <a:p>
+            <a:pPr>
+              <a:spcAft>
+                <a:spcPts val="600"/>
+              </a:spcAft>
+              <a:defRPr sz="1300" b="0">
+                <a:solidFill>
+                  <a:srgbClr val="334155"/>
+                </a:solidFill>
+                <a:latin typeface="Arial"/>
+              </a:defRPr>
+            </a:pPr>
+            <a:r>
+              <a:t>•      -&gt; prefetch -&gt; process_lane (catalog_search)</a:t>
+            </a:r>
+          </a:p>
+          <a:p>
+            <a:pPr>
+              <a:spcAft>
+                <a:spcPts val="600"/>
+              </a:spcAft>
+              <a:defRPr sz="1300" b="0">
+                <a:solidFill>
+                  <a:srgbClr val="334155"/>
+                </a:solidFill>
+                <a:latin typeface="Arial"/>
+              </a:defRPr>
+            </a:pPr>
+            <a:r>
+              <a:t>• -&gt; cache_store -&gt; END</a:t>
+            </a:r>
+          </a:p>
+          <a:p>
+            <a:pPr>
+              <a:spcAft>
+                <a:spcPts val="600"/>
+              </a:spcAft>
+              <a:defRPr sz="1300" b="0">
+                <a:solidFill>
+                  <a:srgbClr val="334155"/>
+                </a:solidFill>
+                <a:latin typeface="Arial"/>
+              </a:defRPr>
+            </a:pPr>
+            <a:r>
+              <a:t>• process_lane calls dispatch_process(run_process_lane) directly —</a:t>
+            </a:r>
+          </a:p>
+          <a:p>
+            <a:pPr>
+              <a:spcAft>
+                <a:spcPts val="600"/>
+              </a:spcAft>
+              <a:defRPr sz="1300" b="0">
+                <a:solidFill>
+                  <a:srgbClr val="334155"/>
+                </a:solidFill>
+                <a:latin typeface="Arial"/>
+              </a:defRPr>
+            </a:pPr>
+            <a:r>
+              <a:t>  the same ACP dispatch this repo's catalog lane already used.</a:t>
+            </a:r>
+          </a:p>
+          <a:p>
+            <a:pPr>
+              <a:spcAft>
+                <a:spcPts val="600"/>
+              </a:spcAft>
+              <a:defRPr sz="1300" b="1">
+                <a:solidFill>
+                  <a:srgbClr val="0A2540"/>
+                </a:solidFill>
+                <a:latin typeface="Arial"/>
+              </a:defRPr>
+            </a:pPr>
+            <a:r>
+              <a:t>What a full audit found</a:t>
+            </a:r>
+          </a:p>
+          <a:p>
+            <a:pPr>
+              <a:spcAft>
+                <a:spcPts val="600"/>
+              </a:spcAft>
+              <a:defRPr sz="1300" b="0">
+                <a:solidFill>
+                  <a:srgbClr val="334155"/>
+                </a:solidFill>
+                <a:latin typeface="Arial"/>
+              </a:defRPr>
+            </a:pPr>
+            <a:r>
+              <a:t>• 2 real gaps in an earlier, looser translation: UI model override</a:t>
+            </a:r>
+          </a:p>
+          <a:p>
+            <a:pPr>
+              <a:spcAft>
+                <a:spcPts val="600"/>
+              </a:spcAft>
+              <a:defRPr sz="1300" b="0">
+                <a:solidFill>
+                  <a:srgbClr val="334155"/>
+                </a:solidFill>
+                <a:latin typeface="Arial"/>
+              </a:defRPr>
+            </a:pPr>
+            <a:r>
+              <a:t>  silently ignored; no chat-level cache. Both closed by calling the</a:t>
+            </a:r>
+          </a:p>
+          <a:p>
+            <a:pPr>
+              <a:spcAft>
+                <a:spcPts val="600"/>
+              </a:spcAft>
+              <a:defRPr sz="1300" b="0">
+                <a:solidFill>
+                  <a:srgbClr val="334155"/>
+                </a:solidFill>
+                <a:latin typeface="Arial"/>
+              </a:defRPr>
+            </a:pPr>
+            <a:r>
+              <a:t>  real functions instead of re-deriving equivalent-looking logic.</a:t>
             </a:r>
           </a:p>
         </p:txBody>

</xml_diff>

<commit_message>
docs(ppt): expand LangGraph slide into 3 technical slides (topology, node-by-node calls, audit findings + verified results)
</commit_message>
<xml_diff>
--- a/docs/deliverables/v0.1/zooplus-assistant-interview-15min-pro.pptx
+++ b/docs/deliverables/v0.1/zooplus-assistant-interview-15min-pro.pptx
@@ -19,6 +19,8 @@
     <p:sldId id="265" r:id="rId17"/>
     <p:sldId id="266" r:id="rId18"/>
     <p:sldId id="270" r:id="rId22"/>
+    <p:sldId id="271" r:id="rId23"/>
+    <p:sldId id="272" r:id="rId24"/>
     <p:sldId id="269" r:id="rId21"/>
   </p:sldIdLst>
   <p:sldSz cx="12191695" cy="6858000" type="screen4x3"/>
@@ -8435,7 +8437,7 @@
               </a:defRPr>
             </a:pPr>
             <a:r>
-              <a:t>Release progress — v0.1.0 → v2.1.6</a:t>
+              <a:t>LangGraph 1/3 — explicit graph vs Python branches</a:t>
             </a:r>
           </a:p>
         </p:txBody>
@@ -8471,7 +8473,7 @@
               </a:defRPr>
             </a:pPr>
             <a:r>
-              <a:t>Same five FRs · smarter social routing, flexible picks, chunked UX</a:t>
+              <a:t>Same agentic core, new explicit state graph</a:t>
             </a:r>
           </a:p>
         </p:txBody>
@@ -8550,7 +8552,7 @@
               </a:defRPr>
             </a:pPr>
             <a:r>
-              <a:t>Progress · releases</a:t>
+              <a:t>Architecture · LG</a:t>
             </a:r>
           </a:p>
         </p:txBody>
@@ -8586,7 +8588,7 @@
               </a:defRPr>
             </a:pPr>
             <a:r>
-              <a:t>zooplus Assistant — releases v2.1.6 · progress since v0.1.0</a:t>
+              <a:t>zooplus Assistant — Coding Task PoC v0.1</a:t>
             </a:r>
           </a:p>
         </p:txBody>
@@ -8622,7 +8624,7 @@
               </a:defRPr>
             </a:pPr>
             <a:r>
-              <a:t>15</a:t>
+              <a:t>14</a:t>
             </a:r>
           </a:p>
         </p:txBody>
@@ -8696,7 +8698,7 @@
               <a:spcAft>
                 <a:spcPts val="600"/>
               </a:spcAft>
-              <a:defRPr sz="1500" b="1">
+              <a:defRPr sz="1300" b="1">
                 <a:solidFill>
                   <a:srgbClr val="0A2540"/>
                 </a:solidFill>
@@ -8704,7 +8706,7 @@
               </a:defRPr>
             </a:pPr>
             <a:r>
-              <a:t>Foundation — v0.1.0 → v1.0</a:t>
+              <a:t>The problem this explores</a:t>
             </a:r>
           </a:p>
           <a:p>
@@ -8712,7 +8714,7 @@
               <a:spcAft>
                 <a:spcPts val="600"/>
               </a:spcAft>
-              <a:defRPr sz="1500" b="0">
+              <a:defRPr sz="1300" b="0">
                 <a:solidFill>
                   <a:srgbClr val="334155"/>
                 </a:solidFill>
@@ -8720,7 +8722,7 @@
               </a:defRPr>
             </a:pPr>
             <a:r>
-              <a:t>v0.1.0 — Coding Task PoC: FR1–5, hybrid RAG, FR4 guardrails.</a:t>
+              <a:t>• Legacy: one async function (_handle_chat_inner) with nested</a:t>
             </a:r>
           </a:p>
           <a:p>
@@ -8728,7 +8730,7 @@
               <a:spcAft>
                 <a:spcPts val="600"/>
               </a:spcAft>
-              <a:defRPr sz="1500" b="0">
+              <a:defRPr sz="1300" b="0">
                 <a:solidFill>
                   <a:srgbClr val="334155"/>
                 </a:solidFill>
@@ -8736,7 +8738,7 @@
               </a:defRPr>
             </a:pPr>
             <a:r>
-              <a:t>v0.1.3 — Conductor-first routing; /chat/stream; per-agent OpenCode.</a:t>
+              <a:t>  if/elif per lane — retry/fallback chains hidden inside helpers.</a:t>
             </a:r>
           </a:p>
           <a:p>
@@ -8744,7 +8746,7 @@
               <a:spcAft>
                 <a:spcPts val="600"/>
               </a:spcAft>
-              <a:defRPr sz="1500" b="0">
+              <a:defRPr sz="1300" b="0">
                 <a:solidFill>
                   <a:srgbClr val="334155"/>
                 </a:solidFill>
@@ -8752,46 +8754,23 @@
               </a:defRPr>
             </a:pPr>
             <a:r>
-              <a:t>v1.0 — Stable tag: catalog lexicon at ingest, cache, multilingual.</a:t>
-            </a:r>
-          </a:p>
-        </p:txBody>
-      </p:sp>
-      <p:sp>
-        <p:nvSpPr>
-          <p:cNvPr id="18" name="TextBox 17"/>
-          <p:cNvSpPr txBox="1"/>
-          <p:nvPr/>
-        </p:nvSpPr>
-        <p:spPr>
-          <a:xfrm>
-            <a:off x="6126480" y="1417320"/>
-            <a:ext cx="5257800" cy="4663440"/>
-          </a:xfrm>
-          <a:prstGeom prst="rect">
-            <a:avLst/>
-          </a:prstGeom>
-          <a:noFill/>
-        </p:spPr>
-        <p:txBody>
-          <a:bodyPr wrap="square" anchor="t">
-            <a:spAutoFit/>
-          </a:bodyPr>
-          <a:lstStyle/>
+              <a:t>• Hard to unit-test one decision in isolation — e.g. "what happens</a:t>
+            </a:r>
+          </a:p>
           <a:p>
             <a:pPr>
               <a:spcAft>
                 <a:spcPts val="600"/>
               </a:spcAft>
-              <a:defRPr sz="1500" b="1">
-                <a:solidFill>
-                  <a:srgbClr val="0A2540"/>
-                </a:solidFill>
-                <a:latin typeface="Arial"/>
-              </a:defRPr>
-            </a:pPr>
-            <a:r>
-              <a:t>Shopper experience — v1.4 → v2.1.6 (now)</a:t>
+              <a:defRPr sz="1300" b="0">
+                <a:solidFill>
+                  <a:srgbClr val="334155"/>
+                </a:solidFill>
+                <a:latin typeface="Arial"/>
+              </a:defRPr>
+            </a:pPr>
+            <a:r>
+              <a:t>  on an intent timeout?" — without exercising the whole function.</a:t>
             </a:r>
           </a:p>
           <a:p>
@@ -8799,15 +8778,15 @@
               <a:spcAft>
                 <a:spcPts val="600"/>
               </a:spcAft>
-              <a:defRPr sz="1500" b="0">
-                <a:solidFill>
-                  <a:srgbClr val="334155"/>
-                </a:solidFill>
-                <a:latin typeface="Arial"/>
-              </a:defRPr>
-            </a:pPr>
-            <a:r>
-              <a:t>v2.1 — Playbook MD; social/catalog probe; agent-multilingual.</a:t>
+              <a:defRPr sz="1300" b="1">
+                <a:solidFill>
+                  <a:srgbClr val="0A2540"/>
+                </a:solidFill>
+                <a:latin typeface="Arial"/>
+              </a:defRPr>
+            </a:pPr>
+            <a:r>
+              <a:t>Same agentic core, explicit shape</a:t>
             </a:r>
           </a:p>
           <a:p>
@@ -8815,7 +8794,7 @@
               <a:spcAft>
                 <a:spcPts val="600"/>
               </a:spcAft>
-              <a:defRPr sz="1500" b="0">
+              <a:defRPr sz="1300" b="0">
                 <a:solidFill>
                   <a:srgbClr val="334155"/>
                 </a:solidFill>
@@ -8823,7 +8802,7 @@
               </a:defRPr>
             </a:pPr>
             <a:r>
-              <a:t>v2.1.3 — Fast intent-first stream; conductor intent opt-in.</a:t>
+              <a:t>• feature/lg-catalog-probe-intent — StateGraph: nodes are</a:t>
             </a:r>
           </a:p>
           <a:p>
@@ -8831,7 +8810,7 @@
               <a:spcAft>
                 <a:spcPts val="600"/>
               </a:spcAft>
-              <a:defRPr sz="1500" b="0">
+              <a:defRPr sz="1300" b="0">
                 <a:solidFill>
                   <a:srgbClr val="334155"/>
                 </a:solidFill>
@@ -8839,7 +8818,7 @@
               </a:defRPr>
             </a:pPr>
             <a:r>
-              <a:t>v2.1.4–5 — Species inference; help/saludo detect + dedupe.</a:t>
+              <a:t>  functions, edges are typed routing functions, independently</a:t>
             </a:r>
           </a:p>
           <a:p>
@@ -8847,7 +8826,7 @@
               <a:spcAft>
                 <a:spcPts val="600"/>
               </a:spcAft>
-              <a:defRPr sz="1500" b="0">
+              <a:defRPr sz="1300" b="0">
                 <a:solidFill>
                   <a:srgbClr val="334155"/>
                 </a:solidFill>
@@ -8855,7 +8834,206 @@
               </a:defRPr>
             </a:pPr>
             <a:r>
-              <a:t>v2.1.6 — Dynamic count (4→20); phrase index; product_batch UI.</a:t>
+              <a:t>  testable in isolation (pure dict in, string out).</a:t>
+            </a:r>
+          </a:p>
+          <a:p>
+            <a:pPr>
+              <a:spcAft>
+                <a:spcPts val="600"/>
+              </a:spcAft>
+              <a:defRPr sz="1300" b="0">
+                <a:solidFill>
+                  <a:srgbClr val="334155"/>
+                </a:solidFill>
+                <a:latin typeface="Arial"/>
+              </a:defRPr>
+            </a:pPr>
+            <a:r>
+              <a:t>• Every node calls THIS repo's own functions verbatim — zero</a:t>
+            </a:r>
+          </a:p>
+          <a:p>
+            <a:pPr>
+              <a:spcAft>
+                <a:spcPts val="600"/>
+              </a:spcAft>
+              <a:defRPr sz="1300" b="0">
+                <a:solidFill>
+                  <a:srgbClr val="334155"/>
+                </a:solidFill>
+                <a:latin typeface="Arial"/>
+              </a:defRPr>
+            </a:pPr>
+            <a:r>
+              <a:t>  re-implemented logic, nothing invented.</a:t>
+            </a:r>
+          </a:p>
+        </p:txBody>
+      </p:sp>
+      <p:sp>
+        <p:nvSpPr>
+          <p:cNvPr id="18" name="TextBox 17"/>
+          <p:cNvSpPr txBox="1"/>
+          <p:nvPr/>
+        </p:nvSpPr>
+        <p:spPr>
+          <a:xfrm>
+            <a:off x="6126480" y="1417320"/>
+            <a:ext cx="5257800" cy="4663440"/>
+          </a:xfrm>
+          <a:prstGeom prst="rect">
+            <a:avLst/>
+          </a:prstGeom>
+          <a:noFill/>
+        </p:spPr>
+        <p:txBody>
+          <a:bodyPr wrap="square" anchor="t">
+            <a:spAutoFit/>
+          </a:bodyPr>
+          <a:lstStyle/>
+          <a:p>
+            <a:pPr>
+              <a:spcAft>
+                <a:spcPts val="600"/>
+              </a:spcAft>
+              <a:defRPr sz="1300" b="1">
+                <a:solidFill>
+                  <a:srgbClr val="0A2540"/>
+                </a:solidFill>
+                <a:latin typeface="Arial"/>
+              </a:defRPr>
+            </a:pPr>
+            <a:r>
+              <a:t>Graph topology (7 nodes, all async)</a:t>
+            </a:r>
+          </a:p>
+          <a:p>
+            <a:pPr>
+              <a:spcAft>
+                <a:spcPts val="600"/>
+              </a:spcAft>
+              <a:defRPr sz="1300" b="0">
+                <a:solidFill>
+                  <a:srgbClr val="334155"/>
+                </a:solidFill>
+                <a:latin typeface="Arial"/>
+              </a:defRPr>
+            </a:pPr>
+            <a:r>
+              <a:t>START → cache_check</a:t>
+            </a:r>
+          </a:p>
+          <a:p>
+            <a:pPr>
+              <a:spcAft>
+                <a:spcPts val="600"/>
+              </a:spcAft>
+              <a:defRPr sz="1300" b="0">
+                <a:solidFill>
+                  <a:srgbClr val="334155"/>
+                </a:solidFill>
+                <a:latin typeface="Arial"/>
+              </a:defRPr>
+            </a:pPr>
+            <a:r>
+              <a:t>  ├─ cache hit  → END (cached answer, ~0.02s)</a:t>
+            </a:r>
+          </a:p>
+          <a:p>
+            <a:pPr>
+              <a:spcAft>
+                <a:spcPts val="600"/>
+              </a:spcAft>
+              <a:defRPr sz="1300" b="0">
+                <a:solidFill>
+                  <a:srgbClr val="334155"/>
+                </a:solidFill>
+                <a:latin typeface="Arial"/>
+              </a:defRPr>
+            </a:pPr>
+            <a:r>
+              <a:t>  └─ cache miss → classify_intent</a:t>
+            </a:r>
+          </a:p>
+          <a:p>
+            <a:pPr>
+              <a:spcAft>
+                <a:spcPts val="600"/>
+              </a:spcAft>
+              <a:defRPr sz="1300" b="0">
+                <a:solidFill>
+                  <a:srgbClr val="334155"/>
+                </a:solidFill>
+                <a:latin typeface="Arial"/>
+              </a:defRPr>
+            </a:pPr>
+            <a:r>
+              <a:t>classify_intent → [route_by_lane]</a:t>
+            </a:r>
+          </a:p>
+          <a:p>
+            <a:pPr>
+              <a:spcAft>
+                <a:spcPts val="600"/>
+              </a:spcAft>
+              <a:defRPr sz="1300" b="0">
+                <a:solidFill>
+                  <a:srgbClr val="334155"/>
+                </a:solidFill>
+                <a:latin typeface="Arial"/>
+              </a:defRPr>
+            </a:pPr>
+            <a:r>
+              <a:t>  ├─ social (decline_off_topic | conversational) ──┐</a:t>
+            </a:r>
+          </a:p>
+          <a:p>
+            <a:pPr>
+              <a:spcAft>
+                <a:spcPts val="600"/>
+              </a:spcAft>
+              <a:defRPr sz="1300" b="0">
+                <a:solidFill>
+                  <a:srgbClr val="334155"/>
+                </a:solidFill>
+                <a:latin typeface="Arial"/>
+              </a:defRPr>
+            </a:pPr>
+            <a:r>
+              <a:t>  └─ prefetch → process_lane ─────────────────────┤</a:t>
+            </a:r>
+          </a:p>
+          <a:p>
+            <a:pPr>
+              <a:spcAft>
+                <a:spcPts val="600"/>
+              </a:spcAft>
+              <a:defRPr sz="1300" b="0">
+                <a:solidFill>
+                  <a:srgbClr val="334155"/>
+                </a:solidFill>
+                <a:latin typeface="Arial"/>
+              </a:defRPr>
+            </a:pPr>
+            <a:r>
+              <a:t>                                    cache_store → END</a:t>
+            </a:r>
+          </a:p>
+          <a:p>
+            <a:pPr>
+              <a:spcAft>
+                <a:spcPts val="600"/>
+              </a:spcAft>
+              <a:defRPr sz="1300" b="0">
+                <a:solidFill>
+                  <a:srgbClr val="334155"/>
+                </a:solidFill>
+                <a:latin typeface="Arial"/>
+              </a:defRPr>
+            </a:pPr>
+            <a:r>
+              <a:t>4 routing functions; graph.ainvoke(), not graph.invoke().</a:t>
             </a:r>
           </a:p>
         </p:txBody>
@@ -9253,7 +9431,7 @@
               </a:defRPr>
             </a:pPr>
             <a:r>
-              <a:t>LangGraph approach — standalone showcase branch</a:t>
+              <a:t>Release progress — v0.1.0 → v2.1.6</a:t>
             </a:r>
           </a:p>
         </p:txBody>
@@ -9289,7 +9467,7 @@
               </a:defRPr>
             </a:pPr>
             <a:r>
-              <a:t>Faithful node/edge translation — every node calls this repo's own functions</a:t>
+              <a:t>Same five FRs · smarter social routing, flexible picks, chunked UX</a:t>
             </a:r>
           </a:p>
         </p:txBody>
@@ -9368,7 +9546,7 @@
               </a:defRPr>
             </a:pPr>
             <a:r>
-              <a:t>Architecture · LG</a:t>
+              <a:t>Progress · releases</a:t>
             </a:r>
           </a:p>
         </p:txBody>
@@ -9404,7 +9582,7 @@
               </a:defRPr>
             </a:pPr>
             <a:r>
-              <a:t>zooplus Assistant — Coding Task PoC v0.1</a:t>
+              <a:t>zooplus Assistant — releases v2.1.6 · progress since v0.1.0</a:t>
             </a:r>
           </a:p>
         </p:txBody>
@@ -9440,7 +9618,7 @@
               </a:defRPr>
             </a:pPr>
             <a:r>
-              <a:t>14</a:t>
+              <a:t>17</a:t>
             </a:r>
           </a:p>
         </p:txBody>
@@ -9514,15 +9692,833 @@
               <a:spcAft>
                 <a:spcPts val="600"/>
               </a:spcAft>
+              <a:defRPr sz="1500" b="1">
+                <a:solidFill>
+                  <a:srgbClr val="0A2540"/>
+                </a:solidFill>
+                <a:latin typeface="Arial"/>
+              </a:defRPr>
+            </a:pPr>
+            <a:r>
+              <a:t>Foundation — v0.1.0 → v1.0</a:t>
+            </a:r>
+          </a:p>
+          <a:p>
+            <a:pPr>
+              <a:spcAft>
+                <a:spcPts val="600"/>
+              </a:spcAft>
+              <a:defRPr sz="1500" b="0">
+                <a:solidFill>
+                  <a:srgbClr val="334155"/>
+                </a:solidFill>
+                <a:latin typeface="Arial"/>
+              </a:defRPr>
+            </a:pPr>
+            <a:r>
+              <a:t>v0.1.0 — Coding Task PoC: FR1–5, hybrid RAG, FR4 guardrails.</a:t>
+            </a:r>
+          </a:p>
+          <a:p>
+            <a:pPr>
+              <a:spcAft>
+                <a:spcPts val="600"/>
+              </a:spcAft>
+              <a:defRPr sz="1500" b="0">
+                <a:solidFill>
+                  <a:srgbClr val="334155"/>
+                </a:solidFill>
+                <a:latin typeface="Arial"/>
+              </a:defRPr>
+            </a:pPr>
+            <a:r>
+              <a:t>v0.1.3 — Conductor-first routing; /chat/stream; per-agent OpenCode.</a:t>
+            </a:r>
+          </a:p>
+          <a:p>
+            <a:pPr>
+              <a:spcAft>
+                <a:spcPts val="600"/>
+              </a:spcAft>
+              <a:defRPr sz="1500" b="0">
+                <a:solidFill>
+                  <a:srgbClr val="334155"/>
+                </a:solidFill>
+                <a:latin typeface="Arial"/>
+              </a:defRPr>
+            </a:pPr>
+            <a:r>
+              <a:t>v1.0 — Stable tag: catalog lexicon at ingest, cache, multilingual.</a:t>
+            </a:r>
+          </a:p>
+        </p:txBody>
+      </p:sp>
+      <p:sp>
+        <p:nvSpPr>
+          <p:cNvPr id="18" name="TextBox 17"/>
+          <p:cNvSpPr txBox="1"/>
+          <p:nvPr/>
+        </p:nvSpPr>
+        <p:spPr>
+          <a:xfrm>
+            <a:off x="6126480" y="1417320"/>
+            <a:ext cx="5257800" cy="4663440"/>
+          </a:xfrm>
+          <a:prstGeom prst="rect">
+            <a:avLst/>
+          </a:prstGeom>
+          <a:noFill/>
+        </p:spPr>
+        <p:txBody>
+          <a:bodyPr wrap="square" anchor="t">
+            <a:spAutoFit/>
+          </a:bodyPr>
+          <a:lstStyle/>
+          <a:p>
+            <a:pPr>
+              <a:spcAft>
+                <a:spcPts val="600"/>
+              </a:spcAft>
+              <a:defRPr sz="1500" b="1">
+                <a:solidFill>
+                  <a:srgbClr val="0A2540"/>
+                </a:solidFill>
+                <a:latin typeface="Arial"/>
+              </a:defRPr>
+            </a:pPr>
+            <a:r>
+              <a:t>Shopper experience — v1.4 → v2.1.6 (now)</a:t>
+            </a:r>
+          </a:p>
+          <a:p>
+            <a:pPr>
+              <a:spcAft>
+                <a:spcPts val="600"/>
+              </a:spcAft>
+              <a:defRPr sz="1500" b="0">
+                <a:solidFill>
+                  <a:srgbClr val="334155"/>
+                </a:solidFill>
+                <a:latin typeface="Arial"/>
+              </a:defRPr>
+            </a:pPr>
+            <a:r>
+              <a:t>v2.1 — Playbook MD; social/catalog probe; agent-multilingual.</a:t>
+            </a:r>
+          </a:p>
+          <a:p>
+            <a:pPr>
+              <a:spcAft>
+                <a:spcPts val="600"/>
+              </a:spcAft>
+              <a:defRPr sz="1500" b="0">
+                <a:solidFill>
+                  <a:srgbClr val="334155"/>
+                </a:solidFill>
+                <a:latin typeface="Arial"/>
+              </a:defRPr>
+            </a:pPr>
+            <a:r>
+              <a:t>v2.1.3 — Fast intent-first stream; conductor intent opt-in.</a:t>
+            </a:r>
+          </a:p>
+          <a:p>
+            <a:pPr>
+              <a:spcAft>
+                <a:spcPts val="600"/>
+              </a:spcAft>
+              <a:defRPr sz="1500" b="0">
+                <a:solidFill>
+                  <a:srgbClr val="334155"/>
+                </a:solidFill>
+                <a:latin typeface="Arial"/>
+              </a:defRPr>
+            </a:pPr>
+            <a:r>
+              <a:t>v2.1.4–5 — Species inference; help/saludo detect + dedupe.</a:t>
+            </a:r>
+          </a:p>
+          <a:p>
+            <a:pPr>
+              <a:spcAft>
+                <a:spcPts val="600"/>
+              </a:spcAft>
+              <a:defRPr sz="1500" b="0">
+                <a:solidFill>
+                  <a:srgbClr val="334155"/>
+                </a:solidFill>
+                <a:latin typeface="Arial"/>
+              </a:defRPr>
+            </a:pPr>
+            <a:r>
+              <a:t>v2.1.6 — Dynamic count (4→20); phrase index; product_batch UI.</a:t>
+            </a:r>
+          </a:p>
+        </p:txBody>
+      </p:sp>
+    </p:spTree>
+  </p:cSld>
+  <p:clrMapOvr>
+    <a:masterClrMapping/>
+  </p:clrMapOvr>
+</p:sld>
+</file>
+
+<file path=ppt/slides/slide16.xml><?xml version="1.0" encoding="utf-8"?>
+<p:sld xmlns:a="http://schemas.openxmlformats.org/drawingml/2006/main" xmlns:p="http://schemas.openxmlformats.org/presentationml/2006/main" xmlns:r="http://schemas.openxmlformats.org/officeDocument/2006/relationships">
+  <p:cSld>
+    <p:spTree>
+      <p:nvGrpSpPr>
+        <p:cNvPr id="1" name=""/>
+        <p:cNvGrpSpPr/>
+        <p:nvPr/>
+      </p:nvGrpSpPr>
+      <p:grpSpPr/>
+      <p:sp>
+        <p:nvSpPr>
+          <p:cNvPr id="2" name="Rectangle 1"/>
+          <p:cNvSpPr/>
+          <p:nvPr/>
+        </p:nvSpPr>
+        <p:spPr>
+          <a:xfrm>
+            <a:off x="429768" y="0"/>
+            <a:ext cx="11761927" cy="6858000"/>
+          </a:xfrm>
+          <a:prstGeom prst="rect">
+            <a:avLst/>
+          </a:prstGeom>
+          <a:solidFill>
+            <a:srgbClr val="FFFFFF"/>
+          </a:solidFill>
+          <a:ln>
+            <a:noFill/>
+          </a:ln>
+        </p:spPr>
+        <p:style>
+          <a:lnRef idx="1">
+            <a:schemeClr val="accent1"/>
+          </a:lnRef>
+          <a:fillRef idx="3">
+            <a:schemeClr val="accent1"/>
+          </a:fillRef>
+          <a:effectRef idx="2">
+            <a:schemeClr val="accent1"/>
+          </a:effectRef>
+          <a:fontRef idx="minor">
+            <a:schemeClr val="lt1"/>
+          </a:fontRef>
+        </p:style>
+        <p:txBody>
+          <a:bodyPr rtlCol="0" anchor="ctr"/>
+          <a:lstStyle/>
+          <a:p>
+            <a:pPr algn="ctr"/>
+          </a:p>
+        </p:txBody>
+      </p:sp>
+      <p:sp>
+        <p:nvSpPr>
+          <p:cNvPr id="3" name="Rectangle 2"/>
+          <p:cNvSpPr/>
+          <p:nvPr/>
+        </p:nvSpPr>
+        <p:spPr>
+          <a:xfrm>
+            <a:off x="0" y="0"/>
+            <a:ext cx="384048" cy="6858000"/>
+          </a:xfrm>
+          <a:prstGeom prst="rect">
+            <a:avLst/>
+          </a:prstGeom>
+          <a:solidFill>
+            <a:srgbClr val="0A2540"/>
+          </a:solidFill>
+          <a:ln>
+            <a:noFill/>
+          </a:ln>
+        </p:spPr>
+        <p:style>
+          <a:lnRef idx="1">
+            <a:schemeClr val="accent1"/>
+          </a:lnRef>
+          <a:fillRef idx="3">
+            <a:schemeClr val="accent1"/>
+          </a:fillRef>
+          <a:effectRef idx="2">
+            <a:schemeClr val="accent1"/>
+          </a:effectRef>
+          <a:fontRef idx="minor">
+            <a:schemeClr val="lt1"/>
+          </a:fontRef>
+        </p:style>
+        <p:txBody>
+          <a:bodyPr rtlCol="0" anchor="ctr"/>
+          <a:lstStyle/>
+          <a:p>
+            <a:pPr algn="ctr"/>
+          </a:p>
+        </p:txBody>
+      </p:sp>
+      <p:sp>
+        <p:nvSpPr>
+          <p:cNvPr id="4" name="Rectangle 3"/>
+          <p:cNvSpPr/>
+          <p:nvPr/>
+        </p:nvSpPr>
+        <p:spPr>
+          <a:xfrm>
+            <a:off x="384048" y="0"/>
+            <a:ext cx="45720" cy="6858000"/>
+          </a:xfrm>
+          <a:prstGeom prst="rect">
+            <a:avLst/>
+          </a:prstGeom>
+          <a:solidFill>
+            <a:srgbClr val="2563EB"/>
+          </a:solidFill>
+          <a:ln>
+            <a:noFill/>
+          </a:ln>
+        </p:spPr>
+        <p:style>
+          <a:lnRef idx="1">
+            <a:schemeClr val="accent1"/>
+          </a:lnRef>
+          <a:fillRef idx="3">
+            <a:schemeClr val="accent1"/>
+          </a:fillRef>
+          <a:effectRef idx="2">
+            <a:schemeClr val="accent1"/>
+          </a:effectRef>
+          <a:fontRef idx="minor">
+            <a:schemeClr val="lt1"/>
+          </a:fontRef>
+        </p:style>
+        <p:txBody>
+          <a:bodyPr rtlCol="0" anchor="ctr"/>
+          <a:lstStyle/>
+          <a:p>
+            <a:pPr algn="ctr"/>
+          </a:p>
+        </p:txBody>
+      </p:sp>
+      <p:sp>
+        <p:nvSpPr>
+          <p:cNvPr id="5" name="Rectangle 4"/>
+          <p:cNvSpPr/>
+          <p:nvPr/>
+        </p:nvSpPr>
+        <p:spPr>
+          <a:xfrm>
+            <a:off x="429768" y="0"/>
+            <a:ext cx="11761927" cy="1115568"/>
+          </a:xfrm>
+          <a:prstGeom prst="rect">
+            <a:avLst/>
+          </a:prstGeom>
+          <a:solidFill>
+            <a:srgbClr val="0A2540"/>
+          </a:solidFill>
+          <a:ln>
+            <a:noFill/>
+          </a:ln>
+        </p:spPr>
+        <p:style>
+          <a:lnRef idx="1">
+            <a:schemeClr val="accent1"/>
+          </a:lnRef>
+          <a:fillRef idx="3">
+            <a:schemeClr val="accent1"/>
+          </a:fillRef>
+          <a:effectRef idx="2">
+            <a:schemeClr val="accent1"/>
+          </a:effectRef>
+          <a:fontRef idx="minor">
+            <a:schemeClr val="lt1"/>
+          </a:fontRef>
+        </p:style>
+        <p:txBody>
+          <a:bodyPr rtlCol="0" anchor="ctr"/>
+          <a:lstStyle/>
+          <a:p>
+            <a:pPr algn="ctr"/>
+          </a:p>
+        </p:txBody>
+      </p:sp>
+      <p:sp>
+        <p:nvSpPr>
+          <p:cNvPr id="6" name="Rectangle 5"/>
+          <p:cNvSpPr/>
+          <p:nvPr/>
+        </p:nvSpPr>
+        <p:spPr>
+          <a:xfrm>
+            <a:off x="429768" y="1115568"/>
+            <a:ext cx="11761927" cy="54864"/>
+          </a:xfrm>
+          <a:prstGeom prst="rect">
+            <a:avLst/>
+          </a:prstGeom>
+          <a:solidFill>
+            <a:srgbClr val="2563EB"/>
+          </a:solidFill>
+          <a:ln>
+            <a:noFill/>
+          </a:ln>
+        </p:spPr>
+        <p:style>
+          <a:lnRef idx="1">
+            <a:schemeClr val="accent1"/>
+          </a:lnRef>
+          <a:fillRef idx="3">
+            <a:schemeClr val="accent1"/>
+          </a:fillRef>
+          <a:effectRef idx="2">
+            <a:schemeClr val="accent1"/>
+          </a:effectRef>
+          <a:fontRef idx="minor">
+            <a:schemeClr val="lt1"/>
+          </a:fontRef>
+        </p:style>
+        <p:txBody>
+          <a:bodyPr rtlCol="0" anchor="ctr"/>
+          <a:lstStyle/>
+          <a:p>
+            <a:pPr algn="ctr"/>
+          </a:p>
+        </p:txBody>
+      </p:sp>
+      <p:sp>
+        <p:nvSpPr>
+          <p:cNvPr id="7" name="Rectangle 6"/>
+          <p:cNvSpPr/>
+          <p:nvPr/>
+        </p:nvSpPr>
+        <p:spPr>
+          <a:xfrm>
+            <a:off x="429768" y="6419088"/>
+            <a:ext cx="11761927" cy="438912"/>
+          </a:xfrm>
+          <a:prstGeom prst="rect">
+            <a:avLst/>
+          </a:prstGeom>
+          <a:solidFill>
+            <a:srgbClr val="0A2540"/>
+          </a:solidFill>
+          <a:ln>
+            <a:noFill/>
+          </a:ln>
+        </p:spPr>
+        <p:style>
+          <a:lnRef idx="1">
+            <a:schemeClr val="accent1"/>
+          </a:lnRef>
+          <a:fillRef idx="3">
+            <a:schemeClr val="accent1"/>
+          </a:fillRef>
+          <a:effectRef idx="2">
+            <a:schemeClr val="accent1"/>
+          </a:effectRef>
+          <a:fontRef idx="minor">
+            <a:schemeClr val="lt1"/>
+          </a:fontRef>
+        </p:style>
+        <p:txBody>
+          <a:bodyPr rtlCol="0" anchor="ctr"/>
+          <a:lstStyle/>
+          <a:p>
+            <a:pPr algn="ctr"/>
+          </a:p>
+        </p:txBody>
+      </p:sp>
+      <p:sp>
+        <p:nvSpPr>
+          <p:cNvPr id="8" name="Rectangle 7"/>
+          <p:cNvSpPr/>
+          <p:nvPr/>
+        </p:nvSpPr>
+        <p:spPr>
+          <a:xfrm>
+            <a:off x="0" y="0"/>
+            <a:ext cx="384048" cy="6858000"/>
+          </a:xfrm>
+          <a:prstGeom prst="rect">
+            <a:avLst/>
+          </a:prstGeom>
+          <a:solidFill>
+            <a:srgbClr val="0A2540"/>
+          </a:solidFill>
+          <a:ln>
+            <a:noFill/>
+          </a:ln>
+        </p:spPr>
+        <p:style>
+          <a:lnRef idx="1">
+            <a:schemeClr val="accent1"/>
+          </a:lnRef>
+          <a:fillRef idx="3">
+            <a:schemeClr val="accent1"/>
+          </a:fillRef>
+          <a:effectRef idx="2">
+            <a:schemeClr val="accent1"/>
+          </a:effectRef>
+          <a:fontRef idx="minor">
+            <a:schemeClr val="lt1"/>
+          </a:fontRef>
+        </p:style>
+        <p:txBody>
+          <a:bodyPr rtlCol="0" anchor="ctr"/>
+          <a:lstStyle/>
+          <a:p>
+            <a:pPr algn="ctr"/>
+          </a:p>
+        </p:txBody>
+      </p:sp>
+      <p:sp>
+        <p:nvSpPr>
+          <p:cNvPr id="9" name="Rectangle 8"/>
+          <p:cNvSpPr/>
+          <p:nvPr/>
+        </p:nvSpPr>
+        <p:spPr>
+          <a:xfrm>
+            <a:off x="384048" y="0"/>
+            <a:ext cx="45720" cy="6858000"/>
+          </a:xfrm>
+          <a:prstGeom prst="rect">
+            <a:avLst/>
+          </a:prstGeom>
+          <a:solidFill>
+            <a:srgbClr val="2563EB"/>
+          </a:solidFill>
+          <a:ln>
+            <a:noFill/>
+          </a:ln>
+        </p:spPr>
+        <p:style>
+          <a:lnRef idx="1">
+            <a:schemeClr val="accent1"/>
+          </a:lnRef>
+          <a:fillRef idx="3">
+            <a:schemeClr val="accent1"/>
+          </a:fillRef>
+          <a:effectRef idx="2">
+            <a:schemeClr val="accent1"/>
+          </a:effectRef>
+          <a:fontRef idx="minor">
+            <a:schemeClr val="lt1"/>
+          </a:fontRef>
+        </p:style>
+        <p:txBody>
+          <a:bodyPr rtlCol="0" anchor="ctr"/>
+          <a:lstStyle/>
+          <a:p>
+            <a:pPr algn="ctr"/>
+          </a:p>
+        </p:txBody>
+      </p:sp>
+      <p:sp>
+        <p:nvSpPr>
+          <p:cNvPr id="10" name="TextBox 9"/>
+          <p:cNvSpPr txBox="1"/>
+          <p:nvPr/>
+        </p:nvSpPr>
+        <p:spPr>
+          <a:xfrm>
+            <a:off x="658368" y="182880"/>
+            <a:ext cx="9144000" cy="566928"/>
+          </a:xfrm>
+          <a:prstGeom prst="rect">
+            <a:avLst/>
+          </a:prstGeom>
+          <a:noFill/>
+        </p:spPr>
+        <p:txBody>
+          <a:bodyPr wrap="square" anchor="t">
+            <a:spAutoFit/>
+          </a:bodyPr>
+          <a:lstStyle/>
+          <a:p>
+            <a:pPr algn="l">
+              <a:defRPr sz="3400" b="1">
+                <a:solidFill>
+                  <a:srgbClr val="FFFFFF"/>
+                </a:solidFill>
+                <a:latin typeface="Arial"/>
+              </a:defRPr>
+            </a:pPr>
+            <a:r>
+              <a:t>LangGraph 2/3 — every node, what it calls</a:t>
+            </a:r>
+          </a:p>
+        </p:txBody>
+      </p:sp>
+      <p:sp>
+        <p:nvSpPr>
+          <p:cNvPr id="11" name="TextBox 10"/>
+          <p:cNvSpPr txBox="1"/>
+          <p:nvPr/>
+        </p:nvSpPr>
+        <p:spPr>
+          <a:xfrm>
+            <a:off x="658368" y="713232"/>
+            <a:ext cx="8046720" cy="347472"/>
+          </a:xfrm>
+          <a:prstGeom prst="rect">
+            <a:avLst/>
+          </a:prstGeom>
+          <a:noFill/>
+        </p:spPr>
+        <p:txBody>
+          <a:bodyPr wrap="square" anchor="t">
+            <a:spAutoFit/>
+          </a:bodyPr>
+          <a:lstStyle/>
+          <a:p>
+            <a:pPr algn="l">
+              <a:defRPr sz="1700" b="0">
+                <a:solidFill>
+                  <a:srgbClr val="BFDBFE"/>
+                </a:solidFill>
+                <a:latin typeface="Arial"/>
+              </a:defRPr>
+            </a:pPr>
+            <a:r>
+              <a:t>Every node is a verbatim call into this repo's own functions</a:t>
+            </a:r>
+          </a:p>
+        </p:txBody>
+      </p:sp>
+      <p:sp>
+        <p:nvSpPr>
+          <p:cNvPr id="12" name="Rectangle 11"/>
+          <p:cNvSpPr/>
+          <p:nvPr/>
+        </p:nvSpPr>
+        <p:spPr>
+          <a:xfrm>
+            <a:off x="10241280" y="292608"/>
+            <a:ext cx="1600200" cy="438912"/>
+          </a:xfrm>
+          <a:prstGeom prst="rect">
+            <a:avLst/>
+          </a:prstGeom>
+          <a:solidFill>
+            <a:srgbClr val="2563EB"/>
+          </a:solidFill>
+          <a:ln>
+            <a:noFill/>
+          </a:ln>
+        </p:spPr>
+        <p:style>
+          <a:lnRef idx="1">
+            <a:schemeClr val="accent1"/>
+          </a:lnRef>
+          <a:fillRef idx="3">
+            <a:schemeClr val="accent1"/>
+          </a:fillRef>
+          <a:effectRef idx="2">
+            <a:schemeClr val="accent1"/>
+          </a:effectRef>
+          <a:fontRef idx="minor">
+            <a:schemeClr val="lt1"/>
+          </a:fontRef>
+        </p:style>
+        <p:txBody>
+          <a:bodyPr rtlCol="0" anchor="ctr"/>
+          <a:lstStyle/>
+          <a:p>
+            <a:pPr algn="ctr"/>
+          </a:p>
+        </p:txBody>
+      </p:sp>
+      <p:sp>
+        <p:nvSpPr>
+          <p:cNvPr id="13" name="TextBox 12"/>
+          <p:cNvSpPr txBox="1"/>
+          <p:nvPr/>
+        </p:nvSpPr>
+        <p:spPr>
+          <a:xfrm>
+            <a:off x="10314432" y="347472"/>
+            <a:ext cx="1463040" cy="365760"/>
+          </a:xfrm>
+          <a:prstGeom prst="rect">
+            <a:avLst/>
+          </a:prstGeom>
+          <a:noFill/>
+        </p:spPr>
+        <p:txBody>
+          <a:bodyPr wrap="square" anchor="t">
+            <a:spAutoFit/>
+          </a:bodyPr>
+          <a:lstStyle/>
+          <a:p>
+            <a:pPr algn="ctr">
               <a:defRPr sz="1300" b="1">
                 <a:solidFill>
+                  <a:srgbClr val="FFFFFF"/>
+                </a:solidFill>
+                <a:latin typeface="Arial"/>
+              </a:defRPr>
+            </a:pPr>
+            <a:r>
+              <a:t>Architecture · LG</a:t>
+            </a:r>
+          </a:p>
+        </p:txBody>
+      </p:sp>
+      <p:sp>
+        <p:nvSpPr>
+          <p:cNvPr id="14" name="TextBox 13"/>
+          <p:cNvSpPr txBox="1"/>
+          <p:nvPr/>
+        </p:nvSpPr>
+        <p:spPr>
+          <a:xfrm>
+            <a:off x="658368" y="6492240"/>
+            <a:ext cx="9326880" cy="329184"/>
+          </a:xfrm>
+          <a:prstGeom prst="rect">
+            <a:avLst/>
+          </a:prstGeom>
+          <a:noFill/>
+        </p:spPr>
+        <p:txBody>
+          <a:bodyPr wrap="square" anchor="t">
+            <a:spAutoFit/>
+          </a:bodyPr>
+          <a:lstStyle/>
+          <a:p>
+            <a:pPr algn="l">
+              <a:defRPr sz="1200" b="0">
+                <a:solidFill>
+                  <a:srgbClr val="BFDBFE"/>
+                </a:solidFill>
+                <a:latin typeface="Arial"/>
+              </a:defRPr>
+            </a:pPr>
+            <a:r>
+              <a:t>zooplus Assistant — Coding Task PoC v0.1</a:t>
+            </a:r>
+          </a:p>
+        </p:txBody>
+      </p:sp>
+      <p:sp>
+        <p:nvSpPr>
+          <p:cNvPr id="15" name="TextBox 14"/>
+          <p:cNvSpPr txBox="1"/>
+          <p:nvPr/>
+        </p:nvSpPr>
+        <p:spPr>
+          <a:xfrm>
+            <a:off x="11155680" y="6473952"/>
+            <a:ext cx="868680" cy="329184"/>
+          </a:xfrm>
+          <a:prstGeom prst="rect">
+            <a:avLst/>
+          </a:prstGeom>
+          <a:noFill/>
+        </p:spPr>
+        <p:txBody>
+          <a:bodyPr wrap="square" anchor="t">
+            <a:spAutoFit/>
+          </a:bodyPr>
+          <a:lstStyle/>
+          <a:p>
+            <a:pPr algn="l">
+              <a:defRPr sz="1500" b="1">
+                <a:solidFill>
+                  <a:srgbClr val="FFFFFF"/>
+                </a:solidFill>
+                <a:latin typeface="Arial"/>
+              </a:defRPr>
+            </a:pPr>
+            <a:r>
+              <a:t>15</a:t>
+            </a:r>
+          </a:p>
+        </p:txBody>
+      </p:sp>
+      <p:sp>
+        <p:nvSpPr>
+          <p:cNvPr id="16" name="Rectangle 15"/>
+          <p:cNvSpPr/>
+          <p:nvPr/>
+        </p:nvSpPr>
+        <p:spPr>
+          <a:xfrm>
+            <a:off x="585216" y="1261872"/>
+            <a:ext cx="10972800" cy="4983480"/>
+          </a:xfrm>
+          <a:prstGeom prst="rect">
+            <a:avLst/>
+          </a:prstGeom>
+          <a:solidFill>
+            <a:srgbClr val="F8FAFC"/>
+          </a:solidFill>
+          <a:ln>
+            <a:noFill/>
+          </a:ln>
+        </p:spPr>
+        <p:style>
+          <a:lnRef idx="1">
+            <a:schemeClr val="accent1"/>
+          </a:lnRef>
+          <a:fillRef idx="3">
+            <a:schemeClr val="accent1"/>
+          </a:fillRef>
+          <a:effectRef idx="2">
+            <a:schemeClr val="accent1"/>
+          </a:effectRef>
+          <a:fontRef idx="minor">
+            <a:schemeClr val="lt1"/>
+          </a:fontRef>
+        </p:style>
+        <p:txBody>
+          <a:bodyPr rtlCol="0" anchor="ctr"/>
+          <a:lstStyle/>
+          <a:p>
+            <a:pPr algn="ctr"/>
+          </a:p>
+        </p:txBody>
+      </p:sp>
+      <p:sp>
+        <p:nvSpPr>
+          <p:cNvPr id="17" name="TextBox 16"/>
+          <p:cNvSpPr txBox="1"/>
+          <p:nvPr/>
+        </p:nvSpPr>
+        <p:spPr>
+          <a:xfrm>
+            <a:off x="749808" y="1417320"/>
+            <a:ext cx="5349240" cy="4663440"/>
+          </a:xfrm>
+          <a:prstGeom prst="rect">
+            <a:avLst/>
+          </a:prstGeom>
+          <a:noFill/>
+        </p:spPr>
+        <p:txBody>
+          <a:bodyPr wrap="square" anchor="t">
+            <a:spAutoFit/>
+          </a:bodyPr>
+          <a:lstStyle/>
+          <a:p>
+            <a:pPr>
+              <a:spcAft>
+                <a:spcPts val="600"/>
+              </a:spcAft>
+              <a:defRPr sz="1300" b="1">
+                <a:solidFill>
                   <a:srgbClr val="0A2540"/>
                 </a:solidFill>
                 <a:latin typeface="Arial"/>
               </a:defRPr>
             </a:pPr>
             <a:r>
-              <a:t>feature/lg-catalog-probe-intent</a:t>
+              <a:t>Social path</a:t>
             </a:r>
           </a:p>
           <a:p>
@@ -9538,7 +10534,7 @@
               </a:defRPr>
             </a:pPr>
             <a:r>
-              <a:t>• Standalone branch — not merged into dev/main/releases.</a:t>
+              <a:t>• classify_intent → orchestrator._classify_intent_bounded() —</a:t>
             </a:r>
           </a:p>
           <a:p>
@@ -9554,7 +10550,7 @@
               </a:defRPr>
             </a:pPr>
             <a:r>
-              <a:t>• Same agentic core re-expressed as an explicit LangGraph StateGraph</a:t>
+              <a:t>  same 22s timeout, same _fallback_intent_decision() fallback.</a:t>
             </a:r>
           </a:p>
           <a:p>
@@ -9570,7 +10566,7 @@
               </a:defRPr>
             </a:pPr>
             <a:r>
-              <a:t>  (nodes + typed conditional edges) instead of Python if/else.</a:t>
+              <a:t>• social_node → social_agent.social_reply() — unchanged behaviour,</a:t>
             </a:r>
           </a:p>
           <a:p>
@@ -9586,7 +10582,23 @@
               </a:defRPr>
             </a:pPr>
             <a:r>
-              <a:t>• Design rule: every node calls THIS repo's own orchestrator</a:t>
+              <a:t>  only made async.</a:t>
+            </a:r>
+          </a:p>
+          <a:p>
+            <a:pPr>
+              <a:spcAft>
+                <a:spcPts val="600"/>
+              </a:spcAft>
+              <a:defRPr sz="1300" b="1">
+                <a:solidFill>
+                  <a:srgbClr val="0A2540"/>
+                </a:solidFill>
+                <a:latin typeface="Arial"/>
+              </a:defRPr>
+            </a:pPr>
+            <a:r>
+              <a:t>Cache path (new)</a:t>
             </a:r>
           </a:p>
           <a:p>
@@ -9602,9 +10614,64 @@
               </a:defRPr>
             </a:pPr>
             <a:r>
-              <a:t>  functions directly — zero re-implemented logic, nothing invented.</a:t>
-            </a:r>
-          </a:p>
+              <a:t>• cache_check_node / cache_store_node → the SAME chat_cache</a:t>
+            </a:r>
+          </a:p>
+          <a:p>
+            <a:pPr>
+              <a:spcAft>
+                <a:spcPts val="600"/>
+              </a:spcAft>
+              <a:defRPr sz="1300" b="0">
+                <a:solidFill>
+                  <a:srgbClr val="334155"/>
+                </a:solidFill>
+                <a:latin typeface="Arial"/>
+              </a:defRPr>
+            </a:pPr>
+            <a:r>
+              <a:t>  singleton + key format (site_id:query.lower()) the legacy</a:t>
+            </a:r>
+          </a:p>
+          <a:p>
+            <a:pPr>
+              <a:spcAft>
+                <a:spcPts val="600"/>
+              </a:spcAft>
+              <a:defRPr sz="1300" b="0">
+                <a:solidFill>
+                  <a:srgbClr val="334155"/>
+                </a:solidFill>
+                <a:latin typeface="Arial"/>
+              </a:defRPr>
+            </a:pPr>
+            <a:r>
+              <a:t>  orchestrator already uses — not a separate cache.</a:t>
+            </a:r>
+          </a:p>
+        </p:txBody>
+      </p:sp>
+      <p:sp>
+        <p:nvSpPr>
+          <p:cNvPr id="18" name="TextBox 17"/>
+          <p:cNvSpPr txBox="1"/>
+          <p:nvPr/>
+        </p:nvSpPr>
+        <p:spPr>
+          <a:xfrm>
+            <a:off x="6126480" y="1417320"/>
+            <a:ext cx="5257800" cy="4663440"/>
+          </a:xfrm>
+          <a:prstGeom prst="rect">
+            <a:avLst/>
+          </a:prstGeom>
+          <a:noFill/>
+        </p:spPr>
+        <p:txBody>
+          <a:bodyPr wrap="square" anchor="t">
+            <a:spAutoFit/>
+          </a:bodyPr>
+          <a:lstStyle/>
           <a:p>
             <a:pPr>
               <a:spcAft>
@@ -9618,7 +10685,7 @@
               </a:defRPr>
             </a:pPr>
             <a:r>
-              <a:t>Why explore a state graph</a:t>
+              <a:t>Catalog path</a:t>
             </a:r>
           </a:p>
           <a:p>
@@ -9634,7 +10701,7 @@
               </a:defRPr>
             </a:pPr>
             <a:r>
-              <a:t>• Retry/fallback decisions become named, independently unit-tested</a:t>
+              <a:t>• prefetch_node → resolve_recommendation_count + price_band +</a:t>
             </a:r>
           </a:p>
           <a:p>
@@ -9650,7 +10717,7 @@
               </a:defRPr>
             </a:pPr>
             <a:r>
-              <a:t>  routing functions instead of nested control flow in one function.</a:t>
+              <a:t>  retrieval_pool_size + search_catalog — orchestrator step 3.</a:t>
             </a:r>
           </a:p>
           <a:p>
@@ -9666,32 +10733,57 @@
               </a:defRPr>
             </a:pPr>
             <a:r>
-              <a:t>• Declarative node/edge graph — visualizable, replayable per request.</a:t>
-            </a:r>
-          </a:p>
-        </p:txBody>
-      </p:sp>
-      <p:sp>
-        <p:nvSpPr>
-          <p:cNvPr id="18" name="TextBox 17"/>
-          <p:cNvSpPr txBox="1"/>
-          <p:nvPr/>
-        </p:nvSpPr>
-        <p:spPr>
-          <a:xfrm>
-            <a:off x="6126480" y="1417320"/>
-            <a:ext cx="5257800" cy="4663440"/>
-          </a:xfrm>
-          <a:prstGeom prst="rect">
-            <a:avLst/>
-          </a:prstGeom>
-          <a:noFill/>
-        </p:spPr>
-        <p:txBody>
-          <a:bodyPr wrap="square" anchor="t">
-            <a:spAutoFit/>
-          </a:bodyPr>
-          <a:lstStyle/>
+              <a:t>• process_lane_node → dispatch_process(envelope, run_process_lane,</a:t>
+            </a:r>
+          </a:p>
+          <a:p>
+            <a:pPr>
+              <a:spcAft>
+                <a:spcPts val="600"/>
+              </a:spcAft>
+              <a:defRPr sz="1300" b="0">
+                <a:solidFill>
+                  <a:srgbClr val="334155"/>
+                </a:solidFill>
+                <a:latin typeface="Arial"/>
+              </a:defRPr>
+            </a:pPr>
+            <a:r>
+              <a:t>  timeout=&lt;constraints.yaml&gt;) — the real nested 40s outer /</a:t>
+            </a:r>
+          </a:p>
+          <a:p>
+            <a:pPr>
+              <a:spcAft>
+                <a:spcPts val="600"/>
+              </a:spcAft>
+              <a:defRPr sz="1300" b="0">
+                <a:solidFill>
+                  <a:srgbClr val="334155"/>
+                </a:solidFill>
+                <a:latin typeface="Arial"/>
+              </a:defRPr>
+            </a:pPr>
+            <a:r>
+              <a:t>  18s inner synthesis timeout, replacing two nodes that had</a:t>
+            </a:r>
+          </a:p>
+          <a:p>
+            <a:pPr>
+              <a:spcAft>
+                <a:spcPts val="600"/>
+              </a:spcAft>
+              <a:defRPr sz="1300" b="0">
+                <a:solidFill>
+                  <a:srgbClr val="334155"/>
+                </a:solidFill>
+                <a:latin typeface="Arial"/>
+              </a:defRPr>
+            </a:pPr>
+            <a:r>
+              <a:t>  re-derived retrieval + synthesis + template fallback inline.</a:t>
+            </a:r>
+          </a:p>
           <a:p>
             <a:pPr>
               <a:spcAft>
@@ -9705,7 +10797,7 @@
               </a:defRPr>
             </a:pPr>
             <a:r>
-              <a:t>Topology on that branch</a:t>
+              <a:t>Result</a:t>
             </a:r>
           </a:p>
           <a:p>
@@ -9721,7 +10813,7 @@
               </a:defRPr>
             </a:pPr>
             <a:r>
-              <a:t>• cache_check -&gt; classify_intent -&gt; [route_by_lane]</a:t>
+              <a:t>• rag_node + synthesis_node deleted — process_lane_node replaces</a:t>
             </a:r>
           </a:p>
           <a:p>
@@ -9737,7 +10829,674 @@
               </a:defRPr>
             </a:pPr>
             <a:r>
-              <a:t>•      -&gt; social (decline_off_topic | conversational)</a:t>
+              <a:t>  both with one verbatim call into the existing ACP dispatch.</a:t>
+            </a:r>
+          </a:p>
+        </p:txBody>
+      </p:sp>
+    </p:spTree>
+  </p:cSld>
+  <p:clrMapOvr>
+    <a:masterClrMapping/>
+  </p:clrMapOvr>
+</p:sld>
+</file>
+
+<file path=ppt/slides/slide17.xml><?xml version="1.0" encoding="utf-8"?>
+<p:sld xmlns:a="http://schemas.openxmlformats.org/drawingml/2006/main" xmlns:p="http://schemas.openxmlformats.org/presentationml/2006/main" xmlns:r="http://schemas.openxmlformats.org/officeDocument/2006/relationships">
+  <p:cSld>
+    <p:spTree>
+      <p:nvGrpSpPr>
+        <p:cNvPr id="1" name=""/>
+        <p:cNvGrpSpPr/>
+        <p:nvPr/>
+      </p:nvGrpSpPr>
+      <p:grpSpPr/>
+      <p:sp>
+        <p:nvSpPr>
+          <p:cNvPr id="2" name="Rectangle 1"/>
+          <p:cNvSpPr/>
+          <p:nvPr/>
+        </p:nvSpPr>
+        <p:spPr>
+          <a:xfrm>
+            <a:off x="429768" y="0"/>
+            <a:ext cx="11761927" cy="6858000"/>
+          </a:xfrm>
+          <a:prstGeom prst="rect">
+            <a:avLst/>
+          </a:prstGeom>
+          <a:solidFill>
+            <a:srgbClr val="FFFFFF"/>
+          </a:solidFill>
+          <a:ln>
+            <a:noFill/>
+          </a:ln>
+        </p:spPr>
+        <p:style>
+          <a:lnRef idx="1">
+            <a:schemeClr val="accent1"/>
+          </a:lnRef>
+          <a:fillRef idx="3">
+            <a:schemeClr val="accent1"/>
+          </a:fillRef>
+          <a:effectRef idx="2">
+            <a:schemeClr val="accent1"/>
+          </a:effectRef>
+          <a:fontRef idx="minor">
+            <a:schemeClr val="lt1"/>
+          </a:fontRef>
+        </p:style>
+        <p:txBody>
+          <a:bodyPr rtlCol="0" anchor="ctr"/>
+          <a:lstStyle/>
+          <a:p>
+            <a:pPr algn="ctr"/>
+          </a:p>
+        </p:txBody>
+      </p:sp>
+      <p:sp>
+        <p:nvSpPr>
+          <p:cNvPr id="3" name="Rectangle 2"/>
+          <p:cNvSpPr/>
+          <p:nvPr/>
+        </p:nvSpPr>
+        <p:spPr>
+          <a:xfrm>
+            <a:off x="0" y="0"/>
+            <a:ext cx="384048" cy="6858000"/>
+          </a:xfrm>
+          <a:prstGeom prst="rect">
+            <a:avLst/>
+          </a:prstGeom>
+          <a:solidFill>
+            <a:srgbClr val="0A2540"/>
+          </a:solidFill>
+          <a:ln>
+            <a:noFill/>
+          </a:ln>
+        </p:spPr>
+        <p:style>
+          <a:lnRef idx="1">
+            <a:schemeClr val="accent1"/>
+          </a:lnRef>
+          <a:fillRef idx="3">
+            <a:schemeClr val="accent1"/>
+          </a:fillRef>
+          <a:effectRef idx="2">
+            <a:schemeClr val="accent1"/>
+          </a:effectRef>
+          <a:fontRef idx="minor">
+            <a:schemeClr val="lt1"/>
+          </a:fontRef>
+        </p:style>
+        <p:txBody>
+          <a:bodyPr rtlCol="0" anchor="ctr"/>
+          <a:lstStyle/>
+          <a:p>
+            <a:pPr algn="ctr"/>
+          </a:p>
+        </p:txBody>
+      </p:sp>
+      <p:sp>
+        <p:nvSpPr>
+          <p:cNvPr id="4" name="Rectangle 3"/>
+          <p:cNvSpPr/>
+          <p:nvPr/>
+        </p:nvSpPr>
+        <p:spPr>
+          <a:xfrm>
+            <a:off x="384048" y="0"/>
+            <a:ext cx="45720" cy="6858000"/>
+          </a:xfrm>
+          <a:prstGeom prst="rect">
+            <a:avLst/>
+          </a:prstGeom>
+          <a:solidFill>
+            <a:srgbClr val="2563EB"/>
+          </a:solidFill>
+          <a:ln>
+            <a:noFill/>
+          </a:ln>
+        </p:spPr>
+        <p:style>
+          <a:lnRef idx="1">
+            <a:schemeClr val="accent1"/>
+          </a:lnRef>
+          <a:fillRef idx="3">
+            <a:schemeClr val="accent1"/>
+          </a:fillRef>
+          <a:effectRef idx="2">
+            <a:schemeClr val="accent1"/>
+          </a:effectRef>
+          <a:fontRef idx="minor">
+            <a:schemeClr val="lt1"/>
+          </a:fontRef>
+        </p:style>
+        <p:txBody>
+          <a:bodyPr rtlCol="0" anchor="ctr"/>
+          <a:lstStyle/>
+          <a:p>
+            <a:pPr algn="ctr"/>
+          </a:p>
+        </p:txBody>
+      </p:sp>
+      <p:sp>
+        <p:nvSpPr>
+          <p:cNvPr id="5" name="Rectangle 4"/>
+          <p:cNvSpPr/>
+          <p:nvPr/>
+        </p:nvSpPr>
+        <p:spPr>
+          <a:xfrm>
+            <a:off x="429768" y="0"/>
+            <a:ext cx="11761927" cy="1115568"/>
+          </a:xfrm>
+          <a:prstGeom prst="rect">
+            <a:avLst/>
+          </a:prstGeom>
+          <a:solidFill>
+            <a:srgbClr val="0A2540"/>
+          </a:solidFill>
+          <a:ln>
+            <a:noFill/>
+          </a:ln>
+        </p:spPr>
+        <p:style>
+          <a:lnRef idx="1">
+            <a:schemeClr val="accent1"/>
+          </a:lnRef>
+          <a:fillRef idx="3">
+            <a:schemeClr val="accent1"/>
+          </a:fillRef>
+          <a:effectRef idx="2">
+            <a:schemeClr val="accent1"/>
+          </a:effectRef>
+          <a:fontRef idx="minor">
+            <a:schemeClr val="lt1"/>
+          </a:fontRef>
+        </p:style>
+        <p:txBody>
+          <a:bodyPr rtlCol="0" anchor="ctr"/>
+          <a:lstStyle/>
+          <a:p>
+            <a:pPr algn="ctr"/>
+          </a:p>
+        </p:txBody>
+      </p:sp>
+      <p:sp>
+        <p:nvSpPr>
+          <p:cNvPr id="6" name="Rectangle 5"/>
+          <p:cNvSpPr/>
+          <p:nvPr/>
+        </p:nvSpPr>
+        <p:spPr>
+          <a:xfrm>
+            <a:off x="429768" y="1115568"/>
+            <a:ext cx="11761927" cy="54864"/>
+          </a:xfrm>
+          <a:prstGeom prst="rect">
+            <a:avLst/>
+          </a:prstGeom>
+          <a:solidFill>
+            <a:srgbClr val="2563EB"/>
+          </a:solidFill>
+          <a:ln>
+            <a:noFill/>
+          </a:ln>
+        </p:spPr>
+        <p:style>
+          <a:lnRef idx="1">
+            <a:schemeClr val="accent1"/>
+          </a:lnRef>
+          <a:fillRef idx="3">
+            <a:schemeClr val="accent1"/>
+          </a:fillRef>
+          <a:effectRef idx="2">
+            <a:schemeClr val="accent1"/>
+          </a:effectRef>
+          <a:fontRef idx="minor">
+            <a:schemeClr val="lt1"/>
+          </a:fontRef>
+        </p:style>
+        <p:txBody>
+          <a:bodyPr rtlCol="0" anchor="ctr"/>
+          <a:lstStyle/>
+          <a:p>
+            <a:pPr algn="ctr"/>
+          </a:p>
+        </p:txBody>
+      </p:sp>
+      <p:sp>
+        <p:nvSpPr>
+          <p:cNvPr id="7" name="Rectangle 6"/>
+          <p:cNvSpPr/>
+          <p:nvPr/>
+        </p:nvSpPr>
+        <p:spPr>
+          <a:xfrm>
+            <a:off x="429768" y="6419088"/>
+            <a:ext cx="11761927" cy="438912"/>
+          </a:xfrm>
+          <a:prstGeom prst="rect">
+            <a:avLst/>
+          </a:prstGeom>
+          <a:solidFill>
+            <a:srgbClr val="0A2540"/>
+          </a:solidFill>
+          <a:ln>
+            <a:noFill/>
+          </a:ln>
+        </p:spPr>
+        <p:style>
+          <a:lnRef idx="1">
+            <a:schemeClr val="accent1"/>
+          </a:lnRef>
+          <a:fillRef idx="3">
+            <a:schemeClr val="accent1"/>
+          </a:fillRef>
+          <a:effectRef idx="2">
+            <a:schemeClr val="accent1"/>
+          </a:effectRef>
+          <a:fontRef idx="minor">
+            <a:schemeClr val="lt1"/>
+          </a:fontRef>
+        </p:style>
+        <p:txBody>
+          <a:bodyPr rtlCol="0" anchor="ctr"/>
+          <a:lstStyle/>
+          <a:p>
+            <a:pPr algn="ctr"/>
+          </a:p>
+        </p:txBody>
+      </p:sp>
+      <p:sp>
+        <p:nvSpPr>
+          <p:cNvPr id="8" name="Rectangle 7"/>
+          <p:cNvSpPr/>
+          <p:nvPr/>
+        </p:nvSpPr>
+        <p:spPr>
+          <a:xfrm>
+            <a:off x="0" y="0"/>
+            <a:ext cx="384048" cy="6858000"/>
+          </a:xfrm>
+          <a:prstGeom prst="rect">
+            <a:avLst/>
+          </a:prstGeom>
+          <a:solidFill>
+            <a:srgbClr val="0A2540"/>
+          </a:solidFill>
+          <a:ln>
+            <a:noFill/>
+          </a:ln>
+        </p:spPr>
+        <p:style>
+          <a:lnRef idx="1">
+            <a:schemeClr val="accent1"/>
+          </a:lnRef>
+          <a:fillRef idx="3">
+            <a:schemeClr val="accent1"/>
+          </a:fillRef>
+          <a:effectRef idx="2">
+            <a:schemeClr val="accent1"/>
+          </a:effectRef>
+          <a:fontRef idx="minor">
+            <a:schemeClr val="lt1"/>
+          </a:fontRef>
+        </p:style>
+        <p:txBody>
+          <a:bodyPr rtlCol="0" anchor="ctr"/>
+          <a:lstStyle/>
+          <a:p>
+            <a:pPr algn="ctr"/>
+          </a:p>
+        </p:txBody>
+      </p:sp>
+      <p:sp>
+        <p:nvSpPr>
+          <p:cNvPr id="9" name="Rectangle 8"/>
+          <p:cNvSpPr/>
+          <p:nvPr/>
+        </p:nvSpPr>
+        <p:spPr>
+          <a:xfrm>
+            <a:off x="384048" y="0"/>
+            <a:ext cx="45720" cy="6858000"/>
+          </a:xfrm>
+          <a:prstGeom prst="rect">
+            <a:avLst/>
+          </a:prstGeom>
+          <a:solidFill>
+            <a:srgbClr val="2563EB"/>
+          </a:solidFill>
+          <a:ln>
+            <a:noFill/>
+          </a:ln>
+        </p:spPr>
+        <p:style>
+          <a:lnRef idx="1">
+            <a:schemeClr val="accent1"/>
+          </a:lnRef>
+          <a:fillRef idx="3">
+            <a:schemeClr val="accent1"/>
+          </a:fillRef>
+          <a:effectRef idx="2">
+            <a:schemeClr val="accent1"/>
+          </a:effectRef>
+          <a:fontRef idx="minor">
+            <a:schemeClr val="lt1"/>
+          </a:fontRef>
+        </p:style>
+        <p:txBody>
+          <a:bodyPr rtlCol="0" anchor="ctr"/>
+          <a:lstStyle/>
+          <a:p>
+            <a:pPr algn="ctr"/>
+          </a:p>
+        </p:txBody>
+      </p:sp>
+      <p:sp>
+        <p:nvSpPr>
+          <p:cNvPr id="10" name="TextBox 9"/>
+          <p:cNvSpPr txBox="1"/>
+          <p:nvPr/>
+        </p:nvSpPr>
+        <p:spPr>
+          <a:xfrm>
+            <a:off x="658368" y="182880"/>
+            <a:ext cx="9144000" cy="566928"/>
+          </a:xfrm>
+          <a:prstGeom prst="rect">
+            <a:avLst/>
+          </a:prstGeom>
+          <a:noFill/>
+        </p:spPr>
+        <p:txBody>
+          <a:bodyPr wrap="square" anchor="t">
+            <a:spAutoFit/>
+          </a:bodyPr>
+          <a:lstStyle/>
+          <a:p>
+            <a:pPr algn="l">
+              <a:defRPr sz="3400" b="1">
+                <a:solidFill>
+                  <a:srgbClr val="FFFFFF"/>
+                </a:solidFill>
+                <a:latin typeface="Arial"/>
+              </a:defRPr>
+            </a:pPr>
+            <a:r>
+              <a:t>LangGraph 3/3 — audit findings &amp; verified results</a:t>
+            </a:r>
+          </a:p>
+        </p:txBody>
+      </p:sp>
+      <p:sp>
+        <p:nvSpPr>
+          <p:cNvPr id="11" name="TextBox 10"/>
+          <p:cNvSpPr txBox="1"/>
+          <p:nvPr/>
+        </p:nvSpPr>
+        <p:spPr>
+          <a:xfrm>
+            <a:off x="658368" y="713232"/>
+            <a:ext cx="8046720" cy="347472"/>
+          </a:xfrm>
+          <a:prstGeom prst="rect">
+            <a:avLst/>
+          </a:prstGeom>
+          <a:noFill/>
+        </p:spPr>
+        <p:txBody>
+          <a:bodyPr wrap="square" anchor="t">
+            <a:spAutoFit/>
+          </a:bodyPr>
+          <a:lstStyle/>
+          <a:p>
+            <a:pPr algn="l">
+              <a:defRPr sz="1700" b="0">
+                <a:solidFill>
+                  <a:srgbClr val="BFDBFE"/>
+                </a:solidFill>
+                <a:latin typeface="Arial"/>
+              </a:defRPr>
+            </a:pPr>
+            <a:r>
+              <a:t>What a faithful audit found, and how it was verified</a:t>
+            </a:r>
+          </a:p>
+        </p:txBody>
+      </p:sp>
+      <p:sp>
+        <p:nvSpPr>
+          <p:cNvPr id="12" name="Rectangle 11"/>
+          <p:cNvSpPr/>
+          <p:nvPr/>
+        </p:nvSpPr>
+        <p:spPr>
+          <a:xfrm>
+            <a:off x="10241280" y="292608"/>
+            <a:ext cx="1600200" cy="438912"/>
+          </a:xfrm>
+          <a:prstGeom prst="rect">
+            <a:avLst/>
+          </a:prstGeom>
+          <a:solidFill>
+            <a:srgbClr val="2563EB"/>
+          </a:solidFill>
+          <a:ln>
+            <a:noFill/>
+          </a:ln>
+        </p:spPr>
+        <p:style>
+          <a:lnRef idx="1">
+            <a:schemeClr val="accent1"/>
+          </a:lnRef>
+          <a:fillRef idx="3">
+            <a:schemeClr val="accent1"/>
+          </a:fillRef>
+          <a:effectRef idx="2">
+            <a:schemeClr val="accent1"/>
+          </a:effectRef>
+          <a:fontRef idx="minor">
+            <a:schemeClr val="lt1"/>
+          </a:fontRef>
+        </p:style>
+        <p:txBody>
+          <a:bodyPr rtlCol="0" anchor="ctr"/>
+          <a:lstStyle/>
+          <a:p>
+            <a:pPr algn="ctr"/>
+          </a:p>
+        </p:txBody>
+      </p:sp>
+      <p:sp>
+        <p:nvSpPr>
+          <p:cNvPr id="13" name="TextBox 12"/>
+          <p:cNvSpPr txBox="1"/>
+          <p:nvPr/>
+        </p:nvSpPr>
+        <p:spPr>
+          <a:xfrm>
+            <a:off x="10314432" y="347472"/>
+            <a:ext cx="1463040" cy="365760"/>
+          </a:xfrm>
+          <a:prstGeom prst="rect">
+            <a:avLst/>
+          </a:prstGeom>
+          <a:noFill/>
+        </p:spPr>
+        <p:txBody>
+          <a:bodyPr wrap="square" anchor="t">
+            <a:spAutoFit/>
+          </a:bodyPr>
+          <a:lstStyle/>
+          <a:p>
+            <a:pPr algn="ctr">
+              <a:defRPr sz="1300" b="1">
+                <a:solidFill>
+                  <a:srgbClr val="FFFFFF"/>
+                </a:solidFill>
+                <a:latin typeface="Arial"/>
+              </a:defRPr>
+            </a:pPr>
+            <a:r>
+              <a:t>Architecture · LG</a:t>
+            </a:r>
+          </a:p>
+        </p:txBody>
+      </p:sp>
+      <p:sp>
+        <p:nvSpPr>
+          <p:cNvPr id="14" name="TextBox 13"/>
+          <p:cNvSpPr txBox="1"/>
+          <p:nvPr/>
+        </p:nvSpPr>
+        <p:spPr>
+          <a:xfrm>
+            <a:off x="658368" y="6492240"/>
+            <a:ext cx="9326880" cy="329184"/>
+          </a:xfrm>
+          <a:prstGeom prst="rect">
+            <a:avLst/>
+          </a:prstGeom>
+          <a:noFill/>
+        </p:spPr>
+        <p:txBody>
+          <a:bodyPr wrap="square" anchor="t">
+            <a:spAutoFit/>
+          </a:bodyPr>
+          <a:lstStyle/>
+          <a:p>
+            <a:pPr algn="l">
+              <a:defRPr sz="1200" b="0">
+                <a:solidFill>
+                  <a:srgbClr val="BFDBFE"/>
+                </a:solidFill>
+                <a:latin typeface="Arial"/>
+              </a:defRPr>
+            </a:pPr>
+            <a:r>
+              <a:t>zooplus Assistant — Coding Task PoC v0.1</a:t>
+            </a:r>
+          </a:p>
+        </p:txBody>
+      </p:sp>
+      <p:sp>
+        <p:nvSpPr>
+          <p:cNvPr id="15" name="TextBox 14"/>
+          <p:cNvSpPr txBox="1"/>
+          <p:nvPr/>
+        </p:nvSpPr>
+        <p:spPr>
+          <a:xfrm>
+            <a:off x="11155680" y="6473952"/>
+            <a:ext cx="868680" cy="329184"/>
+          </a:xfrm>
+          <a:prstGeom prst="rect">
+            <a:avLst/>
+          </a:prstGeom>
+          <a:noFill/>
+        </p:spPr>
+        <p:txBody>
+          <a:bodyPr wrap="square" anchor="t">
+            <a:spAutoFit/>
+          </a:bodyPr>
+          <a:lstStyle/>
+          <a:p>
+            <a:pPr algn="l">
+              <a:defRPr sz="1500" b="1">
+                <a:solidFill>
+                  <a:srgbClr val="FFFFFF"/>
+                </a:solidFill>
+                <a:latin typeface="Arial"/>
+              </a:defRPr>
+            </a:pPr>
+            <a:r>
+              <a:t>16</a:t>
+            </a:r>
+          </a:p>
+        </p:txBody>
+      </p:sp>
+      <p:sp>
+        <p:nvSpPr>
+          <p:cNvPr id="16" name="Rectangle 15"/>
+          <p:cNvSpPr/>
+          <p:nvPr/>
+        </p:nvSpPr>
+        <p:spPr>
+          <a:xfrm>
+            <a:off x="585216" y="1261872"/>
+            <a:ext cx="10972800" cy="4983480"/>
+          </a:xfrm>
+          <a:prstGeom prst="rect">
+            <a:avLst/>
+          </a:prstGeom>
+          <a:solidFill>
+            <a:srgbClr val="F8FAFC"/>
+          </a:solidFill>
+          <a:ln>
+            <a:noFill/>
+          </a:ln>
+        </p:spPr>
+        <p:style>
+          <a:lnRef idx="1">
+            <a:schemeClr val="accent1"/>
+          </a:lnRef>
+          <a:fillRef idx="3">
+            <a:schemeClr val="accent1"/>
+          </a:fillRef>
+          <a:effectRef idx="2">
+            <a:schemeClr val="accent1"/>
+          </a:effectRef>
+          <a:fontRef idx="minor">
+            <a:schemeClr val="lt1"/>
+          </a:fontRef>
+        </p:style>
+        <p:txBody>
+          <a:bodyPr rtlCol="0" anchor="ctr"/>
+          <a:lstStyle/>
+          <a:p>
+            <a:pPr algn="ctr"/>
+          </a:p>
+        </p:txBody>
+      </p:sp>
+      <p:sp>
+        <p:nvSpPr>
+          <p:cNvPr id="17" name="TextBox 16"/>
+          <p:cNvSpPr txBox="1"/>
+          <p:nvPr/>
+        </p:nvSpPr>
+        <p:spPr>
+          <a:xfrm>
+            <a:off x="749808" y="1417320"/>
+            <a:ext cx="5349240" cy="4663440"/>
+          </a:xfrm>
+          <a:prstGeom prst="rect">
+            <a:avLst/>
+          </a:prstGeom>
+          <a:noFill/>
+        </p:spPr>
+        <p:txBody>
+          <a:bodyPr wrap="square" anchor="t">
+            <a:spAutoFit/>
+          </a:bodyPr>
+          <a:lstStyle/>
+          <a:p>
+            <a:pPr>
+              <a:spcAft>
+                <a:spcPts val="600"/>
+              </a:spcAft>
+              <a:defRPr sz="1300" b="1">
+                <a:solidFill>
+                  <a:srgbClr val="0A2540"/>
+                </a:solidFill>
+                <a:latin typeface="Arial"/>
+              </a:defRPr>
+            </a:pPr>
+            <a:r>
+              <a:t>3 real gaps found in the first migration</a:t>
             </a:r>
           </a:p>
           <a:p>
@@ -9753,7 +11512,7 @@
               </a:defRPr>
             </a:pPr>
             <a:r>
-              <a:t>•      -&gt; prefetch -&gt; process_lane (catalog_search)</a:t>
+              <a:t>1. preferred_model (UI's per-request model override) was stored</a:t>
             </a:r>
           </a:p>
           <a:p>
@@ -9769,7 +11528,7 @@
               </a:defRPr>
             </a:pPr>
             <a:r>
-              <a:t>• -&gt; cache_store -&gt; END</a:t>
+              <a:t>   in graph state but no node ever read it — silently inert.</a:t>
             </a:r>
           </a:p>
           <a:p>
@@ -9785,7 +11544,7 @@
               </a:defRPr>
             </a:pPr>
             <a:r>
-              <a:t>• process_lane calls dispatch_process(run_process_lane) directly —</a:t>
+              <a:t>   Fixed: ContextVar set for the whole graph run, mirroring</a:t>
             </a:r>
           </a:p>
           <a:p>
@@ -9801,9 +11560,80 @@
               </a:defRPr>
             </a:pPr>
             <a:r>
-              <a:t>  the same ACP dispatch this repo's catalog lane already used.</a:t>
-            </a:r>
-          </a:p>
+              <a:t>   handle_chat()'s own wrapper.</a:t>
+            </a:r>
+          </a:p>
+          <a:p>
+            <a:pPr>
+              <a:spcAft>
+                <a:spcPts val="600"/>
+              </a:spcAft>
+              <a:defRPr sz="1300" b="0">
+                <a:solidFill>
+                  <a:srgbClr val="334155"/>
+                </a:solidFill>
+                <a:latin typeface="Arial"/>
+              </a:defRPr>
+            </a:pPr>
+            <a:r>
+              <a:t>2. No chat-level cache existed on the LangGraph path at all.</a:t>
+            </a:r>
+          </a:p>
+          <a:p>
+            <a:pPr>
+              <a:spcAft>
+                <a:spcPts val="600"/>
+              </a:spcAft>
+              <a:defRPr sz="1300" b="0">
+                <a:solidFill>
+                  <a:srgbClr val="334155"/>
+                </a:solidFill>
+                <a:latin typeface="Arial"/>
+              </a:defRPr>
+            </a:pPr>
+            <a:r>
+              <a:t>3. Catalog path bypassed dispatch_process — one 18s timeout, no</a:t>
+            </a:r>
+          </a:p>
+          <a:p>
+            <a:pPr>
+              <a:spcAft>
+                <a:spcPts val="600"/>
+              </a:spcAft>
+              <a:defRPr sz="1300" b="0">
+                <a:solidFill>
+                  <a:srgbClr val="334155"/>
+                </a:solidFill>
+                <a:latin typeface="Arial"/>
+              </a:defRPr>
+            </a:pPr>
+            <a:r>
+              <a:t>   outer-timeout cancellation message was ever reachable.</a:t>
+            </a:r>
+          </a:p>
+        </p:txBody>
+      </p:sp>
+      <p:sp>
+        <p:nvSpPr>
+          <p:cNvPr id="18" name="TextBox 17"/>
+          <p:cNvSpPr txBox="1"/>
+          <p:nvPr/>
+        </p:nvSpPr>
+        <p:spPr>
+          <a:xfrm>
+            <a:off x="6126480" y="1417320"/>
+            <a:ext cx="5257800" cy="4663440"/>
+          </a:xfrm>
+          <a:prstGeom prst="rect">
+            <a:avLst/>
+          </a:prstGeom>
+          <a:noFill/>
+        </p:spPr>
+        <p:txBody>
+          <a:bodyPr wrap="square" anchor="t">
+            <a:spAutoFit/>
+          </a:bodyPr>
+          <a:lstStyle/>
           <a:p>
             <a:pPr>
               <a:spcAft>
@@ -9817,7 +11647,7 @@
               </a:defRPr>
             </a:pPr>
             <a:r>
-              <a:t>What a full audit found</a:t>
+              <a:t>Verified live against the running server</a:t>
             </a:r>
           </a:p>
           <a:p>
@@ -9833,7 +11663,7 @@
               </a:defRPr>
             </a:pPr>
             <a:r>
-              <a:t>• 2 real gaps in an earlier, looser translation: UI model override</a:t>
+              <a:t>• preferred_model: requested opencode/deepseek-v4-flash-free →</a:t>
             </a:r>
           </a:p>
           <a:p>
@@ -9849,7 +11679,7 @@
               </a:defRPr>
             </a:pPr>
             <a:r>
-              <a:t>  silently ignored; no chat-level cache. Both closed by calling the</a:t>
+              <a:t>  that exact value now echoed in meta.llm_model (previously</a:t>
             </a:r>
           </a:p>
           <a:p>
@@ -9865,7 +11695,119 @@
               </a:defRPr>
             </a:pPr>
             <a:r>
-              <a:t>  real functions instead of re-deriving equivalent-looking logic.</a:t>
+              <a:t>  always silently ignored).</a:t>
+            </a:r>
+          </a:p>
+          <a:p>
+            <a:pPr>
+              <a:spcAft>
+                <a:spcPts val="600"/>
+              </a:spcAft>
+              <a:defRPr sz="1300" b="0">
+                <a:solidFill>
+                  <a:srgbClr val="334155"/>
+                </a:solidFill>
+                <a:latin typeface="Arial"/>
+              </a:defRPr>
+            </a:pPr>
+            <a:r>
+              <a:t>• Cache: identical repeat query — 19.2s (cold) → 0.02s (hit),</a:t>
+            </a:r>
+          </a:p>
+          <a:p>
+            <a:pPr>
+              <a:spcAft>
+                <a:spcPts val="600"/>
+              </a:spcAft>
+              <a:defRPr sz="1300" b="0">
+                <a:solidFill>
+                  <a:srgbClr val="334155"/>
+                </a:solidFill>
+                <a:latin typeface="Arial"/>
+              </a:defRPr>
+            </a:pPr>
+            <a:r>
+              <a:t>  same answer.</a:t>
+            </a:r>
+          </a:p>
+          <a:p>
+            <a:pPr>
+              <a:spcAft>
+                <a:spcPts val="600"/>
+              </a:spcAft>
+              <a:defRPr sz="1300" b="1">
+                <a:solidFill>
+                  <a:srgbClr val="0A2540"/>
+                </a:solidFill>
+                <a:latin typeface="Arial"/>
+              </a:defRPr>
+            </a:pPr>
+            <a:r>
+              <a:t>Test coverage</a:t>
+            </a:r>
+          </a:p>
+          <a:p>
+            <a:pPr>
+              <a:spcAft>
+                <a:spcPts val="600"/>
+              </a:spcAft>
+              <a:defRPr sz="1300" b="0">
+                <a:solidFill>
+                  <a:srgbClr val="334155"/>
+                </a:solidFill>
+                <a:latin typeface="Arial"/>
+              </a:defRPr>
+            </a:pPr>
+            <a:r>
+              <a:t>• 179/180 unit (+19 new tests for the 3 gaps), 206/206</a:t>
+            </a:r>
+          </a:p>
+          <a:p>
+            <a:pPr>
+              <a:spcAft>
+                <a:spcPts val="600"/>
+              </a:spcAft>
+              <a:defRPr sz="1300" b="0">
+                <a:solidFill>
+                  <a:srgbClr val="334155"/>
+                </a:solidFill>
+                <a:latin typeface="Arial"/>
+              </a:defRPr>
+            </a:pPr>
+            <a:r>
+              <a:t>  acceptance, 33/33 integration — ZOOPLUS_ORCHESTRATOR=langchain.</a:t>
+            </a:r>
+          </a:p>
+          <a:p>
+            <a:pPr>
+              <a:spcAft>
+                <a:spcPts val="600"/>
+              </a:spcAft>
+              <a:defRPr sz="1300" b="0">
+                <a:solidFill>
+                  <a:srgbClr val="334155"/>
+                </a:solidFill>
+                <a:latin typeface="Arial"/>
+              </a:defRPr>
+            </a:pPr>
+            <a:r>
+              <a:t>• Branch: feature/lg-catalog-probe-intent — standalone, not</a:t>
+            </a:r>
+          </a:p>
+          <a:p>
+            <a:pPr>
+              <a:spcAft>
+                <a:spcPts val="600"/>
+              </a:spcAft>
+              <a:defRPr sz="1300" b="0">
+                <a:solidFill>
+                  <a:srgbClr val="334155"/>
+                </a:solidFill>
+                <a:latin typeface="Arial"/>
+              </a:defRPr>
+            </a:pPr>
+            <a:r>
+              <a:t>  merged into dev/main/releases.</a:t>
             </a:r>
           </a:p>
         </p:txBody>

</xml_diff>

<commit_message>
docs(ppt): replace LangGraph slide bullets with real visuals — flowchart diagram, node table, bar chart + callout cards
</commit_message>
<xml_diff>
--- a/docs/deliverables/v0.1/zooplus-assistant-interview-15min-pro.pptx
+++ b/docs/deliverables/v0.1/zooplus-assistant-interview-15min-pro.pptx
@@ -123,6 +123,185 @@
 </p:presentation>
 </file>
 
+<file path=ppt/charts/chart1.xml><?xml version="1.0" encoding="utf-8"?>
+<c:chartSpace xmlns:c="http://schemas.openxmlformats.org/drawingml/2006/chart" xmlns:a="http://schemas.openxmlformats.org/drawingml/2006/main" xmlns:r="http://schemas.openxmlformats.org/officeDocument/2006/relationships">
+  <c:date1904 val="0"/>
+  <c:chart>
+    <c:title>
+      <c:tx>
+        <c:rich>
+          <a:bodyPr/>
+          <a:lstStyle/>
+          <a:p>
+            <a:pPr>
+              <a:defRPr sz="1300" b="1"/>
+            </a:pPr>
+            <a:r>
+              <a:t>Verified live: cache-hit speedup</a:t>
+            </a:r>
+          </a:p>
+        </c:rich>
+      </c:tx>
+      <c:layout/>
+      <c:overlay val="0"/>
+    </c:title>
+    <c:autoTitleDeleted val="0"/>
+    <c:plotArea>
+      <c:barChart>
+        <c:barDir val="col"/>
+        <c:grouping val="clustered"/>
+        <c:ser>
+          <c:idx val="0"/>
+          <c:order val="0"/>
+          <c:tx>
+            <c:strRef>
+              <c:f>Sheet1!$B$1</c:f>
+              <c:strCache>
+                <c:ptCount val="1"/>
+                <c:pt idx="0">
+                  <c:v>Response time (seconds)</c:v>
+                </c:pt>
+              </c:strCache>
+            </c:strRef>
+          </c:tx>
+          <c:spPr>
+            <a:solidFill>
+              <a:srgbClr val="60A5FA"/>
+            </a:solidFill>
+          </c:spPr>
+          <c:cat>
+            <c:strRef>
+              <c:f>Sheet1!$A$2:$A$3</c:f>
+              <c:strCache>
+                <c:ptCount val="2"/>
+                <c:pt idx="0">
+                  <c:v>Cache miss
+(cold, real OpenCode call)</c:v>
+                </c:pt>
+                <c:pt idx="1">
+                  <c:v>Cache hit
+(repeat query)</c:v>
+                </c:pt>
+              </c:strCache>
+            </c:strRef>
+          </c:cat>
+          <c:val>
+            <c:numRef>
+              <c:f>Sheet1!$B$2:$B$3</c:f>
+              <c:numCache>
+                <c:formatCode>General</c:formatCode>
+                <c:ptCount val="2"/>
+                <c:pt idx="0">
+                  <c:v>19.2</c:v>
+                </c:pt>
+                <c:pt idx="1">
+                  <c:v>0.02</c:v>
+                </c:pt>
+              </c:numCache>
+            </c:numRef>
+          </c:val>
+        </c:ser>
+        <c:dLbls>
+          <c:numFmt formatCode="0.00&quot;s&quot;" sourceLinked="0"/>
+          <c:txPr>
+            <a:bodyPr/>
+            <a:lstStyle/>
+            <a:p>
+              <a:pPr>
+                <a:defRPr sz="1200" b="1">
+                  <a:solidFill>
+                    <a:srgbClr val="0A2540"/>
+                  </a:solidFill>
+                </a:defRPr>
+              </a:pPr>
+            </a:p>
+          </c:txPr>
+          <c:showLegendKey val="0"/>
+          <c:showVal val="1"/>
+          <c:showCatName val="0"/>
+          <c:showSerName val="0"/>
+          <c:showPercent val="0"/>
+          <c:showBubbleSize val="0"/>
+          <c:showLeaderLines val="1"/>
+        </c:dLbls>
+        <c:axId val="-2068027336"/>
+        <c:axId val="-2113994440"/>
+      </c:barChart>
+      <c:catAx>
+        <c:axId val="-2068027336"/>
+        <c:scaling>
+          <c:orientation val="minMax"/>
+        </c:scaling>
+        <c:delete val="0"/>
+        <c:axPos val="b"/>
+        <c:majorTickMark val="out"/>
+        <c:minorTickMark val="none"/>
+        <c:tickLblPos val="nextTo"/>
+        <c:txPr>
+          <a:bodyPr/>
+          <a:lstStyle/>
+          <a:p>
+            <a:pPr>
+              <a:defRPr sz="1000"/>
+            </a:pPr>
+          </a:p>
+        </c:txPr>
+        <c:crossAx val="-2113994440"/>
+        <c:crosses val="autoZero"/>
+        <c:auto val="1"/>
+        <c:lblAlgn val="ctr"/>
+        <c:lblOffset val="100"/>
+        <c:noMultiLvlLbl val="0"/>
+      </c:catAx>
+      <c:valAx>
+        <c:axId val="-2113994440"/>
+        <c:scaling/>
+        <c:delete val="0"/>
+        <c:axPos val="l"/>
+        <c:majorGridlines/>
+        <c:title>
+          <c:tx>
+            <c:rich>
+              <a:bodyPr/>
+              <a:lstStyle/>
+              <a:p>
+                <a:pPr>
+                  <a:defRPr sz="1000"/>
+                </a:pPr>
+                <a:r>
+                  <a:t>Seconds</a:t>
+                </a:r>
+              </a:p>
+            </c:rich>
+          </c:tx>
+          <c:layout/>
+          <c:overlay val="0"/>
+        </c:title>
+        <c:majorTickMark val="out"/>
+        <c:minorTickMark val="none"/>
+        <c:tickLblPos val="nextTo"/>
+        <c:crossAx val="-2068027336"/>
+        <c:crosses val="autoZero"/>
+      </c:valAx>
+    </c:plotArea>
+    <c:dispBlanksAs val="gap"/>
+  </c:chart>
+  <c:txPr>
+    <a:bodyPr/>
+    <a:lstStyle/>
+    <a:p>
+      <a:pPr>
+        <a:defRPr sz="1800"/>
+      </a:pPr>
+      <a:endParaRPr lang="en-US"/>
+    </a:p>
+  </c:txPr>
+  <c:externalData r:id="rId1">
+    <c:autoUpdate val="0"/>
+  </c:externalData>
+</c:chartSpace>
+</file>
+
 <file path=ppt/notesMasters/notesMaster1.xml><?xml version="1.0" encoding="utf-8"?>
 <p:notesMaster xmlns:a="http://schemas.openxmlformats.org/drawingml/2006/main" xmlns:p="http://schemas.openxmlformats.org/presentationml/2006/main" xmlns:r="http://schemas.openxmlformats.org/officeDocument/2006/relationships">
   <p:cSld>
@@ -8681,7 +8860,7 @@
         <p:spPr>
           <a:xfrm>
             <a:off x="749808" y="1417320"/>
-            <a:ext cx="5349240" cy="4663440"/>
+            <a:ext cx="4160520" cy="4663440"/>
           </a:xfrm>
           <a:prstGeom prst="rect">
             <a:avLst/>
@@ -8698,7 +8877,7 @@
               <a:spcAft>
                 <a:spcPts val="600"/>
               </a:spcAft>
-              <a:defRPr sz="1300" b="1">
+              <a:defRPr sz="1200" b="1">
                 <a:solidFill>
                   <a:srgbClr val="0A2540"/>
                 </a:solidFill>
@@ -8714,7 +8893,7 @@
               <a:spcAft>
                 <a:spcPts val="600"/>
               </a:spcAft>
-              <a:defRPr sz="1300" b="0">
+              <a:defRPr sz="1200" b="0">
                 <a:solidFill>
                   <a:srgbClr val="334155"/>
                 </a:solidFill>
@@ -8722,7 +8901,7 @@
               </a:defRPr>
             </a:pPr>
             <a:r>
-              <a:t>• Legacy: one async function (_handle_chat_inner) with nested</a:t>
+              <a:t>• Legacy: one async function with nested if/elif per lane —</a:t>
             </a:r>
           </a:p>
           <a:p>
@@ -8730,7 +8909,7 @@
               <a:spcAft>
                 <a:spcPts val="600"/>
               </a:spcAft>
-              <a:defRPr sz="1300" b="0">
+              <a:defRPr sz="1200" b="0">
                 <a:solidFill>
                   <a:srgbClr val="334155"/>
                 </a:solidFill>
@@ -8738,7 +8917,7 @@
               </a:defRPr>
             </a:pPr>
             <a:r>
-              <a:t>  if/elif per lane — retry/fallback chains hidden inside helpers.</a:t>
+              <a:t>  retry/fallback chains hidden inside helper functions.</a:t>
             </a:r>
           </a:p>
           <a:p>
@@ -8746,7 +8925,7 @@
               <a:spcAft>
                 <a:spcPts val="600"/>
               </a:spcAft>
-              <a:defRPr sz="1300" b="0">
+              <a:defRPr sz="1200" b="0">
                 <a:solidFill>
                   <a:srgbClr val="334155"/>
                 </a:solidFill>
@@ -8754,7 +8933,7 @@
               </a:defRPr>
             </a:pPr>
             <a:r>
-              <a:t>• Hard to unit-test one decision in isolation — e.g. "what happens</a:t>
+              <a:t>• Hard to unit-test one decision in isolation (e.g. "what happens</a:t>
             </a:r>
           </a:p>
           <a:p>
@@ -8762,7 +8941,7 @@
               <a:spcAft>
                 <a:spcPts val="600"/>
               </a:spcAft>
-              <a:defRPr sz="1300" b="0">
+              <a:defRPr sz="1200" b="0">
                 <a:solidFill>
                   <a:srgbClr val="334155"/>
                 </a:solidFill>
@@ -8770,7 +8949,7 @@
               </a:defRPr>
             </a:pPr>
             <a:r>
-              <a:t>  on an intent timeout?" — without exercising the whole function.</a:t>
+              <a:t>  on an intent timeout?") without exercising the whole function.</a:t>
             </a:r>
           </a:p>
           <a:p>
@@ -8778,7 +8957,7 @@
               <a:spcAft>
                 <a:spcPts val="600"/>
               </a:spcAft>
-              <a:defRPr sz="1300" b="1">
+              <a:defRPr sz="1200" b="1">
                 <a:solidFill>
                   <a:srgbClr val="0A2540"/>
                 </a:solidFill>
@@ -8794,7 +8973,7 @@
               <a:spcAft>
                 <a:spcPts val="600"/>
               </a:spcAft>
-              <a:defRPr sz="1300" b="0">
+              <a:defRPr sz="1200" b="0">
                 <a:solidFill>
                   <a:srgbClr val="334155"/>
                 </a:solidFill>
@@ -8802,7 +8981,7 @@
               </a:defRPr>
             </a:pPr>
             <a:r>
-              <a:t>• feature/lg-catalog-probe-intent — StateGraph: nodes are</a:t>
+              <a:t>• Every node calls THIS repo's own functions verbatim — zero</a:t>
             </a:r>
           </a:p>
           <a:p>
@@ -8810,7 +8989,7 @@
               <a:spcAft>
                 <a:spcPts val="600"/>
               </a:spcAft>
-              <a:defRPr sz="1300" b="0">
+              <a:defRPr sz="1200" b="0">
                 <a:solidFill>
                   <a:srgbClr val="334155"/>
                 </a:solidFill>
@@ -8818,7 +8997,7 @@
               </a:defRPr>
             </a:pPr>
             <a:r>
-              <a:t>  functions, edges are typed routing functions, independently</a:t>
+              <a:t>  re-implemented logic, nothing invented.</a:t>
             </a:r>
           </a:p>
           <a:p>
@@ -8826,7 +9005,7 @@
               <a:spcAft>
                 <a:spcPts val="600"/>
               </a:spcAft>
-              <a:defRPr sz="1300" b="0">
+              <a:defRPr sz="1200" b="0">
                 <a:solidFill>
                   <a:srgbClr val="334155"/>
                 </a:solidFill>
@@ -8834,7 +9013,7 @@
               </a:defRPr>
             </a:pPr>
             <a:r>
-              <a:t>  testable in isolation (pure dict in, string out).</a:t>
+              <a:t>• 4 typed routing functions, independently unit-tested.</a:t>
             </a:r>
           </a:p>
           <a:p>
@@ -8842,7 +9021,7 @@
               <a:spcAft>
                 <a:spcPts val="600"/>
               </a:spcAft>
-              <a:defRPr sz="1300" b="0">
+              <a:defRPr sz="1200" b="0">
                 <a:solidFill>
                   <a:srgbClr val="334155"/>
                 </a:solidFill>
@@ -8850,37 +9029,1037 @@
               </a:defRPr>
             </a:pPr>
             <a:r>
-              <a:t>• Every node calls THIS repo's own functions verbatim — zero</a:t>
-            </a:r>
-          </a:p>
-          <a:p>
-            <a:pPr>
-              <a:spcAft>
-                <a:spcPts val="600"/>
-              </a:spcAft>
-              <a:defRPr sz="1300" b="0">
-                <a:solidFill>
-                  <a:srgbClr val="334155"/>
-                </a:solidFill>
-                <a:latin typeface="Arial"/>
-              </a:defRPr>
-            </a:pPr>
-            <a:r>
-              <a:t>  re-implemented logic, nothing invented.</a:t>
-            </a:r>
-          </a:p>
-        </p:txBody>
-      </p:sp>
-      <p:sp>
-        <p:nvSpPr>
-          <p:cNvPr id="18" name="TextBox 17"/>
+              <a:t>• All 7 nodes async — graph.ainvoke(), not graph.invoke().</a:t>
+            </a:r>
+          </a:p>
+        </p:txBody>
+      </p:sp>
+      <p:sp>
+        <p:nvSpPr>
+          <p:cNvPr id="18" name="Rounded Rectangle 17"/>
+          <p:cNvSpPr/>
+          <p:nvPr/>
+        </p:nvSpPr>
+        <p:spPr>
+          <a:xfrm>
+            <a:off x="7818120" y="1417320"/>
+            <a:ext cx="1188720" cy="292608"/>
+          </a:xfrm>
+          <a:prstGeom prst="roundRect">
+            <a:avLst/>
+          </a:prstGeom>
+          <a:solidFill>
+            <a:srgbClr val="334155"/>
+          </a:solidFill>
+          <a:ln>
+            <a:solidFill>
+              <a:srgbClr val="334155"/>
+            </a:solidFill>
+          </a:ln>
+          <a:effectLst/>
+        </p:spPr>
+        <p:style>
+          <a:lnRef idx="1">
+            <a:schemeClr val="accent1"/>
+          </a:lnRef>
+          <a:fillRef idx="3">
+            <a:schemeClr val="accent1"/>
+          </a:fillRef>
+          <a:effectRef idx="2">
+            <a:schemeClr val="accent1"/>
+          </a:effectRef>
+          <a:fontRef idx="minor">
+            <a:schemeClr val="lt1"/>
+          </a:fontRef>
+        </p:style>
+        <p:txBody>
+          <a:bodyPr rtlCol="0" anchor="ctr" wrap="square" lIns="38100" rIns="38100" tIns="12700" bIns="12700"/>
+          <a:lstStyle/>
+          <a:p>
+            <a:pPr algn="ctr">
+              <a:defRPr sz="1000" b="1">
+                <a:solidFill>
+                  <a:srgbClr val="FFFFFF"/>
+                </a:solidFill>
+                <a:latin typeface="Arial"/>
+              </a:defRPr>
+            </a:pPr>
+            <a:r>
+              <a:t>START</a:t>
+            </a:r>
+          </a:p>
+        </p:txBody>
+      </p:sp>
+      <p:sp>
+        <p:nvSpPr>
+          <p:cNvPr id="19" name="Rounded Rectangle 18"/>
+          <p:cNvSpPr/>
+          <p:nvPr/>
+        </p:nvSpPr>
+        <p:spPr>
+          <a:xfrm>
+            <a:off x="6629400" y="1965960"/>
+            <a:ext cx="2468880" cy="384048"/>
+          </a:xfrm>
+          <a:prstGeom prst="roundRect">
+            <a:avLst/>
+          </a:prstGeom>
+          <a:solidFill>
+            <a:srgbClr val="60A5FA"/>
+          </a:solidFill>
+          <a:ln>
+            <a:solidFill>
+              <a:srgbClr val="60A5FA"/>
+            </a:solidFill>
+          </a:ln>
+          <a:effectLst/>
+        </p:spPr>
+        <p:style>
+          <a:lnRef idx="1">
+            <a:schemeClr val="accent1"/>
+          </a:lnRef>
+          <a:fillRef idx="3">
+            <a:schemeClr val="accent1"/>
+          </a:fillRef>
+          <a:effectRef idx="2">
+            <a:schemeClr val="accent1"/>
+          </a:effectRef>
+          <a:fontRef idx="minor">
+            <a:schemeClr val="lt1"/>
+          </a:fontRef>
+        </p:style>
+        <p:txBody>
+          <a:bodyPr rtlCol="0" anchor="ctr" wrap="square" lIns="38100" rIns="38100" tIns="12700" bIns="12700"/>
+          <a:lstStyle/>
+          <a:p>
+            <a:pPr algn="ctr">
+              <a:defRPr sz="1100" b="1">
+                <a:solidFill>
+                  <a:srgbClr val="FFFFFF"/>
+                </a:solidFill>
+                <a:latin typeface="Arial"/>
+              </a:defRPr>
+            </a:pPr>
+            <a:r>
+              <a:t>cache_check</a:t>
+            </a:r>
+          </a:p>
+        </p:txBody>
+      </p:sp>
+      <p:sp>
+        <p:nvSpPr>
+          <p:cNvPr id="20" name="Rounded Rectangle 19"/>
+          <p:cNvSpPr/>
+          <p:nvPr/>
+        </p:nvSpPr>
+        <p:spPr>
+          <a:xfrm>
+            <a:off x="9829800" y="1920240"/>
+            <a:ext cx="1417320" cy="457200"/>
+          </a:xfrm>
+          <a:prstGeom prst="roundRect">
+            <a:avLst/>
+          </a:prstGeom>
+          <a:solidFill>
+            <a:srgbClr val="334155"/>
+          </a:solidFill>
+          <a:ln>
+            <a:solidFill>
+              <a:srgbClr val="334155"/>
+            </a:solidFill>
+          </a:ln>
+          <a:effectLst/>
+        </p:spPr>
+        <p:style>
+          <a:lnRef idx="1">
+            <a:schemeClr val="accent1"/>
+          </a:lnRef>
+          <a:fillRef idx="3">
+            <a:schemeClr val="accent1"/>
+          </a:fillRef>
+          <a:effectRef idx="2">
+            <a:schemeClr val="accent1"/>
+          </a:effectRef>
+          <a:fontRef idx="minor">
+            <a:schemeClr val="lt1"/>
+          </a:fontRef>
+        </p:style>
+        <p:txBody>
+          <a:bodyPr rtlCol="0" anchor="ctr" wrap="square" lIns="38100" rIns="38100" tIns="12700" bIns="12700"/>
+          <a:lstStyle/>
+          <a:p>
+            <a:pPr algn="ctr">
+              <a:defRPr sz="900" b="1">
+                <a:solidFill>
+                  <a:srgbClr val="FFFFFF"/>
+                </a:solidFill>
+                <a:latin typeface="Arial"/>
+              </a:defRPr>
+            </a:pPr>
+            <a:r>
+              <a:t>END</a:t>
+            </a:r>
+            <a:br/>
+            <a:r>
+              <a:t>(cached answer)</a:t>
+            </a:r>
+          </a:p>
+        </p:txBody>
+      </p:sp>
+      <p:sp>
+        <p:nvSpPr>
+          <p:cNvPr id="21" name="Rounded Rectangle 20"/>
+          <p:cNvSpPr/>
+          <p:nvPr/>
+        </p:nvSpPr>
+        <p:spPr>
+          <a:xfrm>
+            <a:off x="6629400" y="2697480"/>
+            <a:ext cx="2468880" cy="384048"/>
+          </a:xfrm>
+          <a:prstGeom prst="roundRect">
+            <a:avLst/>
+          </a:prstGeom>
+          <a:solidFill>
+            <a:srgbClr val="F59E0B"/>
+          </a:solidFill>
+          <a:ln>
+            <a:solidFill>
+              <a:srgbClr val="F59E0B"/>
+            </a:solidFill>
+          </a:ln>
+          <a:effectLst/>
+        </p:spPr>
+        <p:style>
+          <a:lnRef idx="1">
+            <a:schemeClr val="accent1"/>
+          </a:lnRef>
+          <a:fillRef idx="3">
+            <a:schemeClr val="accent1"/>
+          </a:fillRef>
+          <a:effectRef idx="2">
+            <a:schemeClr val="accent1"/>
+          </a:effectRef>
+          <a:fontRef idx="minor">
+            <a:schemeClr val="lt1"/>
+          </a:fontRef>
+        </p:style>
+        <p:txBody>
+          <a:bodyPr rtlCol="0" anchor="ctr" wrap="square" lIns="38100" rIns="38100" tIns="12700" bIns="12700"/>
+          <a:lstStyle/>
+          <a:p>
+            <a:pPr algn="ctr">
+              <a:defRPr sz="1100" b="1">
+                <a:solidFill>
+                  <a:srgbClr val="FFFFFF"/>
+                </a:solidFill>
+                <a:latin typeface="Arial"/>
+              </a:defRPr>
+            </a:pPr>
+            <a:r>
+              <a:t>classify_intent</a:t>
+            </a:r>
+          </a:p>
+        </p:txBody>
+      </p:sp>
+      <p:sp>
+        <p:nvSpPr>
+          <p:cNvPr id="22" name="Rounded Rectangle 21"/>
+          <p:cNvSpPr/>
+          <p:nvPr/>
+        </p:nvSpPr>
+        <p:spPr>
+          <a:xfrm>
+            <a:off x="5349240" y="3429000"/>
+            <a:ext cx="1737360" cy="384048"/>
+          </a:xfrm>
+          <a:prstGeom prst="roundRect">
+            <a:avLst/>
+          </a:prstGeom>
+          <a:solidFill>
+            <a:srgbClr val="34D399"/>
+          </a:solidFill>
+          <a:ln>
+            <a:solidFill>
+              <a:srgbClr val="34D399"/>
+            </a:solidFill>
+          </a:ln>
+          <a:effectLst/>
+        </p:spPr>
+        <p:style>
+          <a:lnRef idx="1">
+            <a:schemeClr val="accent1"/>
+          </a:lnRef>
+          <a:fillRef idx="3">
+            <a:schemeClr val="accent1"/>
+          </a:fillRef>
+          <a:effectRef idx="2">
+            <a:schemeClr val="accent1"/>
+          </a:effectRef>
+          <a:fontRef idx="minor">
+            <a:schemeClr val="lt1"/>
+          </a:fontRef>
+        </p:style>
+        <p:txBody>
+          <a:bodyPr rtlCol="0" anchor="ctr" wrap="square" lIns="38100" rIns="38100" tIns="12700" bIns="12700"/>
+          <a:lstStyle/>
+          <a:p>
+            <a:pPr algn="ctr">
+              <a:defRPr sz="1100" b="1">
+                <a:solidFill>
+                  <a:srgbClr val="FFFFFF"/>
+                </a:solidFill>
+                <a:latin typeface="Arial"/>
+              </a:defRPr>
+            </a:pPr>
+            <a:r>
+              <a:t>social</a:t>
+            </a:r>
+          </a:p>
+        </p:txBody>
+      </p:sp>
+      <p:sp>
+        <p:nvSpPr>
+          <p:cNvPr id="23" name="Rounded Rectangle 22"/>
+          <p:cNvSpPr/>
+          <p:nvPr/>
+        </p:nvSpPr>
+        <p:spPr>
+          <a:xfrm>
+            <a:off x="8183879" y="3429000"/>
+            <a:ext cx="1737360" cy="384048"/>
+          </a:xfrm>
+          <a:prstGeom prst="roundRect">
+            <a:avLst/>
+          </a:prstGeom>
+          <a:solidFill>
+            <a:srgbClr val="A78BFA"/>
+          </a:solidFill>
+          <a:ln>
+            <a:solidFill>
+              <a:srgbClr val="A78BFA"/>
+            </a:solidFill>
+          </a:ln>
+          <a:effectLst/>
+        </p:spPr>
+        <p:style>
+          <a:lnRef idx="1">
+            <a:schemeClr val="accent1"/>
+          </a:lnRef>
+          <a:fillRef idx="3">
+            <a:schemeClr val="accent1"/>
+          </a:fillRef>
+          <a:effectRef idx="2">
+            <a:schemeClr val="accent1"/>
+          </a:effectRef>
+          <a:fontRef idx="minor">
+            <a:schemeClr val="lt1"/>
+          </a:fontRef>
+        </p:style>
+        <p:txBody>
+          <a:bodyPr rtlCol="0" anchor="ctr" wrap="square" lIns="38100" rIns="38100" tIns="12700" bIns="12700"/>
+          <a:lstStyle/>
+          <a:p>
+            <a:pPr algn="ctr">
+              <a:defRPr sz="1100" b="1">
+                <a:solidFill>
+                  <a:srgbClr val="FFFFFF"/>
+                </a:solidFill>
+                <a:latin typeface="Arial"/>
+              </a:defRPr>
+            </a:pPr>
+            <a:r>
+              <a:t>prefetch</a:t>
+            </a:r>
+          </a:p>
+        </p:txBody>
+      </p:sp>
+      <p:sp>
+        <p:nvSpPr>
+          <p:cNvPr id="24" name="Rounded Rectangle 23"/>
+          <p:cNvSpPr/>
+          <p:nvPr/>
+        </p:nvSpPr>
+        <p:spPr>
+          <a:xfrm>
+            <a:off x="8183879" y="4069080"/>
+            <a:ext cx="2011680" cy="384048"/>
+          </a:xfrm>
+          <a:prstGeom prst="roundRect">
+            <a:avLst/>
+          </a:prstGeom>
+          <a:solidFill>
+            <a:srgbClr val="A78BFA"/>
+          </a:solidFill>
+          <a:ln>
+            <a:solidFill>
+              <a:srgbClr val="A78BFA"/>
+            </a:solidFill>
+          </a:ln>
+          <a:effectLst/>
+        </p:spPr>
+        <p:style>
+          <a:lnRef idx="1">
+            <a:schemeClr val="accent1"/>
+          </a:lnRef>
+          <a:fillRef idx="3">
+            <a:schemeClr val="accent1"/>
+          </a:fillRef>
+          <a:effectRef idx="2">
+            <a:schemeClr val="accent1"/>
+          </a:effectRef>
+          <a:fontRef idx="minor">
+            <a:schemeClr val="lt1"/>
+          </a:fontRef>
+        </p:style>
+        <p:txBody>
+          <a:bodyPr rtlCol="0" anchor="ctr" wrap="square" lIns="38100" rIns="38100" tIns="12700" bIns="12700"/>
+          <a:lstStyle/>
+          <a:p>
+            <a:pPr algn="ctr">
+              <a:defRPr sz="1100" b="1">
+                <a:solidFill>
+                  <a:srgbClr val="FFFFFF"/>
+                </a:solidFill>
+                <a:latin typeface="Arial"/>
+              </a:defRPr>
+            </a:pPr>
+            <a:r>
+              <a:t>process_lane</a:t>
+            </a:r>
+          </a:p>
+        </p:txBody>
+      </p:sp>
+      <p:sp>
+        <p:nvSpPr>
+          <p:cNvPr id="25" name="Rounded Rectangle 24"/>
+          <p:cNvSpPr/>
+          <p:nvPr/>
+        </p:nvSpPr>
+        <p:spPr>
+          <a:xfrm>
+            <a:off x="6629400" y="4800600"/>
+            <a:ext cx="2468880" cy="384048"/>
+          </a:xfrm>
+          <a:prstGeom prst="roundRect">
+            <a:avLst/>
+          </a:prstGeom>
+          <a:solidFill>
+            <a:srgbClr val="60A5FA"/>
+          </a:solidFill>
+          <a:ln>
+            <a:solidFill>
+              <a:srgbClr val="60A5FA"/>
+            </a:solidFill>
+          </a:ln>
+          <a:effectLst/>
+        </p:spPr>
+        <p:style>
+          <a:lnRef idx="1">
+            <a:schemeClr val="accent1"/>
+          </a:lnRef>
+          <a:fillRef idx="3">
+            <a:schemeClr val="accent1"/>
+          </a:fillRef>
+          <a:effectRef idx="2">
+            <a:schemeClr val="accent1"/>
+          </a:effectRef>
+          <a:fontRef idx="minor">
+            <a:schemeClr val="lt1"/>
+          </a:fontRef>
+        </p:style>
+        <p:txBody>
+          <a:bodyPr rtlCol="0" anchor="ctr" wrap="square" lIns="38100" rIns="38100" tIns="12700" bIns="12700"/>
+          <a:lstStyle/>
+          <a:p>
+            <a:pPr algn="ctr">
+              <a:defRPr sz="1100" b="1">
+                <a:solidFill>
+                  <a:srgbClr val="FFFFFF"/>
+                </a:solidFill>
+                <a:latin typeface="Arial"/>
+              </a:defRPr>
+            </a:pPr>
+            <a:r>
+              <a:t>cache_store</a:t>
+            </a:r>
+          </a:p>
+        </p:txBody>
+      </p:sp>
+      <p:sp>
+        <p:nvSpPr>
+          <p:cNvPr id="26" name="Rounded Rectangle 25"/>
+          <p:cNvSpPr/>
+          <p:nvPr/>
+        </p:nvSpPr>
+        <p:spPr>
+          <a:xfrm>
+            <a:off x="7635240" y="5486400"/>
+            <a:ext cx="1188720" cy="274320"/>
+          </a:xfrm>
+          <a:prstGeom prst="roundRect">
+            <a:avLst/>
+          </a:prstGeom>
+          <a:solidFill>
+            <a:srgbClr val="334155"/>
+          </a:solidFill>
+          <a:ln>
+            <a:solidFill>
+              <a:srgbClr val="334155"/>
+            </a:solidFill>
+          </a:ln>
+          <a:effectLst/>
+        </p:spPr>
+        <p:style>
+          <a:lnRef idx="1">
+            <a:schemeClr val="accent1"/>
+          </a:lnRef>
+          <a:fillRef idx="3">
+            <a:schemeClr val="accent1"/>
+          </a:fillRef>
+          <a:effectRef idx="2">
+            <a:schemeClr val="accent1"/>
+          </a:effectRef>
+          <a:fontRef idx="minor">
+            <a:schemeClr val="lt1"/>
+          </a:fontRef>
+        </p:style>
+        <p:txBody>
+          <a:bodyPr rtlCol="0" anchor="ctr" wrap="square" lIns="38100" rIns="38100" tIns="12700" bIns="12700"/>
+          <a:lstStyle/>
+          <a:p>
+            <a:pPr algn="ctr">
+              <a:defRPr sz="1000" b="1">
+                <a:solidFill>
+                  <a:srgbClr val="FFFFFF"/>
+                </a:solidFill>
+                <a:latin typeface="Arial"/>
+              </a:defRPr>
+            </a:pPr>
+            <a:r>
+              <a:t>END</a:t>
+            </a:r>
+          </a:p>
+        </p:txBody>
+      </p:sp>
+      <p:cxnSp>
+        <p:nvCxnSpPr>
+          <p:cNvPr id="27" name="Connector 26"/>
+          <p:cNvCxnSpPr/>
+          <p:nvPr/>
+        </p:nvCxnSpPr>
+        <p:spPr>
+          <a:xfrm flipH="1">
+            <a:off x="7863840" y="1709928"/>
+            <a:ext cx="548640" cy="256032"/>
+          </a:xfrm>
+          <a:prstGeom prst="line">
+            <a:avLst/>
+          </a:prstGeom>
+          <a:ln w="19050">
+            <a:solidFill>
+              <a:srgbClr val="556680"/>
+            </a:solidFill>
+            <a:tailEnd type="triangle" w="med" len="med"/>
+          </a:ln>
+        </p:spPr>
+        <p:style>
+          <a:lnRef idx="2">
+            <a:schemeClr val="accent1"/>
+          </a:lnRef>
+          <a:fillRef idx="0">
+            <a:schemeClr val="accent1"/>
+          </a:fillRef>
+          <a:effectRef idx="1">
+            <a:schemeClr val="accent1"/>
+          </a:effectRef>
+          <a:fontRef idx="minor">
+            <a:schemeClr val="tx1"/>
+          </a:fontRef>
+        </p:style>
+      </p:cxnSp>
+      <p:cxnSp>
+        <p:nvCxnSpPr>
+          <p:cNvPr id="28" name="Connector 27"/>
+          <p:cNvCxnSpPr/>
+          <p:nvPr/>
+        </p:nvCxnSpPr>
+        <p:spPr>
+          <a:xfrm flipV="1">
+            <a:off x="9098280" y="2148840"/>
+            <a:ext cx="731520" cy="9144"/>
+          </a:xfrm>
+          <a:prstGeom prst="line">
+            <a:avLst/>
+          </a:prstGeom>
+          <a:ln w="19050">
+            <a:solidFill>
+              <a:srgbClr val="556680"/>
+            </a:solidFill>
+            <a:tailEnd type="triangle" w="med" len="med"/>
+          </a:ln>
+        </p:spPr>
+        <p:style>
+          <a:lnRef idx="2">
+            <a:schemeClr val="accent1"/>
+          </a:lnRef>
+          <a:fillRef idx="0">
+            <a:schemeClr val="accent1"/>
+          </a:fillRef>
+          <a:effectRef idx="1">
+            <a:schemeClr val="accent1"/>
+          </a:effectRef>
+          <a:fontRef idx="minor">
+            <a:schemeClr val="tx1"/>
+          </a:fontRef>
+        </p:style>
+      </p:cxnSp>
+      <p:sp>
+        <p:nvSpPr>
+          <p:cNvPr id="29" name="TextBox 28"/>
           <p:cNvSpPr txBox="1"/>
           <p:nvPr/>
         </p:nvSpPr>
         <p:spPr>
           <a:xfrm>
-            <a:off x="6126480" y="1417320"/>
-            <a:ext cx="5257800" cy="4663440"/>
+            <a:off x="8961119" y="2034540"/>
+            <a:ext cx="1005840" cy="237744"/>
+          </a:xfrm>
+          <a:prstGeom prst="rect">
+            <a:avLst/>
+          </a:prstGeom>
+          <a:noFill/>
+        </p:spPr>
+        <p:txBody>
+          <a:bodyPr wrap="none" lIns="0" rIns="0" tIns="0" bIns="0">
+            <a:spAutoFit/>
+          </a:bodyPr>
+          <a:lstStyle/>
+          <a:p>
+            <a:pPr algn="ctr">
+              <a:defRPr sz="900" i="1" b="1">
+                <a:solidFill>
+                  <a:srgbClr val="6B7280"/>
+                </a:solidFill>
+              </a:defRPr>
+            </a:pPr>
+            <a:r>
+              <a:t>hit</a:t>
+            </a:r>
+          </a:p>
+        </p:txBody>
+      </p:sp>
+      <p:cxnSp>
+        <p:nvCxnSpPr>
+          <p:cNvPr id="30" name="Connector 29"/>
+          <p:cNvCxnSpPr/>
+          <p:nvPr/>
+        </p:nvCxnSpPr>
+        <p:spPr>
+          <a:xfrm>
+            <a:off x="7863840" y="2350008"/>
+            <a:ext cx="0" cy="347472"/>
+          </a:xfrm>
+          <a:prstGeom prst="line">
+            <a:avLst/>
+          </a:prstGeom>
+          <a:ln w="19050">
+            <a:solidFill>
+              <a:srgbClr val="556680"/>
+            </a:solidFill>
+            <a:tailEnd type="triangle" w="med" len="med"/>
+          </a:ln>
+        </p:spPr>
+        <p:style>
+          <a:lnRef idx="2">
+            <a:schemeClr val="accent1"/>
+          </a:lnRef>
+          <a:fillRef idx="0">
+            <a:schemeClr val="accent1"/>
+          </a:fillRef>
+          <a:effectRef idx="1">
+            <a:schemeClr val="accent1"/>
+          </a:effectRef>
+          <a:fontRef idx="minor">
+            <a:schemeClr val="tx1"/>
+          </a:fontRef>
+        </p:style>
+      </p:cxnSp>
+      <p:sp>
+        <p:nvSpPr>
+          <p:cNvPr id="31" name="TextBox 30"/>
+          <p:cNvSpPr txBox="1"/>
+          <p:nvPr/>
+        </p:nvSpPr>
+        <p:spPr>
+          <a:xfrm>
+            <a:off x="7360919" y="2404872"/>
+            <a:ext cx="1005840" cy="237744"/>
+          </a:xfrm>
+          <a:prstGeom prst="rect">
+            <a:avLst/>
+          </a:prstGeom>
+          <a:noFill/>
+        </p:spPr>
+        <p:txBody>
+          <a:bodyPr wrap="none" lIns="0" rIns="0" tIns="0" bIns="0">
+            <a:spAutoFit/>
+          </a:bodyPr>
+          <a:lstStyle/>
+          <a:p>
+            <a:pPr algn="ctr">
+              <a:defRPr sz="900" i="1" b="1">
+                <a:solidFill>
+                  <a:srgbClr val="6B7280"/>
+                </a:solidFill>
+              </a:defRPr>
+            </a:pPr>
+            <a:r>
+              <a:t>miss</a:t>
+            </a:r>
+          </a:p>
+        </p:txBody>
+      </p:sp>
+      <p:cxnSp>
+        <p:nvCxnSpPr>
+          <p:cNvPr id="32" name="Connector 31"/>
+          <p:cNvCxnSpPr/>
+          <p:nvPr/>
+        </p:nvCxnSpPr>
+        <p:spPr>
+          <a:xfrm flipH="1">
+            <a:off x="6217920" y="3081528"/>
+            <a:ext cx="1097280" cy="347472"/>
+          </a:xfrm>
+          <a:prstGeom prst="line">
+            <a:avLst/>
+          </a:prstGeom>
+          <a:ln w="19050">
+            <a:solidFill>
+              <a:srgbClr val="556680"/>
+            </a:solidFill>
+            <a:tailEnd type="triangle" w="med" len="med"/>
+          </a:ln>
+        </p:spPr>
+        <p:style>
+          <a:lnRef idx="2">
+            <a:schemeClr val="accent1"/>
+          </a:lnRef>
+          <a:fillRef idx="0">
+            <a:schemeClr val="accent1"/>
+          </a:fillRef>
+          <a:effectRef idx="1">
+            <a:schemeClr val="accent1"/>
+          </a:effectRef>
+          <a:fontRef idx="minor">
+            <a:schemeClr val="tx1"/>
+          </a:fontRef>
+        </p:style>
+      </p:cxnSp>
+      <p:sp>
+        <p:nvSpPr>
+          <p:cNvPr id="33" name="TextBox 32"/>
+          <p:cNvSpPr txBox="1"/>
+          <p:nvPr/>
+        </p:nvSpPr>
+        <p:spPr>
+          <a:xfrm>
+            <a:off x="6263640" y="3136392"/>
+            <a:ext cx="1005840" cy="237744"/>
+          </a:xfrm>
+          <a:prstGeom prst="rect">
+            <a:avLst/>
+          </a:prstGeom>
+          <a:noFill/>
+        </p:spPr>
+        <p:txBody>
+          <a:bodyPr wrap="none" lIns="0" rIns="0" tIns="0" bIns="0">
+            <a:spAutoFit/>
+          </a:bodyPr>
+          <a:lstStyle/>
+          <a:p>
+            <a:pPr algn="ctr">
+              <a:defRPr sz="900" i="1" b="1">
+                <a:solidFill>
+                  <a:srgbClr val="6B7280"/>
+                </a:solidFill>
+              </a:defRPr>
+            </a:pPr>
+            <a:r>
+              <a:t>social</a:t>
+            </a:r>
+          </a:p>
+        </p:txBody>
+      </p:sp>
+      <p:cxnSp>
+        <p:nvCxnSpPr>
+          <p:cNvPr id="34" name="Connector 33"/>
+          <p:cNvCxnSpPr/>
+          <p:nvPr/>
+        </p:nvCxnSpPr>
+        <p:spPr>
+          <a:xfrm>
+            <a:off x="8503920" y="3081528"/>
+            <a:ext cx="548640" cy="347472"/>
+          </a:xfrm>
+          <a:prstGeom prst="line">
+            <a:avLst/>
+          </a:prstGeom>
+          <a:ln w="19050">
+            <a:solidFill>
+              <a:srgbClr val="556680"/>
+            </a:solidFill>
+            <a:tailEnd type="triangle" w="med" len="med"/>
+          </a:ln>
+        </p:spPr>
+        <p:style>
+          <a:lnRef idx="2">
+            <a:schemeClr val="accent1"/>
+          </a:lnRef>
+          <a:fillRef idx="0">
+            <a:schemeClr val="accent1"/>
+          </a:fillRef>
+          <a:effectRef idx="1">
+            <a:schemeClr val="accent1"/>
+          </a:effectRef>
+          <a:fontRef idx="minor">
+            <a:schemeClr val="tx1"/>
+          </a:fontRef>
+        </p:style>
+      </p:cxnSp>
+      <p:sp>
+        <p:nvSpPr>
+          <p:cNvPr id="35" name="TextBox 34"/>
+          <p:cNvSpPr txBox="1"/>
+          <p:nvPr/>
+        </p:nvSpPr>
+        <p:spPr>
+          <a:xfrm>
+            <a:off x="8275320" y="3136392"/>
+            <a:ext cx="1005840" cy="237744"/>
+          </a:xfrm>
+          <a:prstGeom prst="rect">
+            <a:avLst/>
+          </a:prstGeom>
+          <a:noFill/>
+        </p:spPr>
+        <p:txBody>
+          <a:bodyPr wrap="none" lIns="0" rIns="0" tIns="0" bIns="0">
+            <a:spAutoFit/>
+          </a:bodyPr>
+          <a:lstStyle/>
+          <a:p>
+            <a:pPr algn="ctr">
+              <a:defRPr sz="900" i="1" b="1">
+                <a:solidFill>
+                  <a:srgbClr val="6B7280"/>
+                </a:solidFill>
+              </a:defRPr>
+            </a:pPr>
+            <a:r>
+              <a:t>catalog</a:t>
+            </a:r>
+          </a:p>
+        </p:txBody>
+      </p:sp>
+      <p:cxnSp>
+        <p:nvCxnSpPr>
+          <p:cNvPr id="36" name="Connector 35"/>
+          <p:cNvCxnSpPr/>
+          <p:nvPr/>
+        </p:nvCxnSpPr>
+        <p:spPr>
+          <a:xfrm>
+            <a:off x="9052560" y="3813048"/>
+            <a:ext cx="137160" cy="256032"/>
+          </a:xfrm>
+          <a:prstGeom prst="line">
+            <a:avLst/>
+          </a:prstGeom>
+          <a:ln w="19050">
+            <a:solidFill>
+              <a:srgbClr val="556680"/>
+            </a:solidFill>
+            <a:tailEnd type="triangle" w="med" len="med"/>
+          </a:ln>
+        </p:spPr>
+        <p:style>
+          <a:lnRef idx="2">
+            <a:schemeClr val="accent1"/>
+          </a:lnRef>
+          <a:fillRef idx="0">
+            <a:schemeClr val="accent1"/>
+          </a:fillRef>
+          <a:effectRef idx="1">
+            <a:schemeClr val="accent1"/>
+          </a:effectRef>
+          <a:fontRef idx="minor">
+            <a:schemeClr val="tx1"/>
+          </a:fontRef>
+        </p:style>
+      </p:cxnSp>
+      <p:cxnSp>
+        <p:nvCxnSpPr>
+          <p:cNvPr id="37" name="Connector 36"/>
+          <p:cNvCxnSpPr/>
+          <p:nvPr/>
+        </p:nvCxnSpPr>
+        <p:spPr>
+          <a:xfrm>
+            <a:off x="6217920" y="3813048"/>
+            <a:ext cx="1005840" cy="987552"/>
+          </a:xfrm>
+          <a:prstGeom prst="line">
+            <a:avLst/>
+          </a:prstGeom>
+          <a:ln w="19050">
+            <a:solidFill>
+              <a:srgbClr val="556680"/>
+            </a:solidFill>
+            <a:tailEnd type="triangle" w="med" len="med"/>
+          </a:ln>
+        </p:spPr>
+        <p:style>
+          <a:lnRef idx="2">
+            <a:schemeClr val="accent1"/>
+          </a:lnRef>
+          <a:fillRef idx="0">
+            <a:schemeClr val="accent1"/>
+          </a:fillRef>
+          <a:effectRef idx="1">
+            <a:schemeClr val="accent1"/>
+          </a:effectRef>
+          <a:fontRef idx="minor">
+            <a:schemeClr val="tx1"/>
+          </a:fontRef>
+        </p:style>
+      </p:cxnSp>
+      <p:cxnSp>
+        <p:nvCxnSpPr>
+          <p:cNvPr id="38" name="Connector 37"/>
+          <p:cNvCxnSpPr/>
+          <p:nvPr/>
+        </p:nvCxnSpPr>
+        <p:spPr>
+          <a:xfrm flipH="1">
+            <a:off x="8778240" y="4453128"/>
+            <a:ext cx="411480" cy="347472"/>
+          </a:xfrm>
+          <a:prstGeom prst="line">
+            <a:avLst/>
+          </a:prstGeom>
+          <a:ln w="19050">
+            <a:solidFill>
+              <a:srgbClr val="556680"/>
+            </a:solidFill>
+            <a:tailEnd type="triangle" w="med" len="med"/>
+          </a:ln>
+        </p:spPr>
+        <p:style>
+          <a:lnRef idx="2">
+            <a:schemeClr val="accent1"/>
+          </a:lnRef>
+          <a:fillRef idx="0">
+            <a:schemeClr val="accent1"/>
+          </a:fillRef>
+          <a:effectRef idx="1">
+            <a:schemeClr val="accent1"/>
+          </a:effectRef>
+          <a:fontRef idx="minor">
+            <a:schemeClr val="tx1"/>
+          </a:fontRef>
+        </p:style>
+      </p:cxnSp>
+      <p:cxnSp>
+        <p:nvCxnSpPr>
+          <p:cNvPr id="39" name="Connector 38"/>
+          <p:cNvCxnSpPr/>
+          <p:nvPr/>
+        </p:nvCxnSpPr>
+        <p:spPr>
+          <a:xfrm>
+            <a:off x="7863840" y="5184648"/>
+            <a:ext cx="320039" cy="301752"/>
+          </a:xfrm>
+          <a:prstGeom prst="line">
+            <a:avLst/>
+          </a:prstGeom>
+          <a:ln w="19050">
+            <a:solidFill>
+              <a:srgbClr val="556680"/>
+            </a:solidFill>
+            <a:tailEnd type="triangle" w="med" len="med"/>
+          </a:ln>
+        </p:spPr>
+        <p:style>
+          <a:lnRef idx="2">
+            <a:schemeClr val="accent1"/>
+          </a:lnRef>
+          <a:fillRef idx="0">
+            <a:schemeClr val="accent1"/>
+          </a:fillRef>
+          <a:effectRef idx="1">
+            <a:schemeClr val="accent1"/>
+          </a:effectRef>
+          <a:fontRef idx="minor">
+            <a:schemeClr val="tx1"/>
+          </a:fontRef>
+        </p:style>
+      </p:cxnSp>
+      <p:sp>
+        <p:nvSpPr>
+          <p:cNvPr id="40" name="Oval 39"/>
+          <p:cNvSpPr/>
+          <p:nvPr/>
+        </p:nvSpPr>
+        <p:spPr>
+          <a:xfrm>
+            <a:off x="5349240" y="5806440"/>
+            <a:ext cx="146304" cy="146304"/>
+          </a:xfrm>
+          <a:prstGeom prst="ellipse">
+            <a:avLst/>
+          </a:prstGeom>
+          <a:solidFill>
+            <a:srgbClr val="60A5FA"/>
+          </a:solidFill>
+          <a:ln>
+            <a:noFill/>
+          </a:ln>
+          <a:effectLst/>
+        </p:spPr>
+        <p:style>
+          <a:lnRef idx="1">
+            <a:schemeClr val="accent1"/>
+          </a:lnRef>
+          <a:fillRef idx="3">
+            <a:schemeClr val="accent1"/>
+          </a:fillRef>
+          <a:effectRef idx="2">
+            <a:schemeClr val="accent1"/>
+          </a:effectRef>
+          <a:fontRef idx="minor">
+            <a:schemeClr val="lt1"/>
+          </a:fontRef>
+        </p:style>
+        <p:txBody>
+          <a:bodyPr rtlCol="0" anchor="ctr"/>
+          <a:lstStyle/>
+          <a:p>
+            <a:pPr algn="ctr"/>
+          </a:p>
+        </p:txBody>
+      </p:sp>
+      <p:sp>
+        <p:nvSpPr>
+          <p:cNvPr id="41" name="TextBox 40"/>
+          <p:cNvSpPr txBox="1"/>
+          <p:nvPr/>
+        </p:nvSpPr>
+        <p:spPr>
+          <a:xfrm>
+            <a:off x="5550407" y="5769864"/>
+            <a:ext cx="1463040" cy="219456"/>
           </a:xfrm>
           <a:prstGeom prst="rect">
             <a:avLst/>
@@ -8893,27 +10072,8 @@
           </a:bodyPr>
           <a:lstStyle/>
           <a:p>
-            <a:pPr>
-              <a:spcAft>
-                <a:spcPts val="600"/>
-              </a:spcAft>
-              <a:defRPr sz="1300" b="1">
-                <a:solidFill>
-                  <a:srgbClr val="0A2540"/>
-                </a:solidFill>
-                <a:latin typeface="Arial"/>
-              </a:defRPr>
-            </a:pPr>
-            <a:r>
-              <a:t>Graph topology (7 nodes, all async)</a:t>
-            </a:r>
-          </a:p>
-          <a:p>
-            <a:pPr>
-              <a:spcAft>
-                <a:spcPts val="600"/>
-              </a:spcAft>
-              <a:defRPr sz="1300" b="0">
+            <a:pPr algn="l">
+              <a:defRPr sz="1000" b="0">
                 <a:solidFill>
                   <a:srgbClr val="334155"/>
                 </a:solidFill>
@@ -8921,15 +10081,79 @@
               </a:defRPr>
             </a:pPr>
             <a:r>
-              <a:t>START → cache_check</a:t>
-            </a:r>
-          </a:p>
-          <a:p>
-            <a:pPr>
-              <a:spcAft>
-                <a:spcPts val="600"/>
-              </a:spcAft>
-              <a:defRPr sz="1300" b="0">
+              <a:t>cache</a:t>
+            </a:r>
+          </a:p>
+        </p:txBody>
+      </p:sp>
+      <p:sp>
+        <p:nvSpPr>
+          <p:cNvPr id="42" name="Oval 41"/>
+          <p:cNvSpPr/>
+          <p:nvPr/>
+        </p:nvSpPr>
+        <p:spPr>
+          <a:xfrm>
+            <a:off x="6537960" y="5806440"/>
+            <a:ext cx="146304" cy="146304"/>
+          </a:xfrm>
+          <a:prstGeom prst="ellipse">
+            <a:avLst/>
+          </a:prstGeom>
+          <a:solidFill>
+            <a:srgbClr val="F59E0B"/>
+          </a:solidFill>
+          <a:ln>
+            <a:noFill/>
+          </a:ln>
+          <a:effectLst/>
+        </p:spPr>
+        <p:style>
+          <a:lnRef idx="1">
+            <a:schemeClr val="accent1"/>
+          </a:lnRef>
+          <a:fillRef idx="3">
+            <a:schemeClr val="accent1"/>
+          </a:fillRef>
+          <a:effectRef idx="2">
+            <a:schemeClr val="accent1"/>
+          </a:effectRef>
+          <a:fontRef idx="minor">
+            <a:schemeClr val="lt1"/>
+          </a:fontRef>
+        </p:style>
+        <p:txBody>
+          <a:bodyPr rtlCol="0" anchor="ctr"/>
+          <a:lstStyle/>
+          <a:p>
+            <a:pPr algn="ctr"/>
+          </a:p>
+        </p:txBody>
+      </p:sp>
+      <p:sp>
+        <p:nvSpPr>
+          <p:cNvPr id="43" name="TextBox 42"/>
+          <p:cNvSpPr txBox="1"/>
+          <p:nvPr/>
+        </p:nvSpPr>
+        <p:spPr>
+          <a:xfrm>
+            <a:off x="6739128" y="5769864"/>
+            <a:ext cx="1463040" cy="219456"/>
+          </a:xfrm>
+          <a:prstGeom prst="rect">
+            <a:avLst/>
+          </a:prstGeom>
+          <a:noFill/>
+        </p:spPr>
+        <p:txBody>
+          <a:bodyPr wrap="square" anchor="t">
+            <a:spAutoFit/>
+          </a:bodyPr>
+          <a:lstStyle/>
+          <a:p>
+            <a:pPr algn="l">
+              <a:defRPr sz="1000" b="0">
                 <a:solidFill>
                   <a:srgbClr val="334155"/>
                 </a:solidFill>
@@ -8937,15 +10161,79 @@
               </a:defRPr>
             </a:pPr>
             <a:r>
-              <a:t>  ├─ cache hit  → END (cached answer, ~0.02s)</a:t>
-            </a:r>
-          </a:p>
-          <a:p>
-            <a:pPr>
-              <a:spcAft>
-                <a:spcPts val="600"/>
-              </a:spcAft>
-              <a:defRPr sz="1300" b="0">
+              <a:t>intent</a:t>
+            </a:r>
+          </a:p>
+        </p:txBody>
+      </p:sp>
+      <p:sp>
+        <p:nvSpPr>
+          <p:cNvPr id="44" name="Oval 43"/>
+          <p:cNvSpPr/>
+          <p:nvPr/>
+        </p:nvSpPr>
+        <p:spPr>
+          <a:xfrm>
+            <a:off x="7680960" y="5806440"/>
+            <a:ext cx="146304" cy="146304"/>
+          </a:xfrm>
+          <a:prstGeom prst="ellipse">
+            <a:avLst/>
+          </a:prstGeom>
+          <a:solidFill>
+            <a:srgbClr val="34D399"/>
+          </a:solidFill>
+          <a:ln>
+            <a:noFill/>
+          </a:ln>
+          <a:effectLst/>
+        </p:spPr>
+        <p:style>
+          <a:lnRef idx="1">
+            <a:schemeClr val="accent1"/>
+          </a:lnRef>
+          <a:fillRef idx="3">
+            <a:schemeClr val="accent1"/>
+          </a:fillRef>
+          <a:effectRef idx="2">
+            <a:schemeClr val="accent1"/>
+          </a:effectRef>
+          <a:fontRef idx="minor">
+            <a:schemeClr val="lt1"/>
+          </a:fontRef>
+        </p:style>
+        <p:txBody>
+          <a:bodyPr rtlCol="0" anchor="ctr"/>
+          <a:lstStyle/>
+          <a:p>
+            <a:pPr algn="ctr"/>
+          </a:p>
+        </p:txBody>
+      </p:sp>
+      <p:sp>
+        <p:nvSpPr>
+          <p:cNvPr id="45" name="TextBox 44"/>
+          <p:cNvSpPr txBox="1"/>
+          <p:nvPr/>
+        </p:nvSpPr>
+        <p:spPr>
+          <a:xfrm>
+            <a:off x="7882128" y="5769864"/>
+            <a:ext cx="1463040" cy="219456"/>
+          </a:xfrm>
+          <a:prstGeom prst="rect">
+            <a:avLst/>
+          </a:prstGeom>
+          <a:noFill/>
+        </p:spPr>
+        <p:txBody>
+          <a:bodyPr wrap="square" anchor="t">
+            <a:spAutoFit/>
+          </a:bodyPr>
+          <a:lstStyle/>
+          <a:p>
+            <a:pPr algn="l">
+              <a:defRPr sz="1000" b="0">
                 <a:solidFill>
                   <a:srgbClr val="334155"/>
                 </a:solidFill>
@@ -8953,15 +10241,79 @@
               </a:defRPr>
             </a:pPr>
             <a:r>
-              <a:t>  └─ cache miss → classify_intent</a:t>
-            </a:r>
-          </a:p>
-          <a:p>
-            <a:pPr>
-              <a:spcAft>
-                <a:spcPts val="600"/>
-              </a:spcAft>
-              <a:defRPr sz="1300" b="0">
+              <a:t>social</a:t>
+            </a:r>
+          </a:p>
+        </p:txBody>
+      </p:sp>
+      <p:sp>
+        <p:nvSpPr>
+          <p:cNvPr id="46" name="Oval 45"/>
+          <p:cNvSpPr/>
+          <p:nvPr/>
+        </p:nvSpPr>
+        <p:spPr>
+          <a:xfrm>
+            <a:off x="8778240" y="5806440"/>
+            <a:ext cx="146304" cy="146304"/>
+          </a:xfrm>
+          <a:prstGeom prst="ellipse">
+            <a:avLst/>
+          </a:prstGeom>
+          <a:solidFill>
+            <a:srgbClr val="A78BFA"/>
+          </a:solidFill>
+          <a:ln>
+            <a:noFill/>
+          </a:ln>
+          <a:effectLst/>
+        </p:spPr>
+        <p:style>
+          <a:lnRef idx="1">
+            <a:schemeClr val="accent1"/>
+          </a:lnRef>
+          <a:fillRef idx="3">
+            <a:schemeClr val="accent1"/>
+          </a:fillRef>
+          <a:effectRef idx="2">
+            <a:schemeClr val="accent1"/>
+          </a:effectRef>
+          <a:fontRef idx="minor">
+            <a:schemeClr val="lt1"/>
+          </a:fontRef>
+        </p:style>
+        <p:txBody>
+          <a:bodyPr rtlCol="0" anchor="ctr"/>
+          <a:lstStyle/>
+          <a:p>
+            <a:pPr algn="ctr"/>
+          </a:p>
+        </p:txBody>
+      </p:sp>
+      <p:sp>
+        <p:nvSpPr>
+          <p:cNvPr id="47" name="TextBox 46"/>
+          <p:cNvSpPr txBox="1"/>
+          <p:nvPr/>
+        </p:nvSpPr>
+        <p:spPr>
+          <a:xfrm>
+            <a:off x="8979408" y="5769864"/>
+            <a:ext cx="1463040" cy="219456"/>
+          </a:xfrm>
+          <a:prstGeom prst="rect">
+            <a:avLst/>
+          </a:prstGeom>
+          <a:noFill/>
+        </p:spPr>
+        <p:txBody>
+          <a:bodyPr wrap="square" anchor="t">
+            <a:spAutoFit/>
+          </a:bodyPr>
+          <a:lstStyle/>
+          <a:p>
+            <a:pPr algn="l">
+              <a:defRPr sz="1000" b="0">
                 <a:solidFill>
                   <a:srgbClr val="334155"/>
                 </a:solidFill>
@@ -8969,71 +10321,7 @@
               </a:defRPr>
             </a:pPr>
             <a:r>
-              <a:t>classify_intent → [route_by_lane]</a:t>
-            </a:r>
-          </a:p>
-          <a:p>
-            <a:pPr>
-              <a:spcAft>
-                <a:spcPts val="600"/>
-              </a:spcAft>
-              <a:defRPr sz="1300" b="0">
-                <a:solidFill>
-                  <a:srgbClr val="334155"/>
-                </a:solidFill>
-                <a:latin typeface="Arial"/>
-              </a:defRPr>
-            </a:pPr>
-            <a:r>
-              <a:t>  ├─ social (decline_off_topic | conversational) ──┐</a:t>
-            </a:r>
-          </a:p>
-          <a:p>
-            <a:pPr>
-              <a:spcAft>
-                <a:spcPts val="600"/>
-              </a:spcAft>
-              <a:defRPr sz="1300" b="0">
-                <a:solidFill>
-                  <a:srgbClr val="334155"/>
-                </a:solidFill>
-                <a:latin typeface="Arial"/>
-              </a:defRPr>
-            </a:pPr>
-            <a:r>
-              <a:t>  └─ prefetch → process_lane ─────────────────────┤</a:t>
-            </a:r>
-          </a:p>
-          <a:p>
-            <a:pPr>
-              <a:spcAft>
-                <a:spcPts val="600"/>
-              </a:spcAft>
-              <a:defRPr sz="1300" b="0">
-                <a:solidFill>
-                  <a:srgbClr val="334155"/>
-                </a:solidFill>
-                <a:latin typeface="Arial"/>
-              </a:defRPr>
-            </a:pPr>
-            <a:r>
-              <a:t>                                    cache_store → END</a:t>
-            </a:r>
-          </a:p>
-          <a:p>
-            <a:pPr>
-              <a:spcAft>
-                <a:spcPts val="600"/>
-              </a:spcAft>
-              <a:defRPr sz="1300" b="0">
-                <a:solidFill>
-                  <a:srgbClr val="334155"/>
-                </a:solidFill>
-                <a:latin typeface="Arial"/>
-              </a:defRPr>
-            </a:pPr>
-            <a:r>
-              <a:t>4 routing functions; graph.ainvoke(), not graph.invoke().</a:t>
+              <a:t>catalog</a:t>
             </a:r>
           </a:p>
         </p:txBody>
@@ -9431,7 +10719,7 @@
               </a:defRPr>
             </a:pPr>
             <a:r>
-              <a:t>Release progress — v0.1.0 → v2.1.6</a:t>
+              <a:t>LangGraph 2/3 — every node, what it calls</a:t>
             </a:r>
           </a:p>
         </p:txBody>
@@ -9467,7 +10755,7 @@
               </a:defRPr>
             </a:pPr>
             <a:r>
-              <a:t>Same five FRs · smarter social routing, flexible picks, chunked UX</a:t>
+              <a:t>Every node is a verbatim call into this repo's own functions</a:t>
             </a:r>
           </a:p>
         </p:txBody>
@@ -9546,7 +10834,7 @@
               </a:defRPr>
             </a:pPr>
             <a:r>
-              <a:t>Progress · releases</a:t>
+              <a:t>Architecture · LG</a:t>
             </a:r>
           </a:p>
         </p:txBody>
@@ -9582,7 +10870,7 @@
               </a:defRPr>
             </a:pPr>
             <a:r>
-              <a:t>zooplus Assistant — releases v2.1.6 · progress since v0.1.0</a:t>
+              <a:t>zooplus Assistant — Coding Task PoC v0.1</a:t>
             </a:r>
           </a:p>
         </p:txBody>
@@ -9618,7 +10906,7 @@
               </a:defRPr>
             </a:pPr>
             <a:r>
-              <a:t>17</a:t>
+              <a:t>15</a:t>
             </a:r>
           </a:p>
         </p:txBody>
@@ -9674,8 +10962,8 @@
         </p:nvSpPr>
         <p:spPr>
           <a:xfrm>
-            <a:off x="749808" y="1417320"/>
-            <a:ext cx="5349240" cy="4663440"/>
+            <a:off x="749808" y="1371600"/>
+            <a:ext cx="10607040" cy="411480"/>
           </a:xfrm>
           <a:prstGeom prst="rect">
             <a:avLst/>
@@ -9688,27 +10976,8 @@
           </a:bodyPr>
           <a:lstStyle/>
           <a:p>
-            <a:pPr>
-              <a:spcAft>
-                <a:spcPts val="600"/>
-              </a:spcAft>
-              <a:defRPr sz="1500" b="1">
-                <a:solidFill>
-                  <a:srgbClr val="0A2540"/>
-                </a:solidFill>
-                <a:latin typeface="Arial"/>
-              </a:defRPr>
-            </a:pPr>
-            <a:r>
-              <a:t>Foundation — v0.1.0 → v1.0</a:t>
-            </a:r>
-          </a:p>
-          <a:p>
-            <a:pPr>
-              <a:spcAft>
-                <a:spcPts val="600"/>
-              </a:spcAft>
-              <a:defRPr sz="1500" b="0">
+            <a:pPr algn="l">
+              <a:defRPr sz="1300" b="0">
                 <a:solidFill>
                   <a:srgbClr val="334155"/>
                 </a:solidFill>
@@ -9716,146 +10985,556 @@
               </a:defRPr>
             </a:pPr>
             <a:r>
-              <a:t>v0.1.0 — Coding Task PoC: FR1–5, hybrid RAG, FR4 guardrails.</a:t>
-            </a:r>
-          </a:p>
-          <a:p>
-            <a:pPr>
-              <a:spcAft>
-                <a:spcPts val="600"/>
-              </a:spcAft>
-              <a:defRPr sz="1500" b="0">
-                <a:solidFill>
-                  <a:srgbClr val="334155"/>
-                </a:solidFill>
-                <a:latin typeface="Arial"/>
-              </a:defRPr>
-            </a:pPr>
-            <a:r>
-              <a:t>v0.1.3 — Conductor-first routing; /chat/stream; per-agent OpenCode.</a:t>
-            </a:r>
-          </a:p>
-          <a:p>
-            <a:pPr>
-              <a:spcAft>
-                <a:spcPts val="600"/>
-              </a:spcAft>
-              <a:defRPr sz="1500" b="0">
-                <a:solidFill>
-                  <a:srgbClr val="334155"/>
-                </a:solidFill>
-                <a:latin typeface="Arial"/>
-              </a:defRPr>
-            </a:pPr>
-            <a:r>
-              <a:t>v1.0 — Stable tag: catalog lexicon at ingest, cache, multilingual.</a:t>
-            </a:r>
-          </a:p>
-        </p:txBody>
-      </p:sp>
-      <p:sp>
-        <p:nvSpPr>
-          <p:cNvPr id="18" name="TextBox 17"/>
-          <p:cNvSpPr txBox="1"/>
-          <p:nvPr/>
-        </p:nvSpPr>
-        <p:spPr>
-          <a:xfrm>
-            <a:off x="6126480" y="1417320"/>
-            <a:ext cx="5257800" cy="4663440"/>
-          </a:xfrm>
-          <a:prstGeom prst="rect">
-            <a:avLst/>
-          </a:prstGeom>
-          <a:noFill/>
-        </p:spPr>
-        <p:txBody>
-          <a:bodyPr wrap="square" anchor="t">
-            <a:spAutoFit/>
-          </a:bodyPr>
-          <a:lstStyle/>
-          <a:p>
-            <a:pPr>
-              <a:spcAft>
-                <a:spcPts val="600"/>
-              </a:spcAft>
-              <a:defRPr sz="1500" b="1">
-                <a:solidFill>
-                  <a:srgbClr val="0A2540"/>
-                </a:solidFill>
-                <a:latin typeface="Arial"/>
-              </a:defRPr>
-            </a:pPr>
-            <a:r>
-              <a:t>Shopper experience — v1.4 → v2.1.6 (now)</a:t>
-            </a:r>
-          </a:p>
-          <a:p>
-            <a:pPr>
-              <a:spcAft>
-                <a:spcPts val="600"/>
-              </a:spcAft>
-              <a:defRPr sz="1500" b="0">
-                <a:solidFill>
-                  <a:srgbClr val="334155"/>
-                </a:solidFill>
-                <a:latin typeface="Arial"/>
-              </a:defRPr>
-            </a:pPr>
-            <a:r>
-              <a:t>v2.1 — Playbook MD; social/catalog probe; agent-multilingual.</a:t>
-            </a:r>
-          </a:p>
-          <a:p>
-            <a:pPr>
-              <a:spcAft>
-                <a:spcPts val="600"/>
-              </a:spcAft>
-              <a:defRPr sz="1500" b="0">
-                <a:solidFill>
-                  <a:srgbClr val="334155"/>
-                </a:solidFill>
-                <a:latin typeface="Arial"/>
-              </a:defRPr>
-            </a:pPr>
-            <a:r>
-              <a:t>v2.1.3 — Fast intent-first stream; conductor intent opt-in.</a:t>
-            </a:r>
-          </a:p>
-          <a:p>
-            <a:pPr>
-              <a:spcAft>
-                <a:spcPts val="600"/>
-              </a:spcAft>
-              <a:defRPr sz="1500" b="0">
-                <a:solidFill>
-                  <a:srgbClr val="334155"/>
-                </a:solidFill>
-                <a:latin typeface="Arial"/>
-              </a:defRPr>
-            </a:pPr>
-            <a:r>
-              <a:t>v2.1.4–5 — Species inference; help/saludo detect + dedupe.</a:t>
-            </a:r>
-          </a:p>
-          <a:p>
-            <a:pPr>
-              <a:spcAft>
-                <a:spcPts val="600"/>
-              </a:spcAft>
-              <a:defRPr sz="1500" b="0">
-                <a:solidFill>
-                  <a:srgbClr val="334155"/>
-                </a:solidFill>
-                <a:latin typeface="Arial"/>
-              </a:defRPr>
-            </a:pPr>
-            <a:r>
-              <a:t>v2.1.6 — Dynamic count (4→20); phrase index; product_batch UI.</a:t>
-            </a:r>
-          </a:p>
-        </p:txBody>
-      </p:sp>
+              <a:t>rag_node + synthesis_node deleted — process_lane replaces both with one call into the existing ACP dispatch.</a:t>
+            </a:r>
+          </a:p>
+        </p:txBody>
+      </p:sp>
+      <p:graphicFrame>
+        <p:nvGraphicFramePr>
+          <p:cNvPr id="18" name="Table 17"/>
+          <p:cNvGraphicFramePr>
+            <a:graphicFrameLocks noGrp="1"/>
+          </p:cNvGraphicFramePr>
+          <p:nvPr/>
+        </p:nvGraphicFramePr>
+        <p:xfrm>
+          <a:off x="749808" y="1874519"/>
+          <a:ext cx="10607040" cy="4114800"/>
+        </p:xfrm>
+        <a:graphic>
+          <a:graphicData uri="http://schemas.openxmlformats.org/drawingml/2006/table">
+            <a:tbl>
+              <a:tblPr firstRow="1" bandRow="1">
+                <a:tableStyleId>{5C22544A-7EE6-4342-B048-85BDC9FD1C3A}</a:tableStyleId>
+              </a:tblPr>
+              <a:tblGrid>
+                <a:gridCol w="1828800"/>
+                <a:gridCol w="4206240"/>
+                <a:gridCol w="4572000"/>
+              </a:tblGrid>
+              <a:tr h="384048">
+                <a:tc>
+                  <a:txBody>
+                    <a:bodyPr wrap="square"/>
+                    <a:lstStyle/>
+                    <a:p>
+                      <a:pPr algn="l">
+                        <a:defRPr sz="1300" b="1">
+                          <a:solidFill>
+                            <a:srgbClr val="FFFFFF"/>
+                          </a:solidFill>
+                          <a:latin typeface="Arial"/>
+                        </a:defRPr>
+                      </a:pPr>
+                      <a:r>
+                        <a:t>Node</a:t>
+                      </a:r>
+                    </a:p>
+                  </a:txBody>
+                  <a:tcPr anchor="ctr" marL="101600" marR="101600" marT="50800" marB="50800">
+                    <a:solidFill>
+                      <a:srgbClr val="0A2540"/>
+                    </a:solidFill>
+                  </a:tcPr>
+                </a:tc>
+                <a:tc>
+                  <a:txBody>
+                    <a:bodyPr wrap="square"/>
+                    <a:lstStyle/>
+                    <a:p>
+                      <a:pPr algn="l">
+                        <a:defRPr sz="1200" b="1">
+                          <a:solidFill>
+                            <a:srgbClr val="FFFFFF"/>
+                          </a:solidFill>
+                          <a:latin typeface="Arial"/>
+                        </a:defRPr>
+                      </a:pPr>
+                      <a:r>
+                        <a:t>Calls (verbatim)</a:t>
+                      </a:r>
+                    </a:p>
+                  </a:txBody>
+                  <a:tcPr anchor="ctr" marL="101600" marR="101600" marT="50800" marB="50800">
+                    <a:solidFill>
+                      <a:srgbClr val="0A2540"/>
+                    </a:solidFill>
+                  </a:tcPr>
+                </a:tc>
+                <a:tc>
+                  <a:txBody>
+                    <a:bodyPr wrap="square"/>
+                    <a:lstStyle/>
+                    <a:p>
+                      <a:pPr algn="l">
+                        <a:defRPr sz="1200" b="1">
+                          <a:solidFill>
+                            <a:srgbClr val="FFFFFF"/>
+                          </a:solidFill>
+                          <a:latin typeface="Arial"/>
+                        </a:defRPr>
+                      </a:pPr>
+                      <a:r>
+                        <a:t>Purpose</a:t>
+                      </a:r>
+                    </a:p>
+                  </a:txBody>
+                  <a:tcPr anchor="ctr" marL="101600" marR="101600" marT="50800" marB="50800">
+                    <a:solidFill>
+                      <a:srgbClr val="0A2540"/>
+                    </a:solidFill>
+                  </a:tcPr>
+                </a:tc>
+              </a:tr>
+              <a:tr h="621792">
+                <a:tc>
+                  <a:txBody>
+                    <a:bodyPr wrap="square"/>
+                    <a:lstStyle/>
+                    <a:p>
+                      <a:pPr algn="l">
+                        <a:defRPr sz="1200" b="1">
+                          <a:solidFill>
+                            <a:srgbClr val="334155"/>
+                          </a:solidFill>
+                          <a:latin typeface="Arial"/>
+                        </a:defRPr>
+                      </a:pPr>
+                      <a:r>
+                        <a:t>cache_check</a:t>
+                      </a:r>
+                    </a:p>
+                  </a:txBody>
+                  <a:tcPr anchor="ctr" marL="101600" marR="101600" marT="50800" marB="50800">
+                    <a:solidFill>
+                      <a:srgbClr val="FFFFFF"/>
+                    </a:solidFill>
+                  </a:tcPr>
+                </a:tc>
+                <a:tc>
+                  <a:txBody>
+                    <a:bodyPr wrap="square"/>
+                    <a:lstStyle/>
+                    <a:p>
+                      <a:pPr algn="l">
+                        <a:defRPr sz="1100" b="0">
+                          <a:solidFill>
+                            <a:srgbClr val="334155"/>
+                          </a:solidFill>
+                          <a:latin typeface="Arial"/>
+                        </a:defRPr>
+                      </a:pPr>
+                      <a:r>
+                        <a:t>chat_cache.get(key)</a:t>
+                      </a:r>
+                    </a:p>
+                  </a:txBody>
+                  <a:tcPr anchor="ctr" marL="101600" marR="101600" marT="50800" marB="50800">
+                    <a:solidFill>
+                      <a:srgbClr val="FFFFFF"/>
+                    </a:solidFill>
+                  </a:tcPr>
+                </a:tc>
+                <a:tc>
+                  <a:txBody>
+                    <a:bodyPr wrap="square"/>
+                    <a:lstStyle/>
+                    <a:p>
+                      <a:pPr algn="l">
+                        <a:defRPr sz="1100" b="0">
+                          <a:solidFill>
+                            <a:srgbClr val="334155"/>
+                          </a:solidFill>
+                          <a:latin typeface="Arial"/>
+                        </a:defRPr>
+                      </a:pPr>
+                      <a:r>
+                        <a:t>Same singleton + key format as the legacy orchestrator</a:t>
+                      </a:r>
+                    </a:p>
+                  </a:txBody>
+                  <a:tcPr anchor="ctr" marL="101600" marR="101600" marT="50800" marB="50800">
+                    <a:solidFill>
+                      <a:srgbClr val="FFFFFF"/>
+                    </a:solidFill>
+                  </a:tcPr>
+                </a:tc>
+              </a:tr>
+              <a:tr h="621792">
+                <a:tc>
+                  <a:txBody>
+                    <a:bodyPr wrap="square"/>
+                    <a:lstStyle/>
+                    <a:p>
+                      <a:pPr algn="l">
+                        <a:defRPr sz="1200" b="1">
+                          <a:solidFill>
+                            <a:srgbClr val="334155"/>
+                          </a:solidFill>
+                          <a:latin typeface="Arial"/>
+                        </a:defRPr>
+                      </a:pPr>
+                      <a:r>
+                        <a:t>classify_intent</a:t>
+                      </a:r>
+                    </a:p>
+                  </a:txBody>
+                  <a:tcPr anchor="ctr" marL="101600" marR="101600" marT="50800" marB="50800">
+                    <a:solidFill>
+                      <a:srgbClr val="F8FAFC"/>
+                    </a:solidFill>
+                  </a:tcPr>
+                </a:tc>
+                <a:tc>
+                  <a:txBody>
+                    <a:bodyPr wrap="square"/>
+                    <a:lstStyle/>
+                    <a:p>
+                      <a:pPr algn="l">
+                        <a:defRPr sz="1100" b="0">
+                          <a:solidFill>
+                            <a:srgbClr val="334155"/>
+                          </a:solidFill>
+                          <a:latin typeface="Arial"/>
+                        </a:defRPr>
+                      </a:pPr>
+                      <a:r>
+                        <a:t>orchestrator._classify_intent_bounded()</a:t>
+                      </a:r>
+                    </a:p>
+                  </a:txBody>
+                  <a:tcPr anchor="ctr" marL="101600" marR="101600" marT="50800" marB="50800">
+                    <a:solidFill>
+                      <a:srgbClr val="F8FAFC"/>
+                    </a:solidFill>
+                  </a:tcPr>
+                </a:tc>
+                <a:tc>
+                  <a:txBody>
+                    <a:bodyPr wrap="square"/>
+                    <a:lstStyle/>
+                    <a:p>
+                      <a:pPr algn="l">
+                        <a:defRPr sz="1100" b="0">
+                          <a:solidFill>
+                            <a:srgbClr val="334155"/>
+                          </a:solidFill>
+                          <a:latin typeface="Arial"/>
+                        </a:defRPr>
+                      </a:pPr>
+                      <a:r>
+                        <a:t>Same 22s timeout, same _fallback_intent_decision() on timeout</a:t>
+                      </a:r>
+                    </a:p>
+                  </a:txBody>
+                  <a:tcPr anchor="ctr" marL="101600" marR="101600" marT="50800" marB="50800">
+                    <a:solidFill>
+                      <a:srgbClr val="F8FAFC"/>
+                    </a:solidFill>
+                  </a:tcPr>
+                </a:tc>
+              </a:tr>
+              <a:tr h="621792">
+                <a:tc>
+                  <a:txBody>
+                    <a:bodyPr wrap="square"/>
+                    <a:lstStyle/>
+                    <a:p>
+                      <a:pPr algn="l">
+                        <a:defRPr sz="1200" b="1">
+                          <a:solidFill>
+                            <a:srgbClr val="334155"/>
+                          </a:solidFill>
+                          <a:latin typeface="Arial"/>
+                        </a:defRPr>
+                      </a:pPr>
+                      <a:r>
+                        <a:t>prefetch</a:t>
+                      </a:r>
+                    </a:p>
+                  </a:txBody>
+                  <a:tcPr anchor="ctr" marL="101600" marR="101600" marT="50800" marB="50800">
+                    <a:solidFill>
+                      <a:srgbClr val="FFFFFF"/>
+                    </a:solidFill>
+                  </a:tcPr>
+                </a:tc>
+                <a:tc>
+                  <a:txBody>
+                    <a:bodyPr wrap="square"/>
+                    <a:lstStyle/>
+                    <a:p>
+                      <a:pPr algn="l">
+                        <a:defRPr sz="1100" b="0">
+                          <a:solidFill>
+                            <a:srgbClr val="334155"/>
+                          </a:solidFill>
+                          <a:latin typeface="Arial"/>
+                        </a:defRPr>
+                      </a:pPr>
+                      <a:r>
+                        <a:t>resolve_recommendation_count + price_band + search_catalog</a:t>
+                      </a:r>
+                    </a:p>
+                  </a:txBody>
+                  <a:tcPr anchor="ctr" marL="101600" marR="101600" marT="50800" marB="50800">
+                    <a:solidFill>
+                      <a:srgbClr val="FFFFFF"/>
+                    </a:solidFill>
+                  </a:tcPr>
+                </a:tc>
+                <a:tc>
+                  <a:txBody>
+                    <a:bodyPr wrap="square"/>
+                    <a:lstStyle/>
+                    <a:p>
+                      <a:pPr algn="l">
+                        <a:defRPr sz="1100" b="0">
+                          <a:solidFill>
+                            <a:srgbClr val="334155"/>
+                          </a:solidFill>
+                          <a:latin typeface="Arial"/>
+                        </a:defRPr>
+                      </a:pPr>
+                      <a:r>
+                        <a:t>Catalog hits fetched once — orchestrator.py step 3</a:t>
+                      </a:r>
+                    </a:p>
+                  </a:txBody>
+                  <a:tcPr anchor="ctr" marL="101600" marR="101600" marT="50800" marB="50800">
+                    <a:solidFill>
+                      <a:srgbClr val="FFFFFF"/>
+                    </a:solidFill>
+                  </a:tcPr>
+                </a:tc>
+              </a:tr>
+              <a:tr h="621792">
+                <a:tc>
+                  <a:txBody>
+                    <a:bodyPr wrap="square"/>
+                    <a:lstStyle/>
+                    <a:p>
+                      <a:pPr algn="l">
+                        <a:defRPr sz="1200" b="1">
+                          <a:solidFill>
+                            <a:srgbClr val="334155"/>
+                          </a:solidFill>
+                          <a:latin typeface="Arial"/>
+                        </a:defRPr>
+                      </a:pPr>
+                      <a:r>
+                        <a:t>social</a:t>
+                      </a:r>
+                    </a:p>
+                  </a:txBody>
+                  <a:tcPr anchor="ctr" marL="101600" marR="101600" marT="50800" marB="50800">
+                    <a:solidFill>
+                      <a:srgbClr val="F8FAFC"/>
+                    </a:solidFill>
+                  </a:tcPr>
+                </a:tc>
+                <a:tc>
+                  <a:txBody>
+                    <a:bodyPr wrap="square"/>
+                    <a:lstStyle/>
+                    <a:p>
+                      <a:pPr algn="l">
+                        <a:defRPr sz="1100" b="0">
+                          <a:solidFill>
+                            <a:srgbClr val="334155"/>
+                          </a:solidFill>
+                          <a:latin typeface="Arial"/>
+                        </a:defRPr>
+                      </a:pPr>
+                      <a:r>
+                        <a:t>social_agent.social_reply()</a:t>
+                      </a:r>
+                    </a:p>
+                  </a:txBody>
+                  <a:tcPr anchor="ctr" marL="101600" marR="101600" marT="50800" marB="50800">
+                    <a:solidFill>
+                      <a:srgbClr val="F8FAFC"/>
+                    </a:solidFill>
+                  </a:tcPr>
+                </a:tc>
+                <a:tc>
+                  <a:txBody>
+                    <a:bodyPr wrap="square"/>
+                    <a:lstStyle/>
+                    <a:p>
+                      <a:pPr algn="l">
+                        <a:defRPr sz="1100" b="0">
+                          <a:solidFill>
+                            <a:srgbClr val="334155"/>
+                          </a:solidFill>
+                          <a:latin typeface="Arial"/>
+                        </a:defRPr>
+                      </a:pPr>
+                      <a:r>
+                        <a:t>Unchanged behaviour, only made async</a:t>
+                      </a:r>
+                    </a:p>
+                  </a:txBody>
+                  <a:tcPr anchor="ctr" marL="101600" marR="101600" marT="50800" marB="50800">
+                    <a:solidFill>
+                      <a:srgbClr val="F8FAFC"/>
+                    </a:solidFill>
+                  </a:tcPr>
+                </a:tc>
+              </a:tr>
+              <a:tr h="621792">
+                <a:tc>
+                  <a:txBody>
+                    <a:bodyPr wrap="square"/>
+                    <a:lstStyle/>
+                    <a:p>
+                      <a:pPr algn="l">
+                        <a:defRPr sz="1200" b="1">
+                          <a:solidFill>
+                            <a:srgbClr val="334155"/>
+                          </a:solidFill>
+                          <a:latin typeface="Arial"/>
+                        </a:defRPr>
+                      </a:pPr>
+                      <a:r>
+                        <a:t>process_lane</a:t>
+                      </a:r>
+                    </a:p>
+                  </a:txBody>
+                  <a:tcPr anchor="ctr" marL="101600" marR="101600" marT="50800" marB="50800">
+                    <a:solidFill>
+                      <a:srgbClr val="FFFFFF"/>
+                    </a:solidFill>
+                  </a:tcPr>
+                </a:tc>
+                <a:tc>
+                  <a:txBody>
+                    <a:bodyPr wrap="square"/>
+                    <a:lstStyle/>
+                    <a:p>
+                      <a:pPr algn="l">
+                        <a:defRPr sz="1100" b="0">
+                          <a:solidFill>
+                            <a:srgbClr val="334155"/>
+                          </a:solidFill>
+                          <a:latin typeface="Arial"/>
+                        </a:defRPr>
+                      </a:pPr>
+                      <a:r>
+                        <a:t>dispatch_process(run_process_lane, timeout=&lt;constraints.yaml&gt;)</a:t>
+                      </a:r>
+                    </a:p>
+                  </a:txBody>
+                  <a:tcPr anchor="ctr" marL="101600" marR="101600" marT="50800" marB="50800">
+                    <a:solidFill>
+                      <a:srgbClr val="FFFFFF"/>
+                    </a:solidFill>
+                  </a:tcPr>
+                </a:tc>
+                <a:tc>
+                  <a:txBody>
+                    <a:bodyPr wrap="square"/>
+                    <a:lstStyle/>
+                    <a:p>
+                      <a:pPr algn="l">
+                        <a:defRPr sz="1100" b="0">
+                          <a:solidFill>
+                            <a:srgbClr val="334155"/>
+                          </a:solidFill>
+                          <a:latin typeface="Arial"/>
+                        </a:defRPr>
+                      </a:pPr>
+                      <a:r>
+                        <a:t>Real nested 40s outer / 18s inner timeout — replaces rag_node + synthesis_node</a:t>
+                      </a:r>
+                    </a:p>
+                  </a:txBody>
+                  <a:tcPr anchor="ctr" marL="101600" marR="101600" marT="50800" marB="50800">
+                    <a:solidFill>
+                      <a:srgbClr val="FFFFFF"/>
+                    </a:solidFill>
+                  </a:tcPr>
+                </a:tc>
+              </a:tr>
+              <a:tr h="621792">
+                <a:tc>
+                  <a:txBody>
+                    <a:bodyPr wrap="square"/>
+                    <a:lstStyle/>
+                    <a:p>
+                      <a:pPr algn="l">
+                        <a:defRPr sz="1200" b="1">
+                          <a:solidFill>
+                            <a:srgbClr val="334155"/>
+                          </a:solidFill>
+                          <a:latin typeface="Arial"/>
+                        </a:defRPr>
+                      </a:pPr>
+                      <a:r>
+                        <a:t>cache_store</a:t>
+                      </a:r>
+                    </a:p>
+                  </a:txBody>
+                  <a:tcPr anchor="ctr" marL="101600" marR="101600" marT="50800" marB="50800">
+                    <a:solidFill>
+                      <a:srgbClr val="F8FAFC"/>
+                    </a:solidFill>
+                  </a:tcPr>
+                </a:tc>
+                <a:tc>
+                  <a:txBody>
+                    <a:bodyPr wrap="square"/>
+                    <a:lstStyle/>
+                    <a:p>
+                      <a:pPr algn="l">
+                        <a:defRPr sz="1100" b="0">
+                          <a:solidFill>
+                            <a:srgbClr val="334155"/>
+                          </a:solidFill>
+                          <a:latin typeface="Arial"/>
+                        </a:defRPr>
+                      </a:pPr>
+                      <a:r>
+                        <a:t>chat_cache.set(key, response)</a:t>
+                      </a:r>
+                    </a:p>
+                  </a:txBody>
+                  <a:tcPr anchor="ctr" marL="101600" marR="101600" marT="50800" marB="50800">
+                    <a:solidFill>
+                      <a:srgbClr val="F8FAFC"/>
+                    </a:solidFill>
+                  </a:tcPr>
+                </a:tc>
+                <a:tc>
+                  <a:txBody>
+                    <a:bodyPr wrap="square"/>
+                    <a:lstStyle/>
+                    <a:p>
+                      <a:pPr algn="l">
+                        <a:defRPr sz="1100" b="0">
+                          <a:solidFill>
+                            <a:srgbClr val="334155"/>
+                          </a:solidFill>
+                          <a:latin typeface="Arial"/>
+                        </a:defRPr>
+                      </a:pPr>
+                      <a:r>
+                        <a:t>Same singleton as the legacy orchestrator</a:t>
+                      </a:r>
+                    </a:p>
+                  </a:txBody>
+                  <a:tcPr anchor="ctr" marL="101600" marR="101600" marT="50800" marB="50800">
+                    <a:solidFill>
+                      <a:srgbClr val="F8FAFC"/>
+                    </a:solidFill>
+                  </a:tcPr>
+                </a:tc>
+              </a:tr>
+            </a:tbl>
+          </a:graphicData>
+        </a:graphic>
+      </p:graphicFrame>
     </p:spTree>
   </p:cSld>
   <p:clrMapOvr>
@@ -10249,7 +11928,7 @@
               </a:defRPr>
             </a:pPr>
             <a:r>
-              <a:t>LangGraph 2/3 — every node, what it calls</a:t>
+              <a:t>LangGraph 3/3 — audit findings &amp; verified results</a:t>
             </a:r>
           </a:p>
         </p:txBody>
@@ -10285,7 +11964,7 @@
               </a:defRPr>
             </a:pPr>
             <a:r>
-              <a:t>Every node is a verbatim call into this repo's own functions</a:t>
+              <a:t>What a faithful audit found, and how it was verified</a:t>
             </a:r>
           </a:p>
         </p:txBody>
@@ -10436,7 +12115,7 @@
               </a:defRPr>
             </a:pPr>
             <a:r>
-              <a:t>15</a:t>
+              <a:t>16</a:t>
             </a:r>
           </a:p>
         </p:txBody>
@@ -10486,14 +12165,113 @@
       </p:sp>
       <p:sp>
         <p:nvSpPr>
-          <p:cNvPr id="17" name="TextBox 16"/>
+          <p:cNvPr id="17" name="Rounded Rectangle 16"/>
+          <p:cNvSpPr/>
+          <p:nvPr/>
+        </p:nvSpPr>
+        <p:spPr>
+          <a:xfrm>
+            <a:off x="749808" y="1783080"/>
+            <a:ext cx="5074920" cy="1234440"/>
+          </a:xfrm>
+          <a:prstGeom prst="roundRect">
+            <a:avLst/>
+          </a:prstGeom>
+          <a:solidFill>
+            <a:srgbClr val="FFFFFF"/>
+          </a:solidFill>
+          <a:ln w="15875">
+            <a:solidFill>
+              <a:srgbClr val="F59E0B"/>
+            </a:solidFill>
+          </a:ln>
+          <a:effectLst/>
+        </p:spPr>
+        <p:style>
+          <a:lnRef idx="1">
+            <a:schemeClr val="accent1"/>
+          </a:lnRef>
+          <a:fillRef idx="3">
+            <a:schemeClr val="accent1"/>
+          </a:fillRef>
+          <a:effectRef idx="2">
+            <a:schemeClr val="accent1"/>
+          </a:effectRef>
+          <a:fontRef idx="minor">
+            <a:schemeClr val="lt1"/>
+          </a:fontRef>
+        </p:style>
+        <p:txBody>
+          <a:bodyPr rtlCol="0" anchor="ctr"/>
+          <a:lstStyle/>
+          <a:p>
+            <a:pPr algn="ctr"/>
+          </a:p>
+        </p:txBody>
+      </p:sp>
+      <p:sp>
+        <p:nvSpPr>
+          <p:cNvPr id="18" name="Oval 17"/>
+          <p:cNvSpPr/>
+          <p:nvPr/>
+        </p:nvSpPr>
+        <p:spPr>
+          <a:xfrm>
+            <a:off x="859536" y="1892807"/>
+            <a:ext cx="384048" cy="384048"/>
+          </a:xfrm>
+          <a:prstGeom prst="ellipse">
+            <a:avLst/>
+          </a:prstGeom>
+          <a:solidFill>
+            <a:srgbClr val="F59E0B"/>
+          </a:solidFill>
+          <a:ln>
+            <a:noFill/>
+          </a:ln>
+          <a:effectLst/>
+        </p:spPr>
+        <p:style>
+          <a:lnRef idx="1">
+            <a:schemeClr val="accent1"/>
+          </a:lnRef>
+          <a:fillRef idx="3">
+            <a:schemeClr val="accent1"/>
+          </a:fillRef>
+          <a:effectRef idx="2">
+            <a:schemeClr val="accent1"/>
+          </a:effectRef>
+          <a:fontRef idx="minor">
+            <a:schemeClr val="lt1"/>
+          </a:fontRef>
+        </p:style>
+        <p:txBody>
+          <a:bodyPr rtlCol="0" anchor="ctr"/>
+          <a:lstStyle/>
+          <a:p>
+            <a:pPr algn="ctr">
+              <a:defRPr b="1" sz="1600">
+                <a:solidFill>
+                  <a:srgbClr val="FFFFFF"/>
+                </a:solidFill>
+              </a:defRPr>
+            </a:pPr>
+            <a:r>
+              <a:t>1</a:t>
+            </a:r>
+          </a:p>
+        </p:txBody>
+      </p:sp>
+      <p:sp>
+        <p:nvSpPr>
+          <p:cNvPr id="19" name="TextBox 18"/>
           <p:cNvSpPr txBox="1"/>
           <p:nvPr/>
         </p:nvSpPr>
         <p:spPr>
           <a:xfrm>
-            <a:off x="749808" y="1417320"/>
-            <a:ext cx="5349240" cy="4663440"/>
+            <a:off x="1371600" y="1856231"/>
+            <a:ext cx="4343400" cy="274320"/>
           </a:xfrm>
           <a:prstGeom prst="rect">
             <a:avLst/>
@@ -10506,10 +12284,7 @@
           </a:bodyPr>
           <a:lstStyle/>
           <a:p>
-            <a:pPr>
-              <a:spcAft>
-                <a:spcPts val="600"/>
-              </a:spcAft>
+            <a:pPr algn="l">
               <a:defRPr sz="1300" b="1">
                 <a:solidFill>
                   <a:srgbClr val="0A2540"/>
@@ -10518,149 +12293,21 @@
               </a:defRPr>
             </a:pPr>
             <a:r>
-              <a:t>Social path</a:t>
-            </a:r>
-          </a:p>
-          <a:p>
-            <a:pPr>
-              <a:spcAft>
-                <a:spcPts val="600"/>
-              </a:spcAft>
-              <a:defRPr sz="1300" b="0">
-                <a:solidFill>
-                  <a:srgbClr val="334155"/>
-                </a:solidFill>
-                <a:latin typeface="Arial"/>
-              </a:defRPr>
-            </a:pPr>
-            <a:r>
-              <a:t>• classify_intent → orchestrator._classify_intent_bounded() —</a:t>
-            </a:r>
-          </a:p>
-          <a:p>
-            <a:pPr>
-              <a:spcAft>
-                <a:spcPts val="600"/>
-              </a:spcAft>
-              <a:defRPr sz="1300" b="0">
-                <a:solidFill>
-                  <a:srgbClr val="334155"/>
-                </a:solidFill>
-                <a:latin typeface="Arial"/>
-              </a:defRPr>
-            </a:pPr>
-            <a:r>
-              <a:t>  same 22s timeout, same _fallback_intent_decision() fallback.</a:t>
-            </a:r>
-          </a:p>
-          <a:p>
-            <a:pPr>
-              <a:spcAft>
-                <a:spcPts val="600"/>
-              </a:spcAft>
-              <a:defRPr sz="1300" b="0">
-                <a:solidFill>
-                  <a:srgbClr val="334155"/>
-                </a:solidFill>
-                <a:latin typeface="Arial"/>
-              </a:defRPr>
-            </a:pPr>
-            <a:r>
-              <a:t>• social_node → social_agent.social_reply() — unchanged behaviour,</a:t>
-            </a:r>
-          </a:p>
-          <a:p>
-            <a:pPr>
-              <a:spcAft>
-                <a:spcPts val="600"/>
-              </a:spcAft>
-              <a:defRPr sz="1300" b="0">
-                <a:solidFill>
-                  <a:srgbClr val="334155"/>
-                </a:solidFill>
-                <a:latin typeface="Arial"/>
-              </a:defRPr>
-            </a:pPr>
-            <a:r>
-              <a:t>  only made async.</a:t>
-            </a:r>
-          </a:p>
-          <a:p>
-            <a:pPr>
-              <a:spcAft>
-                <a:spcPts val="600"/>
-              </a:spcAft>
-              <a:defRPr sz="1300" b="1">
-                <a:solidFill>
-                  <a:srgbClr val="0A2540"/>
-                </a:solidFill>
-                <a:latin typeface="Arial"/>
-              </a:defRPr>
-            </a:pPr>
-            <a:r>
-              <a:t>Cache path (new)</a:t>
-            </a:r>
-          </a:p>
-          <a:p>
-            <a:pPr>
-              <a:spcAft>
-                <a:spcPts val="600"/>
-              </a:spcAft>
-              <a:defRPr sz="1300" b="0">
-                <a:solidFill>
-                  <a:srgbClr val="334155"/>
-                </a:solidFill>
-                <a:latin typeface="Arial"/>
-              </a:defRPr>
-            </a:pPr>
-            <a:r>
-              <a:t>• cache_check_node / cache_store_node → the SAME chat_cache</a:t>
-            </a:r>
-          </a:p>
-          <a:p>
-            <a:pPr>
-              <a:spcAft>
-                <a:spcPts val="600"/>
-              </a:spcAft>
-              <a:defRPr sz="1300" b="0">
-                <a:solidFill>
-                  <a:srgbClr val="334155"/>
-                </a:solidFill>
-                <a:latin typeface="Arial"/>
-              </a:defRPr>
-            </a:pPr>
-            <a:r>
-              <a:t>  singleton + key format (site_id:query.lower()) the legacy</a:t>
-            </a:r>
-          </a:p>
-          <a:p>
-            <a:pPr>
-              <a:spcAft>
-                <a:spcPts val="600"/>
-              </a:spcAft>
-              <a:defRPr sz="1300" b="0">
-                <a:solidFill>
-                  <a:srgbClr val="334155"/>
-                </a:solidFill>
-                <a:latin typeface="Arial"/>
-              </a:defRPr>
-            </a:pPr>
-            <a:r>
-              <a:t>  orchestrator already uses — not a separate cache.</a:t>
-            </a:r>
-          </a:p>
-        </p:txBody>
-      </p:sp>
-      <p:sp>
-        <p:nvSpPr>
-          <p:cNvPr id="18" name="TextBox 17"/>
+              <a:t>preferred_model silently ignored</a:t>
+            </a:r>
+          </a:p>
+        </p:txBody>
+      </p:sp>
+      <p:sp>
+        <p:nvSpPr>
+          <p:cNvPr id="20" name="TextBox 19"/>
           <p:cNvSpPr txBox="1"/>
           <p:nvPr/>
         </p:nvSpPr>
         <p:spPr>
           <a:xfrm>
-            <a:off x="6126480" y="1417320"/>
-            <a:ext cx="5257800" cy="4663440"/>
+            <a:off x="1371600" y="2148840"/>
+            <a:ext cx="4343400" cy="822960"/>
           </a:xfrm>
           <a:prstGeom prst="rect">
             <a:avLst/>
@@ -10673,10 +12320,142 @@
           </a:bodyPr>
           <a:lstStyle/>
           <a:p>
-            <a:pPr>
-              <a:spcAft>
-                <a:spcPts val="600"/>
-              </a:spcAft>
+            <a:pPr algn="l">
+              <a:defRPr sz="1100" b="0">
+                <a:solidFill>
+                  <a:srgbClr val="334155"/>
+                </a:solidFill>
+                <a:latin typeface="Arial"/>
+              </a:defRPr>
+            </a:pPr>
+            <a:r>
+              <a:t>UI's model override stored in state but no node read it. Fixed via ContextVar set for the whole graph run.</a:t>
+            </a:r>
+          </a:p>
+        </p:txBody>
+      </p:sp>
+      <p:sp>
+        <p:nvSpPr>
+          <p:cNvPr id="21" name="Rounded Rectangle 20"/>
+          <p:cNvSpPr/>
+          <p:nvPr/>
+        </p:nvSpPr>
+        <p:spPr>
+          <a:xfrm>
+            <a:off x="749808" y="3127248"/>
+            <a:ext cx="5074920" cy="1234440"/>
+          </a:xfrm>
+          <a:prstGeom prst="roundRect">
+            <a:avLst/>
+          </a:prstGeom>
+          <a:solidFill>
+            <a:srgbClr val="FFFFFF"/>
+          </a:solidFill>
+          <a:ln w="15875">
+            <a:solidFill>
+              <a:srgbClr val="F59E0B"/>
+            </a:solidFill>
+          </a:ln>
+          <a:effectLst/>
+        </p:spPr>
+        <p:style>
+          <a:lnRef idx="1">
+            <a:schemeClr val="accent1"/>
+          </a:lnRef>
+          <a:fillRef idx="3">
+            <a:schemeClr val="accent1"/>
+          </a:fillRef>
+          <a:effectRef idx="2">
+            <a:schemeClr val="accent1"/>
+          </a:effectRef>
+          <a:fontRef idx="minor">
+            <a:schemeClr val="lt1"/>
+          </a:fontRef>
+        </p:style>
+        <p:txBody>
+          <a:bodyPr rtlCol="0" anchor="ctr"/>
+          <a:lstStyle/>
+          <a:p>
+            <a:pPr algn="ctr"/>
+          </a:p>
+        </p:txBody>
+      </p:sp>
+      <p:sp>
+        <p:nvSpPr>
+          <p:cNvPr id="22" name="Oval 21"/>
+          <p:cNvSpPr/>
+          <p:nvPr/>
+        </p:nvSpPr>
+        <p:spPr>
+          <a:xfrm>
+            <a:off x="859536" y="3236976"/>
+            <a:ext cx="384048" cy="384048"/>
+          </a:xfrm>
+          <a:prstGeom prst="ellipse">
+            <a:avLst/>
+          </a:prstGeom>
+          <a:solidFill>
+            <a:srgbClr val="F59E0B"/>
+          </a:solidFill>
+          <a:ln>
+            <a:noFill/>
+          </a:ln>
+          <a:effectLst/>
+        </p:spPr>
+        <p:style>
+          <a:lnRef idx="1">
+            <a:schemeClr val="accent1"/>
+          </a:lnRef>
+          <a:fillRef idx="3">
+            <a:schemeClr val="accent1"/>
+          </a:fillRef>
+          <a:effectRef idx="2">
+            <a:schemeClr val="accent1"/>
+          </a:effectRef>
+          <a:fontRef idx="minor">
+            <a:schemeClr val="lt1"/>
+          </a:fontRef>
+        </p:style>
+        <p:txBody>
+          <a:bodyPr rtlCol="0" anchor="ctr"/>
+          <a:lstStyle/>
+          <a:p>
+            <a:pPr algn="ctr">
+              <a:defRPr b="1" sz="1600">
+                <a:solidFill>
+                  <a:srgbClr val="FFFFFF"/>
+                </a:solidFill>
+              </a:defRPr>
+            </a:pPr>
+            <a:r>
+              <a:t>2</a:t>
+            </a:r>
+          </a:p>
+        </p:txBody>
+      </p:sp>
+      <p:sp>
+        <p:nvSpPr>
+          <p:cNvPr id="23" name="TextBox 22"/>
+          <p:cNvSpPr txBox="1"/>
+          <p:nvPr/>
+        </p:nvSpPr>
+        <p:spPr>
+          <a:xfrm>
+            <a:off x="1371600" y="3200400"/>
+            <a:ext cx="4343400" cy="274320"/>
+          </a:xfrm>
+          <a:prstGeom prst="rect">
+            <a:avLst/>
+          </a:prstGeom>
+          <a:noFill/>
+        </p:spPr>
+        <p:txBody>
+          <a:bodyPr wrap="square" anchor="t">
+            <a:spAutoFit/>
+          </a:bodyPr>
+          <a:lstStyle/>
+          <a:p>
+            <a:pPr algn="l">
               <a:defRPr sz="1300" b="1">
                 <a:solidFill>
                   <a:srgbClr val="0A2540"/>
@@ -10685,15 +12464,35 @@
               </a:defRPr>
             </a:pPr>
             <a:r>
-              <a:t>Catalog path</a:t>
-            </a:r>
-          </a:p>
-          <a:p>
-            <a:pPr>
-              <a:spcAft>
-                <a:spcPts val="600"/>
-              </a:spcAft>
-              <a:defRPr sz="1300" b="0">
+              <a:t>No chat-level cache existed</a:t>
+            </a:r>
+          </a:p>
+        </p:txBody>
+      </p:sp>
+      <p:sp>
+        <p:nvSpPr>
+          <p:cNvPr id="24" name="TextBox 23"/>
+          <p:cNvSpPr txBox="1"/>
+          <p:nvPr/>
+        </p:nvSpPr>
+        <p:spPr>
+          <a:xfrm>
+            <a:off x="1371600" y="3493008"/>
+            <a:ext cx="4343400" cy="822960"/>
+          </a:xfrm>
+          <a:prstGeom prst="rect">
+            <a:avLst/>
+          </a:prstGeom>
+          <a:noFill/>
+        </p:spPr>
+        <p:txBody>
+          <a:bodyPr wrap="square" anchor="t">
+            <a:spAutoFit/>
+          </a:bodyPr>
+          <a:lstStyle/>
+          <a:p>
+            <a:pPr algn="l">
+              <a:defRPr sz="1100" b="0">
                 <a:solidFill>
                   <a:srgbClr val="334155"/>
                 </a:solidFill>
@@ -10701,15 +12500,170 @@
               </a:defRPr>
             </a:pPr>
             <a:r>
-              <a:t>• prefetch_node → resolve_recommendation_count + price_band +</a:t>
-            </a:r>
-          </a:p>
-          <a:p>
-            <a:pPr>
-              <a:spcAft>
-                <a:spcPts val="600"/>
-              </a:spcAft>
-              <a:defRPr sz="1300" b="0">
+              <a:t>cache_check_node / cache_store_node now share the legacy orchestrator's own chat_cache singleton.</a:t>
+            </a:r>
+          </a:p>
+        </p:txBody>
+      </p:sp>
+      <p:sp>
+        <p:nvSpPr>
+          <p:cNvPr id="25" name="Rounded Rectangle 24"/>
+          <p:cNvSpPr/>
+          <p:nvPr/>
+        </p:nvSpPr>
+        <p:spPr>
+          <a:xfrm>
+            <a:off x="749808" y="4471416"/>
+            <a:ext cx="5074920" cy="1234440"/>
+          </a:xfrm>
+          <a:prstGeom prst="roundRect">
+            <a:avLst/>
+          </a:prstGeom>
+          <a:solidFill>
+            <a:srgbClr val="FFFFFF"/>
+          </a:solidFill>
+          <a:ln w="15875">
+            <a:solidFill>
+              <a:srgbClr val="F59E0B"/>
+            </a:solidFill>
+          </a:ln>
+          <a:effectLst/>
+        </p:spPr>
+        <p:style>
+          <a:lnRef idx="1">
+            <a:schemeClr val="accent1"/>
+          </a:lnRef>
+          <a:fillRef idx="3">
+            <a:schemeClr val="accent1"/>
+          </a:fillRef>
+          <a:effectRef idx="2">
+            <a:schemeClr val="accent1"/>
+          </a:effectRef>
+          <a:fontRef idx="minor">
+            <a:schemeClr val="lt1"/>
+          </a:fontRef>
+        </p:style>
+        <p:txBody>
+          <a:bodyPr rtlCol="0" anchor="ctr"/>
+          <a:lstStyle/>
+          <a:p>
+            <a:pPr algn="ctr"/>
+          </a:p>
+        </p:txBody>
+      </p:sp>
+      <p:sp>
+        <p:nvSpPr>
+          <p:cNvPr id="26" name="Oval 25"/>
+          <p:cNvSpPr/>
+          <p:nvPr/>
+        </p:nvSpPr>
+        <p:spPr>
+          <a:xfrm>
+            <a:off x="859536" y="4581144"/>
+            <a:ext cx="384048" cy="384048"/>
+          </a:xfrm>
+          <a:prstGeom prst="ellipse">
+            <a:avLst/>
+          </a:prstGeom>
+          <a:solidFill>
+            <a:srgbClr val="F59E0B"/>
+          </a:solidFill>
+          <a:ln>
+            <a:noFill/>
+          </a:ln>
+          <a:effectLst/>
+        </p:spPr>
+        <p:style>
+          <a:lnRef idx="1">
+            <a:schemeClr val="accent1"/>
+          </a:lnRef>
+          <a:fillRef idx="3">
+            <a:schemeClr val="accent1"/>
+          </a:fillRef>
+          <a:effectRef idx="2">
+            <a:schemeClr val="accent1"/>
+          </a:effectRef>
+          <a:fontRef idx="minor">
+            <a:schemeClr val="lt1"/>
+          </a:fontRef>
+        </p:style>
+        <p:txBody>
+          <a:bodyPr rtlCol="0" anchor="ctr"/>
+          <a:lstStyle/>
+          <a:p>
+            <a:pPr algn="ctr">
+              <a:defRPr b="1" sz="1600">
+                <a:solidFill>
+                  <a:srgbClr val="FFFFFF"/>
+                </a:solidFill>
+              </a:defRPr>
+            </a:pPr>
+            <a:r>
+              <a:t>3</a:t>
+            </a:r>
+          </a:p>
+        </p:txBody>
+      </p:sp>
+      <p:sp>
+        <p:nvSpPr>
+          <p:cNvPr id="27" name="TextBox 26"/>
+          <p:cNvSpPr txBox="1"/>
+          <p:nvPr/>
+        </p:nvSpPr>
+        <p:spPr>
+          <a:xfrm>
+            <a:off x="1371600" y="4544568"/>
+            <a:ext cx="4343400" cy="274320"/>
+          </a:xfrm>
+          <a:prstGeom prst="rect">
+            <a:avLst/>
+          </a:prstGeom>
+          <a:noFill/>
+        </p:spPr>
+        <p:txBody>
+          <a:bodyPr wrap="square" anchor="t">
+            <a:spAutoFit/>
+          </a:bodyPr>
+          <a:lstStyle/>
+          <a:p>
+            <a:pPr algn="l">
+              <a:defRPr sz="1300" b="1">
+                <a:solidFill>
+                  <a:srgbClr val="0A2540"/>
+                </a:solidFill>
+                <a:latin typeface="Arial"/>
+              </a:defRPr>
+            </a:pPr>
+            <a:r>
+              <a:t>Catalog path bypassed dispatch_process</a:t>
+            </a:r>
+          </a:p>
+        </p:txBody>
+      </p:sp>
+      <p:sp>
+        <p:nvSpPr>
+          <p:cNvPr id="28" name="TextBox 27"/>
+          <p:cNvSpPr txBox="1"/>
+          <p:nvPr/>
+        </p:nvSpPr>
+        <p:spPr>
+          <a:xfrm>
+            <a:off x="1371600" y="4837176"/>
+            <a:ext cx="4343400" cy="822960"/>
+          </a:xfrm>
+          <a:prstGeom prst="rect">
+            <a:avLst/>
+          </a:prstGeom>
+          <a:noFill/>
+        </p:spPr>
+        <p:txBody>
+          <a:bodyPr wrap="square" anchor="t">
+            <a:spAutoFit/>
+          </a:bodyPr>
+          <a:lstStyle/>
+          <a:p>
+            <a:pPr algn="l">
+              <a:defRPr sz="1100" b="0">
                 <a:solidFill>
                   <a:srgbClr val="334155"/>
                 </a:solidFill>
@@ -10717,119 +12671,292 @@
               </a:defRPr>
             </a:pPr>
             <a:r>
-              <a:t>  retrieval_pool_size + search_catalog — orchestrator step 3.</a:t>
-            </a:r>
-          </a:p>
-          <a:p>
-            <a:pPr>
-              <a:spcAft>
-                <a:spcPts val="600"/>
-              </a:spcAft>
-              <a:defRPr sz="1300" b="0">
-                <a:solidFill>
-                  <a:srgbClr val="334155"/>
-                </a:solidFill>
-                <a:latin typeface="Arial"/>
-              </a:defRPr>
-            </a:pPr>
-            <a:r>
-              <a:t>• process_lane_node → dispatch_process(envelope, run_process_lane,</a:t>
-            </a:r>
-          </a:p>
-          <a:p>
-            <a:pPr>
-              <a:spcAft>
-                <a:spcPts val="600"/>
-              </a:spcAft>
-              <a:defRPr sz="1300" b="0">
-                <a:solidFill>
-                  <a:srgbClr val="334155"/>
-                </a:solidFill>
-                <a:latin typeface="Arial"/>
-              </a:defRPr>
-            </a:pPr>
-            <a:r>
-              <a:t>  timeout=&lt;constraints.yaml&gt;) — the real nested 40s outer /</a:t>
-            </a:r>
-          </a:p>
-          <a:p>
-            <a:pPr>
-              <a:spcAft>
-                <a:spcPts val="600"/>
-              </a:spcAft>
-              <a:defRPr sz="1300" b="0">
-                <a:solidFill>
-                  <a:srgbClr val="334155"/>
-                </a:solidFill>
-                <a:latin typeface="Arial"/>
-              </a:defRPr>
-            </a:pPr>
-            <a:r>
-              <a:t>  18s inner synthesis timeout, replacing two nodes that had</a:t>
-            </a:r>
-          </a:p>
-          <a:p>
-            <a:pPr>
-              <a:spcAft>
-                <a:spcPts val="600"/>
-              </a:spcAft>
-              <a:defRPr sz="1300" b="0">
-                <a:solidFill>
-                  <a:srgbClr val="334155"/>
-                </a:solidFill>
-                <a:latin typeface="Arial"/>
-              </a:defRPr>
-            </a:pPr>
-            <a:r>
-              <a:t>  re-derived retrieval + synthesis + template fallback inline.</a:t>
-            </a:r>
-          </a:p>
-          <a:p>
-            <a:pPr>
-              <a:spcAft>
-                <a:spcPts val="600"/>
-              </a:spcAft>
-              <a:defRPr sz="1300" b="1">
-                <a:solidFill>
-                  <a:srgbClr val="0A2540"/>
-                </a:solidFill>
-                <a:latin typeface="Arial"/>
-              </a:defRPr>
-            </a:pPr>
-            <a:r>
-              <a:t>Result</a:t>
-            </a:r>
-          </a:p>
-          <a:p>
-            <a:pPr>
-              <a:spcAft>
-                <a:spcPts val="600"/>
-              </a:spcAft>
-              <a:defRPr sz="1300" b="0">
-                <a:solidFill>
-                  <a:srgbClr val="334155"/>
-                </a:solidFill>
-                <a:latin typeface="Arial"/>
-              </a:defRPr>
-            </a:pPr>
-            <a:r>
-              <a:t>• rag_node + synthesis_node deleted — process_lane_node replaces</a:t>
-            </a:r>
-          </a:p>
-          <a:p>
-            <a:pPr>
-              <a:spcAft>
-                <a:spcPts val="600"/>
-              </a:spcAft>
-              <a:defRPr sz="1300" b="0">
-                <a:solidFill>
-                  <a:srgbClr val="334155"/>
-                </a:solidFill>
-                <a:latin typeface="Arial"/>
-              </a:defRPr>
-            </a:pPr>
-            <a:r>
-              <a:t>  both with one verbatim call into the existing ACP dispatch.</a:t>
+              <a:t>Single 18s timeout, no outer-timeout cancellation. process_lane_node now calls the real ACP dispatch.</a:t>
+            </a:r>
+          </a:p>
+        </p:txBody>
+      </p:sp>
+      <p:graphicFrame>
+        <p:nvGraphicFramePr>
+          <p:cNvPr id="29" name="Chart 28"/>
+          <p:cNvGraphicFramePr>
+            <a:graphicFrameLocks noGrp="1"/>
+          </p:cNvGraphicFramePr>
+          <p:nvPr/>
+        </p:nvGraphicFramePr>
+        <p:xfrm>
+          <a:off x="6263640" y="1783080"/>
+          <a:ext cx="5074920" cy="3246120"/>
+        </p:xfrm>
+        <a:graphic>
+          <a:graphicData uri="http://schemas.openxmlformats.org/drawingml/2006/chart">
+            <c:chart xmlns:c="http://schemas.openxmlformats.org/drawingml/2006/chart" r:id="rId2"/>
+          </a:graphicData>
+        </a:graphic>
+      </p:graphicFrame>
+      <p:sp>
+        <p:nvSpPr>
+          <p:cNvPr id="30" name="TextBox 29"/>
+          <p:cNvSpPr txBox="1"/>
+          <p:nvPr/>
+        </p:nvSpPr>
+        <p:spPr>
+          <a:xfrm>
+            <a:off x="6263640" y="5138928"/>
+            <a:ext cx="5074920" cy="365760"/>
+          </a:xfrm>
+          <a:prstGeom prst="rect">
+            <a:avLst/>
+          </a:prstGeom>
+          <a:noFill/>
+        </p:spPr>
+        <p:txBody>
+          <a:bodyPr wrap="square" anchor="t">
+            <a:spAutoFit/>
+          </a:bodyPr>
+          <a:lstStyle/>
+          <a:p>
+            <a:pPr algn="ctr">
+              <a:defRPr sz="1400" b="1">
+                <a:solidFill>
+                  <a:srgbClr val="60A5FA"/>
+                </a:solidFill>
+                <a:latin typeface="Arial"/>
+              </a:defRPr>
+            </a:pPr>
+            <a:r>
+              <a:t>~960x faster — same answer, identical bytes.</a:t>
+            </a:r>
+          </a:p>
+        </p:txBody>
+      </p:sp>
+      <p:sp>
+        <p:nvSpPr>
+          <p:cNvPr id="31" name="Rounded Rectangle 30"/>
+          <p:cNvSpPr/>
+          <p:nvPr/>
+        </p:nvSpPr>
+        <p:spPr>
+          <a:xfrm>
+            <a:off x="6263640" y="5623560"/>
+            <a:ext cx="1600200" cy="566928"/>
+          </a:xfrm>
+          <a:prstGeom prst="roundRect">
+            <a:avLst/>
+          </a:prstGeom>
+          <a:solidFill>
+            <a:srgbClr val="0A2540"/>
+          </a:solidFill>
+          <a:ln>
+            <a:noFill/>
+          </a:ln>
+          <a:effectLst/>
+        </p:spPr>
+        <p:style>
+          <a:lnRef idx="1">
+            <a:schemeClr val="accent1"/>
+          </a:lnRef>
+          <a:fillRef idx="3">
+            <a:schemeClr val="accent1"/>
+          </a:fillRef>
+          <a:effectRef idx="2">
+            <a:schemeClr val="accent1"/>
+          </a:effectRef>
+          <a:fontRef idx="minor">
+            <a:schemeClr val="lt1"/>
+          </a:fontRef>
+        </p:style>
+        <p:txBody>
+          <a:bodyPr rtlCol="0" anchor="ctr" tIns="12700" bIns="12700"/>
+          <a:lstStyle/>
+          <a:p>
+            <a:pPr algn="ctr">
+              <a:defRPr b="1" sz="1500">
+                <a:solidFill>
+                  <a:srgbClr val="FFFFFF"/>
+                </a:solidFill>
+              </a:defRPr>
+            </a:pPr>
+            <a:r>
+              <a:t>179/180</a:t>
+            </a:r>
+          </a:p>
+          <a:p>
+            <a:pPr algn="ctr">
+              <a:defRPr sz="900">
+                <a:solidFill>
+                  <a:srgbClr val="BFDBFE"/>
+                </a:solidFill>
+              </a:defRPr>
+            </a:pPr>
+            <a:r>
+              <a:t>unit tests</a:t>
+            </a:r>
+          </a:p>
+        </p:txBody>
+      </p:sp>
+      <p:sp>
+        <p:nvSpPr>
+          <p:cNvPr id="32" name="Rounded Rectangle 31"/>
+          <p:cNvSpPr/>
+          <p:nvPr/>
+        </p:nvSpPr>
+        <p:spPr>
+          <a:xfrm>
+            <a:off x="8001000" y="5623560"/>
+            <a:ext cx="1600200" cy="566928"/>
+          </a:xfrm>
+          <a:prstGeom prst="roundRect">
+            <a:avLst/>
+          </a:prstGeom>
+          <a:solidFill>
+            <a:srgbClr val="0A2540"/>
+          </a:solidFill>
+          <a:ln>
+            <a:noFill/>
+          </a:ln>
+          <a:effectLst/>
+        </p:spPr>
+        <p:style>
+          <a:lnRef idx="1">
+            <a:schemeClr val="accent1"/>
+          </a:lnRef>
+          <a:fillRef idx="3">
+            <a:schemeClr val="accent1"/>
+          </a:fillRef>
+          <a:effectRef idx="2">
+            <a:schemeClr val="accent1"/>
+          </a:effectRef>
+          <a:fontRef idx="minor">
+            <a:schemeClr val="lt1"/>
+          </a:fontRef>
+        </p:style>
+        <p:txBody>
+          <a:bodyPr rtlCol="0" anchor="ctr" tIns="12700" bIns="12700"/>
+          <a:lstStyle/>
+          <a:p>
+            <a:pPr algn="ctr">
+              <a:defRPr b="1" sz="1500">
+                <a:solidFill>
+                  <a:srgbClr val="FFFFFF"/>
+                </a:solidFill>
+              </a:defRPr>
+            </a:pPr>
+            <a:r>
+              <a:t>206/206</a:t>
+            </a:r>
+          </a:p>
+          <a:p>
+            <a:pPr algn="ctr">
+              <a:defRPr sz="900">
+                <a:solidFill>
+                  <a:srgbClr val="BFDBFE"/>
+                </a:solidFill>
+              </a:defRPr>
+            </a:pPr>
+            <a:r>
+              <a:t>acceptance tests</a:t>
+            </a:r>
+          </a:p>
+        </p:txBody>
+      </p:sp>
+      <p:sp>
+        <p:nvSpPr>
+          <p:cNvPr id="33" name="Rounded Rectangle 32"/>
+          <p:cNvSpPr/>
+          <p:nvPr/>
+        </p:nvSpPr>
+        <p:spPr>
+          <a:xfrm>
+            <a:off x="9738359" y="5623560"/>
+            <a:ext cx="1600200" cy="566928"/>
+          </a:xfrm>
+          <a:prstGeom prst="roundRect">
+            <a:avLst/>
+          </a:prstGeom>
+          <a:solidFill>
+            <a:srgbClr val="0A2540"/>
+          </a:solidFill>
+          <a:ln>
+            <a:noFill/>
+          </a:ln>
+          <a:effectLst/>
+        </p:spPr>
+        <p:style>
+          <a:lnRef idx="1">
+            <a:schemeClr val="accent1"/>
+          </a:lnRef>
+          <a:fillRef idx="3">
+            <a:schemeClr val="accent1"/>
+          </a:fillRef>
+          <a:effectRef idx="2">
+            <a:schemeClr val="accent1"/>
+          </a:effectRef>
+          <a:fontRef idx="minor">
+            <a:schemeClr val="lt1"/>
+          </a:fontRef>
+        </p:style>
+        <p:txBody>
+          <a:bodyPr rtlCol="0" anchor="ctr" tIns="12700" bIns="12700"/>
+          <a:lstStyle/>
+          <a:p>
+            <a:pPr algn="ctr">
+              <a:defRPr b="1" sz="1500">
+                <a:solidFill>
+                  <a:srgbClr val="FFFFFF"/>
+                </a:solidFill>
+              </a:defRPr>
+            </a:pPr>
+            <a:r>
+              <a:t>33/33</a:t>
+            </a:r>
+          </a:p>
+          <a:p>
+            <a:pPr algn="ctr">
+              <a:defRPr sz="900">
+                <a:solidFill>
+                  <a:srgbClr val="BFDBFE"/>
+                </a:solidFill>
+              </a:defRPr>
+            </a:pPr>
+            <a:r>
+              <a:t>integration tests</a:t>
+            </a:r>
+          </a:p>
+        </p:txBody>
+      </p:sp>
+      <p:sp>
+        <p:nvSpPr>
+          <p:cNvPr id="34" name="TextBox 33"/>
+          <p:cNvSpPr txBox="1"/>
+          <p:nvPr/>
+        </p:nvSpPr>
+        <p:spPr>
+          <a:xfrm>
+            <a:off x="749808" y="6080760"/>
+            <a:ext cx="5074920" cy="274320"/>
+          </a:xfrm>
+          <a:prstGeom prst="rect">
+            <a:avLst/>
+          </a:prstGeom>
+          <a:noFill/>
+        </p:spPr>
+        <p:txBody>
+          <a:bodyPr wrap="square" anchor="t">
+            <a:spAutoFit/>
+          </a:bodyPr>
+          <a:lstStyle/>
+          <a:p>
+            <a:pPr algn="l">
+              <a:defRPr sz="1000" b="0">
+                <a:solidFill>
+                  <a:srgbClr val="6B7280"/>
+                </a:solidFill>
+                <a:latin typeface="Arial"/>
+              </a:defRPr>
+            </a:pPr>
+            <a:r>
+              <a:t>Branch: feature/lg-catalog-probe-intent — standalone, not merged into dev/main/releases.</a:t>
             </a:r>
           </a:p>
         </p:txBody>
@@ -11227,7 +13354,7 @@
               </a:defRPr>
             </a:pPr>
             <a:r>
-              <a:t>LangGraph 3/3 — audit findings &amp; verified results</a:t>
+              <a:t>Release progress — v0.1.0 → v2.1.6</a:t>
             </a:r>
           </a:p>
         </p:txBody>
@@ -11263,7 +13390,7 @@
               </a:defRPr>
             </a:pPr>
             <a:r>
-              <a:t>What a faithful audit found, and how it was verified</a:t>
+              <a:t>Same five FRs · smarter social routing, flexible picks, chunked UX</a:t>
             </a:r>
           </a:p>
         </p:txBody>
@@ -11342,7 +13469,7 @@
               </a:defRPr>
             </a:pPr>
             <a:r>
-              <a:t>Architecture · LG</a:t>
+              <a:t>Progress · releases</a:t>
             </a:r>
           </a:p>
         </p:txBody>
@@ -11378,7 +13505,7 @@
               </a:defRPr>
             </a:pPr>
             <a:r>
-              <a:t>zooplus Assistant — Coding Task PoC v0.1</a:t>
+              <a:t>zooplus Assistant — releases v2.1.6 · progress since v0.1.0</a:t>
             </a:r>
           </a:p>
         </p:txBody>
@@ -11414,7 +13541,7 @@
               </a:defRPr>
             </a:pPr>
             <a:r>
-              <a:t>16</a:t>
+              <a:t>17</a:t>
             </a:r>
           </a:p>
         </p:txBody>
@@ -11488,7 +13615,7 @@
               <a:spcAft>
                 <a:spcPts val="600"/>
               </a:spcAft>
-              <a:defRPr sz="1300" b="1">
+              <a:defRPr sz="1500" b="1">
                 <a:solidFill>
                   <a:srgbClr val="0A2540"/>
                 </a:solidFill>
@@ -11496,7 +13623,7 @@
               </a:defRPr>
             </a:pPr>
             <a:r>
-              <a:t>3 real gaps found in the first migration</a:t>
+              <a:t>Foundation — v0.1.0 → v1.0</a:t>
             </a:r>
           </a:p>
           <a:p>
@@ -11504,7 +13631,7 @@
               <a:spcAft>
                 <a:spcPts val="600"/>
               </a:spcAft>
-              <a:defRPr sz="1300" b="0">
+              <a:defRPr sz="1500" b="0">
                 <a:solidFill>
                   <a:srgbClr val="334155"/>
                 </a:solidFill>
@@ -11512,7 +13639,7 @@
               </a:defRPr>
             </a:pPr>
             <a:r>
-              <a:t>1. preferred_model (UI's per-request model override) was stored</a:t>
+              <a:t>v0.1.0 — Coding Task PoC: FR1–5, hybrid RAG, FR4 guardrails.</a:t>
             </a:r>
           </a:p>
           <a:p>
@@ -11520,7 +13647,7 @@
               <a:spcAft>
                 <a:spcPts val="600"/>
               </a:spcAft>
-              <a:defRPr sz="1300" b="0">
+              <a:defRPr sz="1500" b="0">
                 <a:solidFill>
                   <a:srgbClr val="334155"/>
                 </a:solidFill>
@@ -11528,7 +13655,7 @@
               </a:defRPr>
             </a:pPr>
             <a:r>
-              <a:t>   in graph state but no node ever read it — silently inert.</a:t>
+              <a:t>v0.1.3 — Conductor-first routing; /chat/stream; per-agent OpenCode.</a:t>
             </a:r>
           </a:p>
           <a:p>
@@ -11536,7 +13663,7 @@
               <a:spcAft>
                 <a:spcPts val="600"/>
               </a:spcAft>
-              <a:defRPr sz="1300" b="0">
+              <a:defRPr sz="1500" b="0">
                 <a:solidFill>
                   <a:srgbClr val="334155"/>
                 </a:solidFill>
@@ -11544,23 +13671,46 @@
               </a:defRPr>
             </a:pPr>
             <a:r>
-              <a:t>   Fixed: ContextVar set for the whole graph run, mirroring</a:t>
-            </a:r>
-          </a:p>
+              <a:t>v1.0 — Stable tag: catalog lexicon at ingest, cache, multilingual.</a:t>
+            </a:r>
+          </a:p>
+        </p:txBody>
+      </p:sp>
+      <p:sp>
+        <p:nvSpPr>
+          <p:cNvPr id="18" name="TextBox 17"/>
+          <p:cNvSpPr txBox="1"/>
+          <p:nvPr/>
+        </p:nvSpPr>
+        <p:spPr>
+          <a:xfrm>
+            <a:off x="6126480" y="1417320"/>
+            <a:ext cx="5257800" cy="4663440"/>
+          </a:xfrm>
+          <a:prstGeom prst="rect">
+            <a:avLst/>
+          </a:prstGeom>
+          <a:noFill/>
+        </p:spPr>
+        <p:txBody>
+          <a:bodyPr wrap="square" anchor="t">
+            <a:spAutoFit/>
+          </a:bodyPr>
+          <a:lstStyle/>
           <a:p>
             <a:pPr>
               <a:spcAft>
                 <a:spcPts val="600"/>
               </a:spcAft>
-              <a:defRPr sz="1300" b="0">
-                <a:solidFill>
-                  <a:srgbClr val="334155"/>
-                </a:solidFill>
-                <a:latin typeface="Arial"/>
-              </a:defRPr>
-            </a:pPr>
-            <a:r>
-              <a:t>   handle_chat()'s own wrapper.</a:t>
+              <a:defRPr sz="1500" b="1">
+                <a:solidFill>
+                  <a:srgbClr val="0A2540"/>
+                </a:solidFill>
+                <a:latin typeface="Arial"/>
+              </a:defRPr>
+            </a:pPr>
+            <a:r>
+              <a:t>Shopper experience — v1.4 → v2.1.6 (now)</a:t>
             </a:r>
           </a:p>
           <a:p>
@@ -11568,7 +13718,7 @@
               <a:spcAft>
                 <a:spcPts val="600"/>
               </a:spcAft>
-              <a:defRPr sz="1300" b="0">
+              <a:defRPr sz="1500" b="0">
                 <a:solidFill>
                   <a:srgbClr val="334155"/>
                 </a:solidFill>
@@ -11576,7 +13726,7 @@
               </a:defRPr>
             </a:pPr>
             <a:r>
-              <a:t>2. No chat-level cache existed on the LangGraph path at all.</a:t>
+              <a:t>v2.1 — Playbook MD; social/catalog probe; agent-multilingual.</a:t>
             </a:r>
           </a:p>
           <a:p>
@@ -11584,7 +13734,7 @@
               <a:spcAft>
                 <a:spcPts val="600"/>
               </a:spcAft>
-              <a:defRPr sz="1300" b="0">
+              <a:defRPr sz="1500" b="0">
                 <a:solidFill>
                   <a:srgbClr val="334155"/>
                 </a:solidFill>
@@ -11592,7 +13742,7 @@
               </a:defRPr>
             </a:pPr>
             <a:r>
-              <a:t>3. Catalog path bypassed dispatch_process — one 18s timeout, no</a:t>
+              <a:t>v2.1.3 — Fast intent-first stream; conductor intent opt-in.</a:t>
             </a:r>
           </a:p>
           <a:p>
@@ -11600,7 +13750,7 @@
               <a:spcAft>
                 <a:spcPts val="600"/>
               </a:spcAft>
-              <a:defRPr sz="1300" b="0">
+              <a:defRPr sz="1500" b="0">
                 <a:solidFill>
                   <a:srgbClr val="334155"/>
                 </a:solidFill>
@@ -11608,54 +13758,15 @@
               </a:defRPr>
             </a:pPr>
             <a:r>
-              <a:t>   outer-timeout cancellation message was ever reachable.</a:t>
-            </a:r>
-          </a:p>
-        </p:txBody>
-      </p:sp>
-      <p:sp>
-        <p:nvSpPr>
-          <p:cNvPr id="18" name="TextBox 17"/>
-          <p:cNvSpPr txBox="1"/>
-          <p:nvPr/>
-        </p:nvSpPr>
-        <p:spPr>
-          <a:xfrm>
-            <a:off x="6126480" y="1417320"/>
-            <a:ext cx="5257800" cy="4663440"/>
-          </a:xfrm>
-          <a:prstGeom prst="rect">
-            <a:avLst/>
-          </a:prstGeom>
-          <a:noFill/>
-        </p:spPr>
-        <p:txBody>
-          <a:bodyPr wrap="square" anchor="t">
-            <a:spAutoFit/>
-          </a:bodyPr>
-          <a:lstStyle/>
+              <a:t>v2.1.4–5 — Species inference; help/saludo detect + dedupe.</a:t>
+            </a:r>
+          </a:p>
           <a:p>
             <a:pPr>
               <a:spcAft>
                 <a:spcPts val="600"/>
               </a:spcAft>
-              <a:defRPr sz="1300" b="1">
-                <a:solidFill>
-                  <a:srgbClr val="0A2540"/>
-                </a:solidFill>
-                <a:latin typeface="Arial"/>
-              </a:defRPr>
-            </a:pPr>
-            <a:r>
-              <a:t>Verified live against the running server</a:t>
-            </a:r>
-          </a:p>
-          <a:p>
-            <a:pPr>
-              <a:spcAft>
-                <a:spcPts val="600"/>
-              </a:spcAft>
-              <a:defRPr sz="1300" b="0">
+              <a:defRPr sz="1500" b="0">
                 <a:solidFill>
                   <a:srgbClr val="334155"/>
                 </a:solidFill>
@@ -11663,151 +13774,7 @@
               </a:defRPr>
             </a:pPr>
             <a:r>
-              <a:t>• preferred_model: requested opencode/deepseek-v4-flash-free →</a:t>
-            </a:r>
-          </a:p>
-          <a:p>
-            <a:pPr>
-              <a:spcAft>
-                <a:spcPts val="600"/>
-              </a:spcAft>
-              <a:defRPr sz="1300" b="0">
-                <a:solidFill>
-                  <a:srgbClr val="334155"/>
-                </a:solidFill>
-                <a:latin typeface="Arial"/>
-              </a:defRPr>
-            </a:pPr>
-            <a:r>
-              <a:t>  that exact value now echoed in meta.llm_model (previously</a:t>
-            </a:r>
-          </a:p>
-          <a:p>
-            <a:pPr>
-              <a:spcAft>
-                <a:spcPts val="600"/>
-              </a:spcAft>
-              <a:defRPr sz="1300" b="0">
-                <a:solidFill>
-                  <a:srgbClr val="334155"/>
-                </a:solidFill>
-                <a:latin typeface="Arial"/>
-              </a:defRPr>
-            </a:pPr>
-            <a:r>
-              <a:t>  always silently ignored).</a:t>
-            </a:r>
-          </a:p>
-          <a:p>
-            <a:pPr>
-              <a:spcAft>
-                <a:spcPts val="600"/>
-              </a:spcAft>
-              <a:defRPr sz="1300" b="0">
-                <a:solidFill>
-                  <a:srgbClr val="334155"/>
-                </a:solidFill>
-                <a:latin typeface="Arial"/>
-              </a:defRPr>
-            </a:pPr>
-            <a:r>
-              <a:t>• Cache: identical repeat query — 19.2s (cold) → 0.02s (hit),</a:t>
-            </a:r>
-          </a:p>
-          <a:p>
-            <a:pPr>
-              <a:spcAft>
-                <a:spcPts val="600"/>
-              </a:spcAft>
-              <a:defRPr sz="1300" b="0">
-                <a:solidFill>
-                  <a:srgbClr val="334155"/>
-                </a:solidFill>
-                <a:latin typeface="Arial"/>
-              </a:defRPr>
-            </a:pPr>
-            <a:r>
-              <a:t>  same answer.</a:t>
-            </a:r>
-          </a:p>
-          <a:p>
-            <a:pPr>
-              <a:spcAft>
-                <a:spcPts val="600"/>
-              </a:spcAft>
-              <a:defRPr sz="1300" b="1">
-                <a:solidFill>
-                  <a:srgbClr val="0A2540"/>
-                </a:solidFill>
-                <a:latin typeface="Arial"/>
-              </a:defRPr>
-            </a:pPr>
-            <a:r>
-              <a:t>Test coverage</a:t>
-            </a:r>
-          </a:p>
-          <a:p>
-            <a:pPr>
-              <a:spcAft>
-                <a:spcPts val="600"/>
-              </a:spcAft>
-              <a:defRPr sz="1300" b="0">
-                <a:solidFill>
-                  <a:srgbClr val="334155"/>
-                </a:solidFill>
-                <a:latin typeface="Arial"/>
-              </a:defRPr>
-            </a:pPr>
-            <a:r>
-              <a:t>• 179/180 unit (+19 new tests for the 3 gaps), 206/206</a:t>
-            </a:r>
-          </a:p>
-          <a:p>
-            <a:pPr>
-              <a:spcAft>
-                <a:spcPts val="600"/>
-              </a:spcAft>
-              <a:defRPr sz="1300" b="0">
-                <a:solidFill>
-                  <a:srgbClr val="334155"/>
-                </a:solidFill>
-                <a:latin typeface="Arial"/>
-              </a:defRPr>
-            </a:pPr>
-            <a:r>
-              <a:t>  acceptance, 33/33 integration — ZOOPLUS_ORCHESTRATOR=langchain.</a:t>
-            </a:r>
-          </a:p>
-          <a:p>
-            <a:pPr>
-              <a:spcAft>
-                <a:spcPts val="600"/>
-              </a:spcAft>
-              <a:defRPr sz="1300" b="0">
-                <a:solidFill>
-                  <a:srgbClr val="334155"/>
-                </a:solidFill>
-                <a:latin typeface="Arial"/>
-              </a:defRPr>
-            </a:pPr>
-            <a:r>
-              <a:t>• Branch: feature/lg-catalog-probe-intent — standalone, not</a:t>
-            </a:r>
-          </a:p>
-          <a:p>
-            <a:pPr>
-              <a:spcAft>
-                <a:spcPts val="600"/>
-              </a:spcAft>
-              <a:defRPr sz="1300" b="0">
-                <a:solidFill>
-                  <a:srgbClr val="334155"/>
-                </a:solidFill>
-                <a:latin typeface="Arial"/>
-              </a:defRPr>
-            </a:pPr>
-            <a:r>
-              <a:t>  merged into dev/main/releases.</a:t>
+              <a:t>v2.1.6 — Dynamic count (4→20); phrase index; product_batch UI.</a:t>
             </a:r>
           </a:p>
         </p:txBody>

</xml_diff>

<commit_message>
docs(ppt+roadmap): elevate LangGraph to Phase 0 priority — reposition slides before Roadmap, update priority order in PPT/FUTURE_IMPROVEMENTS/README
</commit_message>
<xml_diff>
--- a/docs/deliverables/v0.1/zooplus-assistant-interview-15min-pro.pptx
+++ b/docs/deliverables/v0.1/zooplus-assistant-interview-15min-pro.pptx
@@ -15,12 +15,12 @@
     <p:sldId id="261" r:id="rId13"/>
     <p:sldId id="262" r:id="rId14"/>
     <p:sldId id="263" r:id="rId15"/>
+    <p:sldId id="270" r:id="rId22"/>
+    <p:sldId id="271" r:id="rId23"/>
+    <p:sldId id="272" r:id="rId24"/>
     <p:sldId id="264" r:id="rId16"/>
     <p:sldId id="265" r:id="rId17"/>
     <p:sldId id="266" r:id="rId18"/>
-    <p:sldId id="270" r:id="rId22"/>
-    <p:sldId id="271" r:id="rId23"/>
-    <p:sldId id="272" r:id="rId24"/>
     <p:sldId id="269" r:id="rId21"/>
   </p:sldIdLst>
   <p:sldSz cx="12191695" cy="6858000" type="screen4x3"/>
@@ -5978,7 +5978,7 @@
               </a:defRPr>
             </a:pPr>
             <a:r>
-              <a:t>Phase 1 · P0 — security and better filters (items 2–3)</a:t>
+              <a:t>Phase 0 done · Phase 1 P0 — LangGraph foundation, then security (items 0, 2–3)</a:t>
             </a:r>
           </a:p>
         </p:txBody>
@@ -6118,82 +6118,108 @@
               </a:defRPr>
             </a:pPr>
             <a:r>
-              <a:t>Why first: FR4 guardrails must survive prompt injection and policy drift</a:t>
+              <a:rPr sz="2000" b="1">
+                <a:solidFill>
+                  <a:srgbClr val="0A2540"/>
+                </a:solidFill>
+                <a:latin typeface="Arial"/>
+              </a:rPr>
+              <a:t>Phase 0 — DONE: LangGraph state-graph foundation</a:t>
             </a:r>
           </a:p>
           <a:p>
             <a:pPr>
-              <a:lnSpc>
-                <a:spcPct val="115000"/>
-              </a:lnSpc>
               <a:spcAft>
                 <a:spcPts val="800"/>
               </a:spcAft>
-              <a:defRPr sz="2000" b="0">
+            </a:pPr>
+            <a:r>
+              <a:rPr sz="2000" b="0">
                 <a:solidFill>
                   <a:srgbClr val="0F172A"/>
                 </a:solidFill>
                 <a:latin typeface="Arial"/>
-              </a:defRPr>
-            </a:pPr>
-            <a:r>
-              <a:t>Constraints v2: versioned YAML + injection scanner + security CI gate</a:t>
+              </a:rPr>
+              <a:t>feature/lg-catalog-probe-intent — faithful redesign, audited live (see previous slides)</a:t>
             </a:r>
           </a:p>
           <a:p>
             <a:pPr>
-              <a:lnSpc>
-                <a:spcPct val="115000"/>
-              </a:lnSpc>
               <a:spcAft>
                 <a:spcPts val="800"/>
               </a:spcAft>
-              <a:defRPr sz="2000" b="0">
-                <a:solidFill>
-                  <a:srgbClr val="0F172A"/>
-                </a:solidFill>
-                <a:latin typeface="Arial"/>
-              </a:defRPr>
-            </a:pPr>
-            <a:r>
-              <a:t>Intent facets: pet_type, price band, category in JSON → deterministic RAG</a:t>
+            </a:pPr>
+            <a:r>
+              <a:rPr sz="2000" b="1">
+                <a:solidFill>
+                  <a:srgbClr val="0A2540"/>
+                </a:solidFill>
+                <a:latin typeface="Arial"/>
+              </a:rPr>
+              <a:t>Why first: FR4 guardrails must survive prompt injection and policy drift</a:t>
             </a:r>
           </a:p>
           <a:p>
             <a:pPr>
-              <a:lnSpc>
-                <a:spcPct val="115000"/>
-              </a:lnSpc>
               <a:spcAft>
                 <a:spcPts val="800"/>
               </a:spcAft>
-              <a:defRPr sz="2000" b="0">
+            </a:pPr>
+            <a:r>
+              <a:rPr sz="2000" b="0">
                 <a:solidFill>
                   <a:srgbClr val="0F172A"/>
                 </a:solidFill>
                 <a:latin typeface="Arial"/>
-              </a:defRPr>
-            </a:pPr>
-            <a:r>
-              <a:t>Fixes real gaps (e.g. wrong species in results) before more traffic</a:t>
+              </a:rPr>
+              <a:t>Constraints v2: versioned YAML + injection scanner + security CI gate</a:t>
             </a:r>
           </a:p>
           <a:p>
             <a:pPr>
-              <a:lnSpc>
-                <a:spcPct val="115000"/>
-              </a:lnSpc>
               <a:spcAft>
                 <a:spcPts val="800"/>
               </a:spcAft>
-              <a:defRPr sz="2000" b="0">
+            </a:pPr>
+            <a:r>
+              <a:rPr sz="2000" b="0">
                 <a:solidFill>
                   <a:srgbClr val="0F172A"/>
                 </a:solidFill>
                 <a:latin typeface="Arial"/>
-              </a:defRPr>
-            </a:pPr>
-            <a:r>
+              </a:rPr>
+              <a:t>Intent facets: pet_type, price band, category in JSON → deterministic RAG</a:t>
+            </a:r>
+          </a:p>
+          <a:p>
+            <a:pPr>
+              <a:spcAft>
+                <a:spcPts val="800"/>
+              </a:spcAft>
+            </a:pPr>
+            <a:r>
+              <a:rPr sz="2000" b="0">
+                <a:solidFill>
+                  <a:srgbClr val="0F172A"/>
+                </a:solidFill>
+                <a:latin typeface="Arial"/>
+              </a:rPr>
+              <a:t>Fixes real gaps (e.g. wrong species in results) before more traffic</a:t>
+            </a:r>
+          </a:p>
+          <a:p>
+            <a:pPr>
+              <a:spcAft>
+                <a:spcPts val="800"/>
+              </a:spcAft>
+            </a:pPr>
+            <a:r>
+              <a:rPr sz="2000" b="0">
+                <a:solidFill>
+                  <a:srgbClr val="0F172A"/>
+                </a:solidFill>
+                <a:latin typeface="Arial"/>
+              </a:rPr>
               <a:t>Detail: docs/FUTURE_IMPROVEMENTS.md §2–§3</a:t>
             </a:r>
           </a:p>
@@ -6464,7 +6490,7 @@
               </a:defRPr>
             </a:pPr>
             <a:r>
-              <a:t>11</a:t>
+              <a:t>14</a:t>
             </a:r>
           </a:p>
         </p:txBody>
@@ -7341,7 +7367,7 @@
               </a:defRPr>
             </a:pPr>
             <a:r>
-              <a:t>12</a:t>
+              <a:t>15</a:t>
             </a:r>
           </a:p>
         </p:txBody>
@@ -7929,7 +7955,7 @@
               </a:defRPr>
             </a:pPr>
             <a:r>
-              <a:t>Priority order: 2→3→8→9→4→5→7→1→6</a:t>
+              <a:t>Priority order: 0→2→3→8→9→4→5→7→1→6</a:t>
             </a:r>
           </a:p>
           <a:p>
@@ -8218,7 +8244,7 @@
               </a:defRPr>
             </a:pPr>
             <a:r>
-              <a:t>13</a:t>
+              <a:t>16</a:t>
             </a:r>
           </a:p>
         </p:txBody>
@@ -8803,7 +8829,7 @@
               </a:defRPr>
             </a:pPr>
             <a:r>
-              <a:t>14</a:t>
+              <a:t>11</a:t>
             </a:r>
           </a:p>
         </p:txBody>
@@ -10906,7 +10932,7 @@
               </a:defRPr>
             </a:pPr>
             <a:r>
-              <a:t>15</a:t>
+              <a:t>12</a:t>
             </a:r>
           </a:p>
         </p:txBody>
@@ -12115,7 +12141,7 @@
               </a:defRPr>
             </a:pPr>
             <a:r>
-              <a:t>16</a:t>
+              <a:t>13</a:t>
             </a:r>
           </a:p>
         </p:txBody>

</xml_diff>